<commit_message>
Replace Budapest with Madrid as destination 2
Slides 7-12 now cover Madrid, Spain:
- Iberia/Eurowings from DUS, 2h30m, Oct 29 evening (~19:55→22:35) or Oct 30
- Airbnb Sonder Malasaña (rooms/47308216), 2BR, balcony, ~€150/night
- Bar Crawl Madrid Halloween Pub Crawl (€20pp, Puerta del Sol, Oct 31)
- Cooking Point tapas class (€85pp, 7 recipes + sangría)
- SANDEMANs free tour from Plaza Mayor
- Halloween on a Friday + Nov 1 public holiday = clubs open till 7AM
- Comparison slide updated to Lisbon vs Madrid

https://claude.ai/code/session_01L6yqHvAh94hYDWd4BReLCK
</commit_message>
<xml_diff>
--- a/halloween_trip_2025.pptx
+++ b/halloween_trip_2025.pptx
@@ -2437,11 +2437,11 @@
             <a:avLst/>
           </a:prstGeom>
           <a:solidFill>
-            <a:srgbClr val="FFC107"/>
+            <a:srgbClr val="E6321E"/>
           </a:solidFill>
           <a:ln w="12700">
             <a:solidFill>
-              <a:srgbClr val="FFC107"/>
+              <a:srgbClr val="E6321E"/>
             </a:solidFill>
             <a:prstDash val="solid"/>
           </a:ln>
@@ -2505,7 +2505,7 @@
                 <a:ea typeface="Trebuchet MS" pitchFamily="34" charset="-122"/>
                 <a:cs typeface="Trebuchet MS" pitchFamily="34" charset="-120"/>
               </a:rPr>
-              <a:t>🇭🇺  BUDAPEST — DAY-BY-DAY ITINERARY</a:t>
+              <a:t>🇪🇸  MADRID — DAY-BY-DAY ITINERARY</a:t>
             </a:r>
             <a:endParaRPr lang="en-US" sz="2200" dirty="0"/>
           </a:p>
@@ -2526,11 +2526,11 @@
             <a:avLst/>
           </a:prstGeom>
           <a:solidFill>
-            <a:srgbClr val="FFC107"/>
+            <a:srgbClr val="E6321E"/>
           </a:solidFill>
           <a:ln w="12700">
             <a:solidFill>
-              <a:srgbClr val="FFC107"/>
+              <a:srgbClr val="E6321E"/>
             </a:solidFill>
             <a:prstDash val="solid"/>
           </a:ln>
@@ -2555,7 +2555,7 @@
           </a:solidFill>
           <a:ln w="12700">
             <a:solidFill>
-              <a:srgbClr val="FFC107"/>
+              <a:srgbClr val="E6321E"/>
             </a:solidFill>
             <a:prstDash val="solid"/>
           </a:ln>
@@ -2613,7 +2613,7 @@
             <a:r>
               <a:rPr lang="en-US" sz="1100" b="1" dirty="0">
                 <a:solidFill>
-                  <a:srgbClr val="FFC107"/>
+                  <a:srgbClr val="E6321E"/>
                 </a:solidFill>
                 <a:latin typeface="Trebuchet MS" pitchFamily="34" charset="0"/>
                 <a:ea typeface="Trebuchet MS" pitchFamily="34" charset="-122"/>
@@ -2697,7 +2697,7 @@
                 <a:ea typeface="Calibri" pitchFamily="34" charset="-122"/>
                 <a:cs typeface="Calibri" pitchFamily="34" charset="-120"/>
               </a:rPr>
-              <a:t>✈  W62292 lands BUD 17:55 from DTM</a:t>
+              <a:t>✈  Iberia ~22:35 lands MAD from DUS</a:t>
             </a:r>
             <a:endParaRPr lang="en-US" sz="900" dirty="0"/>
           </a:p>
@@ -2736,7 +2736,7 @@
                 <a:ea typeface="Calibri" pitchFamily="34" charset="-122"/>
                 <a:cs typeface="Calibri" pitchFamily="34" charset="-120"/>
               </a:rPr>
-              <a:t>🏠  Check in District VII apartment</a:t>
+              <a:t>🚇  Metro Line 8 to centre (~€5, 20 min)</a:t>
             </a:r>
             <a:endParaRPr lang="en-US" sz="900" dirty="0"/>
           </a:p>
@@ -2775,7 +2775,7 @@
                 <a:ea typeface="Calibri" pitchFamily="34" charset="-122"/>
                 <a:cs typeface="Calibri" pitchFamily="34" charset="-120"/>
               </a:rPr>
-              <a:t>🍜  Dinner: Goulash at Menza or Hungarikum Bisztro</a:t>
+              <a:t>🏠  Check in Malasaña apartment</a:t>
             </a:r>
             <a:endParaRPr lang="en-US" sz="900" dirty="0"/>
           </a:p>
@@ -2814,7 +2814,7 @@
                 <a:ea typeface="Calibri" pitchFamily="34" charset="-122"/>
                 <a:cs typeface="Calibri" pitchFamily="34" charset="-120"/>
               </a:rPr>
-              <a:t>🍺  First ruin bar: Szimpla Kert (Kazinczy u. 14)</a:t>
+              <a:t>🍷  Bodega de la Ardosa: vermouth on tap since 1892</a:t>
             </a:r>
             <a:endParaRPr lang="en-US" sz="900" dirty="0"/>
           </a:p>
@@ -2853,7 +2853,7 @@
                 <a:ea typeface="Calibri" pitchFamily="34" charset="-122"/>
                 <a:cs typeface="Calibri" pitchFamily="34" charset="-120"/>
               </a:rPr>
-              <a:t>   The original (2002) — iconic labyrinthine courtyard</a:t>
+              <a:t>🍺  Malasaña bar crawl: Calle de la Palma, Tupperware</a:t>
             </a:r>
             <a:endParaRPr lang="en-US" sz="900" dirty="0"/>
           </a:p>
@@ -2892,7 +2892,7 @@
                 <a:ea typeface="Calibri" pitchFamily="34" charset="-122"/>
                 <a:cs typeface="Calibri" pitchFamily="34" charset="-120"/>
               </a:rPr>
-              <a:t>   Beer: Dreher Classic ~€3 · Open till 4 AM</a:t>
+              <a:t>   Beer: Mahou 5 Estrellas ~€3 · La Vía Láctea till 3 AM</a:t>
             </a:r>
             <a:endParaRPr lang="en-US" sz="900" dirty="0"/>
           </a:p>
@@ -2917,7 +2917,7 @@
           </a:solidFill>
           <a:ln w="12700">
             <a:solidFill>
-              <a:srgbClr val="FFC107"/>
+              <a:srgbClr val="E6321E"/>
             </a:solidFill>
             <a:prstDash val="solid"/>
           </a:ln>
@@ -2975,7 +2975,7 @@
             <a:r>
               <a:rPr lang="en-US" sz="1100" b="1" dirty="0">
                 <a:solidFill>
-                  <a:srgbClr val="FFC107"/>
+                  <a:srgbClr val="E6321E"/>
                 </a:solidFill>
                 <a:latin typeface="Trebuchet MS" pitchFamily="34" charset="0"/>
                 <a:ea typeface="Trebuchet MS" pitchFamily="34" charset="-122"/>
@@ -3020,7 +3020,7 @@
                 <a:ea typeface="Calibri" pitchFamily="34" charset="-122"/>
                 <a:cs typeface="Calibri" pitchFamily="34" charset="-120"/>
               </a:rPr>
-              <a:t>Thermal Bath Day</a:t>
+              <a:t>Walking Tour + Cooking</a:t>
             </a:r>
             <a:endParaRPr lang="en-US" sz="900" dirty="0"/>
           </a:p>
@@ -3059,7 +3059,7 @@
                 <a:ea typeface="Calibri" pitchFamily="34" charset="-122"/>
                 <a:cs typeface="Calibri" pitchFamily="34" charset="-120"/>
               </a:rPr>
-              <a:t>🚶  TripToBudapest Free Walking Tour 10 AM</a:t>
+              <a:t>🚶  SANDEMANs Free Tour 11:30 AM @ Plaza Mayor</a:t>
             </a:r>
             <a:endParaRPr lang="en-US" sz="900" dirty="0"/>
           </a:p>
@@ -3098,7 +3098,7 @@
                 <a:ea typeface="Calibri" pitchFamily="34" charset="-122"/>
                 <a:cs typeface="Calibri" pitchFamily="34" charset="-120"/>
               </a:rPr>
-              <a:t>   Erzsébet tér (look for blue FREE TOUR flag) · 2.5h</a:t>
+              <a:t>   2.5h · Royal Palace, Sol, La Latina, historic Madrid</a:t>
             </a:r>
             <a:endParaRPr lang="en-US" sz="900" dirty="0"/>
           </a:p>
@@ -3137,7 +3137,7 @@
                 <a:ea typeface="Calibri" pitchFamily="34" charset="-122"/>
                 <a:cs typeface="Calibri" pitchFamily="34" charset="-120"/>
               </a:rPr>
-              <a:t>🛁  Széchenyi Thermal Bath afternoon (€30pp)</a:t>
+              <a:t>🥘  Lunch tapas on Calle de la Cava Baja (La Latina)</a:t>
             </a:r>
             <a:endParaRPr lang="en-US" sz="900" dirty="0"/>
           </a:p>
@@ -3176,7 +3176,7 @@
                 <a:ea typeface="Calibri" pitchFamily="34" charset="-122"/>
                 <a:cs typeface="Calibri" pitchFamily="34" charset="-120"/>
               </a:rPr>
-              <a:t>   18 pools, outdoor thermal · open till 10 PM</a:t>
+              <a:t>🍳  Cooking Point Tapas Class 17:30–21:30 (€85pp)</a:t>
             </a:r>
             <a:endParaRPr lang="en-US" sz="900" dirty="0"/>
           </a:p>
@@ -3215,7 +3215,7 @@
                 <a:ea typeface="Calibri" pitchFamily="34" charset="-122"/>
                 <a:cs typeface="Calibri" pitchFamily="34" charset="-120"/>
               </a:rPr>
-              <a:t>🍺  Mazel Tov bar (Akácfa u. 47) dinner + drinks</a:t>
+              <a:t>   7 tapas recipes + sangría · Calle de Moratín, 11</a:t>
             </a:r>
             <a:endParaRPr lang="en-US" sz="900" dirty="0"/>
           </a:p>
@@ -3254,7 +3254,7 @@
                 <a:ea typeface="Calibri" pitchFamily="34" charset="-122"/>
                 <a:cs typeface="Calibri" pitchFamily="34" charset="-120"/>
               </a:rPr>
-              <a:t>🌃  Instant-Fogas complex (Akácfa u. 51)</a:t>
+              <a:t>   Book: cookingpoint.es  · Group max 12</a:t>
             </a:r>
             <a:endParaRPr lang="en-US" sz="900" dirty="0"/>
           </a:p>
@@ -3293,7 +3293,7 @@
                 <a:ea typeface="Calibri" pitchFamily="34" charset="-122"/>
                 <a:cs typeface="Calibri" pitchFamily="34" charset="-120"/>
               </a:rPr>
-              <a:t>   18 bars + 7 dance floors · open till 6 AM · FREE entry</a:t>
+              <a:t>🌃  After: Chueca bar scene + El Tigre free tapas</a:t>
             </a:r>
             <a:endParaRPr lang="en-US" sz="900" dirty="0"/>
           </a:p>
@@ -3318,7 +3318,7 @@
           </a:solidFill>
           <a:ln w="12700">
             <a:solidFill>
-              <a:srgbClr val="FFC107"/>
+              <a:srgbClr val="E6321E"/>
             </a:solidFill>
             <a:prstDash val="solid"/>
           </a:ln>
@@ -3376,7 +3376,7 @@
             <a:r>
               <a:rPr lang="en-US" sz="1100" b="1" dirty="0">
                 <a:solidFill>
-                  <a:srgbClr val="FFC107"/>
+                  <a:srgbClr val="E6321E"/>
                 </a:solidFill>
                 <a:latin typeface="Trebuchet MS" pitchFamily="34" charset="0"/>
                 <a:ea typeface="Trebuchet MS" pitchFamily="34" charset="-122"/>
@@ -3460,7 +3460,7 @@
                 <a:ea typeface="Calibri" pitchFamily="34" charset="-122"/>
                 <a:cs typeface="Calibri" pitchFamily="34" charset="-120"/>
               </a:rPr>
-              <a:t>🍳  Chefparade Hungarian Cooking Class (3h, €105pp)</a:t>
+              <a:t>🌞  Sleep in — Madrid nights go till 7 AM</a:t>
             </a:r>
             <a:endParaRPr lang="en-US" sz="900" dirty="0"/>
           </a:p>
@@ -3499,7 +3499,7 @@
                 <a:ea typeface="Calibri" pitchFamily="34" charset="-122"/>
                 <a:cs typeface="Calibri" pitchFamily="34" charset="-120"/>
               </a:rPr>
-              <a:t>   Hands-on goulash + stuffed cabbage + chimney cake</a:t>
+              <a:t>🏛  Afternoon: Prado Museum or Retiro Park stroll</a:t>
             </a:r>
             <a:endParaRPr lang="en-US" sz="900" dirty="0"/>
           </a:p>
@@ -3538,7 +3538,7 @@
                 <a:ea typeface="Calibri" pitchFamily="34" charset="-122"/>
                 <a:cs typeface="Calibri" pitchFamily="34" charset="-120"/>
               </a:rPr>
-              <a:t>   Book: cookingbudapest.com  · Group max 12</a:t>
+              <a:t>🎃  Halloween Pub Crawl 22:00 · €20pp</a:t>
             </a:r>
             <a:endParaRPr lang="en-US" sz="900" dirty="0"/>
           </a:p>
@@ -3577,7 +3577,7 @@
                 <a:ea typeface="Calibri" pitchFamily="34" charset="-122"/>
                 <a:cs typeface="Calibri" pitchFamily="34" charset="-120"/>
               </a:rPr>
-              <a:t>🕙  Original Halloween Pub Crawl 9:30 PM · €19pp</a:t>
+              <a:t>   Meet: Mulberry's Bar, Calle de Núñez de Arce 9</a:t>
             </a:r>
             <a:endParaRPr lang="en-US" sz="900" dirty="0"/>
           </a:p>
@@ -3616,7 +3616,7 @@
                 <a:ea typeface="Calibri" pitchFamily="34" charset="-122"/>
                 <a:cs typeface="Calibri" pitchFamily="34" charset="-120"/>
               </a:rPr>
-              <a:t>   Meet: Király utca 56 · guide with umbrella</a:t>
+              <a:t>   4 bars · tequila shots · €100 costume contest</a:t>
             </a:r>
             <a:endParaRPr lang="en-US" sz="900" dirty="0"/>
           </a:p>
@@ -3655,7 +3655,7 @@
                 <a:ea typeface="Calibri" pitchFamily="34" charset="-122"/>
                 <a:cs typeface="Calibri" pitchFamily="34" charset="-120"/>
               </a:rPr>
-              <a:t>   Free shots + costume contest + VIP club entry</a:t>
+              <a:t>🎶  After 1 AM: Teatro Kapital — 7 floors, till 6 AM</a:t>
             </a:r>
             <a:endParaRPr lang="en-US" sz="900" dirty="0"/>
           </a:p>
@@ -3694,7 +3694,7 @@
                 <a:ea typeface="Calibri" pitchFamily="34" charset="-122"/>
                 <a:cs typeface="Calibri" pitchFamily="34" charset="-120"/>
               </a:rPr>
-              <a:t>🎉  After: International Halloween Madness @ Akvárium Klub</a:t>
+              <a:t>   Calle Atocha 125 · €21pp entry · most central club</a:t>
             </a:r>
             <a:endParaRPr lang="en-US" sz="900" dirty="0"/>
           </a:p>
@@ -3733,7 +3733,7 @@
                 <a:ea typeface="Calibri" pitchFamily="34" charset="-122"/>
                 <a:cs typeface="Calibri" pitchFamily="34" charset="-120"/>
               </a:rPr>
-              <a:t>   3 dance floors, 2,500 people · pre-sale €15–18</a:t>
+              <a:t>   OR Fabrik Halloween party (20 min Uber, bigger)</a:t>
             </a:r>
             <a:endParaRPr lang="en-US" sz="900" dirty="0"/>
           </a:p>
@@ -3758,7 +3758,7 @@
           </a:solidFill>
           <a:ln w="12700">
             <a:solidFill>
-              <a:srgbClr val="FFC107"/>
+              <a:srgbClr val="E6321E"/>
             </a:solidFill>
             <a:prstDash val="solid"/>
           </a:ln>
@@ -3816,13 +3816,13 @@
             <a:r>
               <a:rPr lang="en-US" sz="1100" b="1" dirty="0">
                 <a:solidFill>
-                  <a:srgbClr val="FFC107"/>
+                  <a:srgbClr val="E6321E"/>
                 </a:solidFill>
                 <a:latin typeface="Trebuchet MS" pitchFamily="34" charset="0"/>
                 <a:ea typeface="Trebuchet MS" pitchFamily="34" charset="-122"/>
                 <a:cs typeface="Trebuchet MS" pitchFamily="34" charset="-120"/>
               </a:rPr>
-              <a:t>DAY 4 — SAT Nov 1 → Nov 2</a:t>
+              <a:t>DAY 4 — SAT Nov 1 (hol) + Nov 2</a:t>
             </a:r>
             <a:endParaRPr lang="en-US" sz="1100" dirty="0"/>
           </a:p>
@@ -3861,7 +3861,7 @@
                 <a:ea typeface="Calibri" pitchFamily="34" charset="-122"/>
                 <a:cs typeface="Calibri" pitchFamily="34" charset="-120"/>
               </a:rPr>
-              <a:t>Explore + Depart</a:t>
+              <a:t>Public Holiday + Depart</a:t>
             </a:r>
             <a:endParaRPr lang="en-US" sz="900" dirty="0"/>
           </a:p>
@@ -3900,7 +3900,7 @@
                 <a:ea typeface="Calibri" pitchFamily="34" charset="-122"/>
                 <a:cs typeface="Calibri" pitchFamily="34" charset="-120"/>
               </a:rPr>
-              <a:t>🏛  Heroes' Square + Vajdahunyad Castle (free)</a:t>
+              <a:t>🌞  Nov 1 = ALL SAINTS DAY (public holiday in Spain)</a:t>
             </a:r>
             <a:endParaRPr lang="en-US" sz="900" dirty="0"/>
           </a:p>
@@ -3939,7 +3939,7 @@
                 <a:ea typeface="Calibri" pitchFamily="34" charset="-122"/>
                 <a:cs typeface="Calibri" pitchFamily="34" charset="-120"/>
               </a:rPr>
-              <a:t>🛍  Great Market Hall: paprika, pálinka, lángos</a:t>
+              <a:t>☕  Brunch: Churros con Chocolate at Chocolatería San Ginés</a:t>
             </a:r>
             <a:endParaRPr lang="en-US" sz="900" dirty="0"/>
           </a:p>
@@ -3978,7 +3978,7 @@
                 <a:ea typeface="Calibri" pitchFamily="34" charset="-122"/>
                 <a:cs typeface="Calibri" pitchFamily="34" charset="-120"/>
               </a:rPr>
-              <a:t>🍺  Great ruin bar bar afternoon: Ötkert outdoor</a:t>
+              <a:t>🏺  Mercado de San Miguel: pintxos + local wines</a:t>
             </a:r>
             <a:endParaRPr lang="en-US" sz="900" dirty="0"/>
           </a:p>
@@ -4017,7 +4017,7 @@
                 <a:ea typeface="Calibri" pitchFamily="34" charset="-122"/>
                 <a:cs typeface="Calibri" pitchFamily="34" charset="-120"/>
               </a:rPr>
-              <a:t>🌙  Optional: Rudas Night Bath 10 PM – 3 AM (€37)</a:t>
+              <a:t>🍺  Afternoon vermut: La Hora del Vermut (~noon–3 PM)</a:t>
             </a:r>
             <a:endParaRPr lang="en-US" sz="900" dirty="0"/>
           </a:p>
@@ -4032,34 +4032,6 @@
         <p:spPr>
           <a:xfrm>
             <a:off x="6309360" y="5276088"/>
-            <a:ext cx="5486400" cy="256032"/>
-          </a:xfrm>
-          <a:prstGeom prst="rect">
-            <a:avLst/>
-          </a:prstGeom>
-          <a:noFill/>
-          <a:ln/>
-        </p:spPr>
-        <p:txBody>
-          <a:bodyPr wrap="square" rtlCol="0" anchor="t"/>
-          <a:lstStyle/>
-          <a:p>
-            <a:pPr indent="0" marL="0">
-              <a:buNone/>
-            </a:pPr>
-            <a:endParaRPr lang="en-US" sz="900" dirty="0"/>
-          </a:p>
-        </p:txBody>
-      </p:sp>
-      <p:sp>
-        <p:nvSpPr>
-          <p:cNvPr id="48" name="Text 46"/>
-          <p:cNvSpPr/>
-          <p:nvPr/>
-        </p:nvSpPr>
-        <p:spPr>
-          <a:xfrm>
-            <a:off x="6309360" y="5541264"/>
             <a:ext cx="5486400" cy="256032"/>
           </a:xfrm>
           <a:prstGeom prst="rect">
@@ -4084,8 +4056,36 @@
                 <a:ea typeface="Calibri" pitchFamily="34" charset="-122"/>
                 <a:cs typeface="Calibri" pitchFamily="34" charset="-120"/>
               </a:rPr>
-              <a:t>☀  NOV 2: W62291 departs BUD 10:40 → DTM 12:35</a:t>
+              <a:t>🌃  Final night: Malasaña or Lavapiés late bars</a:t>
             </a:r>
+            <a:endParaRPr lang="en-US" sz="900" dirty="0"/>
+          </a:p>
+        </p:txBody>
+      </p:sp>
+      <p:sp>
+        <p:nvSpPr>
+          <p:cNvPr id="48" name="Text 46"/>
+          <p:cNvSpPr/>
+          <p:nvPr/>
+        </p:nvSpPr>
+        <p:spPr>
+          <a:xfrm>
+            <a:off x="6309360" y="5541264"/>
+            <a:ext cx="5486400" cy="256032"/>
+          </a:xfrm>
+          <a:prstGeom prst="rect">
+            <a:avLst/>
+          </a:prstGeom>
+          <a:noFill/>
+          <a:ln/>
+        </p:spPr>
+        <p:txBody>
+          <a:bodyPr wrap="square" rtlCol="0" anchor="t"/>
+          <a:lstStyle/>
+          <a:p>
+            <a:pPr indent="0" marL="0">
+              <a:buNone/>
+            </a:pPr>
             <a:endParaRPr lang="en-US" sz="900" dirty="0"/>
           </a:p>
         </p:txBody>
@@ -4123,7 +4123,7 @@
                 <a:ea typeface="Calibri" pitchFamily="34" charset="-122"/>
                 <a:cs typeface="Calibri" pitchFamily="34" charset="-120"/>
               </a:rPr>
-              <a:t>   Bolt taxi to BKK airport (30 min, ~€15)</a:t>
+              <a:t>✈  NOV 2: DUS return flight (check Iberia/Eurowings)</a:t>
             </a:r>
             <a:endParaRPr lang="en-US" sz="900" dirty="0"/>
           </a:p>
@@ -4131,7 +4131,46 @@
       </p:sp>
       <p:sp>
         <p:nvSpPr>
-          <p:cNvPr id="50" name="Shape 48"/>
+          <p:cNvPr id="50" name="Text 48"/>
+          <p:cNvSpPr/>
+          <p:nvPr/>
+        </p:nvSpPr>
+        <p:spPr>
+          <a:xfrm>
+            <a:off x="6309360" y="6071616"/>
+            <a:ext cx="5486400" cy="256032"/>
+          </a:xfrm>
+          <a:prstGeom prst="rect">
+            <a:avLst/>
+          </a:prstGeom>
+          <a:noFill/>
+          <a:ln/>
+        </p:spPr>
+        <p:txBody>
+          <a:bodyPr wrap="square" rtlCol="0" anchor="t"/>
+          <a:lstStyle/>
+          <a:p>
+            <a:pPr indent="0" marL="0">
+              <a:buNone/>
+            </a:pPr>
+            <a:r>
+              <a:rPr lang="en-US" sz="900" dirty="0">
+                <a:solidFill>
+                  <a:srgbClr val="E8E8E8"/>
+                </a:solidFill>
+                <a:latin typeface="Calibri" pitchFamily="34" charset="0"/>
+                <a:ea typeface="Calibri" pitchFamily="34" charset="-122"/>
+                <a:cs typeface="Calibri" pitchFamily="34" charset="-120"/>
+              </a:rPr>
+              <a:t>   Metro Line 8 to airport (~€5, allow 45 min)</a:t>
+            </a:r>
+            <a:endParaRPr lang="en-US" sz="900" dirty="0"/>
+          </a:p>
+        </p:txBody>
+      </p:sp>
+      <p:sp>
+        <p:nvSpPr>
+          <p:cNvPr id="51" name="Shape 49"/>
           <p:cNvSpPr/>
           <p:nvPr/>
         </p:nvSpPr>
@@ -4156,7 +4195,7 @@
       </p:sp>
       <p:sp>
         <p:nvSpPr>
-          <p:cNvPr id="51" name="Text 49"/>
+          <p:cNvPr id="52" name="Text 50"/>
           <p:cNvSpPr/>
           <p:nvPr/>
         </p:nvSpPr>
@@ -4187,7 +4226,7 @@
                 <a:ea typeface="Calibri" pitchFamily="34" charset="-122"/>
                 <a:cs typeface="Calibri" pitchFamily="34" charset="-120"/>
               </a:rPr>
-              <a:t>Halloween Pub Crawl: originalberlintours.com/budapest-halloween  ·  Cooking: cookingbudapest.com  ·  Free tour: triptobudapest.hu  ·  Thermal: szechenyibath.hu</a:t>
+              <a:t>Halloween Pub Crawl: eventbrite.es/e/1037812363717  ·  Cooking: cookingpoint.es  ·  Free tour: neweuropetours.eu/madrid  ·  Club: teatrokapital.com</a:t>
             </a:r>
             <a:endParaRPr lang="en-US" sz="800" dirty="0"/>
           </a:p>
@@ -4195,7 +4234,7 @@
       </p:sp>
       <p:sp>
         <p:nvSpPr>
-          <p:cNvPr id="52" name="Shape 50"/>
+          <p:cNvPr id="53" name="Shape 51"/>
           <p:cNvSpPr/>
           <p:nvPr/>
         </p:nvSpPr>
@@ -4265,11 +4304,11 @@
             <a:avLst/>
           </a:prstGeom>
           <a:solidFill>
-            <a:srgbClr val="FFC107"/>
+            <a:srgbClr val="E6321E"/>
           </a:solidFill>
           <a:ln w="12700">
             <a:solidFill>
-              <a:srgbClr val="FFC107"/>
+              <a:srgbClr val="E6321E"/>
             </a:solidFill>
             <a:prstDash val="solid"/>
           </a:ln>
@@ -4333,7 +4372,7 @@
                 <a:ea typeface="Trebuchet MS" pitchFamily="34" charset="-122"/>
                 <a:cs typeface="Trebuchet MS" pitchFamily="34" charset="-120"/>
               </a:rPr>
-              <a:t>🇭🇺  BUDAPEST — COST SUMMARY</a:t>
+              <a:t>🇪🇸  MADRID — COST SUMMARY</a:t>
             </a:r>
             <a:endParaRPr lang="en-US" sz="2200" dirty="0"/>
           </a:p>
@@ -4354,11 +4393,11 @@
             <a:avLst/>
           </a:prstGeom>
           <a:solidFill>
-            <a:srgbClr val="FFC107"/>
+            <a:srgbClr val="E6321E"/>
           </a:solidFill>
           <a:ln w="12700">
             <a:solidFill>
-              <a:srgbClr val="FFC107"/>
+              <a:srgbClr val="E6321E"/>
             </a:solidFill>
             <a:prstDash val="solid"/>
           </a:ln>
@@ -4404,7 +4443,7 @@
                       <a:r>
                         <a:rPr lang="en-US" sz="1200" b="1" dirty="0">
                           <a:solidFill>
-                            <a:srgbClr val="FFC107"/>
+                            <a:srgbClr val="E6321E"/>
                           </a:solidFill>
                           <a:latin typeface="Trebuchet MS" pitchFamily="34" charset="0"/>
                           <a:ea typeface="Trebuchet MS" pitchFamily="34" charset="-122"/>
@@ -4472,7 +4511,7 @@
                       <a:r>
                         <a:rPr lang="en-US" sz="1200" b="1" dirty="0">
                           <a:solidFill>
-                            <a:srgbClr val="FFC107"/>
+                            <a:srgbClr val="E6321E"/>
                           </a:solidFill>
                           <a:latin typeface="Trebuchet MS" pitchFamily="34" charset="0"/>
                           <a:ea typeface="Trebuchet MS" pitchFamily="34" charset="-122"/>
@@ -4540,7 +4579,7 @@
                       <a:r>
                         <a:rPr lang="en-US" sz="1200" b="1" dirty="0">
                           <a:solidFill>
-                            <a:srgbClr val="FFC107"/>
+                            <a:srgbClr val="E6321E"/>
                           </a:solidFill>
                           <a:latin typeface="Trebuchet MS" pitchFamily="34" charset="0"/>
                           <a:ea typeface="Trebuchet MS" pitchFamily="34" charset="-122"/>
@@ -4666,7 +4705,7 @@
                   </a:tcPr>
                 </a:tc>
               </a:tr>
-              <a:tr h="411480">
+              <a:tr h="438912">
                 <a:tc>
                   <a:txBody>
                     <a:bodyPr/>
@@ -4752,7 +4791,7 @@
                           <a:ea typeface="Calibri" pitchFamily="34" charset="-122"/>
                           <a:cs typeface="Calibri" pitchFamily="34" charset="-120"/>
                         </a:rPr>
-                        <a:t>Wizz Air W62292/W62291  DTM ↔ BUD</a:t>
+                        <a:t>Iberia / Eurowings  DUS ↔ MAD</a:t>
                       </a:r>
                       <a:endParaRPr lang="en-US" sz="1100" dirty="0">
                         <a:latin typeface="Calibri" charset="0"/>
@@ -4820,7 +4859,7 @@
                           <a:ea typeface="Calibri" pitchFamily="34" charset="-122"/>
                           <a:cs typeface="Calibri" pitchFamily="34" charset="-120"/>
                         </a:rPr>
-                        <a:t>~€135</a:t>
+                        <a:t>~€175</a:t>
                       </a:r>
                       <a:endParaRPr lang="en-US" sz="1100" dirty="0">
                         <a:latin typeface="Calibri" charset="0"/>
@@ -4888,7 +4927,7 @@
                           <a:ea typeface="Calibri" pitchFamily="34" charset="-122"/>
                           <a:cs typeface="Calibri" pitchFamily="34" charset="-120"/>
                         </a:rPr>
-                        <a:t>~€540</a:t>
+                        <a:t>~€700</a:t>
                       </a:r>
                       <a:endParaRPr lang="en-US" sz="1100" dirty="0">
                         <a:latin typeface="Calibri" charset="0"/>
@@ -4940,7 +4979,7 @@
                   </a:tcPr>
                 </a:tc>
               </a:tr>
-              <a:tr h="411480">
+              <a:tr h="438912">
                 <a:tc>
                   <a:txBody>
                     <a:bodyPr/>
@@ -5026,7 +5065,7 @@
                           <a:ea typeface="Calibri" pitchFamily="34" charset="-122"/>
                           <a:cs typeface="Calibri" pitchFamily="34" charset="-120"/>
                         </a:rPr>
-                        <a:t>Airbnb District VII — 3 nights (inc. fees)</a:t>
+                        <a:t>Airbnb Malasaña — 3 nights (inc. fees)</a:t>
                       </a:r>
                       <a:endParaRPr lang="en-US" sz="1100" dirty="0">
                         <a:latin typeface="Calibri" charset="0"/>
@@ -5094,7 +5133,7 @@
                           <a:ea typeface="Calibri" pitchFamily="34" charset="-122"/>
                           <a:cs typeface="Calibri" pitchFamily="34" charset="-120"/>
                         </a:rPr>
-                        <a:t>~€90</a:t>
+                        <a:t>~€130</a:t>
                       </a:r>
                       <a:endParaRPr lang="en-US" sz="1100" dirty="0">
                         <a:latin typeface="Calibri" charset="0"/>
@@ -5162,7 +5201,7 @@
                           <a:ea typeface="Calibri" pitchFamily="34" charset="-122"/>
                           <a:cs typeface="Calibri" pitchFamily="34" charset="-120"/>
                         </a:rPr>
-                        <a:t>~€360</a:t>
+                        <a:t>~€520</a:t>
                       </a:r>
                       <a:endParaRPr lang="en-US" sz="1100" dirty="0">
                         <a:latin typeface="Calibri" charset="0"/>
@@ -5214,7 +5253,7 @@
                   </a:tcPr>
                 </a:tc>
               </a:tr>
-              <a:tr h="411480">
+              <a:tr h="438912">
                 <a:tc>
                   <a:txBody>
                     <a:bodyPr/>
@@ -5300,7 +5339,7 @@
                           <a:ea typeface="Calibri" pitchFamily="34" charset="-122"/>
                           <a:cs typeface="Calibri" pitchFamily="34" charset="-120"/>
                         </a:rPr>
-                        <a:t>Original Halloween Pub Crawl (Oct 31)</a:t>
+                        <a:t>Bar Crawl Madrid — Puerta del Sol (Oct 31)</a:t>
                       </a:r>
                       <a:endParaRPr lang="en-US" sz="1100" dirty="0">
                         <a:latin typeface="Calibri" charset="0"/>
@@ -5368,7 +5407,7 @@
                           <a:ea typeface="Calibri" pitchFamily="34" charset="-122"/>
                           <a:cs typeface="Calibri" pitchFamily="34" charset="-120"/>
                         </a:rPr>
-                        <a:t>€19</a:t>
+                        <a:t>€20</a:t>
                       </a:r>
                       <a:endParaRPr lang="en-US" sz="1100" dirty="0">
                         <a:latin typeface="Calibri" charset="0"/>
@@ -5436,7 +5475,7 @@
                           <a:ea typeface="Calibri" pitchFamily="34" charset="-122"/>
                           <a:cs typeface="Calibri" pitchFamily="34" charset="-120"/>
                         </a:rPr>
-                        <a:t>€76</a:t>
+                        <a:t>€80</a:t>
                       </a:r>
                       <a:endParaRPr lang="en-US" sz="1100" dirty="0">
                         <a:latin typeface="Calibri" charset="0"/>
@@ -5488,7 +5527,7 @@
                   </a:tcPr>
                 </a:tc>
               </a:tr>
-              <a:tr h="411480">
+              <a:tr h="438912">
                 <a:tc>
                   <a:txBody>
                     <a:bodyPr/>
@@ -5574,7 +5613,7 @@
                           <a:ea typeface="Calibri" pitchFamily="34" charset="-122"/>
                           <a:cs typeface="Calibri" pitchFamily="34" charset="-120"/>
                         </a:rPr>
-                        <a:t>Chefparade — Hungarian goulash + chimney cake</a:t>
+                        <a:t>Cooking Point — 7 tapas + sangría (4h)</a:t>
                       </a:r>
                       <a:endParaRPr lang="en-US" sz="1100" dirty="0">
                         <a:latin typeface="Calibri" charset="0"/>
@@ -5642,7 +5681,7 @@
                           <a:ea typeface="Calibri" pitchFamily="34" charset="-122"/>
                           <a:cs typeface="Calibri" pitchFamily="34" charset="-120"/>
                         </a:rPr>
-                        <a:t>€105</a:t>
+                        <a:t>€85</a:t>
                       </a:r>
                       <a:endParaRPr lang="en-US" sz="1100" dirty="0">
                         <a:latin typeface="Calibri" charset="0"/>
@@ -5710,7 +5749,7 @@
                           <a:ea typeface="Calibri" pitchFamily="34" charset="-122"/>
                           <a:cs typeface="Calibri" pitchFamily="34" charset="-120"/>
                         </a:rPr>
-                        <a:t>€420</a:t>
+                        <a:t>€340</a:t>
                       </a:r>
                       <a:endParaRPr lang="en-US" sz="1100" dirty="0">
                         <a:latin typeface="Calibri" charset="0"/>
@@ -5762,281 +5801,7 @@
                   </a:tcPr>
                 </a:tc>
               </a:tr>
-              <a:tr h="411480">
-                <a:tc>
-                  <a:txBody>
-                    <a:bodyPr/>
-                    <a:lstStyle/>
-                    <a:p>
-                      <a:pPr algn="l" indent="0" marL="0">
-                        <a:buNone/>
-                      </a:pPr>
-                      <a:r>
-                        <a:rPr lang="en-US" sz="1100" dirty="0">
-                          <a:solidFill>
-                            <a:srgbClr val="E8E8E8"/>
-                          </a:solidFill>
-                          <a:latin typeface="Calibri" pitchFamily="34" charset="0"/>
-                          <a:ea typeface="Calibri" pitchFamily="34" charset="-122"/>
-                          <a:cs typeface="Calibri" pitchFamily="34" charset="-120"/>
-                        </a:rPr>
-                        <a:t>Thermal Bath</a:t>
-                      </a:r>
-                      <a:endParaRPr lang="en-US" sz="1100" dirty="0">
-                        <a:latin typeface="Calibri" charset="0"/>
-                        <a:ea typeface="Calibri" charset="0"/>
-                        <a:cs typeface="Calibri" charset="0"/>
-                      </a:endParaRPr>
-                    </a:p>
-                  </a:txBody>
-                  <a:tcPr marL="91440" marR="91440" marT="45720" marB="45720" anchor="ctr">
-                    <a:lnL w="12700" cap="flat" cmpd="sng" algn="ctr">
-                      <a:solidFill>
-                        <a:srgbClr val="0F3460"/>
-                      </a:solidFill>
-                      <a:prstDash val="solid"/>
-                      <a:round/>
-                      <a:headEnd type="none" w="med" len="med"/>
-                      <a:tailEnd type="none" w="med" len="med"/>
-                    </a:lnL>
-                    <a:lnR w="12700" cap="flat" cmpd="sng" algn="ctr">
-                      <a:solidFill>
-                        <a:srgbClr val="0F3460"/>
-                      </a:solidFill>
-                      <a:prstDash val="solid"/>
-                      <a:round/>
-                      <a:headEnd type="none" w="med" len="med"/>
-                      <a:tailEnd type="none" w="med" len="med"/>
-                    </a:lnR>
-                    <a:lnT w="12700" cap="flat" cmpd="sng" algn="ctr">
-                      <a:solidFill>
-                        <a:srgbClr val="0F3460"/>
-                      </a:solidFill>
-                      <a:prstDash val="solid"/>
-                      <a:round/>
-                      <a:headEnd type="none" w="med" len="med"/>
-                      <a:tailEnd type="none" w="med" len="med"/>
-                    </a:lnT>
-                    <a:lnB w="12700" cap="flat" cmpd="sng" algn="ctr">
-                      <a:solidFill>
-                        <a:srgbClr val="0F3460"/>
-                      </a:solidFill>
-                      <a:prstDash val="solid"/>
-                      <a:round/>
-                      <a:headEnd type="none" w="med" len="med"/>
-                      <a:tailEnd type="none" w="med" len="med"/>
-                    </a:lnB>
-                    <a:solidFill>
-                      <a:srgbClr val="16213E"/>
-                    </a:solidFill>
-                  </a:tcPr>
-                </a:tc>
-                <a:tc>
-                  <a:txBody>
-                    <a:bodyPr/>
-                    <a:lstStyle/>
-                    <a:p>
-                      <a:pPr algn="l" indent="0" marL="0">
-                        <a:buNone/>
-                      </a:pPr>
-                      <a:r>
-                        <a:rPr lang="en-US" sz="1100" dirty="0">
-                          <a:solidFill>
-                            <a:srgbClr val="E8E8E8"/>
-                          </a:solidFill>
-                          <a:latin typeface="Calibri" pitchFamily="34" charset="0"/>
-                          <a:ea typeface="Calibri" pitchFamily="34" charset="-122"/>
-                          <a:cs typeface="Calibri" pitchFamily="34" charset="-120"/>
-                        </a:rPr>
-                        <a:t>Széchenyi — all-day thermal (Oct 30)</a:t>
-                      </a:r>
-                      <a:endParaRPr lang="en-US" sz="1100" dirty="0">
-                        <a:latin typeface="Calibri" charset="0"/>
-                        <a:ea typeface="Calibri" charset="0"/>
-                        <a:cs typeface="Calibri" charset="0"/>
-                      </a:endParaRPr>
-                    </a:p>
-                  </a:txBody>
-                  <a:tcPr marL="91440" marR="91440" marT="45720" marB="45720" anchor="ctr">
-                    <a:lnL w="12700" cap="flat" cmpd="sng" algn="ctr">
-                      <a:solidFill>
-                        <a:srgbClr val="0F3460"/>
-                      </a:solidFill>
-                      <a:prstDash val="solid"/>
-                      <a:round/>
-                      <a:headEnd type="none" w="med" len="med"/>
-                      <a:tailEnd type="none" w="med" len="med"/>
-                    </a:lnL>
-                    <a:lnR w="12700" cap="flat" cmpd="sng" algn="ctr">
-                      <a:solidFill>
-                        <a:srgbClr val="0F3460"/>
-                      </a:solidFill>
-                      <a:prstDash val="solid"/>
-                      <a:round/>
-                      <a:headEnd type="none" w="med" len="med"/>
-                      <a:tailEnd type="none" w="med" len="med"/>
-                    </a:lnR>
-                    <a:lnT w="12700" cap="flat" cmpd="sng" algn="ctr">
-                      <a:solidFill>
-                        <a:srgbClr val="0F3460"/>
-                      </a:solidFill>
-                      <a:prstDash val="solid"/>
-                      <a:round/>
-                      <a:headEnd type="none" w="med" len="med"/>
-                      <a:tailEnd type="none" w="med" len="med"/>
-                    </a:lnT>
-                    <a:lnB w="12700" cap="flat" cmpd="sng" algn="ctr">
-                      <a:solidFill>
-                        <a:srgbClr val="0F3460"/>
-                      </a:solidFill>
-                      <a:prstDash val="solid"/>
-                      <a:round/>
-                      <a:headEnd type="none" w="med" len="med"/>
-                      <a:tailEnd type="none" w="med" len="med"/>
-                    </a:lnB>
-                    <a:solidFill>
-                      <a:srgbClr val="16213E"/>
-                    </a:solidFill>
-                  </a:tcPr>
-                </a:tc>
-                <a:tc>
-                  <a:txBody>
-                    <a:bodyPr/>
-                    <a:lstStyle/>
-                    <a:p>
-                      <a:pPr algn="r" indent="0" marL="0">
-                        <a:buNone/>
-                      </a:pPr>
-                      <a:r>
-                        <a:rPr lang="en-US" sz="1100" dirty="0">
-                          <a:solidFill>
-                            <a:srgbClr val="E8E8E8"/>
-                          </a:solidFill>
-                          <a:latin typeface="Calibri" pitchFamily="34" charset="0"/>
-                          <a:ea typeface="Calibri" pitchFamily="34" charset="-122"/>
-                          <a:cs typeface="Calibri" pitchFamily="34" charset="-120"/>
-                        </a:rPr>
-                        <a:t>€32</a:t>
-                      </a:r>
-                      <a:endParaRPr lang="en-US" sz="1100" dirty="0">
-                        <a:latin typeface="Calibri" charset="0"/>
-                        <a:ea typeface="Calibri" charset="0"/>
-                        <a:cs typeface="Calibri" charset="0"/>
-                      </a:endParaRPr>
-                    </a:p>
-                  </a:txBody>
-                  <a:tcPr marL="91440" marR="91440" marT="45720" marB="45720" anchor="ctr">
-                    <a:lnL w="12700" cap="flat" cmpd="sng" algn="ctr">
-                      <a:solidFill>
-                        <a:srgbClr val="0F3460"/>
-                      </a:solidFill>
-                      <a:prstDash val="solid"/>
-                      <a:round/>
-                      <a:headEnd type="none" w="med" len="med"/>
-                      <a:tailEnd type="none" w="med" len="med"/>
-                    </a:lnL>
-                    <a:lnR w="12700" cap="flat" cmpd="sng" algn="ctr">
-                      <a:solidFill>
-                        <a:srgbClr val="0F3460"/>
-                      </a:solidFill>
-                      <a:prstDash val="solid"/>
-                      <a:round/>
-                      <a:headEnd type="none" w="med" len="med"/>
-                      <a:tailEnd type="none" w="med" len="med"/>
-                    </a:lnR>
-                    <a:lnT w="12700" cap="flat" cmpd="sng" algn="ctr">
-                      <a:solidFill>
-                        <a:srgbClr val="0F3460"/>
-                      </a:solidFill>
-                      <a:prstDash val="solid"/>
-                      <a:round/>
-                      <a:headEnd type="none" w="med" len="med"/>
-                      <a:tailEnd type="none" w="med" len="med"/>
-                    </a:lnT>
-                    <a:lnB w="12700" cap="flat" cmpd="sng" algn="ctr">
-                      <a:solidFill>
-                        <a:srgbClr val="0F3460"/>
-                      </a:solidFill>
-                      <a:prstDash val="solid"/>
-                      <a:round/>
-                      <a:headEnd type="none" w="med" len="med"/>
-                      <a:tailEnd type="none" w="med" len="med"/>
-                    </a:lnB>
-                    <a:solidFill>
-                      <a:srgbClr val="16213E"/>
-                    </a:solidFill>
-                  </a:tcPr>
-                </a:tc>
-                <a:tc>
-                  <a:txBody>
-                    <a:bodyPr/>
-                    <a:lstStyle/>
-                    <a:p>
-                      <a:pPr algn="r" indent="0" marL="0">
-                        <a:buNone/>
-                      </a:pPr>
-                      <a:r>
-                        <a:rPr lang="en-US" sz="1100" dirty="0">
-                          <a:solidFill>
-                            <a:srgbClr val="E8E8E8"/>
-                          </a:solidFill>
-                          <a:latin typeface="Calibri" pitchFamily="34" charset="0"/>
-                          <a:ea typeface="Calibri" pitchFamily="34" charset="-122"/>
-                          <a:cs typeface="Calibri" pitchFamily="34" charset="-120"/>
-                        </a:rPr>
-                        <a:t>€128</a:t>
-                      </a:r>
-                      <a:endParaRPr lang="en-US" sz="1100" dirty="0">
-                        <a:latin typeface="Calibri" charset="0"/>
-                        <a:ea typeface="Calibri" charset="0"/>
-                        <a:cs typeface="Calibri" charset="0"/>
-                      </a:endParaRPr>
-                    </a:p>
-                  </a:txBody>
-                  <a:tcPr marL="91440" marR="91440" marT="45720" marB="45720" anchor="ctr">
-                    <a:lnL w="12700" cap="flat" cmpd="sng" algn="ctr">
-                      <a:solidFill>
-                        <a:srgbClr val="0F3460"/>
-                      </a:solidFill>
-                      <a:prstDash val="solid"/>
-                      <a:round/>
-                      <a:headEnd type="none" w="med" len="med"/>
-                      <a:tailEnd type="none" w="med" len="med"/>
-                    </a:lnL>
-                    <a:lnR w="12700" cap="flat" cmpd="sng" algn="ctr">
-                      <a:solidFill>
-                        <a:srgbClr val="0F3460"/>
-                      </a:solidFill>
-                      <a:prstDash val="solid"/>
-                      <a:round/>
-                      <a:headEnd type="none" w="med" len="med"/>
-                      <a:tailEnd type="none" w="med" len="med"/>
-                    </a:lnR>
-                    <a:lnT w="12700" cap="flat" cmpd="sng" algn="ctr">
-                      <a:solidFill>
-                        <a:srgbClr val="0F3460"/>
-                      </a:solidFill>
-                      <a:prstDash val="solid"/>
-                      <a:round/>
-                      <a:headEnd type="none" w="med" len="med"/>
-                      <a:tailEnd type="none" w="med" len="med"/>
-                    </a:lnT>
-                    <a:lnB w="12700" cap="flat" cmpd="sng" algn="ctr">
-                      <a:solidFill>
-                        <a:srgbClr val="0F3460"/>
-                      </a:solidFill>
-                      <a:prstDash val="solid"/>
-                      <a:round/>
-                      <a:headEnd type="none" w="med" len="med"/>
-                      <a:tailEnd type="none" w="med" len="med"/>
-                    </a:lnB>
-                    <a:solidFill>
-                      <a:srgbClr val="16213E"/>
-                    </a:solidFill>
-                  </a:tcPr>
-                </a:tc>
-              </a:tr>
-              <a:tr h="411480">
+              <a:tr h="438912">
                 <a:tc>
                   <a:txBody>
                     <a:bodyPr/>
@@ -6101,7 +5866,7 @@
                       <a:tailEnd type="none" w="med" len="med"/>
                     </a:lnB>
                     <a:solidFill>
-                      <a:srgbClr val="1A1A2E"/>
+                      <a:srgbClr val="16213E"/>
                     </a:solidFill>
                   </a:tcPr>
                 </a:tc>
@@ -6122,7 +5887,7 @@
                           <a:ea typeface="Calibri" pitchFamily="34" charset="-122"/>
                           <a:cs typeface="Calibri" pitchFamily="34" charset="-120"/>
                         </a:rPr>
-                        <a:t>TripToBudapest — Erzsébet tér (tip)</a:t>
+                        <a:t>SANDEMANs — Plaza Mayor (tip)</a:t>
                       </a:r>
                       <a:endParaRPr lang="en-US" sz="1100" dirty="0">
                         <a:latin typeface="Calibri" charset="0"/>
@@ -6169,7 +5934,7 @@
                       <a:tailEnd type="none" w="med" len="med"/>
                     </a:lnB>
                     <a:solidFill>
-                      <a:srgbClr val="1A1A2E"/>
+                      <a:srgbClr val="16213E"/>
                     </a:solidFill>
                   </a:tcPr>
                 </a:tc>
@@ -6237,7 +6002,7 @@
                       <a:tailEnd type="none" w="med" len="med"/>
                     </a:lnB>
                     <a:solidFill>
-                      <a:srgbClr val="1A1A2E"/>
+                      <a:srgbClr val="16213E"/>
                     </a:solidFill>
                   </a:tcPr>
                 </a:tc>
@@ -6305,12 +6070,12 @@
                       <a:tailEnd type="none" w="med" len="med"/>
                     </a:lnB>
                     <a:solidFill>
-                      <a:srgbClr val="1A1A2E"/>
+                      <a:srgbClr val="16213E"/>
                     </a:solidFill>
                   </a:tcPr>
                 </a:tc>
               </a:tr>
-              <a:tr h="411480">
+              <a:tr h="438912">
                 <a:tc>
                   <a:txBody>
                     <a:bodyPr/>
@@ -6375,7 +6140,7 @@
                       <a:tailEnd type="none" w="med" len="med"/>
                     </a:lnB>
                     <a:solidFill>
-                      <a:srgbClr val="16213E"/>
+                      <a:srgbClr val="1A1A2E"/>
                     </a:solidFill>
                   </a:tcPr>
                 </a:tc>
@@ -6396,7 +6161,7 @@
                           <a:ea typeface="Calibri" pitchFamily="34" charset="-122"/>
                           <a:cs typeface="Calibri" pitchFamily="34" charset="-120"/>
                         </a:rPr>
-                        <a:t>Goulash, lángos, chimney cakes — avg €10–20/meal</a:t>
+                        <a:t>Tapas, churros, market food — avg €15–20/meal</a:t>
                       </a:r>
                       <a:endParaRPr lang="en-US" sz="1100" dirty="0">
                         <a:latin typeface="Calibri" charset="0"/>
@@ -6443,7 +6208,7 @@
                       <a:tailEnd type="none" w="med" len="med"/>
                     </a:lnB>
                     <a:solidFill>
-                      <a:srgbClr val="16213E"/>
+                      <a:srgbClr val="1A1A2E"/>
                     </a:solidFill>
                   </a:tcPr>
                 </a:tc>
@@ -6464,7 +6229,7 @@
                           <a:ea typeface="Calibri" pitchFamily="34" charset="-122"/>
                           <a:cs typeface="Calibri" pitchFamily="34" charset="-120"/>
                         </a:rPr>
-                        <a:t>~€95</a:t>
+                        <a:t>~€115</a:t>
                       </a:r>
                       <a:endParaRPr lang="en-US" sz="1100" dirty="0">
                         <a:latin typeface="Calibri" charset="0"/>
@@ -6511,7 +6276,7 @@
                       <a:tailEnd type="none" w="med" len="med"/>
                     </a:lnB>
                     <a:solidFill>
-                      <a:srgbClr val="16213E"/>
+                      <a:srgbClr val="1A1A2E"/>
                     </a:solidFill>
                   </a:tcPr>
                 </a:tc>
@@ -6532,7 +6297,7 @@
                           <a:ea typeface="Calibri" pitchFamily="34" charset="-122"/>
                           <a:cs typeface="Calibri" pitchFamily="34" charset="-120"/>
                         </a:rPr>
-                        <a:t>~€380</a:t>
+                        <a:t>~€460</a:t>
                       </a:r>
                       <a:endParaRPr lang="en-US" sz="1100" dirty="0">
                         <a:latin typeface="Calibri" charset="0"/>
@@ -6579,12 +6344,12 @@
                       <a:tailEnd type="none" w="med" len="med"/>
                     </a:lnB>
                     <a:solidFill>
-                      <a:srgbClr val="16213E"/>
+                      <a:srgbClr val="1A1A2E"/>
                     </a:solidFill>
                   </a:tcPr>
                 </a:tc>
               </a:tr>
-              <a:tr h="411480">
+              <a:tr h="438912">
                 <a:tc>
                   <a:txBody>
                     <a:bodyPr/>
@@ -6649,7 +6414,7 @@
                       <a:tailEnd type="none" w="med" len="med"/>
                     </a:lnB>
                     <a:solidFill>
-                      <a:srgbClr val="1A1A2E"/>
+                      <a:srgbClr val="16213E"/>
                     </a:solidFill>
                   </a:tcPr>
                 </a:tc>
@@ -6670,7 +6435,7 @@
                           <a:ea typeface="Calibri" pitchFamily="34" charset="-122"/>
                           <a:cs typeface="Calibri" pitchFamily="34" charset="-120"/>
                         </a:rPr>
-                        <a:t>Ruin bars + clubs (3 nights) — very cheap</a:t>
+                        <a:t>Malasaña + Chueca + Halloween club (3 nights)</a:t>
                       </a:r>
                       <a:endParaRPr lang="en-US" sz="1100" dirty="0">
                         <a:latin typeface="Calibri" charset="0"/>
@@ -6717,7 +6482,7 @@
                       <a:tailEnd type="none" w="med" len="med"/>
                     </a:lnB>
                     <a:solidFill>
-                      <a:srgbClr val="1A1A2E"/>
+                      <a:srgbClr val="16213E"/>
                     </a:solidFill>
                   </a:tcPr>
                 </a:tc>
@@ -6738,7 +6503,7 @@
                           <a:ea typeface="Calibri" pitchFamily="34" charset="-122"/>
                           <a:cs typeface="Calibri" pitchFamily="34" charset="-120"/>
                         </a:rPr>
-                        <a:t>~€110</a:t>
+                        <a:t>~€140</a:t>
                       </a:r>
                       <a:endParaRPr lang="en-US" sz="1100" dirty="0">
                         <a:latin typeface="Calibri" charset="0"/>
@@ -6785,7 +6550,7 @@
                       <a:tailEnd type="none" w="med" len="med"/>
                     </a:lnB>
                     <a:solidFill>
-                      <a:srgbClr val="1A1A2E"/>
+                      <a:srgbClr val="16213E"/>
                     </a:solidFill>
                   </a:tcPr>
                 </a:tc>
@@ -6806,7 +6571,7 @@
                           <a:ea typeface="Calibri" pitchFamily="34" charset="-122"/>
                           <a:cs typeface="Calibri" pitchFamily="34" charset="-120"/>
                         </a:rPr>
-                        <a:t>~€440</a:t>
+                        <a:t>~€560</a:t>
                       </a:r>
                       <a:endParaRPr lang="en-US" sz="1100" dirty="0">
                         <a:latin typeface="Calibri" charset="0"/>
@@ -6853,12 +6618,12 @@
                       <a:tailEnd type="none" w="med" len="med"/>
                     </a:lnB>
                     <a:solidFill>
-                      <a:srgbClr val="1A1A2E"/>
+                      <a:srgbClr val="16213E"/>
                     </a:solidFill>
                   </a:tcPr>
                 </a:tc>
               </a:tr>
-              <a:tr h="411480">
+              <a:tr h="438912">
                 <a:tc>
                   <a:txBody>
                     <a:bodyPr/>
@@ -6923,7 +6688,7 @@
                       <a:tailEnd type="none" w="med" len="med"/>
                     </a:lnB>
                     <a:solidFill>
-                      <a:srgbClr val="16213E"/>
+                      <a:srgbClr val="1A1A2E"/>
                     </a:solidFill>
                   </a:tcPr>
                 </a:tc>
@@ -6944,7 +6709,7 @@
                           <a:ea typeface="Calibri" pitchFamily="34" charset="-122"/>
                           <a:cs typeface="Calibri" pitchFamily="34" charset="-120"/>
                         </a:rPr>
-                        <a:t>Bolt rides, Budapest GO transit card, souvenirs</a:t>
+                        <a:t>Metro, Uber, souvenirs, airport taxi</a:t>
                       </a:r>
                       <a:endParaRPr lang="en-US" sz="1100" dirty="0">
                         <a:latin typeface="Calibri" charset="0"/>
@@ -6991,7 +6756,7 @@
                       <a:tailEnd type="none" w="med" len="med"/>
                     </a:lnB>
                     <a:solidFill>
-                      <a:srgbClr val="16213E"/>
+                      <a:srgbClr val="1A1A2E"/>
                     </a:solidFill>
                   </a:tcPr>
                 </a:tc>
@@ -7012,7 +6777,7 @@
                           <a:ea typeface="Calibri" pitchFamily="34" charset="-122"/>
                           <a:cs typeface="Calibri" pitchFamily="34" charset="-120"/>
                         </a:rPr>
-                        <a:t>~€25</a:t>
+                        <a:t>~€35</a:t>
                       </a:r>
                       <a:endParaRPr lang="en-US" sz="1100" dirty="0">
                         <a:latin typeface="Calibri" charset="0"/>
@@ -7059,7 +6824,7 @@
                       <a:tailEnd type="none" w="med" len="med"/>
                     </a:lnB>
                     <a:solidFill>
-                      <a:srgbClr val="16213E"/>
+                      <a:srgbClr val="1A1A2E"/>
                     </a:solidFill>
                   </a:tcPr>
                 </a:tc>
@@ -7080,7 +6845,7 @@
                           <a:ea typeface="Calibri" pitchFamily="34" charset="-122"/>
                           <a:cs typeface="Calibri" pitchFamily="34" charset="-120"/>
                         </a:rPr>
-                        <a:t>~€100</a:t>
+                        <a:t>~€140</a:t>
                       </a:r>
                       <a:endParaRPr lang="en-US" sz="1100" dirty="0">
                         <a:latin typeface="Calibri" charset="0"/>
@@ -7127,12 +6892,12 @@
                       <a:tailEnd type="none" w="med" len="med"/>
                     </a:lnB>
                     <a:solidFill>
-                      <a:srgbClr val="16213E"/>
+                      <a:srgbClr val="1A1A2E"/>
                     </a:solidFill>
                   </a:tcPr>
                 </a:tc>
               </a:tr>
-              <a:tr h="475488">
+              <a:tr h="502920">
                 <a:tc>
                   <a:txBody>
                     <a:bodyPr/>
@@ -7218,7 +6983,7 @@
                           <a:ea typeface="Trebuchet MS" pitchFamily="34" charset="-122"/>
                           <a:cs typeface="Trebuchet MS" pitchFamily="34" charset="-120"/>
                         </a:rPr>
-                        <a:t>Budapest, Oct 29 – Nov 2, 2025</a:t>
+                        <a:t>Madrid, Oct 29/30 – Nov 2, 2025</a:t>
                       </a:r>
                       <a:endParaRPr lang="en-US" sz="1300" dirty="0">
                         <a:latin typeface="Trebuchet MS" charset="0"/>
@@ -7280,13 +7045,13 @@
                       <a:r>
                         <a:rPr lang="en-US" sz="1300" b="1" dirty="0">
                           <a:solidFill>
-                            <a:srgbClr val="FFC107"/>
+                            <a:srgbClr val="E6321E"/>
                           </a:solidFill>
                           <a:latin typeface="Trebuchet MS" pitchFamily="34" charset="0"/>
                           <a:ea typeface="Trebuchet MS" pitchFamily="34" charset="-122"/>
                           <a:cs typeface="Trebuchet MS" pitchFamily="34" charset="-120"/>
                         </a:rPr>
-                        <a:t>~€623</a:t>
+                        <a:t>~€712</a:t>
                       </a:r>
                       <a:endParaRPr lang="en-US" sz="1300" dirty="0">
                         <a:latin typeface="Trebuchet MS" charset="0"/>
@@ -7354,7 +7119,7 @@
                           <a:ea typeface="Trebuchet MS" pitchFamily="34" charset="-122"/>
                           <a:cs typeface="Trebuchet MS" pitchFamily="34" charset="-120"/>
                         </a:rPr>
-                        <a:t>~€2,492</a:t>
+                        <a:t>~€2,848</a:t>
                       </a:r>
                       <a:endParaRPr lang="en-US" sz="1300" dirty="0">
                         <a:latin typeface="Trebuchet MS" charset="0"/>
@@ -7418,8 +7183,8 @@
         </p:nvSpPr>
         <p:spPr>
           <a:xfrm>
-            <a:off x="457200" y="6080760"/>
-            <a:ext cx="11247120" cy="502920"/>
+            <a:off x="457200" y="5961888"/>
+            <a:ext cx="11247120" cy="621792"/>
           </a:xfrm>
           <a:prstGeom prst="rect">
             <a:avLst/>
@@ -7429,7 +7194,7 @@
           </a:solidFill>
           <a:ln w="12700">
             <a:solidFill>
-              <a:srgbClr val="FFC107"/>
+              <a:srgbClr val="E6321E"/>
             </a:solidFill>
             <a:prstDash val="solid"/>
           </a:ln>
@@ -7443,8 +7208,8 @@
         </p:nvSpPr>
         <p:spPr>
           <a:xfrm>
-            <a:off x="594360" y="6099048"/>
-            <a:ext cx="10972800" cy="457200"/>
+            <a:off x="594360" y="5980176"/>
+            <a:ext cx="10972800" cy="585216"/>
           </a:xfrm>
           <a:prstGeom prst="rect">
             <a:avLst/>
@@ -7468,7 +7233,7 @@
                 <a:ea typeface="Calibri" pitchFamily="34" charset="-122"/>
                 <a:cs typeface="Calibri" pitchFamily="34" charset="-120"/>
               </a:rPr>
-              <a:t>💡 Budget range: €500–750pp.  Ruin bars = NO cover charge most nights.  Beers from €1.25 (pub) to €4.50 (ruin bar).  Optional Rudas Night Bath (€37) or Akvárium Klub Halloween event (+€15–18) are add-ons.</a:t>
+              <a:t>💡 Budget range: €600–900pp depending on accommodation choice and club nights.  El Tigre bar gives MASSIVE free tapas plates with every €3 beer — take advantage.  Oct 31 is a Friday + Nov 1 is a public holiday = the best possible Halloween combo in Europe.</a:t>
             </a:r>
             <a:endParaRPr lang="en-US" sz="1050" dirty="0"/>
           </a:p>
@@ -7753,7 +7518,7 @@
           </a:solidFill>
           <a:ln w="12700">
             <a:solidFill>
-              <a:srgbClr val="FFC107"/>
+              <a:srgbClr val="E6321E"/>
             </a:solidFill>
             <a:prstDash val="solid"/>
           </a:ln>
@@ -7786,13 +7551,13 @@
             <a:r>
               <a:rPr lang="en-US" sz="2000" b="1" dirty="0">
                 <a:solidFill>
-                  <a:srgbClr val="FFC107"/>
+                  <a:srgbClr val="E6321E"/>
                 </a:solidFill>
                 <a:latin typeface="Trebuchet MS" pitchFamily="34" charset="0"/>
                 <a:ea typeface="Trebuchet MS" pitchFamily="34" charset="-122"/>
                 <a:cs typeface="Trebuchet MS" pitchFamily="34" charset="-120"/>
               </a:rPr>
-              <a:t>🇭🇺  BUDAPEST</a:t>
+              <a:t>🇪🇸  MADRID</a:t>
             </a:r>
             <a:endParaRPr lang="en-US" sz="2000" dirty="0"/>
           </a:p>
@@ -7990,7 +7755,7 @@
                 <a:ea typeface="Calibri" pitchFamily="34" charset="-122"/>
                 <a:cs typeface="Calibri" pitchFamily="34" charset="-120"/>
               </a:rPr>
-              <a:t>~€623</a:t>
+              <a:t>~€712</a:t>
             </a:r>
             <a:endParaRPr lang="en-US" sz="1000" dirty="0"/>
           </a:p>
@@ -8188,7 +7953,7 @@
                 <a:ea typeface="Calibri" pitchFamily="34" charset="-122"/>
                 <a:cs typeface="Calibri" pitchFamily="34" charset="-120"/>
               </a:rPr>
-              <a:t>1h 45m · DTM or DUS</a:t>
+              <a:t>2h 30m · DUS only</a:t>
             </a:r>
             <a:endParaRPr lang="en-US" sz="1000" dirty="0"/>
           </a:p>
@@ -8386,7 +8151,7 @@
                 <a:ea typeface="Calibri" pitchFamily="34" charset="-122"/>
                 <a:cs typeface="Calibri" pitchFamily="34" charset="-120"/>
               </a:rPr>
-              <a:t>DTM + DUS (Wizz + Eurowings)</a:t>
+              <a:t>DUS only (Iberia / Eurowings)</a:t>
             </a:r>
             <a:endParaRPr lang="en-US" sz="1000" dirty="0"/>
           </a:p>
@@ -8584,7 +8349,7 @@
                 <a:ea typeface="Calibri" pitchFamily="34" charset="-122"/>
                 <a:cs typeface="Calibri" pitchFamily="34" charset="-120"/>
               </a:rPr>
-              <a:t>€1.25 – €4.50 per pint</a:t>
+              <a:t>€2 – €4 per caña / tubo</a:t>
             </a:r>
             <a:endParaRPr lang="en-US" sz="1000" dirty="0"/>
           </a:p>
@@ -8782,7 +8547,7 @@
                 <a:ea typeface="Calibri" pitchFamily="34" charset="-122"/>
                 <a:cs typeface="Calibri" pitchFamily="34" charset="-120"/>
               </a:rPr>
-              <a:t>5–12°C 🧥 Jacket needed</a:t>
+              <a:t>18–20°C ☀ Warmer at night</a:t>
             </a:r>
             <a:endParaRPr lang="en-US" sz="1000" dirty="0"/>
           </a:p>
@@ -8914,7 +8679,7 @@
                 <a:ea typeface="Calibri" pitchFamily="34" charset="-122"/>
                 <a:cs typeface="Calibri" pitchFamily="34" charset="-120"/>
               </a:rPr>
-              <a:t>⭐⭐⭐⭐  Pub crawl + big clubs</a:t>
+              <a:t>⭐⭐⭐⭐  Fri pub crawl + clubs</a:t>
             </a:r>
             <a:endParaRPr lang="en-US" sz="1000" dirty="0"/>
           </a:p>
@@ -8980,7 +8745,7 @@
                 <a:ea typeface="Calibri" pitchFamily="34" charset="-122"/>
                 <a:cs typeface="Calibri" pitchFamily="34" charset="-120"/>
               </a:rPr>
-              <a:t>⭐⭐⭐⭐⭐ District VII insanity</a:t>
+              <a:t>⭐⭐⭐⭐⭐ Fri + PUBLIC HOLIDAY</a:t>
             </a:r>
             <a:endParaRPr lang="en-US" sz="1000" dirty="0"/>
           </a:p>
@@ -9178,7 +8943,7 @@
                 <a:ea typeface="Calibri" pitchFamily="34" charset="-122"/>
                 <a:cs typeface="Calibri" pitchFamily="34" charset="-120"/>
               </a:rPr>
-              <a:t>Ruin Bars · Thermal Baths</a:t>
+              <a:t>Malasaña · Tapas · Vermouth</a:t>
             </a:r>
             <a:endParaRPr lang="en-US" sz="1000" dirty="0"/>
           </a:p>
@@ -9376,7 +9141,7 @@
                 <a:ea typeface="Calibri" pitchFamily="34" charset="-122"/>
                 <a:cs typeface="Calibri" pitchFamily="34" charset="-120"/>
               </a:rPr>
-              <a:t>Ruin bars till 6 AM · FREE</a:t>
+              <a:t>Clubs till 6–7 AM · free tapas</a:t>
             </a:r>
             <a:endParaRPr lang="en-US" sz="1000" dirty="0"/>
           </a:p>
@@ -9574,7 +9339,7 @@
                 <a:ea typeface="Calibri" pitchFamily="34" charset="-122"/>
                 <a:cs typeface="Calibri" pitchFamily="34" charset="-120"/>
               </a:rPr>
-              <a:t>Goulash · Lángos · €10–20</a:t>
+              <a:t>Tapas · Pintxos · €15–20/meal</a:t>
             </a:r>
             <a:endParaRPr lang="en-US" sz="1000" dirty="0"/>
           </a:p>
@@ -9772,7 +9537,7 @@
                 <a:ea typeface="Calibri" pitchFamily="34" charset="-122"/>
                 <a:cs typeface="Calibri" pitchFamily="34" charset="-120"/>
               </a:rPr>
-              <a:t>Original BPT Crawl · €19pp</a:t>
+              <a:t>Bar Crawl Madrid · €20pp</a:t>
             </a:r>
             <a:endParaRPr lang="en-US" sz="1000" dirty="0"/>
           </a:p>
@@ -9970,7 +9735,7 @@
                 <a:ea typeface="Calibri" pitchFamily="34" charset="-122"/>
                 <a:cs typeface="Calibri" pitchFamily="34" charset="-120"/>
               </a:rPr>
-              <a:t>Chefparade · €105pp</a:t>
+              <a:t>Cooking Point · €85pp</a:t>
             </a:r>
             <a:endParaRPr lang="en-US" sz="1000" dirty="0"/>
           </a:p>
@@ -10098,7 +9863,7 @@
                 <a:ea typeface="Trebuchet MS" pitchFamily="34" charset="-122"/>
                 <a:cs typeface="Trebuchet MS" pitchFamily="34" charset="-120"/>
               </a:rPr>
-              <a:t>Warm, chic, world-class nightlife</a:t>
+              <a:t>Atlantic charm, Fado, warmer Airbnb</a:t>
             </a:r>
             <a:endParaRPr lang="en-US" sz="1150" dirty="0"/>
           </a:p>
@@ -10123,7 +9888,7 @@
           </a:solidFill>
           <a:ln w="12700">
             <a:solidFill>
-              <a:srgbClr val="FFC107"/>
+              <a:srgbClr val="E6321E"/>
             </a:solidFill>
             <a:prstDash val="solid"/>
           </a:ln>
@@ -10156,13 +9921,13 @@
             <a:r>
               <a:rPr lang="en-US" sz="1150" b="1" dirty="0">
                 <a:solidFill>
-                  <a:srgbClr val="FFC107"/>
+                  <a:srgbClr val="E6321E"/>
                 </a:solidFill>
                 <a:latin typeface="Trebuchet MS" pitchFamily="34" charset="0"/>
                 <a:ea typeface="Trebuchet MS" pitchFamily="34" charset="-122"/>
                 <a:cs typeface="Trebuchet MS" pitchFamily="34" charset="-120"/>
               </a:rPr>
-              <a:t>Cheapest, wildest, most unique</a:t>
+              <a:t>BEST Halloween in Europe 2025</a:t>
             </a:r>
             <a:endParaRPr lang="en-US" sz="1150" dirty="0"/>
           </a:p>
@@ -21758,11 +21523,11 @@
             <a:avLst/>
           </a:prstGeom>
           <a:solidFill>
-            <a:srgbClr val="FFC107"/>
+            <a:srgbClr val="E6321E"/>
           </a:solidFill>
           <a:ln w="12700">
             <a:solidFill>
-              <a:srgbClr val="FFC107"/>
+              <a:srgbClr val="E6321E"/>
             </a:solidFill>
             <a:prstDash val="solid"/>
           </a:ln>
@@ -21826,7 +21591,7 @@
                 <a:ea typeface="Trebuchet MS" pitchFamily="34" charset="-122"/>
                 <a:cs typeface="Trebuchet MS" pitchFamily="34" charset="-120"/>
               </a:rPr>
-              <a:t>🇭🇺  DESTINATION 2 — BUDAPEST, HUNGARY</a:t>
+              <a:t>🇪🇸  DESTINATION 2 — MADRID, SPAIN</a:t>
             </a:r>
             <a:endParaRPr lang="en-US" sz="2200" dirty="0"/>
           </a:p>
@@ -21847,11 +21612,11 @@
             <a:avLst/>
           </a:prstGeom>
           <a:solidFill>
-            <a:srgbClr val="FFC107"/>
+            <a:srgbClr val="E6321E"/>
           </a:solidFill>
           <a:ln w="12700">
             <a:solidFill>
-              <a:srgbClr val="FFC107"/>
+              <a:srgbClr val="E6321E"/>
             </a:solidFill>
             <a:prstDash val="solid"/>
           </a:ln>
@@ -21859,7 +21624,7 @@
       </p:sp>
       <p:pic>
         <p:nvPicPr>
-          <p:cNvPr id="6" name="Image 0" descr="/home/user/Excelhaus/halloween_trip/budapest_hero.png">    </p:cNvPr>
+          <p:cNvPr id="6" name="Image 0" descr="/home/user/Excelhaus/halloween_trip/madrid_hero.png">    </p:cNvPr>
           <p:cNvPicPr>
             <a:picLocks noChangeAspect="1"/>
           </p:cNvPicPr>
@@ -21933,13 +21698,13 @@
             <a:r>
               <a:rPr lang="en-US" sz="1600" b="1" dirty="0">
                 <a:solidFill>
-                  <a:srgbClr val="FFC107"/>
+                  <a:srgbClr val="E6321E"/>
                 </a:solidFill>
                 <a:latin typeface="Trebuchet MS" pitchFamily="34" charset="0"/>
                 <a:ea typeface="Trebuchet MS" pitchFamily="34" charset="-122"/>
                 <a:cs typeface="Trebuchet MS" pitchFamily="34" charset="-120"/>
               </a:rPr>
-              <a:t>Ruin Bar Capital of the World</a:t>
+              <a:t>The City That Never Sleeps — Literally</a:t>
             </a:r>
             <a:endParaRPr lang="en-US" sz="1600" dirty="0"/>
           </a:p>
@@ -21978,7 +21743,7 @@
                 <a:ea typeface="Calibri" pitchFamily="34" charset="-122"/>
                 <a:cs typeface="Calibri" pitchFamily="34" charset="-120"/>
               </a:rPr>
-              <a:t>District VII  ·  Szimpla Kert  ·  Thermal Baths  ·  Parliament at Night</a:t>
+              <a:t>Malasaña  ·  Chueca  ·  Gran Vía  ·  La Latina tapas  ·  Clubs till 7 AM</a:t>
             </a:r>
             <a:endParaRPr lang="en-US" sz="1000" dirty="0"/>
           </a:p>
@@ -22003,7 +21768,7 @@
           </a:solidFill>
           <a:ln w="12700">
             <a:solidFill>
-              <a:srgbClr val="FFC107"/>
+              <a:srgbClr val="E6321E"/>
             </a:solidFill>
             <a:prstDash val="solid"/>
           </a:ln>
@@ -22075,13 +21840,13 @@
             <a:r>
               <a:rPr lang="en-US" sz="1600" b="1" dirty="0">
                 <a:solidFill>
-                  <a:srgbClr val="FFC107"/>
+                  <a:srgbClr val="E6321E"/>
                 </a:solidFill>
                 <a:latin typeface="Trebuchet MS" pitchFamily="34" charset="0"/>
                 <a:ea typeface="Trebuchet MS" pitchFamily="34" charset="-122"/>
                 <a:cs typeface="Trebuchet MS" pitchFamily="34" charset="-120"/>
               </a:rPr>
-              <a:t>1h 45m</a:t>
+              <a:t>2h 30m</a:t>
             </a:r>
             <a:endParaRPr lang="en-US" sz="1600" dirty="0"/>
           </a:p>
@@ -22092,13 +21857,13 @@
             <a:r>
               <a:rPr lang="en-US" sz="1600" b="1" dirty="0">
                 <a:solidFill>
-                  <a:srgbClr val="FFC107"/>
+                  <a:srgbClr val="E6321E"/>
                 </a:solidFill>
                 <a:latin typeface="Trebuchet MS" pitchFamily="34" charset="0"/>
                 <a:ea typeface="Trebuchet MS" pitchFamily="34" charset="-122"/>
                 <a:cs typeface="Trebuchet MS" pitchFamily="34" charset="-120"/>
               </a:rPr>
-              <a:t>from DTM</a:t>
+              <a:t>from DUS</a:t>
             </a:r>
             <a:endParaRPr lang="en-US" sz="1600" dirty="0"/>
           </a:p>
@@ -22123,7 +21888,7 @@
           </a:solidFill>
           <a:ln w="12700">
             <a:solidFill>
-              <a:srgbClr val="FFC107"/>
+              <a:srgbClr val="E6321E"/>
             </a:solidFill>
             <a:prstDash val="solid"/>
           </a:ln>
@@ -22195,13 +21960,13 @@
             <a:r>
               <a:rPr lang="en-US" sz="1600" b="1" dirty="0">
                 <a:solidFill>
-                  <a:srgbClr val="FFC107"/>
+                  <a:srgbClr val="E6321E"/>
                 </a:solidFill>
                 <a:latin typeface="Trebuchet MS" pitchFamily="34" charset="0"/>
                 <a:ea typeface="Trebuchet MS" pitchFamily="34" charset="-122"/>
                 <a:cs typeface="Trebuchet MS" pitchFamily="34" charset="-120"/>
               </a:rPr>
-              <a:t>€1.25–4.50</a:t>
+              <a:t>€2 – €4</a:t>
             </a:r>
             <a:endParaRPr lang="en-US" sz="1600" dirty="0"/>
           </a:p>
@@ -22212,13 +21977,13 @@
             <a:r>
               <a:rPr lang="en-US" sz="1600" b="1" dirty="0">
                 <a:solidFill>
-                  <a:srgbClr val="FFC107"/>
+                  <a:srgbClr val="E6321E"/>
                 </a:solidFill>
                 <a:latin typeface="Trebuchet MS" pitchFamily="34" charset="0"/>
                 <a:ea typeface="Trebuchet MS" pitchFamily="34" charset="-122"/>
                 <a:cs typeface="Trebuchet MS" pitchFamily="34" charset="-120"/>
               </a:rPr>
-              <a:t>avg per pint</a:t>
+              <a:t>caña or tubo</a:t>
             </a:r>
             <a:endParaRPr lang="en-US" sz="1600" dirty="0"/>
           </a:p>
@@ -22243,7 +22008,7 @@
           </a:solidFill>
           <a:ln w="12700">
             <a:solidFill>
-              <a:srgbClr val="FFC107"/>
+              <a:srgbClr val="E6321E"/>
             </a:solidFill>
             <a:prstDash val="solid"/>
           </a:ln>
@@ -22315,13 +22080,13 @@
             <a:r>
               <a:rPr lang="en-US" sz="1600" b="1" dirty="0">
                 <a:solidFill>
-                  <a:srgbClr val="FFC107"/>
+                  <a:srgbClr val="E6321E"/>
                 </a:solidFill>
                 <a:latin typeface="Trebuchet MS" pitchFamily="34" charset="0"/>
                 <a:ea typeface="Trebuchet MS" pitchFamily="34" charset="-122"/>
                 <a:cs typeface="Trebuchet MS" pitchFamily="34" charset="-120"/>
               </a:rPr>
-              <a:t>5–12°C</a:t>
+              <a:t>18–20°C ☀</a:t>
             </a:r>
             <a:endParaRPr lang="en-US" sz="1600" dirty="0"/>
           </a:p>
@@ -22332,7 +22097,7 @@
             <a:r>
               <a:rPr lang="en-US" sz="1600" b="1" dirty="0">
                 <a:solidFill>
-                  <a:srgbClr val="FFC107"/>
+                  <a:srgbClr val="E6321E"/>
                 </a:solidFill>
                 <a:latin typeface="Trebuchet MS" pitchFamily="34" charset="0"/>
                 <a:ea typeface="Trebuchet MS" pitchFamily="34" charset="-122"/>
@@ -22363,7 +22128,7 @@
           </a:solidFill>
           <a:ln w="12700">
             <a:solidFill>
-              <a:srgbClr val="FFC107"/>
+              <a:srgbClr val="E6321E"/>
             </a:solidFill>
             <a:prstDash val="solid"/>
           </a:ln>
@@ -22435,13 +22200,13 @@
             <a:r>
               <a:rPr lang="en-US" sz="1600" b="1" dirty="0">
                 <a:solidFill>
-                  <a:srgbClr val="FFC107"/>
+                  <a:srgbClr val="E6321E"/>
                 </a:solidFill>
                 <a:latin typeface="Trebuchet MS" pitchFamily="34" charset="0"/>
                 <a:ea typeface="Trebuchet MS" pitchFamily="34" charset="-122"/>
                 <a:cs typeface="Trebuchet MS" pitchFamily="34" charset="-120"/>
               </a:rPr>
-              <a:t>~€550</a:t>
+              <a:t>~€712</a:t>
             </a:r>
             <a:endParaRPr lang="en-US" sz="1600" dirty="0"/>
           </a:p>
@@ -22452,7 +22217,7 @@
             <a:r>
               <a:rPr lang="en-US" sz="1600" b="1" dirty="0">
                 <a:solidFill>
-                  <a:srgbClr val="FFC107"/>
+                  <a:srgbClr val="E6321E"/>
                 </a:solidFill>
                 <a:latin typeface="Trebuchet MS" pitchFamily="34" charset="0"/>
                 <a:ea typeface="Trebuchet MS" pitchFamily="34" charset="-122"/>
@@ -22483,7 +22248,7 @@
           </a:solidFill>
           <a:ln w="12700">
             <a:solidFill>
-              <a:srgbClr val="FFC107"/>
+              <a:srgbClr val="E6321E"/>
             </a:solidFill>
             <a:prstDash val="solid"/>
           </a:ln>
@@ -22555,7 +22320,7 @@
             <a:r>
               <a:rPr lang="en-US" sz="1600" b="1" dirty="0">
                 <a:solidFill>
-                  <a:srgbClr val="FFC107"/>
+                  <a:srgbClr val="E6321E"/>
                 </a:solidFill>
                 <a:latin typeface="Trebuchet MS" pitchFamily="34" charset="0"/>
                 <a:ea typeface="Trebuchet MS" pitchFamily="34" charset="-122"/>
@@ -22572,13 +22337,13 @@
             <a:r>
               <a:rPr lang="en-US" sz="1600" b="1" dirty="0">
                 <a:solidFill>
-                  <a:srgbClr val="FFC107"/>
+                  <a:srgbClr val="E6321E"/>
                 </a:solidFill>
                 <a:latin typeface="Trebuchet MS" pitchFamily="34" charset="0"/>
                 <a:ea typeface="Trebuchet MS" pitchFamily="34" charset="-122"/>
                 <a:cs typeface="Trebuchet MS" pitchFamily="34" charset="-120"/>
               </a:rPr>
-              <a:t>Ruin Bar Gold</a:t>
+              <a:t>Clubs till 7 AM</a:t>
             </a:r>
             <a:endParaRPr lang="en-US" sz="1600" dirty="0"/>
           </a:p>
@@ -22603,7 +22368,7 @@
           </a:solidFill>
           <a:ln w="12700">
             <a:solidFill>
-              <a:srgbClr val="FFC107"/>
+              <a:srgbClr val="E6321E"/>
             </a:solidFill>
             <a:prstDash val="solid"/>
           </a:ln>
@@ -22675,13 +22440,13 @@
             <a:r>
               <a:rPr lang="en-US" sz="1600" b="1" dirty="0">
                 <a:solidFill>
-                  <a:srgbClr val="FFC107"/>
+                  <a:srgbClr val="E6321E"/>
                 </a:solidFill>
                 <a:latin typeface="Trebuchet MS" pitchFamily="34" charset="0"/>
                 <a:ea typeface="Trebuchet MS" pitchFamily="34" charset="-122"/>
                 <a:cs typeface="Trebuchet MS" pitchFamily="34" charset="-120"/>
               </a:rPr>
-              <a:t>DTM or DUS</a:t>
+              <a:t>DUS only</a:t>
             </a:r>
             <a:endParaRPr lang="en-US" sz="1600" dirty="0"/>
           </a:p>
@@ -22692,13 +22457,13 @@
             <a:r>
               <a:rPr lang="en-US" sz="1600" b="1" dirty="0">
                 <a:solidFill>
-                  <a:srgbClr val="FFC107"/>
+                  <a:srgbClr val="E6321E"/>
                 </a:solidFill>
                 <a:latin typeface="Trebuchet MS" pitchFamily="34" charset="0"/>
                 <a:ea typeface="Trebuchet MS" pitchFamily="34" charset="-122"/>
                 <a:cs typeface="Trebuchet MS" pitchFamily="34" charset="-120"/>
               </a:rPr>
-              <a:t>(Wizz/Eurowings)</a:t>
+              <a:t>(Iberia/Eurowings)</a:t>
             </a:r>
             <a:endParaRPr lang="en-US" sz="1600" dirty="0"/>
           </a:p>
@@ -22762,7 +22527,7 @@
                 <a:ea typeface="Calibri" pitchFamily="34" charset="-122"/>
                 <a:cs typeface="Calibri" pitchFamily="34" charset="-120"/>
               </a:rPr>
-              <a:t>Budapest is Europe's undisputed ruin bar capital — abandoned courtyards turned into labyrinthine multi-room bars open till 6 AM. At Halloween, District VII goes completely wild with costumes, themed events at every venue, and zero cover charges. The city is 30–40% cheaper than Lisbon. Thermal baths the morning after? Genuinely spectacular.</a:t>
+              <a:t>Madrid is the warmest Halloween in Europe. Oct 31 is a Friday AND Nov 1 is a Spanish public holiday — meaning absolutely everyone is out and clubs stay open until 7 AM. Malasaña's bohemian bar scene, free tapas at El Tigre, vermouth on tap at 150-year-old bodegas, and Teatro Kapital's 7-floor nightclub. T-shirt weather guaranteed.</a:t>
             </a:r>
             <a:endParaRPr lang="en-US" sz="1050" dirty="0"/>
           </a:p>
@@ -22840,11 +22605,11 @@
             <a:avLst/>
           </a:prstGeom>
           <a:solidFill>
-            <a:srgbClr val="FFC107"/>
+            <a:srgbClr val="E6321E"/>
           </a:solidFill>
           <a:ln w="12700">
             <a:solidFill>
-              <a:srgbClr val="FFC107"/>
+              <a:srgbClr val="E6321E"/>
             </a:solidFill>
             <a:prstDash val="solid"/>
           </a:ln>
@@ -22908,7 +22673,7 @@
                 <a:ea typeface="Trebuchet MS" pitchFamily="34" charset="-122"/>
                 <a:cs typeface="Trebuchet MS" pitchFamily="34" charset="-120"/>
               </a:rPr>
-              <a:t>🇭🇺  BUDAPEST — FLIGHTS</a:t>
+              <a:t>🇪🇸  MADRID — FLIGHTS</a:t>
             </a:r>
             <a:endParaRPr lang="en-US" sz="2200" dirty="0"/>
           </a:p>
@@ -22929,11 +22694,11 @@
             <a:avLst/>
           </a:prstGeom>
           <a:solidFill>
-            <a:srgbClr val="FFC107"/>
+            <a:srgbClr val="E6321E"/>
           </a:solidFill>
           <a:ln w="12700">
             <a:solidFill>
-              <a:srgbClr val="FFC107"/>
+              <a:srgbClr val="E6321E"/>
             </a:solidFill>
             <a:prstDash val="solid"/>
           </a:ln>
@@ -22966,13 +22731,13 @@
             <a:r>
               <a:rPr lang="en-US" sz="1300" b="1" dirty="0">
                 <a:solidFill>
-                  <a:srgbClr val="FFC107"/>
+                  <a:srgbClr val="E6321E"/>
                 </a:solidFill>
                 <a:latin typeface="Trebuchet MS" pitchFamily="34" charset="0"/>
                 <a:ea typeface="Trebuchet MS" pitchFamily="34" charset="-122"/>
                 <a:cs typeface="Trebuchet MS" pitchFamily="34" charset="-120"/>
               </a:rPr>
-              <a:t>OUTBOUND: Germany → Budapest (BUD)</a:t>
+              <a:t>OUTBOUND: Germany → Madrid (MAD / Barajas)</a:t>
             </a:r>
             <a:endParaRPr lang="en-US" sz="1300" dirty="0"/>
           </a:p>
@@ -23022,7 +22787,7 @@
                       <a:r>
                         <a:rPr lang="en-US" sz="1100" b="1" dirty="0">
                           <a:solidFill>
-                            <a:srgbClr val="FFC107"/>
+                            <a:srgbClr val="E6321E"/>
                           </a:solidFill>
                           <a:latin typeface="Trebuchet MS" pitchFamily="34" charset="0"/>
                           <a:ea typeface="Trebuchet MS" pitchFamily="34" charset="-122"/>
@@ -23090,13 +22855,13 @@
                       <a:r>
                         <a:rPr lang="en-US" sz="1100" b="1" dirty="0">
                           <a:solidFill>
-                            <a:srgbClr val="FFC107"/>
+                            <a:srgbClr val="E6321E"/>
                           </a:solidFill>
                           <a:latin typeface="Trebuchet MS" pitchFamily="34" charset="0"/>
                           <a:ea typeface="Trebuchet MS" pitchFamily="34" charset="-122"/>
                           <a:cs typeface="Trebuchet MS" pitchFamily="34" charset="-120"/>
                         </a:rPr>
-                        <a:t>Flight</a:t>
+                        <a:t>Airline</a:t>
                       </a:r>
                       <a:endParaRPr lang="en-US" sz="1100" dirty="0">
                         <a:latin typeface="Trebuchet MS" charset="0"/>
@@ -23158,7 +22923,7 @@
                       <a:r>
                         <a:rPr lang="en-US" sz="1100" b="1" dirty="0">
                           <a:solidFill>
-                            <a:srgbClr val="FFC107"/>
+                            <a:srgbClr val="E6321E"/>
                           </a:solidFill>
                           <a:latin typeface="Trebuchet MS" pitchFamily="34" charset="0"/>
                           <a:ea typeface="Trebuchet MS" pitchFamily="34" charset="-122"/>
@@ -23226,7 +22991,7 @@
                       <a:r>
                         <a:rPr lang="en-US" sz="1100" b="1" dirty="0">
                           <a:solidFill>
-                            <a:srgbClr val="FFC107"/>
+                            <a:srgbClr val="E6321E"/>
                           </a:solidFill>
                           <a:latin typeface="Trebuchet MS" pitchFamily="34" charset="0"/>
                           <a:ea typeface="Trebuchet MS" pitchFamily="34" charset="-122"/>
@@ -23294,7 +23059,7 @@
                       <a:r>
                         <a:rPr lang="en-US" sz="1100" b="1" dirty="0">
                           <a:solidFill>
-                            <a:srgbClr val="FFC107"/>
+                            <a:srgbClr val="E6321E"/>
                           </a:solidFill>
                           <a:latin typeface="Trebuchet MS" pitchFamily="34" charset="0"/>
                           <a:ea typeface="Trebuchet MS" pitchFamily="34" charset="-122"/>
@@ -23362,7 +23127,7 @@
                       <a:r>
                         <a:rPr lang="en-US" sz="1100" b="1" dirty="0">
                           <a:solidFill>
-                            <a:srgbClr val="FFC107"/>
+                            <a:srgbClr val="E6321E"/>
                           </a:solidFill>
                           <a:latin typeface="Trebuchet MS" pitchFamily="34" charset="0"/>
                           <a:ea typeface="Trebuchet MS" pitchFamily="34" charset="-122"/>
@@ -23430,7 +23195,7 @@
                       <a:r>
                         <a:rPr lang="en-US" sz="1100" b="1" dirty="0">
                           <a:solidFill>
-                            <a:srgbClr val="FFC107"/>
+                            <a:srgbClr val="E6321E"/>
                           </a:solidFill>
                           <a:latin typeface="Trebuchet MS" pitchFamily="34" charset="0"/>
                           <a:ea typeface="Trebuchet MS" pitchFamily="34" charset="-122"/>
@@ -23663,7 +23428,7 @@
                           <a:ea typeface="Calibri" pitchFamily="34" charset="-122"/>
                           <a:cs typeface="Calibri" pitchFamily="34" charset="-120"/>
                         </a:rPr>
-                        <a:t>W62292</a:t>
+                        <a:t>Iberia</a:t>
                       </a:r>
                       <a:endParaRPr lang="en-US" sz="1000" dirty="0">
                         <a:latin typeface="Calibri" charset="0"/>
@@ -23684,7 +23449,7 @@
                           <a:ea typeface="Calibri" pitchFamily="34" charset="-122"/>
                           <a:cs typeface="Calibri" pitchFamily="34" charset="-120"/>
                         </a:rPr>
-                        <a:t>Wizz Air</a:t>
+                        <a:t>(IB3166)</a:t>
                       </a:r>
                       <a:endParaRPr lang="en-US" sz="1000" dirty="0">
                         <a:latin typeface="Calibri" charset="0"/>
@@ -23752,7 +23517,7 @@
                           <a:ea typeface="Calibri" pitchFamily="34" charset="-122"/>
                           <a:cs typeface="Calibri" pitchFamily="34" charset="-120"/>
                         </a:rPr>
-                        <a:t>DTM → BUD</a:t>
+                        <a:t>DUS → MAD</a:t>
                       </a:r>
                       <a:endParaRPr lang="en-US" sz="1000" dirty="0">
                         <a:latin typeface="Calibri" charset="0"/>
@@ -23841,7 +23606,7 @@
                           <a:ea typeface="Calibri" pitchFamily="34" charset="-122"/>
                           <a:cs typeface="Calibri" pitchFamily="34" charset="-120"/>
                         </a:rPr>
-                        <a:t>16:10</a:t>
+                        <a:t>~19:55</a:t>
                       </a:r>
                       <a:endParaRPr lang="en-US" sz="1000" dirty="0">
                         <a:latin typeface="Calibri" charset="0"/>
@@ -23909,7 +23674,7 @@
                           <a:ea typeface="Calibri" pitchFamily="34" charset="-122"/>
                           <a:cs typeface="Calibri" pitchFamily="34" charset="-120"/>
                         </a:rPr>
-                        <a:t>17:55</a:t>
+                        <a:t>~22:35</a:t>
                       </a:r>
                       <a:endParaRPr lang="en-US" sz="1000" dirty="0">
                         <a:latin typeface="Calibri" charset="0"/>
@@ -23977,7 +23742,7 @@
                           <a:ea typeface="Calibri" pitchFamily="34" charset="-122"/>
                           <a:cs typeface="Calibri" pitchFamily="34" charset="-120"/>
                         </a:rPr>
-                        <a:t>1h 45m</a:t>
+                        <a:t>2h 30m</a:t>
                       </a:r>
                       <a:endParaRPr lang="en-US" sz="1000" dirty="0">
                         <a:latin typeface="Calibri" charset="0"/>
@@ -24025,6 +23790,594 @@
                     </a:lnB>
                     <a:solidFill>
                       <a:srgbClr val="16213E"/>
+                    </a:solidFill>
+                  </a:tcPr>
+                </a:tc>
+                <a:tc>
+                  <a:txBody>
+                    <a:bodyPr/>
+                    <a:lstStyle/>
+                    <a:p>
+                      <a:pPr algn="ctr" indent="0" marL="0">
+                        <a:buNone/>
+                      </a:pPr>
+                      <a:r>
+                        <a:rPr lang="en-US" sz="1000" dirty="0">
+                          <a:solidFill>
+                            <a:srgbClr val="E8E8E8"/>
+                          </a:solidFill>
+                          <a:latin typeface="Calibri" pitchFamily="34" charset="0"/>
+                          <a:ea typeface="Calibri" pitchFamily="34" charset="-122"/>
+                          <a:cs typeface="Calibri" pitchFamily="34" charset="-120"/>
+                        </a:rPr>
+                        <a:t>~€95</a:t>
+                      </a:r>
+                      <a:endParaRPr lang="en-US" sz="1000" dirty="0">
+                        <a:latin typeface="Calibri" charset="0"/>
+                        <a:ea typeface="Calibri" charset="0"/>
+                        <a:cs typeface="Calibri" charset="0"/>
+                      </a:endParaRPr>
+                    </a:p>
+                  </a:txBody>
+                  <a:tcPr marL="91440" marR="91440" marT="45720" marB="45720">
+                    <a:lnL w="12700" cap="flat" cmpd="sng" algn="ctr">
+                      <a:solidFill>
+                        <a:srgbClr val="0F3460"/>
+                      </a:solidFill>
+                      <a:prstDash val="solid"/>
+                      <a:round/>
+                      <a:headEnd type="none" w="med" len="med"/>
+                      <a:tailEnd type="none" w="med" len="med"/>
+                    </a:lnL>
+                    <a:lnR w="12700" cap="flat" cmpd="sng" algn="ctr">
+                      <a:solidFill>
+                        <a:srgbClr val="0F3460"/>
+                      </a:solidFill>
+                      <a:prstDash val="solid"/>
+                      <a:round/>
+                      <a:headEnd type="none" w="med" len="med"/>
+                      <a:tailEnd type="none" w="med" len="med"/>
+                    </a:lnR>
+                    <a:lnT w="12700" cap="flat" cmpd="sng" algn="ctr">
+                      <a:solidFill>
+                        <a:srgbClr val="0F3460"/>
+                      </a:solidFill>
+                      <a:prstDash val="solid"/>
+                      <a:round/>
+                      <a:headEnd type="none" w="med" len="med"/>
+                      <a:tailEnd type="none" w="med" len="med"/>
+                    </a:lnT>
+                    <a:lnB w="12700" cap="flat" cmpd="sng" algn="ctr">
+                      <a:solidFill>
+                        <a:srgbClr val="0F3460"/>
+                      </a:solidFill>
+                      <a:prstDash val="solid"/>
+                      <a:round/>
+                      <a:headEnd type="none" w="med" len="med"/>
+                      <a:tailEnd type="none" w="med" len="med"/>
+                    </a:lnB>
+                    <a:solidFill>
+                      <a:srgbClr val="16213E"/>
+                    </a:solidFill>
+                  </a:tcPr>
+                </a:tc>
+                <a:tc>
+                  <a:txBody>
+                    <a:bodyPr/>
+                    <a:lstStyle/>
+                    <a:p>
+                      <a:pPr algn="ctr" indent="0" marL="0">
+                        <a:buNone/>
+                      </a:pPr>
+                      <a:r>
+                        <a:rPr lang="en-US" sz="1000" b="1" dirty="0">
+                          <a:solidFill>
+                            <a:srgbClr val="FF8C00"/>
+                          </a:solidFill>
+                          <a:latin typeface="Calibri" pitchFamily="34" charset="0"/>
+                          <a:ea typeface="Calibri" pitchFamily="34" charset="-122"/>
+                          <a:cs typeface="Calibri" pitchFamily="34" charset="-120"/>
+                        </a:rPr>
+                        <a:t>~€380</a:t>
+                      </a:r>
+                      <a:endParaRPr lang="en-US" sz="1000" dirty="0">
+                        <a:latin typeface="Calibri" charset="0"/>
+                        <a:ea typeface="Calibri" charset="0"/>
+                        <a:cs typeface="Calibri" charset="0"/>
+                      </a:endParaRPr>
+                    </a:p>
+                  </a:txBody>
+                  <a:tcPr marL="91440" marR="91440" marT="45720" marB="45720">
+                    <a:lnL w="12700" cap="flat" cmpd="sng" algn="ctr">
+                      <a:solidFill>
+                        <a:srgbClr val="0F3460"/>
+                      </a:solidFill>
+                      <a:prstDash val="solid"/>
+                      <a:round/>
+                      <a:headEnd type="none" w="med" len="med"/>
+                      <a:tailEnd type="none" w="med" len="med"/>
+                    </a:lnL>
+                    <a:lnR w="12700" cap="flat" cmpd="sng" algn="ctr">
+                      <a:solidFill>
+                        <a:srgbClr val="0F3460"/>
+                      </a:solidFill>
+                      <a:prstDash val="solid"/>
+                      <a:round/>
+                      <a:headEnd type="none" w="med" len="med"/>
+                      <a:tailEnd type="none" w="med" len="med"/>
+                    </a:lnR>
+                    <a:lnT w="12700" cap="flat" cmpd="sng" algn="ctr">
+                      <a:solidFill>
+                        <a:srgbClr val="0F3460"/>
+                      </a:solidFill>
+                      <a:prstDash val="solid"/>
+                      <a:round/>
+                      <a:headEnd type="none" w="med" len="med"/>
+                      <a:tailEnd type="none" w="med" len="med"/>
+                    </a:lnT>
+                    <a:lnB w="12700" cap="flat" cmpd="sng" algn="ctr">
+                      <a:solidFill>
+                        <a:srgbClr val="0F3460"/>
+                      </a:solidFill>
+                      <a:prstDash val="solid"/>
+                      <a:round/>
+                      <a:headEnd type="none" w="med" len="med"/>
+                      <a:tailEnd type="none" w="med" len="med"/>
+                    </a:lnB>
+                    <a:solidFill>
+                      <a:srgbClr val="16213E"/>
+                    </a:solidFill>
+                  </a:tcPr>
+                </a:tc>
+              </a:tr>
+              <a:tr h="475488">
+                <a:tc>
+                  <a:txBody>
+                    <a:bodyPr/>
+                    <a:lstStyle/>
+                    <a:p>
+                      <a:pPr algn="ctr" indent="0" marL="0">
+                        <a:buNone/>
+                      </a:pPr>
+                      <a:r>
+                        <a:rPr lang="en-US" sz="1000" dirty="0">
+                          <a:solidFill>
+                            <a:srgbClr val="E8E8E8"/>
+                          </a:solidFill>
+                          <a:latin typeface="Calibri" pitchFamily="34" charset="0"/>
+                          <a:ea typeface="Calibri" pitchFamily="34" charset="-122"/>
+                          <a:cs typeface="Calibri" pitchFamily="34" charset="-120"/>
+                        </a:rPr>
+                        <a:t>Early Oct 30</a:t>
+                      </a:r>
+                      <a:endParaRPr lang="en-US" sz="1000" dirty="0">
+                        <a:latin typeface="Calibri" charset="0"/>
+                        <a:ea typeface="Calibri" charset="0"/>
+                        <a:cs typeface="Calibri" charset="0"/>
+                      </a:endParaRPr>
+                    </a:p>
+                  </a:txBody>
+                  <a:tcPr marL="91440" marR="91440" marT="45720" marB="45720">
+                    <a:lnL w="12700" cap="flat" cmpd="sng" algn="ctr">
+                      <a:solidFill>
+                        <a:srgbClr val="0F3460"/>
+                      </a:solidFill>
+                      <a:prstDash val="solid"/>
+                      <a:round/>
+                      <a:headEnd type="none" w="med" len="med"/>
+                      <a:tailEnd type="none" w="med" len="med"/>
+                    </a:lnL>
+                    <a:lnR w="12700" cap="flat" cmpd="sng" algn="ctr">
+                      <a:solidFill>
+                        <a:srgbClr val="0F3460"/>
+                      </a:solidFill>
+                      <a:prstDash val="solid"/>
+                      <a:round/>
+                      <a:headEnd type="none" w="med" len="med"/>
+                      <a:tailEnd type="none" w="med" len="med"/>
+                    </a:lnR>
+                    <a:lnT w="12700" cap="flat" cmpd="sng" algn="ctr">
+                      <a:solidFill>
+                        <a:srgbClr val="0F3460"/>
+                      </a:solidFill>
+                      <a:prstDash val="solid"/>
+                      <a:round/>
+                      <a:headEnd type="none" w="med" len="med"/>
+                      <a:tailEnd type="none" w="med" len="med"/>
+                    </a:lnT>
+                    <a:lnB w="12700" cap="flat" cmpd="sng" algn="ctr">
+                      <a:solidFill>
+                        <a:srgbClr val="0F3460"/>
+                      </a:solidFill>
+                      <a:prstDash val="solid"/>
+                      <a:round/>
+                      <a:headEnd type="none" w="med" len="med"/>
+                      <a:tailEnd type="none" w="med" len="med"/>
+                    </a:lnB>
+                    <a:solidFill>
+                      <a:srgbClr val="1A1A2E"/>
+                    </a:solidFill>
+                  </a:tcPr>
+                </a:tc>
+                <a:tc>
+                  <a:txBody>
+                    <a:bodyPr/>
+                    <a:lstStyle/>
+                    <a:p>
+                      <a:pPr algn="ctr" indent="0" marL="0">
+                        <a:buNone/>
+                      </a:pPr>
+                      <a:r>
+                        <a:rPr lang="en-US" sz="1000" dirty="0">
+                          <a:solidFill>
+                            <a:srgbClr val="E8E8E8"/>
+                          </a:solidFill>
+                          <a:latin typeface="Calibri" pitchFamily="34" charset="0"/>
+                          <a:ea typeface="Calibri" pitchFamily="34" charset="-122"/>
+                          <a:cs typeface="Calibri" pitchFamily="34" charset="-120"/>
+                        </a:rPr>
+                        <a:t>Iberia</a:t>
+                      </a:r>
+                      <a:endParaRPr lang="en-US" sz="1000" dirty="0">
+                        <a:latin typeface="Calibri" charset="0"/>
+                        <a:ea typeface="Calibri" charset="0"/>
+                        <a:cs typeface="Calibri" charset="0"/>
+                      </a:endParaRPr>
+                    </a:p>
+                    <a:p>
+                      <a:pPr algn="ctr" indent="0" marL="0">
+                        <a:buNone/>
+                      </a:pPr>
+                      <a:r>
+                        <a:rPr lang="en-US" sz="1000" dirty="0">
+                          <a:solidFill>
+                            <a:srgbClr val="E8E8E8"/>
+                          </a:solidFill>
+                          <a:latin typeface="Calibri" pitchFamily="34" charset="0"/>
+                          <a:ea typeface="Calibri" pitchFamily="34" charset="-122"/>
+                          <a:cs typeface="Calibri" pitchFamily="34" charset="-120"/>
+                        </a:rPr>
+                        <a:t>(IB3162)</a:t>
+                      </a:r>
+                      <a:endParaRPr lang="en-US" sz="1000" dirty="0">
+                        <a:latin typeface="Calibri" charset="0"/>
+                        <a:ea typeface="Calibri" charset="0"/>
+                        <a:cs typeface="Calibri" charset="0"/>
+                      </a:endParaRPr>
+                    </a:p>
+                  </a:txBody>
+                  <a:tcPr marL="91440" marR="91440" marT="45720" marB="45720">
+                    <a:lnL w="12700" cap="flat" cmpd="sng" algn="ctr">
+                      <a:solidFill>
+                        <a:srgbClr val="0F3460"/>
+                      </a:solidFill>
+                      <a:prstDash val="solid"/>
+                      <a:round/>
+                      <a:headEnd type="none" w="med" len="med"/>
+                      <a:tailEnd type="none" w="med" len="med"/>
+                    </a:lnL>
+                    <a:lnR w="12700" cap="flat" cmpd="sng" algn="ctr">
+                      <a:solidFill>
+                        <a:srgbClr val="0F3460"/>
+                      </a:solidFill>
+                      <a:prstDash val="solid"/>
+                      <a:round/>
+                      <a:headEnd type="none" w="med" len="med"/>
+                      <a:tailEnd type="none" w="med" len="med"/>
+                    </a:lnR>
+                    <a:lnT w="12700" cap="flat" cmpd="sng" algn="ctr">
+                      <a:solidFill>
+                        <a:srgbClr val="0F3460"/>
+                      </a:solidFill>
+                      <a:prstDash val="solid"/>
+                      <a:round/>
+                      <a:headEnd type="none" w="med" len="med"/>
+                      <a:tailEnd type="none" w="med" len="med"/>
+                    </a:lnT>
+                    <a:lnB w="12700" cap="flat" cmpd="sng" algn="ctr">
+                      <a:solidFill>
+                        <a:srgbClr val="0F3460"/>
+                      </a:solidFill>
+                      <a:prstDash val="solid"/>
+                      <a:round/>
+                      <a:headEnd type="none" w="med" len="med"/>
+                      <a:tailEnd type="none" w="med" len="med"/>
+                    </a:lnB>
+                    <a:solidFill>
+                      <a:srgbClr val="1A1A2E"/>
+                    </a:solidFill>
+                  </a:tcPr>
+                </a:tc>
+                <a:tc>
+                  <a:txBody>
+                    <a:bodyPr/>
+                    <a:lstStyle/>
+                    <a:p>
+                      <a:pPr algn="ctr" indent="0" marL="0">
+                        <a:buNone/>
+                      </a:pPr>
+                      <a:r>
+                        <a:rPr lang="en-US" sz="1000" dirty="0">
+                          <a:solidFill>
+                            <a:srgbClr val="E8E8E8"/>
+                          </a:solidFill>
+                          <a:latin typeface="Calibri" pitchFamily="34" charset="0"/>
+                          <a:ea typeface="Calibri" pitchFamily="34" charset="-122"/>
+                          <a:cs typeface="Calibri" pitchFamily="34" charset="-120"/>
+                        </a:rPr>
+                        <a:t>DUS → MAD</a:t>
+                      </a:r>
+                      <a:endParaRPr lang="en-US" sz="1000" dirty="0">
+                        <a:latin typeface="Calibri" charset="0"/>
+                        <a:ea typeface="Calibri" charset="0"/>
+                        <a:cs typeface="Calibri" charset="0"/>
+                      </a:endParaRPr>
+                    </a:p>
+                    <a:p>
+                      <a:pPr algn="ctr" indent="0" marL="0">
+                        <a:buNone/>
+                      </a:pPr>
+                      <a:r>
+                        <a:rPr lang="en-US" sz="1000" dirty="0">
+                          <a:solidFill>
+                            <a:srgbClr val="E8E8E8"/>
+                          </a:solidFill>
+                          <a:latin typeface="Calibri" pitchFamily="34" charset="0"/>
+                          <a:ea typeface="Calibri" pitchFamily="34" charset="-122"/>
+                          <a:cs typeface="Calibri" pitchFamily="34" charset="-120"/>
+                        </a:rPr>
+                        <a:t>Oct 30 morning</a:t>
+                      </a:r>
+                      <a:endParaRPr lang="en-US" sz="1000" dirty="0">
+                        <a:latin typeface="Calibri" charset="0"/>
+                        <a:ea typeface="Calibri" charset="0"/>
+                        <a:cs typeface="Calibri" charset="0"/>
+                      </a:endParaRPr>
+                    </a:p>
+                  </a:txBody>
+                  <a:tcPr marL="91440" marR="91440" marT="45720" marB="45720">
+                    <a:lnL w="12700" cap="flat" cmpd="sng" algn="ctr">
+                      <a:solidFill>
+                        <a:srgbClr val="0F3460"/>
+                      </a:solidFill>
+                      <a:prstDash val="solid"/>
+                      <a:round/>
+                      <a:headEnd type="none" w="med" len="med"/>
+                      <a:tailEnd type="none" w="med" len="med"/>
+                    </a:lnL>
+                    <a:lnR w="12700" cap="flat" cmpd="sng" algn="ctr">
+                      <a:solidFill>
+                        <a:srgbClr val="0F3460"/>
+                      </a:solidFill>
+                      <a:prstDash val="solid"/>
+                      <a:round/>
+                      <a:headEnd type="none" w="med" len="med"/>
+                      <a:tailEnd type="none" w="med" len="med"/>
+                    </a:lnR>
+                    <a:lnT w="12700" cap="flat" cmpd="sng" algn="ctr">
+                      <a:solidFill>
+                        <a:srgbClr val="0F3460"/>
+                      </a:solidFill>
+                      <a:prstDash val="solid"/>
+                      <a:round/>
+                      <a:headEnd type="none" w="med" len="med"/>
+                      <a:tailEnd type="none" w="med" len="med"/>
+                    </a:lnT>
+                    <a:lnB w="12700" cap="flat" cmpd="sng" algn="ctr">
+                      <a:solidFill>
+                        <a:srgbClr val="0F3460"/>
+                      </a:solidFill>
+                      <a:prstDash val="solid"/>
+                      <a:round/>
+                      <a:headEnd type="none" w="med" len="med"/>
+                      <a:tailEnd type="none" w="med" len="med"/>
+                    </a:lnB>
+                    <a:solidFill>
+                      <a:srgbClr val="1A1A2E"/>
+                    </a:solidFill>
+                  </a:tcPr>
+                </a:tc>
+                <a:tc>
+                  <a:txBody>
+                    <a:bodyPr/>
+                    <a:lstStyle/>
+                    <a:p>
+                      <a:pPr algn="ctr" indent="0" marL="0">
+                        <a:buNone/>
+                      </a:pPr>
+                      <a:r>
+                        <a:rPr lang="en-US" sz="1000" dirty="0">
+                          <a:solidFill>
+                            <a:srgbClr val="E8E8E8"/>
+                          </a:solidFill>
+                          <a:latin typeface="Calibri" pitchFamily="34" charset="0"/>
+                          <a:ea typeface="Calibri" pitchFamily="34" charset="-122"/>
+                          <a:cs typeface="Calibri" pitchFamily="34" charset="-120"/>
+                        </a:rPr>
+                        <a:t>~06:20</a:t>
+                      </a:r>
+                      <a:endParaRPr lang="en-US" sz="1000" dirty="0">
+                        <a:latin typeface="Calibri" charset="0"/>
+                        <a:ea typeface="Calibri" charset="0"/>
+                        <a:cs typeface="Calibri" charset="0"/>
+                      </a:endParaRPr>
+                    </a:p>
+                  </a:txBody>
+                  <a:tcPr marL="91440" marR="91440" marT="45720" marB="45720">
+                    <a:lnL w="12700" cap="flat" cmpd="sng" algn="ctr">
+                      <a:solidFill>
+                        <a:srgbClr val="0F3460"/>
+                      </a:solidFill>
+                      <a:prstDash val="solid"/>
+                      <a:round/>
+                      <a:headEnd type="none" w="med" len="med"/>
+                      <a:tailEnd type="none" w="med" len="med"/>
+                    </a:lnL>
+                    <a:lnR w="12700" cap="flat" cmpd="sng" algn="ctr">
+                      <a:solidFill>
+                        <a:srgbClr val="0F3460"/>
+                      </a:solidFill>
+                      <a:prstDash val="solid"/>
+                      <a:round/>
+                      <a:headEnd type="none" w="med" len="med"/>
+                      <a:tailEnd type="none" w="med" len="med"/>
+                    </a:lnR>
+                    <a:lnT w="12700" cap="flat" cmpd="sng" algn="ctr">
+                      <a:solidFill>
+                        <a:srgbClr val="0F3460"/>
+                      </a:solidFill>
+                      <a:prstDash val="solid"/>
+                      <a:round/>
+                      <a:headEnd type="none" w="med" len="med"/>
+                      <a:tailEnd type="none" w="med" len="med"/>
+                    </a:lnT>
+                    <a:lnB w="12700" cap="flat" cmpd="sng" algn="ctr">
+                      <a:solidFill>
+                        <a:srgbClr val="0F3460"/>
+                      </a:solidFill>
+                      <a:prstDash val="solid"/>
+                      <a:round/>
+                      <a:headEnd type="none" w="med" len="med"/>
+                      <a:tailEnd type="none" w="med" len="med"/>
+                    </a:lnB>
+                    <a:solidFill>
+                      <a:srgbClr val="1A1A2E"/>
+                    </a:solidFill>
+                  </a:tcPr>
+                </a:tc>
+                <a:tc>
+                  <a:txBody>
+                    <a:bodyPr/>
+                    <a:lstStyle/>
+                    <a:p>
+                      <a:pPr algn="ctr" indent="0" marL="0">
+                        <a:buNone/>
+                      </a:pPr>
+                      <a:r>
+                        <a:rPr lang="en-US" sz="1000" dirty="0">
+                          <a:solidFill>
+                            <a:srgbClr val="E8E8E8"/>
+                          </a:solidFill>
+                          <a:latin typeface="Calibri" pitchFamily="34" charset="0"/>
+                          <a:ea typeface="Calibri" pitchFamily="34" charset="-122"/>
+                          <a:cs typeface="Calibri" pitchFamily="34" charset="-120"/>
+                        </a:rPr>
+                        <a:t>~08:50</a:t>
+                      </a:r>
+                      <a:endParaRPr lang="en-US" sz="1000" dirty="0">
+                        <a:latin typeface="Calibri" charset="0"/>
+                        <a:ea typeface="Calibri" charset="0"/>
+                        <a:cs typeface="Calibri" charset="0"/>
+                      </a:endParaRPr>
+                    </a:p>
+                  </a:txBody>
+                  <a:tcPr marL="91440" marR="91440" marT="45720" marB="45720">
+                    <a:lnL w="12700" cap="flat" cmpd="sng" algn="ctr">
+                      <a:solidFill>
+                        <a:srgbClr val="0F3460"/>
+                      </a:solidFill>
+                      <a:prstDash val="solid"/>
+                      <a:round/>
+                      <a:headEnd type="none" w="med" len="med"/>
+                      <a:tailEnd type="none" w="med" len="med"/>
+                    </a:lnL>
+                    <a:lnR w="12700" cap="flat" cmpd="sng" algn="ctr">
+                      <a:solidFill>
+                        <a:srgbClr val="0F3460"/>
+                      </a:solidFill>
+                      <a:prstDash val="solid"/>
+                      <a:round/>
+                      <a:headEnd type="none" w="med" len="med"/>
+                      <a:tailEnd type="none" w="med" len="med"/>
+                    </a:lnR>
+                    <a:lnT w="12700" cap="flat" cmpd="sng" algn="ctr">
+                      <a:solidFill>
+                        <a:srgbClr val="0F3460"/>
+                      </a:solidFill>
+                      <a:prstDash val="solid"/>
+                      <a:round/>
+                      <a:headEnd type="none" w="med" len="med"/>
+                      <a:tailEnd type="none" w="med" len="med"/>
+                    </a:lnT>
+                    <a:lnB w="12700" cap="flat" cmpd="sng" algn="ctr">
+                      <a:solidFill>
+                        <a:srgbClr val="0F3460"/>
+                      </a:solidFill>
+                      <a:prstDash val="solid"/>
+                      <a:round/>
+                      <a:headEnd type="none" w="med" len="med"/>
+                      <a:tailEnd type="none" w="med" len="med"/>
+                    </a:lnB>
+                    <a:solidFill>
+                      <a:srgbClr val="1A1A2E"/>
+                    </a:solidFill>
+                  </a:tcPr>
+                </a:tc>
+                <a:tc>
+                  <a:txBody>
+                    <a:bodyPr/>
+                    <a:lstStyle/>
+                    <a:p>
+                      <a:pPr algn="ctr" indent="0" marL="0">
+                        <a:buNone/>
+                      </a:pPr>
+                      <a:r>
+                        <a:rPr lang="en-US" sz="1000" dirty="0">
+                          <a:solidFill>
+                            <a:srgbClr val="E8E8E8"/>
+                          </a:solidFill>
+                          <a:latin typeface="Calibri" pitchFamily="34" charset="0"/>
+                          <a:ea typeface="Calibri" pitchFamily="34" charset="-122"/>
+                          <a:cs typeface="Calibri" pitchFamily="34" charset="-120"/>
+                        </a:rPr>
+                        <a:t>2h 30m</a:t>
+                      </a:r>
+                      <a:endParaRPr lang="en-US" sz="1000" dirty="0">
+                        <a:latin typeface="Calibri" charset="0"/>
+                        <a:ea typeface="Calibri" charset="0"/>
+                        <a:cs typeface="Calibri" charset="0"/>
+                      </a:endParaRPr>
+                    </a:p>
+                  </a:txBody>
+                  <a:tcPr marL="91440" marR="91440" marT="45720" marB="45720">
+                    <a:lnL w="12700" cap="flat" cmpd="sng" algn="ctr">
+                      <a:solidFill>
+                        <a:srgbClr val="0F3460"/>
+                      </a:solidFill>
+                      <a:prstDash val="solid"/>
+                      <a:round/>
+                      <a:headEnd type="none" w="med" len="med"/>
+                      <a:tailEnd type="none" w="med" len="med"/>
+                    </a:lnL>
+                    <a:lnR w="12700" cap="flat" cmpd="sng" algn="ctr">
+                      <a:solidFill>
+                        <a:srgbClr val="0F3460"/>
+                      </a:solidFill>
+                      <a:prstDash val="solid"/>
+                      <a:round/>
+                      <a:headEnd type="none" w="med" len="med"/>
+                      <a:tailEnd type="none" w="med" len="med"/>
+                    </a:lnR>
+                    <a:lnT w="12700" cap="flat" cmpd="sng" algn="ctr">
+                      <a:solidFill>
+                        <a:srgbClr val="0F3460"/>
+                      </a:solidFill>
+                      <a:prstDash val="solid"/>
+                      <a:round/>
+                      <a:headEnd type="none" w="med" len="med"/>
+                      <a:tailEnd type="none" w="med" len="med"/>
+                    </a:lnT>
+                    <a:lnB w="12700" cap="flat" cmpd="sng" algn="ctr">
+                      <a:solidFill>
+                        <a:srgbClr val="0F3460"/>
+                      </a:solidFill>
+                      <a:prstDash val="solid"/>
+                      <a:round/>
+                      <a:headEnd type="none" w="med" len="med"/>
+                      <a:tailEnd type="none" w="med" len="med"/>
+                    </a:lnB>
+                    <a:solidFill>
+                      <a:srgbClr val="1A1A2E"/>
                     </a:solidFill>
                   </a:tcPr>
                 </a:tc>
@@ -24092,6 +24445,594 @@
                       <a:tailEnd type="none" w="med" len="med"/>
                     </a:lnB>
                     <a:solidFill>
+                      <a:srgbClr val="1A1A2E"/>
+                    </a:solidFill>
+                  </a:tcPr>
+                </a:tc>
+                <a:tc>
+                  <a:txBody>
+                    <a:bodyPr/>
+                    <a:lstStyle/>
+                    <a:p>
+                      <a:pPr algn="ctr" indent="0" marL="0">
+                        <a:buNone/>
+                      </a:pPr>
+                      <a:r>
+                        <a:rPr lang="en-US" sz="1000" b="1" dirty="0">
+                          <a:solidFill>
+                            <a:srgbClr val="22C55E"/>
+                          </a:solidFill>
+                          <a:latin typeface="Calibri" pitchFamily="34" charset="0"/>
+                          <a:ea typeface="Calibri" pitchFamily="34" charset="-122"/>
+                          <a:cs typeface="Calibri" pitchFamily="34" charset="-120"/>
+                        </a:rPr>
+                        <a:t>~€300</a:t>
+                      </a:r>
+                      <a:endParaRPr lang="en-US" sz="1000" dirty="0">
+                        <a:latin typeface="Calibri" charset="0"/>
+                        <a:ea typeface="Calibri" charset="0"/>
+                        <a:cs typeface="Calibri" charset="0"/>
+                      </a:endParaRPr>
+                    </a:p>
+                  </a:txBody>
+                  <a:tcPr marL="91440" marR="91440" marT="45720" marB="45720">
+                    <a:lnL w="12700" cap="flat" cmpd="sng" algn="ctr">
+                      <a:solidFill>
+                        <a:srgbClr val="0F3460"/>
+                      </a:solidFill>
+                      <a:prstDash val="solid"/>
+                      <a:round/>
+                      <a:headEnd type="none" w="med" len="med"/>
+                      <a:tailEnd type="none" w="med" len="med"/>
+                    </a:lnL>
+                    <a:lnR w="12700" cap="flat" cmpd="sng" algn="ctr">
+                      <a:solidFill>
+                        <a:srgbClr val="0F3460"/>
+                      </a:solidFill>
+                      <a:prstDash val="solid"/>
+                      <a:round/>
+                      <a:headEnd type="none" w="med" len="med"/>
+                      <a:tailEnd type="none" w="med" len="med"/>
+                    </a:lnR>
+                    <a:lnT w="12700" cap="flat" cmpd="sng" algn="ctr">
+                      <a:solidFill>
+                        <a:srgbClr val="0F3460"/>
+                      </a:solidFill>
+                      <a:prstDash val="solid"/>
+                      <a:round/>
+                      <a:headEnd type="none" w="med" len="med"/>
+                      <a:tailEnd type="none" w="med" len="med"/>
+                    </a:lnT>
+                    <a:lnB w="12700" cap="flat" cmpd="sng" algn="ctr">
+                      <a:solidFill>
+                        <a:srgbClr val="0F3460"/>
+                      </a:solidFill>
+                      <a:prstDash val="solid"/>
+                      <a:round/>
+                      <a:headEnd type="none" w="med" len="med"/>
+                      <a:tailEnd type="none" w="med" len="med"/>
+                    </a:lnB>
+                    <a:solidFill>
+                      <a:srgbClr val="1A1A2E"/>
+                    </a:solidFill>
+                  </a:tcPr>
+                </a:tc>
+              </a:tr>
+              <a:tr h="475488">
+                <a:tc>
+                  <a:txBody>
+                    <a:bodyPr/>
+                    <a:lstStyle/>
+                    <a:p>
+                      <a:pPr algn="ctr" indent="0" marL="0">
+                        <a:buNone/>
+                      </a:pPr>
+                      <a:r>
+                        <a:rPr lang="en-US" sz="1000" dirty="0">
+                          <a:solidFill>
+                            <a:srgbClr val="E8E8E8"/>
+                          </a:solidFill>
+                          <a:latin typeface="Calibri" pitchFamily="34" charset="0"/>
+                          <a:ea typeface="Calibri" pitchFamily="34" charset="-122"/>
+                          <a:cs typeface="Calibri" pitchFamily="34" charset="-120"/>
+                        </a:rPr>
+                        <a:t>Midday Oct 30</a:t>
+                      </a:r>
+                      <a:endParaRPr lang="en-US" sz="1000" dirty="0">
+                        <a:latin typeface="Calibri" charset="0"/>
+                        <a:ea typeface="Calibri" charset="0"/>
+                        <a:cs typeface="Calibri" charset="0"/>
+                      </a:endParaRPr>
+                    </a:p>
+                  </a:txBody>
+                  <a:tcPr marL="91440" marR="91440" marT="45720" marB="45720">
+                    <a:lnL w="12700" cap="flat" cmpd="sng" algn="ctr">
+                      <a:solidFill>
+                        <a:srgbClr val="0F3460"/>
+                      </a:solidFill>
+                      <a:prstDash val="solid"/>
+                      <a:round/>
+                      <a:headEnd type="none" w="med" len="med"/>
+                      <a:tailEnd type="none" w="med" len="med"/>
+                    </a:lnL>
+                    <a:lnR w="12700" cap="flat" cmpd="sng" algn="ctr">
+                      <a:solidFill>
+                        <a:srgbClr val="0F3460"/>
+                      </a:solidFill>
+                      <a:prstDash val="solid"/>
+                      <a:round/>
+                      <a:headEnd type="none" w="med" len="med"/>
+                      <a:tailEnd type="none" w="med" len="med"/>
+                    </a:lnR>
+                    <a:lnT w="12700" cap="flat" cmpd="sng" algn="ctr">
+                      <a:solidFill>
+                        <a:srgbClr val="0F3460"/>
+                      </a:solidFill>
+                      <a:prstDash val="solid"/>
+                      <a:round/>
+                      <a:headEnd type="none" w="med" len="med"/>
+                      <a:tailEnd type="none" w="med" len="med"/>
+                    </a:lnT>
+                    <a:lnB w="12700" cap="flat" cmpd="sng" algn="ctr">
+                      <a:solidFill>
+                        <a:srgbClr val="0F3460"/>
+                      </a:solidFill>
+                      <a:prstDash val="solid"/>
+                      <a:round/>
+                      <a:headEnd type="none" w="med" len="med"/>
+                      <a:tailEnd type="none" w="med" len="med"/>
+                    </a:lnB>
+                    <a:solidFill>
+                      <a:srgbClr val="16213E"/>
+                    </a:solidFill>
+                  </a:tcPr>
+                </a:tc>
+                <a:tc>
+                  <a:txBody>
+                    <a:bodyPr/>
+                    <a:lstStyle/>
+                    <a:p>
+                      <a:pPr algn="ctr" indent="0" marL="0">
+                        <a:buNone/>
+                      </a:pPr>
+                      <a:r>
+                        <a:rPr lang="en-US" sz="1000" dirty="0">
+                          <a:solidFill>
+                            <a:srgbClr val="E8E8E8"/>
+                          </a:solidFill>
+                          <a:latin typeface="Calibri" pitchFamily="34" charset="0"/>
+                          <a:ea typeface="Calibri" pitchFamily="34" charset="-122"/>
+                          <a:cs typeface="Calibri" pitchFamily="34" charset="-120"/>
+                        </a:rPr>
+                        <a:t>Eurowings</a:t>
+                      </a:r>
+                      <a:endParaRPr lang="en-US" sz="1000" dirty="0">
+                        <a:latin typeface="Calibri" charset="0"/>
+                        <a:ea typeface="Calibri" charset="0"/>
+                        <a:cs typeface="Calibri" charset="0"/>
+                      </a:endParaRPr>
+                    </a:p>
+                    <a:p>
+                      <a:pPr algn="ctr" indent="0" marL="0">
+                        <a:buNone/>
+                      </a:pPr>
+                      <a:r>
+                        <a:rPr lang="en-US" sz="1000" dirty="0">
+                          <a:solidFill>
+                            <a:srgbClr val="E8E8E8"/>
+                          </a:solidFill>
+                          <a:latin typeface="Calibri" pitchFamily="34" charset="0"/>
+                          <a:ea typeface="Calibri" pitchFamily="34" charset="-122"/>
+                          <a:cs typeface="Calibri" pitchFamily="34" charset="-120"/>
+                        </a:rPr>
+                        <a:t>(EW)</a:t>
+                      </a:r>
+                      <a:endParaRPr lang="en-US" sz="1000" dirty="0">
+                        <a:latin typeface="Calibri" charset="0"/>
+                        <a:ea typeface="Calibri" charset="0"/>
+                        <a:cs typeface="Calibri" charset="0"/>
+                      </a:endParaRPr>
+                    </a:p>
+                  </a:txBody>
+                  <a:tcPr marL="91440" marR="91440" marT="45720" marB="45720">
+                    <a:lnL w="12700" cap="flat" cmpd="sng" algn="ctr">
+                      <a:solidFill>
+                        <a:srgbClr val="0F3460"/>
+                      </a:solidFill>
+                      <a:prstDash val="solid"/>
+                      <a:round/>
+                      <a:headEnd type="none" w="med" len="med"/>
+                      <a:tailEnd type="none" w="med" len="med"/>
+                    </a:lnL>
+                    <a:lnR w="12700" cap="flat" cmpd="sng" algn="ctr">
+                      <a:solidFill>
+                        <a:srgbClr val="0F3460"/>
+                      </a:solidFill>
+                      <a:prstDash val="solid"/>
+                      <a:round/>
+                      <a:headEnd type="none" w="med" len="med"/>
+                      <a:tailEnd type="none" w="med" len="med"/>
+                    </a:lnR>
+                    <a:lnT w="12700" cap="flat" cmpd="sng" algn="ctr">
+                      <a:solidFill>
+                        <a:srgbClr val="0F3460"/>
+                      </a:solidFill>
+                      <a:prstDash val="solid"/>
+                      <a:round/>
+                      <a:headEnd type="none" w="med" len="med"/>
+                      <a:tailEnd type="none" w="med" len="med"/>
+                    </a:lnT>
+                    <a:lnB w="12700" cap="flat" cmpd="sng" algn="ctr">
+                      <a:solidFill>
+                        <a:srgbClr val="0F3460"/>
+                      </a:solidFill>
+                      <a:prstDash val="solid"/>
+                      <a:round/>
+                      <a:headEnd type="none" w="med" len="med"/>
+                      <a:tailEnd type="none" w="med" len="med"/>
+                    </a:lnB>
+                    <a:solidFill>
+                      <a:srgbClr val="16213E"/>
+                    </a:solidFill>
+                  </a:tcPr>
+                </a:tc>
+                <a:tc>
+                  <a:txBody>
+                    <a:bodyPr/>
+                    <a:lstStyle/>
+                    <a:p>
+                      <a:pPr algn="ctr" indent="0" marL="0">
+                        <a:buNone/>
+                      </a:pPr>
+                      <a:r>
+                        <a:rPr lang="en-US" sz="1000" dirty="0">
+                          <a:solidFill>
+                            <a:srgbClr val="E8E8E8"/>
+                          </a:solidFill>
+                          <a:latin typeface="Calibri" pitchFamily="34" charset="0"/>
+                          <a:ea typeface="Calibri" pitchFamily="34" charset="-122"/>
+                          <a:cs typeface="Calibri" pitchFamily="34" charset="-120"/>
+                        </a:rPr>
+                        <a:t>DUS → MAD</a:t>
+                      </a:r>
+                      <a:endParaRPr lang="en-US" sz="1000" dirty="0">
+                        <a:latin typeface="Calibri" charset="0"/>
+                        <a:ea typeface="Calibri" charset="0"/>
+                        <a:cs typeface="Calibri" charset="0"/>
+                      </a:endParaRPr>
+                    </a:p>
+                    <a:p>
+                      <a:pPr algn="ctr" indent="0" marL="0">
+                        <a:buNone/>
+                      </a:pPr>
+                      <a:r>
+                        <a:rPr lang="en-US" sz="1000" dirty="0">
+                          <a:solidFill>
+                            <a:srgbClr val="E8E8E8"/>
+                          </a:solidFill>
+                          <a:latin typeface="Calibri" pitchFamily="34" charset="0"/>
+                          <a:ea typeface="Calibri" pitchFamily="34" charset="-122"/>
+                          <a:cs typeface="Calibri" pitchFamily="34" charset="-120"/>
+                        </a:rPr>
+                        <a:t>Oct 30 midday</a:t>
+                      </a:r>
+                      <a:endParaRPr lang="en-US" sz="1000" dirty="0">
+                        <a:latin typeface="Calibri" charset="0"/>
+                        <a:ea typeface="Calibri" charset="0"/>
+                        <a:cs typeface="Calibri" charset="0"/>
+                      </a:endParaRPr>
+                    </a:p>
+                  </a:txBody>
+                  <a:tcPr marL="91440" marR="91440" marT="45720" marB="45720">
+                    <a:lnL w="12700" cap="flat" cmpd="sng" algn="ctr">
+                      <a:solidFill>
+                        <a:srgbClr val="0F3460"/>
+                      </a:solidFill>
+                      <a:prstDash val="solid"/>
+                      <a:round/>
+                      <a:headEnd type="none" w="med" len="med"/>
+                      <a:tailEnd type="none" w="med" len="med"/>
+                    </a:lnL>
+                    <a:lnR w="12700" cap="flat" cmpd="sng" algn="ctr">
+                      <a:solidFill>
+                        <a:srgbClr val="0F3460"/>
+                      </a:solidFill>
+                      <a:prstDash val="solid"/>
+                      <a:round/>
+                      <a:headEnd type="none" w="med" len="med"/>
+                      <a:tailEnd type="none" w="med" len="med"/>
+                    </a:lnR>
+                    <a:lnT w="12700" cap="flat" cmpd="sng" algn="ctr">
+                      <a:solidFill>
+                        <a:srgbClr val="0F3460"/>
+                      </a:solidFill>
+                      <a:prstDash val="solid"/>
+                      <a:round/>
+                      <a:headEnd type="none" w="med" len="med"/>
+                      <a:tailEnd type="none" w="med" len="med"/>
+                    </a:lnT>
+                    <a:lnB w="12700" cap="flat" cmpd="sng" algn="ctr">
+                      <a:solidFill>
+                        <a:srgbClr val="0F3460"/>
+                      </a:solidFill>
+                      <a:prstDash val="solid"/>
+                      <a:round/>
+                      <a:headEnd type="none" w="med" len="med"/>
+                      <a:tailEnd type="none" w="med" len="med"/>
+                    </a:lnB>
+                    <a:solidFill>
+                      <a:srgbClr val="16213E"/>
+                    </a:solidFill>
+                  </a:tcPr>
+                </a:tc>
+                <a:tc>
+                  <a:txBody>
+                    <a:bodyPr/>
+                    <a:lstStyle/>
+                    <a:p>
+                      <a:pPr algn="ctr" indent="0" marL="0">
+                        <a:buNone/>
+                      </a:pPr>
+                      <a:r>
+                        <a:rPr lang="en-US" sz="1000" dirty="0">
+                          <a:solidFill>
+                            <a:srgbClr val="E8E8E8"/>
+                          </a:solidFill>
+                          <a:latin typeface="Calibri" pitchFamily="34" charset="0"/>
+                          <a:ea typeface="Calibri" pitchFamily="34" charset="-122"/>
+                          <a:cs typeface="Calibri" pitchFamily="34" charset="-120"/>
+                        </a:rPr>
+                        <a:t>~13:xx</a:t>
+                      </a:r>
+                      <a:endParaRPr lang="en-US" sz="1000" dirty="0">
+                        <a:latin typeface="Calibri" charset="0"/>
+                        <a:ea typeface="Calibri" charset="0"/>
+                        <a:cs typeface="Calibri" charset="0"/>
+                      </a:endParaRPr>
+                    </a:p>
+                  </a:txBody>
+                  <a:tcPr marL="91440" marR="91440" marT="45720" marB="45720">
+                    <a:lnL w="12700" cap="flat" cmpd="sng" algn="ctr">
+                      <a:solidFill>
+                        <a:srgbClr val="0F3460"/>
+                      </a:solidFill>
+                      <a:prstDash val="solid"/>
+                      <a:round/>
+                      <a:headEnd type="none" w="med" len="med"/>
+                      <a:tailEnd type="none" w="med" len="med"/>
+                    </a:lnL>
+                    <a:lnR w="12700" cap="flat" cmpd="sng" algn="ctr">
+                      <a:solidFill>
+                        <a:srgbClr val="0F3460"/>
+                      </a:solidFill>
+                      <a:prstDash val="solid"/>
+                      <a:round/>
+                      <a:headEnd type="none" w="med" len="med"/>
+                      <a:tailEnd type="none" w="med" len="med"/>
+                    </a:lnR>
+                    <a:lnT w="12700" cap="flat" cmpd="sng" algn="ctr">
+                      <a:solidFill>
+                        <a:srgbClr val="0F3460"/>
+                      </a:solidFill>
+                      <a:prstDash val="solid"/>
+                      <a:round/>
+                      <a:headEnd type="none" w="med" len="med"/>
+                      <a:tailEnd type="none" w="med" len="med"/>
+                    </a:lnT>
+                    <a:lnB w="12700" cap="flat" cmpd="sng" algn="ctr">
+                      <a:solidFill>
+                        <a:srgbClr val="0F3460"/>
+                      </a:solidFill>
+                      <a:prstDash val="solid"/>
+                      <a:round/>
+                      <a:headEnd type="none" w="med" len="med"/>
+                      <a:tailEnd type="none" w="med" len="med"/>
+                    </a:lnB>
+                    <a:solidFill>
+                      <a:srgbClr val="16213E"/>
+                    </a:solidFill>
+                  </a:tcPr>
+                </a:tc>
+                <a:tc>
+                  <a:txBody>
+                    <a:bodyPr/>
+                    <a:lstStyle/>
+                    <a:p>
+                      <a:pPr algn="ctr" indent="0" marL="0">
+                        <a:buNone/>
+                      </a:pPr>
+                      <a:r>
+                        <a:rPr lang="en-US" sz="1000" dirty="0">
+                          <a:solidFill>
+                            <a:srgbClr val="E8E8E8"/>
+                          </a:solidFill>
+                          <a:latin typeface="Calibri" pitchFamily="34" charset="0"/>
+                          <a:ea typeface="Calibri" pitchFamily="34" charset="-122"/>
+                          <a:cs typeface="Calibri" pitchFamily="34" charset="-120"/>
+                        </a:rPr>
+                        <a:t>~15:30</a:t>
+                      </a:r>
+                      <a:endParaRPr lang="en-US" sz="1000" dirty="0">
+                        <a:latin typeface="Calibri" charset="0"/>
+                        <a:ea typeface="Calibri" charset="0"/>
+                        <a:cs typeface="Calibri" charset="0"/>
+                      </a:endParaRPr>
+                    </a:p>
+                  </a:txBody>
+                  <a:tcPr marL="91440" marR="91440" marT="45720" marB="45720">
+                    <a:lnL w="12700" cap="flat" cmpd="sng" algn="ctr">
+                      <a:solidFill>
+                        <a:srgbClr val="0F3460"/>
+                      </a:solidFill>
+                      <a:prstDash val="solid"/>
+                      <a:round/>
+                      <a:headEnd type="none" w="med" len="med"/>
+                      <a:tailEnd type="none" w="med" len="med"/>
+                    </a:lnL>
+                    <a:lnR w="12700" cap="flat" cmpd="sng" algn="ctr">
+                      <a:solidFill>
+                        <a:srgbClr val="0F3460"/>
+                      </a:solidFill>
+                      <a:prstDash val="solid"/>
+                      <a:round/>
+                      <a:headEnd type="none" w="med" len="med"/>
+                      <a:tailEnd type="none" w="med" len="med"/>
+                    </a:lnR>
+                    <a:lnT w="12700" cap="flat" cmpd="sng" algn="ctr">
+                      <a:solidFill>
+                        <a:srgbClr val="0F3460"/>
+                      </a:solidFill>
+                      <a:prstDash val="solid"/>
+                      <a:round/>
+                      <a:headEnd type="none" w="med" len="med"/>
+                      <a:tailEnd type="none" w="med" len="med"/>
+                    </a:lnT>
+                    <a:lnB w="12700" cap="flat" cmpd="sng" algn="ctr">
+                      <a:solidFill>
+                        <a:srgbClr val="0F3460"/>
+                      </a:solidFill>
+                      <a:prstDash val="solid"/>
+                      <a:round/>
+                      <a:headEnd type="none" w="med" len="med"/>
+                      <a:tailEnd type="none" w="med" len="med"/>
+                    </a:lnB>
+                    <a:solidFill>
+                      <a:srgbClr val="16213E"/>
+                    </a:solidFill>
+                  </a:tcPr>
+                </a:tc>
+                <a:tc>
+                  <a:txBody>
+                    <a:bodyPr/>
+                    <a:lstStyle/>
+                    <a:p>
+                      <a:pPr algn="ctr" indent="0" marL="0">
+                        <a:buNone/>
+                      </a:pPr>
+                      <a:r>
+                        <a:rPr lang="en-US" sz="1000" dirty="0">
+                          <a:solidFill>
+                            <a:srgbClr val="E8E8E8"/>
+                          </a:solidFill>
+                          <a:latin typeface="Calibri" pitchFamily="34" charset="0"/>
+                          <a:ea typeface="Calibri" pitchFamily="34" charset="-122"/>
+                          <a:cs typeface="Calibri" pitchFamily="34" charset="-120"/>
+                        </a:rPr>
+                        <a:t>2h 30m</a:t>
+                      </a:r>
+                      <a:endParaRPr lang="en-US" sz="1000" dirty="0">
+                        <a:latin typeface="Calibri" charset="0"/>
+                        <a:ea typeface="Calibri" charset="0"/>
+                        <a:cs typeface="Calibri" charset="0"/>
+                      </a:endParaRPr>
+                    </a:p>
+                  </a:txBody>
+                  <a:tcPr marL="91440" marR="91440" marT="45720" marB="45720">
+                    <a:lnL w="12700" cap="flat" cmpd="sng" algn="ctr">
+                      <a:solidFill>
+                        <a:srgbClr val="0F3460"/>
+                      </a:solidFill>
+                      <a:prstDash val="solid"/>
+                      <a:round/>
+                      <a:headEnd type="none" w="med" len="med"/>
+                      <a:tailEnd type="none" w="med" len="med"/>
+                    </a:lnL>
+                    <a:lnR w="12700" cap="flat" cmpd="sng" algn="ctr">
+                      <a:solidFill>
+                        <a:srgbClr val="0F3460"/>
+                      </a:solidFill>
+                      <a:prstDash val="solid"/>
+                      <a:round/>
+                      <a:headEnd type="none" w="med" len="med"/>
+                      <a:tailEnd type="none" w="med" len="med"/>
+                    </a:lnR>
+                    <a:lnT w="12700" cap="flat" cmpd="sng" algn="ctr">
+                      <a:solidFill>
+                        <a:srgbClr val="0F3460"/>
+                      </a:solidFill>
+                      <a:prstDash val="solid"/>
+                      <a:round/>
+                      <a:headEnd type="none" w="med" len="med"/>
+                      <a:tailEnd type="none" w="med" len="med"/>
+                    </a:lnT>
+                    <a:lnB w="12700" cap="flat" cmpd="sng" algn="ctr">
+                      <a:solidFill>
+                        <a:srgbClr val="0F3460"/>
+                      </a:solidFill>
+                      <a:prstDash val="solid"/>
+                      <a:round/>
+                      <a:headEnd type="none" w="med" len="med"/>
+                      <a:tailEnd type="none" w="med" len="med"/>
+                    </a:lnB>
+                    <a:solidFill>
+                      <a:srgbClr val="16213E"/>
+                    </a:solidFill>
+                  </a:tcPr>
+                </a:tc>
+                <a:tc>
+                  <a:txBody>
+                    <a:bodyPr/>
+                    <a:lstStyle/>
+                    <a:p>
+                      <a:pPr algn="ctr" indent="0" marL="0">
+                        <a:buNone/>
+                      </a:pPr>
+                      <a:r>
+                        <a:rPr lang="en-US" sz="1000" dirty="0">
+                          <a:solidFill>
+                            <a:srgbClr val="E8E8E8"/>
+                          </a:solidFill>
+                          <a:latin typeface="Calibri" pitchFamily="34" charset="0"/>
+                          <a:ea typeface="Calibri" pitchFamily="34" charset="-122"/>
+                          <a:cs typeface="Calibri" pitchFamily="34" charset="-120"/>
+                        </a:rPr>
+                        <a:t>~€90</a:t>
+                      </a:r>
+                      <a:endParaRPr lang="en-US" sz="1000" dirty="0">
+                        <a:latin typeface="Calibri" charset="0"/>
+                        <a:ea typeface="Calibri" charset="0"/>
+                        <a:cs typeface="Calibri" charset="0"/>
+                      </a:endParaRPr>
+                    </a:p>
+                  </a:txBody>
+                  <a:tcPr marL="91440" marR="91440" marT="45720" marB="45720">
+                    <a:lnL w="12700" cap="flat" cmpd="sng" algn="ctr">
+                      <a:solidFill>
+                        <a:srgbClr val="0F3460"/>
+                      </a:solidFill>
+                      <a:prstDash val="solid"/>
+                      <a:round/>
+                      <a:headEnd type="none" w="med" len="med"/>
+                      <a:tailEnd type="none" w="med" len="med"/>
+                    </a:lnL>
+                    <a:lnR w="12700" cap="flat" cmpd="sng" algn="ctr">
+                      <a:solidFill>
+                        <a:srgbClr val="0F3460"/>
+                      </a:solidFill>
+                      <a:prstDash val="solid"/>
+                      <a:round/>
+                      <a:headEnd type="none" w="med" len="med"/>
+                      <a:tailEnd type="none" w="med" len="med"/>
+                    </a:lnR>
+                    <a:lnT w="12700" cap="flat" cmpd="sng" algn="ctr">
+                      <a:solidFill>
+                        <a:srgbClr val="0F3460"/>
+                      </a:solidFill>
+                      <a:prstDash val="solid"/>
+                      <a:round/>
+                      <a:headEnd type="none" w="med" len="med"/>
+                      <a:tailEnd type="none" w="med" len="med"/>
+                    </a:lnT>
+                    <a:lnB w="12700" cap="flat" cmpd="sng" algn="ctr">
+                      <a:solidFill>
+                        <a:srgbClr val="0F3460"/>
+                      </a:solidFill>
+                      <a:prstDash val="solid"/>
+                      <a:round/>
+                      <a:headEnd type="none" w="med" len="med"/>
+                      <a:tailEnd type="none" w="med" len="med"/>
+                    </a:lnB>
+                    <a:solidFill>
                       <a:srgbClr val="16213E"/>
                     </a:solidFill>
                   </a:tcPr>
@@ -24107,13 +25048,13 @@
                       <a:r>
                         <a:rPr lang="en-US" sz="1000" b="1" dirty="0">
                           <a:solidFill>
-                            <a:srgbClr val="FF8C00"/>
+                            <a:srgbClr val="FFC107"/>
                           </a:solidFill>
                           <a:latin typeface="Calibri" pitchFamily="34" charset="0"/>
                           <a:ea typeface="Calibri" pitchFamily="34" charset="-122"/>
                           <a:cs typeface="Calibri" pitchFamily="34" charset="-120"/>
                         </a:rPr>
-                        <a:t>~€300</a:t>
+                        <a:t>~€360</a:t>
                       </a:r>
                       <a:endParaRPr lang="en-US" sz="1000" dirty="0">
                         <a:latin typeface="Calibri" charset="0"/>
@@ -24183,28 +25124,7 @@
                           <a:ea typeface="Calibri" pitchFamily="34" charset="-122"/>
                           <a:cs typeface="Calibri" pitchFamily="34" charset="-120"/>
                         </a:rPr>
-                        <a:t>Oct 30</a:t>
-                      </a:r>
-                      <a:endParaRPr lang="en-US" sz="1000" dirty="0">
-                        <a:latin typeface="Calibri" charset="0"/>
-                        <a:ea typeface="Calibri" charset="0"/>
-                        <a:cs typeface="Calibri" charset="0"/>
-                      </a:endParaRPr>
-                    </a:p>
-                    <a:p>
-                      <a:pPr algn="ctr" indent="0" marL="0">
-                        <a:buNone/>
-                      </a:pPr>
-                      <a:r>
-                        <a:rPr lang="en-US" sz="1000" dirty="0">
-                          <a:solidFill>
-                            <a:srgbClr val="E8E8E8"/>
-                          </a:solidFill>
-                          <a:latin typeface="Calibri" pitchFamily="34" charset="0"/>
-                          <a:ea typeface="Calibri" pitchFamily="34" charset="-122"/>
-                          <a:cs typeface="Calibri" pitchFamily="34" charset="-120"/>
-                        </a:rPr>
-                        <a:t>Morning</a:t>
+                        <a:t>Premium</a:t>
                       </a:r>
                       <a:endParaRPr lang="en-US" sz="1000" dirty="0">
                         <a:latin typeface="Calibri" charset="0"/>
@@ -24272,7 +25192,7 @@
                           <a:ea typeface="Calibri" pitchFamily="34" charset="-122"/>
                           <a:cs typeface="Calibri" pitchFamily="34" charset="-120"/>
                         </a:rPr>
-                        <a:t>W62292</a:t>
+                        <a:t>Vueling</a:t>
                       </a:r>
                       <a:endParaRPr lang="en-US" sz="1000" dirty="0">
                         <a:latin typeface="Calibri" charset="0"/>
@@ -24293,7 +25213,7 @@
                           <a:ea typeface="Calibri" pitchFamily="34" charset="-122"/>
                           <a:cs typeface="Calibri" pitchFamily="34" charset="-120"/>
                         </a:rPr>
-                        <a:t>Wizz Air</a:t>
+                        <a:t>(VY)</a:t>
                       </a:r>
                       <a:endParaRPr lang="en-US" sz="1000" dirty="0">
                         <a:latin typeface="Calibri" charset="0"/>
@@ -24361,7 +25281,7 @@
                           <a:ea typeface="Calibri" pitchFamily="34" charset="-122"/>
                           <a:cs typeface="Calibri" pitchFamily="34" charset="-120"/>
                         </a:rPr>
-                        <a:t>DTM → BUD</a:t>
+                        <a:t>DUS → MAD</a:t>
                       </a:r>
                       <a:endParaRPr lang="en-US" sz="1000" dirty="0">
                         <a:latin typeface="Calibri" charset="0"/>
@@ -24450,7 +25370,7 @@
                           <a:ea typeface="Calibri" pitchFamily="34" charset="-122"/>
                           <a:cs typeface="Calibri" pitchFamily="34" charset="-120"/>
                         </a:rPr>
-                        <a:t>AM slot</a:t>
+                        <a:t>Various</a:t>
                       </a:r>
                       <a:endParaRPr lang="en-US" sz="1000" dirty="0">
                         <a:latin typeface="Calibri" charset="0"/>
@@ -24518,7 +25438,7 @@
                           <a:ea typeface="Calibri" pitchFamily="34" charset="-122"/>
                           <a:cs typeface="Calibri" pitchFamily="34" charset="-120"/>
                         </a:rPr>
-                        <a:t>AM +1h45</a:t>
+                        <a:t>Various</a:t>
                       </a:r>
                       <a:endParaRPr lang="en-US" sz="1000" dirty="0">
                         <a:latin typeface="Calibri" charset="0"/>
@@ -24586,7 +25506,7 @@
                           <a:ea typeface="Calibri" pitchFamily="34" charset="-122"/>
                           <a:cs typeface="Calibri" pitchFamily="34" charset="-120"/>
                         </a:rPr>
-                        <a:t>1h 45m</a:t>
+                        <a:t>2h 30m</a:t>
                       </a:r>
                       <a:endParaRPr lang="en-US" sz="1000" dirty="0">
                         <a:latin typeface="Calibri" charset="0"/>
@@ -24654,733 +25574,7 @@
                           <a:ea typeface="Calibri" pitchFamily="34" charset="-122"/>
                           <a:cs typeface="Calibri" pitchFamily="34" charset="-120"/>
                         </a:rPr>
-                        <a:t>~€65</a:t>
-                      </a:r>
-                      <a:endParaRPr lang="en-US" sz="1000" dirty="0">
-                        <a:latin typeface="Calibri" charset="0"/>
-                        <a:ea typeface="Calibri" charset="0"/>
-                        <a:cs typeface="Calibri" charset="0"/>
-                      </a:endParaRPr>
-                    </a:p>
-                  </a:txBody>
-                  <a:tcPr marL="91440" marR="91440" marT="45720" marB="45720">
-                    <a:lnL w="12700" cap="flat" cmpd="sng" algn="ctr">
-                      <a:solidFill>
-                        <a:srgbClr val="0F3460"/>
-                      </a:solidFill>
-                      <a:prstDash val="solid"/>
-                      <a:round/>
-                      <a:headEnd type="none" w="med" len="med"/>
-                      <a:tailEnd type="none" w="med" len="med"/>
-                    </a:lnL>
-                    <a:lnR w="12700" cap="flat" cmpd="sng" algn="ctr">
-                      <a:solidFill>
-                        <a:srgbClr val="0F3460"/>
-                      </a:solidFill>
-                      <a:prstDash val="solid"/>
-                      <a:round/>
-                      <a:headEnd type="none" w="med" len="med"/>
-                      <a:tailEnd type="none" w="med" len="med"/>
-                    </a:lnR>
-                    <a:lnT w="12700" cap="flat" cmpd="sng" algn="ctr">
-                      <a:solidFill>
-                        <a:srgbClr val="0F3460"/>
-                      </a:solidFill>
-                      <a:prstDash val="solid"/>
-                      <a:round/>
-                      <a:headEnd type="none" w="med" len="med"/>
-                      <a:tailEnd type="none" w="med" len="med"/>
-                    </a:lnT>
-                    <a:lnB w="12700" cap="flat" cmpd="sng" algn="ctr">
-                      <a:solidFill>
-                        <a:srgbClr val="0F3460"/>
-                      </a:solidFill>
-                      <a:prstDash val="solid"/>
-                      <a:round/>
-                      <a:headEnd type="none" w="med" len="med"/>
-                      <a:tailEnd type="none" w="med" len="med"/>
-                    </a:lnB>
-                    <a:solidFill>
-                      <a:srgbClr val="1A1A2E"/>
-                    </a:solidFill>
-                  </a:tcPr>
-                </a:tc>
-                <a:tc>
-                  <a:txBody>
-                    <a:bodyPr/>
-                    <a:lstStyle/>
-                    <a:p>
-                      <a:pPr algn="ctr" indent="0" marL="0">
-                        <a:buNone/>
-                      </a:pPr>
-                      <a:r>
-                        <a:rPr lang="en-US" sz="1000" b="1" dirty="0">
-                          <a:solidFill>
-                            <a:srgbClr val="22C55E"/>
-                          </a:solidFill>
-                          <a:latin typeface="Calibri" pitchFamily="34" charset="0"/>
-                          <a:ea typeface="Calibri" pitchFamily="34" charset="-122"/>
-                          <a:cs typeface="Calibri" pitchFamily="34" charset="-120"/>
-                        </a:rPr>
-                        <a:t>~€260</a:t>
-                      </a:r>
-                      <a:endParaRPr lang="en-US" sz="1000" dirty="0">
-                        <a:latin typeface="Calibri" charset="0"/>
-                        <a:ea typeface="Calibri" charset="0"/>
-                        <a:cs typeface="Calibri" charset="0"/>
-                      </a:endParaRPr>
-                    </a:p>
-                  </a:txBody>
-                  <a:tcPr marL="91440" marR="91440" marT="45720" marB="45720">
-                    <a:lnL w="12700" cap="flat" cmpd="sng" algn="ctr">
-                      <a:solidFill>
-                        <a:srgbClr val="0F3460"/>
-                      </a:solidFill>
-                      <a:prstDash val="solid"/>
-                      <a:round/>
-                      <a:headEnd type="none" w="med" len="med"/>
-                      <a:tailEnd type="none" w="med" len="med"/>
-                    </a:lnL>
-                    <a:lnR w="12700" cap="flat" cmpd="sng" algn="ctr">
-                      <a:solidFill>
-                        <a:srgbClr val="0F3460"/>
-                      </a:solidFill>
-                      <a:prstDash val="solid"/>
-                      <a:round/>
-                      <a:headEnd type="none" w="med" len="med"/>
-                      <a:tailEnd type="none" w="med" len="med"/>
-                    </a:lnR>
-                    <a:lnT w="12700" cap="flat" cmpd="sng" algn="ctr">
-                      <a:solidFill>
-                        <a:srgbClr val="0F3460"/>
-                      </a:solidFill>
-                      <a:prstDash val="solid"/>
-                      <a:round/>
-                      <a:headEnd type="none" w="med" len="med"/>
-                      <a:tailEnd type="none" w="med" len="med"/>
-                    </a:lnT>
-                    <a:lnB w="12700" cap="flat" cmpd="sng" algn="ctr">
-                      <a:solidFill>
-                        <a:srgbClr val="0F3460"/>
-                      </a:solidFill>
-                      <a:prstDash val="solid"/>
-                      <a:round/>
-                      <a:headEnd type="none" w="med" len="med"/>
-                      <a:tailEnd type="none" w="med" len="med"/>
-                    </a:lnB>
-                    <a:solidFill>
-                      <a:srgbClr val="1A1A2E"/>
-                    </a:solidFill>
-                  </a:tcPr>
-                </a:tc>
-              </a:tr>
-              <a:tr h="475488">
-                <a:tc>
-                  <a:txBody>
-                    <a:bodyPr/>
-                    <a:lstStyle/>
-                    <a:p>
-                      <a:pPr algn="ctr" indent="0" marL="0">
-                        <a:buNone/>
-                      </a:pPr>
-                      <a:r>
-                        <a:rPr lang="en-US" sz="1000" dirty="0">
-                          <a:solidFill>
-                            <a:srgbClr val="E8E8E8"/>
-                          </a:solidFill>
-                          <a:latin typeface="Calibri" pitchFamily="34" charset="0"/>
-                          <a:ea typeface="Calibri" pitchFamily="34" charset="-122"/>
-                          <a:cs typeface="Calibri" pitchFamily="34" charset="-120"/>
-                        </a:rPr>
-                        <a:t>Alt: DUS</a:t>
-                      </a:r>
-                      <a:endParaRPr lang="en-US" sz="1000" dirty="0">
-                        <a:latin typeface="Calibri" charset="0"/>
-                        <a:ea typeface="Calibri" charset="0"/>
-                        <a:cs typeface="Calibri" charset="0"/>
-                      </a:endParaRPr>
-                    </a:p>
-                  </a:txBody>
-                  <a:tcPr marL="91440" marR="91440" marT="45720" marB="45720">
-                    <a:lnL w="12700" cap="flat" cmpd="sng" algn="ctr">
-                      <a:solidFill>
-                        <a:srgbClr val="0F3460"/>
-                      </a:solidFill>
-                      <a:prstDash val="solid"/>
-                      <a:round/>
-                      <a:headEnd type="none" w="med" len="med"/>
-                      <a:tailEnd type="none" w="med" len="med"/>
-                    </a:lnL>
-                    <a:lnR w="12700" cap="flat" cmpd="sng" algn="ctr">
-                      <a:solidFill>
-                        <a:srgbClr val="0F3460"/>
-                      </a:solidFill>
-                      <a:prstDash val="solid"/>
-                      <a:round/>
-                      <a:headEnd type="none" w="med" len="med"/>
-                      <a:tailEnd type="none" w="med" len="med"/>
-                    </a:lnR>
-                    <a:lnT w="12700" cap="flat" cmpd="sng" algn="ctr">
-                      <a:solidFill>
-                        <a:srgbClr val="0F3460"/>
-                      </a:solidFill>
-                      <a:prstDash val="solid"/>
-                      <a:round/>
-                      <a:headEnd type="none" w="med" len="med"/>
-                      <a:tailEnd type="none" w="med" len="med"/>
-                    </a:lnT>
-                    <a:lnB w="12700" cap="flat" cmpd="sng" algn="ctr">
-                      <a:solidFill>
-                        <a:srgbClr val="0F3460"/>
-                      </a:solidFill>
-                      <a:prstDash val="solid"/>
-                      <a:round/>
-                      <a:headEnd type="none" w="med" len="med"/>
-                      <a:tailEnd type="none" w="med" len="med"/>
-                    </a:lnB>
-                    <a:solidFill>
-                      <a:srgbClr val="16213E"/>
-                    </a:solidFill>
-                  </a:tcPr>
-                </a:tc>
-                <a:tc>
-                  <a:txBody>
-                    <a:bodyPr/>
-                    <a:lstStyle/>
-                    <a:p>
-                      <a:pPr algn="ctr" indent="0" marL="0">
-                        <a:buNone/>
-                      </a:pPr>
-                      <a:r>
-                        <a:rPr lang="en-US" sz="1000" dirty="0">
-                          <a:solidFill>
-                            <a:srgbClr val="E8E8E8"/>
-                          </a:solidFill>
-                          <a:latin typeface="Calibri" pitchFamily="34" charset="0"/>
-                          <a:ea typeface="Calibri" pitchFamily="34" charset="-122"/>
-                          <a:cs typeface="Calibri" pitchFamily="34" charset="-120"/>
-                        </a:rPr>
-                        <a:t>EW9784</a:t>
-                      </a:r>
-                      <a:endParaRPr lang="en-US" sz="1000" dirty="0">
-                        <a:latin typeface="Calibri" charset="0"/>
-                        <a:ea typeface="Calibri" charset="0"/>
-                        <a:cs typeface="Calibri" charset="0"/>
-                      </a:endParaRPr>
-                    </a:p>
-                    <a:p>
-                      <a:pPr algn="ctr" indent="0" marL="0">
-                        <a:buNone/>
-                      </a:pPr>
-                      <a:r>
-                        <a:rPr lang="en-US" sz="1000" dirty="0">
-                          <a:solidFill>
-                            <a:srgbClr val="E8E8E8"/>
-                          </a:solidFill>
-                          <a:latin typeface="Calibri" pitchFamily="34" charset="0"/>
-                          <a:ea typeface="Calibri" pitchFamily="34" charset="-122"/>
-                          <a:cs typeface="Calibri" pitchFamily="34" charset="-120"/>
-                        </a:rPr>
-                        <a:t>Eurowings</a:t>
-                      </a:r>
-                      <a:endParaRPr lang="en-US" sz="1000" dirty="0">
-                        <a:latin typeface="Calibri" charset="0"/>
-                        <a:ea typeface="Calibri" charset="0"/>
-                        <a:cs typeface="Calibri" charset="0"/>
-                      </a:endParaRPr>
-                    </a:p>
-                  </a:txBody>
-                  <a:tcPr marL="91440" marR="91440" marT="45720" marB="45720">
-                    <a:lnL w="12700" cap="flat" cmpd="sng" algn="ctr">
-                      <a:solidFill>
-                        <a:srgbClr val="0F3460"/>
-                      </a:solidFill>
-                      <a:prstDash val="solid"/>
-                      <a:round/>
-                      <a:headEnd type="none" w="med" len="med"/>
-                      <a:tailEnd type="none" w="med" len="med"/>
-                    </a:lnL>
-                    <a:lnR w="12700" cap="flat" cmpd="sng" algn="ctr">
-                      <a:solidFill>
-                        <a:srgbClr val="0F3460"/>
-                      </a:solidFill>
-                      <a:prstDash val="solid"/>
-                      <a:round/>
-                      <a:headEnd type="none" w="med" len="med"/>
-                      <a:tailEnd type="none" w="med" len="med"/>
-                    </a:lnR>
-                    <a:lnT w="12700" cap="flat" cmpd="sng" algn="ctr">
-                      <a:solidFill>
-                        <a:srgbClr val="0F3460"/>
-                      </a:solidFill>
-                      <a:prstDash val="solid"/>
-                      <a:round/>
-                      <a:headEnd type="none" w="med" len="med"/>
-                      <a:tailEnd type="none" w="med" len="med"/>
-                    </a:lnT>
-                    <a:lnB w="12700" cap="flat" cmpd="sng" algn="ctr">
-                      <a:solidFill>
-                        <a:srgbClr val="0F3460"/>
-                      </a:solidFill>
-                      <a:prstDash val="solid"/>
-                      <a:round/>
-                      <a:headEnd type="none" w="med" len="med"/>
-                      <a:tailEnd type="none" w="med" len="med"/>
-                    </a:lnB>
-                    <a:solidFill>
-                      <a:srgbClr val="16213E"/>
-                    </a:solidFill>
-                  </a:tcPr>
-                </a:tc>
-                <a:tc>
-                  <a:txBody>
-                    <a:bodyPr/>
-                    <a:lstStyle/>
-                    <a:p>
-                      <a:pPr algn="ctr" indent="0" marL="0">
-                        <a:buNone/>
-                      </a:pPr>
-                      <a:r>
-                        <a:rPr lang="en-US" sz="1000" dirty="0">
-                          <a:solidFill>
-                            <a:srgbClr val="E8E8E8"/>
-                          </a:solidFill>
-                          <a:latin typeface="Calibri" pitchFamily="34" charset="0"/>
-                          <a:ea typeface="Calibri" pitchFamily="34" charset="-122"/>
-                          <a:cs typeface="Calibri" pitchFamily="34" charset="-120"/>
-                        </a:rPr>
-                        <a:t>DUS → BUD</a:t>
-                      </a:r>
-                      <a:endParaRPr lang="en-US" sz="1000" dirty="0">
-                        <a:latin typeface="Calibri" charset="0"/>
-                        <a:ea typeface="Calibri" charset="0"/>
-                        <a:cs typeface="Calibri" charset="0"/>
-                      </a:endParaRPr>
-                    </a:p>
-                    <a:p>
-                      <a:pPr algn="ctr" indent="0" marL="0">
-                        <a:buNone/>
-                      </a:pPr>
-                      <a:r>
-                        <a:rPr lang="en-US" sz="1000" dirty="0">
-                          <a:solidFill>
-                            <a:srgbClr val="E8E8E8"/>
-                          </a:solidFill>
-                          <a:latin typeface="Calibri" pitchFamily="34" charset="0"/>
-                          <a:ea typeface="Calibri" pitchFamily="34" charset="-122"/>
-                          <a:cs typeface="Calibri" pitchFamily="34" charset="-120"/>
-                        </a:rPr>
-                        <a:t>Oct 29 evening</a:t>
-                      </a:r>
-                      <a:endParaRPr lang="en-US" sz="1000" dirty="0">
-                        <a:latin typeface="Calibri" charset="0"/>
-                        <a:ea typeface="Calibri" charset="0"/>
-                        <a:cs typeface="Calibri" charset="0"/>
-                      </a:endParaRPr>
-                    </a:p>
-                  </a:txBody>
-                  <a:tcPr marL="91440" marR="91440" marT="45720" marB="45720">
-                    <a:lnL w="12700" cap="flat" cmpd="sng" algn="ctr">
-                      <a:solidFill>
-                        <a:srgbClr val="0F3460"/>
-                      </a:solidFill>
-                      <a:prstDash val="solid"/>
-                      <a:round/>
-                      <a:headEnd type="none" w="med" len="med"/>
-                      <a:tailEnd type="none" w="med" len="med"/>
-                    </a:lnL>
-                    <a:lnR w="12700" cap="flat" cmpd="sng" algn="ctr">
-                      <a:solidFill>
-                        <a:srgbClr val="0F3460"/>
-                      </a:solidFill>
-                      <a:prstDash val="solid"/>
-                      <a:round/>
-                      <a:headEnd type="none" w="med" len="med"/>
-                      <a:tailEnd type="none" w="med" len="med"/>
-                    </a:lnR>
-                    <a:lnT w="12700" cap="flat" cmpd="sng" algn="ctr">
-                      <a:solidFill>
-                        <a:srgbClr val="0F3460"/>
-                      </a:solidFill>
-                      <a:prstDash val="solid"/>
-                      <a:round/>
-                      <a:headEnd type="none" w="med" len="med"/>
-                      <a:tailEnd type="none" w="med" len="med"/>
-                    </a:lnT>
-                    <a:lnB w="12700" cap="flat" cmpd="sng" algn="ctr">
-                      <a:solidFill>
-                        <a:srgbClr val="0F3460"/>
-                      </a:solidFill>
-                      <a:prstDash val="solid"/>
-                      <a:round/>
-                      <a:headEnd type="none" w="med" len="med"/>
-                      <a:tailEnd type="none" w="med" len="med"/>
-                    </a:lnB>
-                    <a:solidFill>
-                      <a:srgbClr val="16213E"/>
-                    </a:solidFill>
-                  </a:tcPr>
-                </a:tc>
-                <a:tc>
-                  <a:txBody>
-                    <a:bodyPr/>
-                    <a:lstStyle/>
-                    <a:p>
-                      <a:pPr algn="ctr" indent="0" marL="0">
-                        <a:buNone/>
-                      </a:pPr>
-                      <a:r>
-                        <a:rPr lang="en-US" sz="1000" dirty="0">
-                          <a:solidFill>
-                            <a:srgbClr val="E8E8E8"/>
-                          </a:solidFill>
-                          <a:latin typeface="Calibri" pitchFamily="34" charset="0"/>
-                          <a:ea typeface="Calibri" pitchFamily="34" charset="-122"/>
-                          <a:cs typeface="Calibri" pitchFamily="34" charset="-120"/>
-                        </a:rPr>
-                        <a:t>17:45</a:t>
-                      </a:r>
-                      <a:endParaRPr lang="en-US" sz="1000" dirty="0">
-                        <a:latin typeface="Calibri" charset="0"/>
-                        <a:ea typeface="Calibri" charset="0"/>
-                        <a:cs typeface="Calibri" charset="0"/>
-                      </a:endParaRPr>
-                    </a:p>
-                  </a:txBody>
-                  <a:tcPr marL="91440" marR="91440" marT="45720" marB="45720">
-                    <a:lnL w="12700" cap="flat" cmpd="sng" algn="ctr">
-                      <a:solidFill>
-                        <a:srgbClr val="0F3460"/>
-                      </a:solidFill>
-                      <a:prstDash val="solid"/>
-                      <a:round/>
-                      <a:headEnd type="none" w="med" len="med"/>
-                      <a:tailEnd type="none" w="med" len="med"/>
-                    </a:lnL>
-                    <a:lnR w="12700" cap="flat" cmpd="sng" algn="ctr">
-                      <a:solidFill>
-                        <a:srgbClr val="0F3460"/>
-                      </a:solidFill>
-                      <a:prstDash val="solid"/>
-                      <a:round/>
-                      <a:headEnd type="none" w="med" len="med"/>
-                      <a:tailEnd type="none" w="med" len="med"/>
-                    </a:lnR>
-                    <a:lnT w="12700" cap="flat" cmpd="sng" algn="ctr">
-                      <a:solidFill>
-                        <a:srgbClr val="0F3460"/>
-                      </a:solidFill>
-                      <a:prstDash val="solid"/>
-                      <a:round/>
-                      <a:headEnd type="none" w="med" len="med"/>
-                      <a:tailEnd type="none" w="med" len="med"/>
-                    </a:lnT>
-                    <a:lnB w="12700" cap="flat" cmpd="sng" algn="ctr">
-                      <a:solidFill>
-                        <a:srgbClr val="0F3460"/>
-                      </a:solidFill>
-                      <a:prstDash val="solid"/>
-                      <a:round/>
-                      <a:headEnd type="none" w="med" len="med"/>
-                      <a:tailEnd type="none" w="med" len="med"/>
-                    </a:lnB>
-                    <a:solidFill>
-                      <a:srgbClr val="16213E"/>
-                    </a:solidFill>
-                  </a:tcPr>
-                </a:tc>
-                <a:tc>
-                  <a:txBody>
-                    <a:bodyPr/>
-                    <a:lstStyle/>
-                    <a:p>
-                      <a:pPr algn="ctr" indent="0" marL="0">
-                        <a:buNone/>
-                      </a:pPr>
-                      <a:r>
-                        <a:rPr lang="en-US" sz="1000" dirty="0">
-                          <a:solidFill>
-                            <a:srgbClr val="E8E8E8"/>
-                          </a:solidFill>
-                          <a:latin typeface="Calibri" pitchFamily="34" charset="0"/>
-                          <a:ea typeface="Calibri" pitchFamily="34" charset="-122"/>
-                          <a:cs typeface="Calibri" pitchFamily="34" charset="-120"/>
-                        </a:rPr>
-                        <a:t>19:30</a:t>
-                      </a:r>
-                      <a:endParaRPr lang="en-US" sz="1000" dirty="0">
-                        <a:latin typeface="Calibri" charset="0"/>
-                        <a:ea typeface="Calibri" charset="0"/>
-                        <a:cs typeface="Calibri" charset="0"/>
-                      </a:endParaRPr>
-                    </a:p>
-                  </a:txBody>
-                  <a:tcPr marL="91440" marR="91440" marT="45720" marB="45720">
-                    <a:lnL w="12700" cap="flat" cmpd="sng" algn="ctr">
-                      <a:solidFill>
-                        <a:srgbClr val="0F3460"/>
-                      </a:solidFill>
-                      <a:prstDash val="solid"/>
-                      <a:round/>
-                      <a:headEnd type="none" w="med" len="med"/>
-                      <a:tailEnd type="none" w="med" len="med"/>
-                    </a:lnL>
-                    <a:lnR w="12700" cap="flat" cmpd="sng" algn="ctr">
-                      <a:solidFill>
-                        <a:srgbClr val="0F3460"/>
-                      </a:solidFill>
-                      <a:prstDash val="solid"/>
-                      <a:round/>
-                      <a:headEnd type="none" w="med" len="med"/>
-                      <a:tailEnd type="none" w="med" len="med"/>
-                    </a:lnR>
-                    <a:lnT w="12700" cap="flat" cmpd="sng" algn="ctr">
-                      <a:solidFill>
-                        <a:srgbClr val="0F3460"/>
-                      </a:solidFill>
-                      <a:prstDash val="solid"/>
-                      <a:round/>
-                      <a:headEnd type="none" w="med" len="med"/>
-                      <a:tailEnd type="none" w="med" len="med"/>
-                    </a:lnT>
-                    <a:lnB w="12700" cap="flat" cmpd="sng" algn="ctr">
-                      <a:solidFill>
-                        <a:srgbClr val="0F3460"/>
-                      </a:solidFill>
-                      <a:prstDash val="solid"/>
-                      <a:round/>
-                      <a:headEnd type="none" w="med" len="med"/>
-                      <a:tailEnd type="none" w="med" len="med"/>
-                    </a:lnB>
-                    <a:solidFill>
-                      <a:srgbClr val="16213E"/>
-                    </a:solidFill>
-                  </a:tcPr>
-                </a:tc>
-                <a:tc>
-                  <a:txBody>
-                    <a:bodyPr/>
-                    <a:lstStyle/>
-                    <a:p>
-                      <a:pPr algn="ctr" indent="0" marL="0">
-                        <a:buNone/>
-                      </a:pPr>
-                      <a:r>
-                        <a:rPr lang="en-US" sz="1000" dirty="0">
-                          <a:solidFill>
-                            <a:srgbClr val="E8E8E8"/>
-                          </a:solidFill>
-                          <a:latin typeface="Calibri" pitchFamily="34" charset="0"/>
-                          <a:ea typeface="Calibri" pitchFamily="34" charset="-122"/>
-                          <a:cs typeface="Calibri" pitchFamily="34" charset="-120"/>
-                        </a:rPr>
-                        <a:t>1h 50m</a:t>
-                      </a:r>
-                      <a:endParaRPr lang="en-US" sz="1000" dirty="0">
-                        <a:latin typeface="Calibri" charset="0"/>
-                        <a:ea typeface="Calibri" charset="0"/>
-                        <a:cs typeface="Calibri" charset="0"/>
-                      </a:endParaRPr>
-                    </a:p>
-                  </a:txBody>
-                  <a:tcPr marL="91440" marR="91440" marT="45720" marB="45720">
-                    <a:lnL w="12700" cap="flat" cmpd="sng" algn="ctr">
-                      <a:solidFill>
-                        <a:srgbClr val="0F3460"/>
-                      </a:solidFill>
-                      <a:prstDash val="solid"/>
-                      <a:round/>
-                      <a:headEnd type="none" w="med" len="med"/>
-                      <a:tailEnd type="none" w="med" len="med"/>
-                    </a:lnL>
-                    <a:lnR w="12700" cap="flat" cmpd="sng" algn="ctr">
-                      <a:solidFill>
-                        <a:srgbClr val="0F3460"/>
-                      </a:solidFill>
-                      <a:prstDash val="solid"/>
-                      <a:round/>
-                      <a:headEnd type="none" w="med" len="med"/>
-                      <a:tailEnd type="none" w="med" len="med"/>
-                    </a:lnR>
-                    <a:lnT w="12700" cap="flat" cmpd="sng" algn="ctr">
-                      <a:solidFill>
-                        <a:srgbClr val="0F3460"/>
-                      </a:solidFill>
-                      <a:prstDash val="solid"/>
-                      <a:round/>
-                      <a:headEnd type="none" w="med" len="med"/>
-                      <a:tailEnd type="none" w="med" len="med"/>
-                    </a:lnT>
-                    <a:lnB w="12700" cap="flat" cmpd="sng" algn="ctr">
-                      <a:solidFill>
-                        <a:srgbClr val="0F3460"/>
-                      </a:solidFill>
-                      <a:prstDash val="solid"/>
-                      <a:round/>
-                      <a:headEnd type="none" w="med" len="med"/>
-                      <a:tailEnd type="none" w="med" len="med"/>
-                    </a:lnB>
-                    <a:solidFill>
-                      <a:srgbClr val="16213E"/>
-                    </a:solidFill>
-                  </a:tcPr>
-                </a:tc>
-                <a:tc>
-                  <a:txBody>
-                    <a:bodyPr/>
-                    <a:lstStyle/>
-                    <a:p>
-                      <a:pPr algn="ctr" indent="0" marL="0">
-                        <a:buNone/>
-                      </a:pPr>
-                      <a:r>
-                        <a:rPr lang="en-US" sz="1000" dirty="0">
-                          <a:solidFill>
-                            <a:srgbClr val="E8E8E8"/>
-                          </a:solidFill>
-                          <a:latin typeface="Calibri" pitchFamily="34" charset="0"/>
-                          <a:ea typeface="Calibri" pitchFamily="34" charset="-122"/>
-                          <a:cs typeface="Calibri" pitchFamily="34" charset="-120"/>
-                        </a:rPr>
-                        <a:t>~€80</a:t>
-                      </a:r>
-                      <a:endParaRPr lang="en-US" sz="1000" dirty="0">
-                        <a:latin typeface="Calibri" charset="0"/>
-                        <a:ea typeface="Calibri" charset="0"/>
-                        <a:cs typeface="Calibri" charset="0"/>
-                      </a:endParaRPr>
-                    </a:p>
-                  </a:txBody>
-                  <a:tcPr marL="91440" marR="91440" marT="45720" marB="45720">
-                    <a:lnL w="12700" cap="flat" cmpd="sng" algn="ctr">
-                      <a:solidFill>
-                        <a:srgbClr val="0F3460"/>
-                      </a:solidFill>
-                      <a:prstDash val="solid"/>
-                      <a:round/>
-                      <a:headEnd type="none" w="med" len="med"/>
-                      <a:tailEnd type="none" w="med" len="med"/>
-                    </a:lnL>
-                    <a:lnR w="12700" cap="flat" cmpd="sng" algn="ctr">
-                      <a:solidFill>
-                        <a:srgbClr val="0F3460"/>
-                      </a:solidFill>
-                      <a:prstDash val="solid"/>
-                      <a:round/>
-                      <a:headEnd type="none" w="med" len="med"/>
-                      <a:tailEnd type="none" w="med" len="med"/>
-                    </a:lnR>
-                    <a:lnT w="12700" cap="flat" cmpd="sng" algn="ctr">
-                      <a:solidFill>
-                        <a:srgbClr val="0F3460"/>
-                      </a:solidFill>
-                      <a:prstDash val="solid"/>
-                      <a:round/>
-                      <a:headEnd type="none" w="med" len="med"/>
-                      <a:tailEnd type="none" w="med" len="med"/>
-                    </a:lnT>
-                    <a:lnB w="12700" cap="flat" cmpd="sng" algn="ctr">
-                      <a:solidFill>
-                        <a:srgbClr val="0F3460"/>
-                      </a:solidFill>
-                      <a:prstDash val="solid"/>
-                      <a:round/>
-                      <a:headEnd type="none" w="med" len="med"/>
-                      <a:tailEnd type="none" w="med" len="med"/>
-                    </a:lnB>
-                    <a:solidFill>
-                      <a:srgbClr val="16213E"/>
-                    </a:solidFill>
-                  </a:tcPr>
-                </a:tc>
-                <a:tc>
-                  <a:txBody>
-                    <a:bodyPr/>
-                    <a:lstStyle/>
-                    <a:p>
-                      <a:pPr algn="ctr" indent="0" marL="0">
-                        <a:buNone/>
-                      </a:pPr>
-                      <a:r>
-                        <a:rPr lang="en-US" sz="1000" b="1" dirty="0">
-                          <a:solidFill>
-                            <a:srgbClr val="FFC107"/>
-                          </a:solidFill>
-                          <a:latin typeface="Calibri" pitchFamily="34" charset="0"/>
-                          <a:ea typeface="Calibri" pitchFamily="34" charset="-122"/>
-                          <a:cs typeface="Calibri" pitchFamily="34" charset="-120"/>
-                        </a:rPr>
-                        <a:t>~€320</a:t>
-                      </a:r>
-                      <a:endParaRPr lang="en-US" sz="1000" dirty="0">
-                        <a:latin typeface="Calibri" charset="0"/>
-                        <a:ea typeface="Calibri" charset="0"/>
-                        <a:cs typeface="Calibri" charset="0"/>
-                      </a:endParaRPr>
-                    </a:p>
-                  </a:txBody>
-                  <a:tcPr marL="91440" marR="91440" marT="45720" marB="45720">
-                    <a:lnL w="12700" cap="flat" cmpd="sng" algn="ctr">
-                      <a:solidFill>
-                        <a:srgbClr val="0F3460"/>
-                      </a:solidFill>
-                      <a:prstDash val="solid"/>
-                      <a:round/>
-                      <a:headEnd type="none" w="med" len="med"/>
-                      <a:tailEnd type="none" w="med" len="med"/>
-                    </a:lnL>
-                    <a:lnR w="12700" cap="flat" cmpd="sng" algn="ctr">
-                      <a:solidFill>
-                        <a:srgbClr val="0F3460"/>
-                      </a:solidFill>
-                      <a:prstDash val="solid"/>
-                      <a:round/>
-                      <a:headEnd type="none" w="med" len="med"/>
-                      <a:tailEnd type="none" w="med" len="med"/>
-                    </a:lnR>
-                    <a:lnT w="12700" cap="flat" cmpd="sng" algn="ctr">
-                      <a:solidFill>
-                        <a:srgbClr val="0F3460"/>
-                      </a:solidFill>
-                      <a:prstDash val="solid"/>
-                      <a:round/>
-                      <a:headEnd type="none" w="med" len="med"/>
-                      <a:tailEnd type="none" w="med" len="med"/>
-                    </a:lnT>
-                    <a:lnB w="12700" cap="flat" cmpd="sng" algn="ctr">
-                      <a:solidFill>
-                        <a:srgbClr val="0F3460"/>
-                      </a:solidFill>
-                      <a:prstDash val="solid"/>
-                      <a:round/>
-                      <a:headEnd type="none" w="med" len="med"/>
-                      <a:tailEnd type="none" w="med" len="med"/>
-                    </a:lnB>
-                    <a:solidFill>
-                      <a:srgbClr val="16213E"/>
-                    </a:solidFill>
-                  </a:tcPr>
-                </a:tc>
-              </a:tr>
-              <a:tr h="475488">
-                <a:tc>
-                  <a:txBody>
-                    <a:bodyPr/>
-                    <a:lstStyle/>
-                    <a:p>
-                      <a:pPr algn="ctr" indent="0" marL="0">
-                        <a:buNone/>
-                      </a:pPr>
-                      <a:r>
-                        <a:rPr lang="en-US" sz="1000" dirty="0">
-                          <a:solidFill>
-                            <a:srgbClr val="E8E8E8"/>
-                          </a:solidFill>
-                          <a:latin typeface="Calibri" pitchFamily="34" charset="0"/>
-                          <a:ea typeface="Calibri" pitchFamily="34" charset="-122"/>
-                          <a:cs typeface="Calibri" pitchFamily="34" charset="-120"/>
-                        </a:rPr>
-                        <a:t>Early DUS</a:t>
+                        <a:t>€100–130</a:t>
                       </a:r>
                       <a:endParaRPr lang="en-US" sz="1000" dirty="0">
                         <a:latin typeface="Calibri" charset="0"/>
@@ -25448,457 +25642,7 @@
                           <a:ea typeface="Calibri" pitchFamily="34" charset="-122"/>
                           <a:cs typeface="Calibri" pitchFamily="34" charset="-120"/>
                         </a:rPr>
-                        <a:t>EW9782</a:t>
-                      </a:r>
-                      <a:endParaRPr lang="en-US" sz="1000" dirty="0">
-                        <a:latin typeface="Calibri" charset="0"/>
-                        <a:ea typeface="Calibri" charset="0"/>
-                        <a:cs typeface="Calibri" charset="0"/>
-                      </a:endParaRPr>
-                    </a:p>
-                    <a:p>
-                      <a:pPr algn="ctr" indent="0" marL="0">
-                        <a:buNone/>
-                      </a:pPr>
-                      <a:r>
-                        <a:rPr lang="en-US" sz="1000" dirty="0">
-                          <a:solidFill>
-                            <a:srgbClr val="E8E8E8"/>
-                          </a:solidFill>
-                          <a:latin typeface="Calibri" pitchFamily="34" charset="0"/>
-                          <a:ea typeface="Calibri" pitchFamily="34" charset="-122"/>
-                          <a:cs typeface="Calibri" pitchFamily="34" charset="-120"/>
-                        </a:rPr>
-                        <a:t>Eurowings</a:t>
-                      </a:r>
-                      <a:endParaRPr lang="en-US" sz="1000" dirty="0">
-                        <a:latin typeface="Calibri" charset="0"/>
-                        <a:ea typeface="Calibri" charset="0"/>
-                        <a:cs typeface="Calibri" charset="0"/>
-                      </a:endParaRPr>
-                    </a:p>
-                  </a:txBody>
-                  <a:tcPr marL="91440" marR="91440" marT="45720" marB="45720">
-                    <a:lnL w="12700" cap="flat" cmpd="sng" algn="ctr">
-                      <a:solidFill>
-                        <a:srgbClr val="0F3460"/>
-                      </a:solidFill>
-                      <a:prstDash val="solid"/>
-                      <a:round/>
-                      <a:headEnd type="none" w="med" len="med"/>
-                      <a:tailEnd type="none" w="med" len="med"/>
-                    </a:lnL>
-                    <a:lnR w="12700" cap="flat" cmpd="sng" algn="ctr">
-                      <a:solidFill>
-                        <a:srgbClr val="0F3460"/>
-                      </a:solidFill>
-                      <a:prstDash val="solid"/>
-                      <a:round/>
-                      <a:headEnd type="none" w="med" len="med"/>
-                      <a:tailEnd type="none" w="med" len="med"/>
-                    </a:lnR>
-                    <a:lnT w="12700" cap="flat" cmpd="sng" algn="ctr">
-                      <a:solidFill>
-                        <a:srgbClr val="0F3460"/>
-                      </a:solidFill>
-                      <a:prstDash val="solid"/>
-                      <a:round/>
-                      <a:headEnd type="none" w="med" len="med"/>
-                      <a:tailEnd type="none" w="med" len="med"/>
-                    </a:lnT>
-                    <a:lnB w="12700" cap="flat" cmpd="sng" algn="ctr">
-                      <a:solidFill>
-                        <a:srgbClr val="0F3460"/>
-                      </a:solidFill>
-                      <a:prstDash val="solid"/>
-                      <a:round/>
-                      <a:headEnd type="none" w="med" len="med"/>
-                      <a:tailEnd type="none" w="med" len="med"/>
-                    </a:lnB>
-                    <a:solidFill>
-                      <a:srgbClr val="1A1A2E"/>
-                    </a:solidFill>
-                  </a:tcPr>
-                </a:tc>
-                <a:tc>
-                  <a:txBody>
-                    <a:bodyPr/>
-                    <a:lstStyle/>
-                    <a:p>
-                      <a:pPr algn="ctr" indent="0" marL="0">
-                        <a:buNone/>
-                      </a:pPr>
-                      <a:r>
-                        <a:rPr lang="en-US" sz="1000" dirty="0">
-                          <a:solidFill>
-                            <a:srgbClr val="E8E8E8"/>
-                          </a:solidFill>
-                          <a:latin typeface="Calibri" pitchFamily="34" charset="0"/>
-                          <a:ea typeface="Calibri" pitchFamily="34" charset="-122"/>
-                          <a:cs typeface="Calibri" pitchFamily="34" charset="-120"/>
-                        </a:rPr>
-                        <a:t>DUS → BUD</a:t>
-                      </a:r>
-                      <a:endParaRPr lang="en-US" sz="1000" dirty="0">
-                        <a:latin typeface="Calibri" charset="0"/>
-                        <a:ea typeface="Calibri" charset="0"/>
-                        <a:cs typeface="Calibri" charset="0"/>
-                      </a:endParaRPr>
-                    </a:p>
-                    <a:p>
-                      <a:pPr algn="ctr" indent="0" marL="0">
-                        <a:buNone/>
-                      </a:pPr>
-                      <a:r>
-                        <a:rPr lang="en-US" sz="1000" dirty="0">
-                          <a:solidFill>
-                            <a:srgbClr val="E8E8E8"/>
-                          </a:solidFill>
-                          <a:latin typeface="Calibri" pitchFamily="34" charset="0"/>
-                          <a:ea typeface="Calibri" pitchFamily="34" charset="-122"/>
-                          <a:cs typeface="Calibri" pitchFamily="34" charset="-120"/>
-                        </a:rPr>
-                        <a:t>Oct 30 early</a:t>
-                      </a:r>
-                      <a:endParaRPr lang="en-US" sz="1000" dirty="0">
-                        <a:latin typeface="Calibri" charset="0"/>
-                        <a:ea typeface="Calibri" charset="0"/>
-                        <a:cs typeface="Calibri" charset="0"/>
-                      </a:endParaRPr>
-                    </a:p>
-                  </a:txBody>
-                  <a:tcPr marL="91440" marR="91440" marT="45720" marB="45720">
-                    <a:lnL w="12700" cap="flat" cmpd="sng" algn="ctr">
-                      <a:solidFill>
-                        <a:srgbClr val="0F3460"/>
-                      </a:solidFill>
-                      <a:prstDash val="solid"/>
-                      <a:round/>
-                      <a:headEnd type="none" w="med" len="med"/>
-                      <a:tailEnd type="none" w="med" len="med"/>
-                    </a:lnL>
-                    <a:lnR w="12700" cap="flat" cmpd="sng" algn="ctr">
-                      <a:solidFill>
-                        <a:srgbClr val="0F3460"/>
-                      </a:solidFill>
-                      <a:prstDash val="solid"/>
-                      <a:round/>
-                      <a:headEnd type="none" w="med" len="med"/>
-                      <a:tailEnd type="none" w="med" len="med"/>
-                    </a:lnR>
-                    <a:lnT w="12700" cap="flat" cmpd="sng" algn="ctr">
-                      <a:solidFill>
-                        <a:srgbClr val="0F3460"/>
-                      </a:solidFill>
-                      <a:prstDash val="solid"/>
-                      <a:round/>
-                      <a:headEnd type="none" w="med" len="med"/>
-                      <a:tailEnd type="none" w="med" len="med"/>
-                    </a:lnT>
-                    <a:lnB w="12700" cap="flat" cmpd="sng" algn="ctr">
-                      <a:solidFill>
-                        <a:srgbClr val="0F3460"/>
-                      </a:solidFill>
-                      <a:prstDash val="solid"/>
-                      <a:round/>
-                      <a:headEnd type="none" w="med" len="med"/>
-                      <a:tailEnd type="none" w="med" len="med"/>
-                    </a:lnB>
-                    <a:solidFill>
-                      <a:srgbClr val="1A1A2E"/>
-                    </a:solidFill>
-                  </a:tcPr>
-                </a:tc>
-                <a:tc>
-                  <a:txBody>
-                    <a:bodyPr/>
-                    <a:lstStyle/>
-                    <a:p>
-                      <a:pPr algn="ctr" indent="0" marL="0">
-                        <a:buNone/>
-                      </a:pPr>
-                      <a:r>
-                        <a:rPr lang="en-US" sz="1000" dirty="0">
-                          <a:solidFill>
-                            <a:srgbClr val="E8E8E8"/>
-                          </a:solidFill>
-                          <a:latin typeface="Calibri" pitchFamily="34" charset="0"/>
-                          <a:ea typeface="Calibri" pitchFamily="34" charset="-122"/>
-                          <a:cs typeface="Calibri" pitchFamily="34" charset="-120"/>
-                        </a:rPr>
-                        <a:t>06:35</a:t>
-                      </a:r>
-                      <a:endParaRPr lang="en-US" sz="1000" dirty="0">
-                        <a:latin typeface="Calibri" charset="0"/>
-                        <a:ea typeface="Calibri" charset="0"/>
-                        <a:cs typeface="Calibri" charset="0"/>
-                      </a:endParaRPr>
-                    </a:p>
-                  </a:txBody>
-                  <a:tcPr marL="91440" marR="91440" marT="45720" marB="45720">
-                    <a:lnL w="12700" cap="flat" cmpd="sng" algn="ctr">
-                      <a:solidFill>
-                        <a:srgbClr val="0F3460"/>
-                      </a:solidFill>
-                      <a:prstDash val="solid"/>
-                      <a:round/>
-                      <a:headEnd type="none" w="med" len="med"/>
-                      <a:tailEnd type="none" w="med" len="med"/>
-                    </a:lnL>
-                    <a:lnR w="12700" cap="flat" cmpd="sng" algn="ctr">
-                      <a:solidFill>
-                        <a:srgbClr val="0F3460"/>
-                      </a:solidFill>
-                      <a:prstDash val="solid"/>
-                      <a:round/>
-                      <a:headEnd type="none" w="med" len="med"/>
-                      <a:tailEnd type="none" w="med" len="med"/>
-                    </a:lnR>
-                    <a:lnT w="12700" cap="flat" cmpd="sng" algn="ctr">
-                      <a:solidFill>
-                        <a:srgbClr val="0F3460"/>
-                      </a:solidFill>
-                      <a:prstDash val="solid"/>
-                      <a:round/>
-                      <a:headEnd type="none" w="med" len="med"/>
-                      <a:tailEnd type="none" w="med" len="med"/>
-                    </a:lnT>
-                    <a:lnB w="12700" cap="flat" cmpd="sng" algn="ctr">
-                      <a:solidFill>
-                        <a:srgbClr val="0F3460"/>
-                      </a:solidFill>
-                      <a:prstDash val="solid"/>
-                      <a:round/>
-                      <a:headEnd type="none" w="med" len="med"/>
-                      <a:tailEnd type="none" w="med" len="med"/>
-                    </a:lnB>
-                    <a:solidFill>
-                      <a:srgbClr val="1A1A2E"/>
-                    </a:solidFill>
-                  </a:tcPr>
-                </a:tc>
-                <a:tc>
-                  <a:txBody>
-                    <a:bodyPr/>
-                    <a:lstStyle/>
-                    <a:p>
-                      <a:pPr algn="ctr" indent="0" marL="0">
-                        <a:buNone/>
-                      </a:pPr>
-                      <a:r>
-                        <a:rPr lang="en-US" sz="1000" dirty="0">
-                          <a:solidFill>
-                            <a:srgbClr val="E8E8E8"/>
-                          </a:solidFill>
-                          <a:latin typeface="Calibri" pitchFamily="34" charset="0"/>
-                          <a:ea typeface="Calibri" pitchFamily="34" charset="-122"/>
-                          <a:cs typeface="Calibri" pitchFamily="34" charset="-120"/>
-                        </a:rPr>
-                        <a:t>08:20</a:t>
-                      </a:r>
-                      <a:endParaRPr lang="en-US" sz="1000" dirty="0">
-                        <a:latin typeface="Calibri" charset="0"/>
-                        <a:ea typeface="Calibri" charset="0"/>
-                        <a:cs typeface="Calibri" charset="0"/>
-                      </a:endParaRPr>
-                    </a:p>
-                  </a:txBody>
-                  <a:tcPr marL="91440" marR="91440" marT="45720" marB="45720">
-                    <a:lnL w="12700" cap="flat" cmpd="sng" algn="ctr">
-                      <a:solidFill>
-                        <a:srgbClr val="0F3460"/>
-                      </a:solidFill>
-                      <a:prstDash val="solid"/>
-                      <a:round/>
-                      <a:headEnd type="none" w="med" len="med"/>
-                      <a:tailEnd type="none" w="med" len="med"/>
-                    </a:lnL>
-                    <a:lnR w="12700" cap="flat" cmpd="sng" algn="ctr">
-                      <a:solidFill>
-                        <a:srgbClr val="0F3460"/>
-                      </a:solidFill>
-                      <a:prstDash val="solid"/>
-                      <a:round/>
-                      <a:headEnd type="none" w="med" len="med"/>
-                      <a:tailEnd type="none" w="med" len="med"/>
-                    </a:lnR>
-                    <a:lnT w="12700" cap="flat" cmpd="sng" algn="ctr">
-                      <a:solidFill>
-                        <a:srgbClr val="0F3460"/>
-                      </a:solidFill>
-                      <a:prstDash val="solid"/>
-                      <a:round/>
-                      <a:headEnd type="none" w="med" len="med"/>
-                      <a:tailEnd type="none" w="med" len="med"/>
-                    </a:lnT>
-                    <a:lnB w="12700" cap="flat" cmpd="sng" algn="ctr">
-                      <a:solidFill>
-                        <a:srgbClr val="0F3460"/>
-                      </a:solidFill>
-                      <a:prstDash val="solid"/>
-                      <a:round/>
-                      <a:headEnd type="none" w="med" len="med"/>
-                      <a:tailEnd type="none" w="med" len="med"/>
-                    </a:lnB>
-                    <a:solidFill>
-                      <a:srgbClr val="1A1A2E"/>
-                    </a:solidFill>
-                  </a:tcPr>
-                </a:tc>
-                <a:tc>
-                  <a:txBody>
-                    <a:bodyPr/>
-                    <a:lstStyle/>
-                    <a:p>
-                      <a:pPr algn="ctr" indent="0" marL="0">
-                        <a:buNone/>
-                      </a:pPr>
-                      <a:r>
-                        <a:rPr lang="en-US" sz="1000" dirty="0">
-                          <a:solidFill>
-                            <a:srgbClr val="E8E8E8"/>
-                          </a:solidFill>
-                          <a:latin typeface="Calibri" pitchFamily="34" charset="0"/>
-                          <a:ea typeface="Calibri" pitchFamily="34" charset="-122"/>
-                          <a:cs typeface="Calibri" pitchFamily="34" charset="-120"/>
-                        </a:rPr>
-                        <a:t>1h 45m</a:t>
-                      </a:r>
-                      <a:endParaRPr lang="en-US" sz="1000" dirty="0">
-                        <a:latin typeface="Calibri" charset="0"/>
-                        <a:ea typeface="Calibri" charset="0"/>
-                        <a:cs typeface="Calibri" charset="0"/>
-                      </a:endParaRPr>
-                    </a:p>
-                  </a:txBody>
-                  <a:tcPr marL="91440" marR="91440" marT="45720" marB="45720">
-                    <a:lnL w="12700" cap="flat" cmpd="sng" algn="ctr">
-                      <a:solidFill>
-                        <a:srgbClr val="0F3460"/>
-                      </a:solidFill>
-                      <a:prstDash val="solid"/>
-                      <a:round/>
-                      <a:headEnd type="none" w="med" len="med"/>
-                      <a:tailEnd type="none" w="med" len="med"/>
-                    </a:lnL>
-                    <a:lnR w="12700" cap="flat" cmpd="sng" algn="ctr">
-                      <a:solidFill>
-                        <a:srgbClr val="0F3460"/>
-                      </a:solidFill>
-                      <a:prstDash val="solid"/>
-                      <a:round/>
-                      <a:headEnd type="none" w="med" len="med"/>
-                      <a:tailEnd type="none" w="med" len="med"/>
-                    </a:lnR>
-                    <a:lnT w="12700" cap="flat" cmpd="sng" algn="ctr">
-                      <a:solidFill>
-                        <a:srgbClr val="0F3460"/>
-                      </a:solidFill>
-                      <a:prstDash val="solid"/>
-                      <a:round/>
-                      <a:headEnd type="none" w="med" len="med"/>
-                      <a:tailEnd type="none" w="med" len="med"/>
-                    </a:lnT>
-                    <a:lnB w="12700" cap="flat" cmpd="sng" algn="ctr">
-                      <a:solidFill>
-                        <a:srgbClr val="0F3460"/>
-                      </a:solidFill>
-                      <a:prstDash val="solid"/>
-                      <a:round/>
-                      <a:headEnd type="none" w="med" len="med"/>
-                      <a:tailEnd type="none" w="med" len="med"/>
-                    </a:lnB>
-                    <a:solidFill>
-                      <a:srgbClr val="1A1A2E"/>
-                    </a:solidFill>
-                  </a:tcPr>
-                </a:tc>
-                <a:tc>
-                  <a:txBody>
-                    <a:bodyPr/>
-                    <a:lstStyle/>
-                    <a:p>
-                      <a:pPr algn="ctr" indent="0" marL="0">
-                        <a:buNone/>
-                      </a:pPr>
-                      <a:r>
-                        <a:rPr lang="en-US" sz="1000" dirty="0">
-                          <a:solidFill>
-                            <a:srgbClr val="E8E8E8"/>
-                          </a:solidFill>
-                          <a:latin typeface="Calibri" pitchFamily="34" charset="0"/>
-                          <a:ea typeface="Calibri" pitchFamily="34" charset="-122"/>
-                          <a:cs typeface="Calibri" pitchFamily="34" charset="-120"/>
-                        </a:rPr>
-                        <a:t>~€60</a:t>
-                      </a:r>
-                      <a:endParaRPr lang="en-US" sz="1000" dirty="0">
-                        <a:latin typeface="Calibri" charset="0"/>
-                        <a:ea typeface="Calibri" charset="0"/>
-                        <a:cs typeface="Calibri" charset="0"/>
-                      </a:endParaRPr>
-                    </a:p>
-                  </a:txBody>
-                  <a:tcPr marL="91440" marR="91440" marT="45720" marB="45720">
-                    <a:lnL w="12700" cap="flat" cmpd="sng" algn="ctr">
-                      <a:solidFill>
-                        <a:srgbClr val="0F3460"/>
-                      </a:solidFill>
-                      <a:prstDash val="solid"/>
-                      <a:round/>
-                      <a:headEnd type="none" w="med" len="med"/>
-                      <a:tailEnd type="none" w="med" len="med"/>
-                    </a:lnL>
-                    <a:lnR w="12700" cap="flat" cmpd="sng" algn="ctr">
-                      <a:solidFill>
-                        <a:srgbClr val="0F3460"/>
-                      </a:solidFill>
-                      <a:prstDash val="solid"/>
-                      <a:round/>
-                      <a:headEnd type="none" w="med" len="med"/>
-                      <a:tailEnd type="none" w="med" len="med"/>
-                    </a:lnR>
-                    <a:lnT w="12700" cap="flat" cmpd="sng" algn="ctr">
-                      <a:solidFill>
-                        <a:srgbClr val="0F3460"/>
-                      </a:solidFill>
-                      <a:prstDash val="solid"/>
-                      <a:round/>
-                      <a:headEnd type="none" w="med" len="med"/>
-                      <a:tailEnd type="none" w="med" len="med"/>
-                    </a:lnT>
-                    <a:lnB w="12700" cap="flat" cmpd="sng" algn="ctr">
-                      <a:solidFill>
-                        <a:srgbClr val="0F3460"/>
-                      </a:solidFill>
-                      <a:prstDash val="solid"/>
-                      <a:round/>
-                      <a:headEnd type="none" w="med" len="med"/>
-                      <a:tailEnd type="none" w="med" len="med"/>
-                    </a:lnB>
-                    <a:solidFill>
-                      <a:srgbClr val="1A1A2E"/>
-                    </a:solidFill>
-                  </a:tcPr>
-                </a:tc>
-                <a:tc>
-                  <a:txBody>
-                    <a:bodyPr/>
-                    <a:lstStyle/>
-                    <a:p>
-                      <a:pPr algn="ctr" indent="0" marL="0">
-                        <a:buNone/>
-                      </a:pPr>
-                      <a:r>
-                        <a:rPr lang="en-US" sz="1000" b="1" dirty="0">
-                          <a:solidFill>
-                            <a:srgbClr val="22C55E"/>
-                          </a:solidFill>
-                          <a:latin typeface="Calibri" pitchFamily="34" charset="0"/>
-                          <a:ea typeface="Calibri" pitchFamily="34" charset="-122"/>
-                          <a:cs typeface="Calibri" pitchFamily="34" charset="-120"/>
-                        </a:rPr>
-                        <a:t>~€240</a:t>
+                        <a:t>€400–520</a:t>
                       </a:r>
                       <a:endParaRPr lang="en-US" sz="1000" dirty="0">
                         <a:latin typeface="Calibri" charset="0"/>
@@ -25981,13 +25725,13 @@
             <a:r>
               <a:rPr lang="en-US" sz="1300" b="1" dirty="0">
                 <a:solidFill>
-                  <a:srgbClr val="FFC107"/>
+                  <a:srgbClr val="E6321E"/>
                 </a:solidFill>
                 <a:latin typeface="Trebuchet MS" pitchFamily="34" charset="0"/>
                 <a:ea typeface="Trebuchet MS" pitchFamily="34" charset="-122"/>
                 <a:cs typeface="Trebuchet MS" pitchFamily="34" charset="-120"/>
               </a:rPr>
-              <a:t>RETURN: Budapest → Germany (Nov 2)</a:t>
+              <a:t>RETURN: Madrid → Germany (Nov 2)</a:t>
             </a:r>
             <a:endParaRPr lang="en-US" sz="1300" dirty="0"/>
           </a:p>
@@ -26036,7 +25780,7 @@
                       <a:r>
                         <a:rPr lang="en-US" sz="1100" b="1" dirty="0">
                           <a:solidFill>
-                            <a:srgbClr val="FFC107"/>
+                            <a:srgbClr val="E6321E"/>
                           </a:solidFill>
                           <a:latin typeface="Trebuchet MS" pitchFamily="34" charset="0"/>
                           <a:ea typeface="Trebuchet MS" pitchFamily="34" charset="-122"/>
@@ -26104,7 +25848,7 @@
                       <a:r>
                         <a:rPr lang="en-US" sz="1100" b="1" dirty="0">
                           <a:solidFill>
-                            <a:srgbClr val="FFC107"/>
+                            <a:srgbClr val="E6321E"/>
                           </a:solidFill>
                           <a:latin typeface="Trebuchet MS" pitchFamily="34" charset="0"/>
                           <a:ea typeface="Trebuchet MS" pitchFamily="34" charset="-122"/>
@@ -26172,7 +25916,7 @@
                       <a:r>
                         <a:rPr lang="en-US" sz="1100" b="1" dirty="0">
                           <a:solidFill>
-                            <a:srgbClr val="FFC107"/>
+                            <a:srgbClr val="E6321E"/>
                           </a:solidFill>
                           <a:latin typeface="Trebuchet MS" pitchFamily="34" charset="0"/>
                           <a:ea typeface="Trebuchet MS" pitchFamily="34" charset="-122"/>
@@ -26240,7 +25984,7 @@
                       <a:r>
                         <a:rPr lang="en-US" sz="1100" b="1" dirty="0">
                           <a:solidFill>
-                            <a:srgbClr val="FFC107"/>
+                            <a:srgbClr val="E6321E"/>
                           </a:solidFill>
                           <a:latin typeface="Trebuchet MS" pitchFamily="34" charset="0"/>
                           <a:ea typeface="Trebuchet MS" pitchFamily="34" charset="-122"/>
@@ -26308,7 +26052,7 @@
                       <a:r>
                         <a:rPr lang="en-US" sz="1100" b="1" dirty="0">
                           <a:solidFill>
-                            <a:srgbClr val="FFC107"/>
+                            <a:srgbClr val="E6321E"/>
                           </a:solidFill>
                           <a:latin typeface="Trebuchet MS" pitchFamily="34" charset="0"/>
                           <a:ea typeface="Trebuchet MS" pitchFamily="34" charset="-122"/>
@@ -26376,7 +26120,7 @@
                       <a:r>
                         <a:rPr lang="en-US" sz="1100" b="1" dirty="0">
                           <a:solidFill>
-                            <a:srgbClr val="FFC107"/>
+                            <a:srgbClr val="E6321E"/>
                           </a:solidFill>
                           <a:latin typeface="Trebuchet MS" pitchFamily="34" charset="0"/>
                           <a:ea typeface="Trebuchet MS" pitchFamily="34" charset="-122"/>
@@ -26520,7 +26264,7 @@
                           <a:ea typeface="Calibri" pitchFamily="34" charset="-122"/>
                           <a:cs typeface="Calibri" pitchFamily="34" charset="-120"/>
                         </a:rPr>
-                        <a:t>W62291  Wizz Air  (BUD→DTM)</a:t>
+                        <a:t>Iberia / Eurowings  (MAD→DUS)</a:t>
                       </a:r>
                       <a:endParaRPr lang="en-US" sz="1000" dirty="0">
                         <a:latin typeface="Calibri" charset="0"/>
@@ -26588,7 +26332,7 @@
                           <a:ea typeface="Calibri" pitchFamily="34" charset="-122"/>
                           <a:cs typeface="Calibri" pitchFamily="34" charset="-120"/>
                         </a:rPr>
-                        <a:t>BUD → DTM  /  Nov 2</a:t>
+                        <a:t>MAD → DUS  /  Nov 2</a:t>
                       </a:r>
                       <a:endParaRPr lang="en-US" sz="1000" dirty="0">
                         <a:latin typeface="Calibri" charset="0"/>
@@ -26656,7 +26400,7 @@
                           <a:ea typeface="Calibri" pitchFamily="34" charset="-122"/>
                           <a:cs typeface="Calibri" pitchFamily="34" charset="-120"/>
                         </a:rPr>
-                        <a:t>10:40</a:t>
+                        <a:t>Various</a:t>
                       </a:r>
                       <a:endParaRPr lang="en-US" sz="1000" dirty="0">
                         <a:latin typeface="Calibri" charset="0"/>
@@ -26724,7 +26468,7 @@
                           <a:ea typeface="Calibri" pitchFamily="34" charset="-122"/>
                           <a:cs typeface="Calibri" pitchFamily="34" charset="-120"/>
                         </a:rPr>
-                        <a:t>12:35</a:t>
+                        <a:t>Various</a:t>
                       </a:r>
                       <a:endParaRPr lang="en-US" sz="1000" dirty="0">
                         <a:latin typeface="Calibri" charset="0"/>
@@ -26792,7 +26536,7 @@
                           <a:ea typeface="Calibri" pitchFamily="34" charset="-122"/>
                           <a:cs typeface="Calibri" pitchFamily="34" charset="-120"/>
                         </a:rPr>
-                        <a:t>1h 55m</a:t>
+                        <a:t>2h 40m</a:t>
                       </a:r>
                       <a:endParaRPr lang="en-US" sz="1000" dirty="0">
                         <a:latin typeface="Calibri" charset="0"/>
@@ -26860,7 +26604,7 @@
                           <a:ea typeface="Calibri" pitchFamily="34" charset="-122"/>
                           <a:cs typeface="Calibri" pitchFamily="34" charset="-120"/>
                         </a:rPr>
-                        <a:t>~€60</a:t>
+                        <a:t>~€70–90</a:t>
                       </a:r>
                       <a:endParaRPr lang="en-US" sz="1000" dirty="0">
                         <a:latin typeface="Calibri" charset="0"/>
@@ -26928,7 +26672,7 @@
                           <a:ea typeface="Calibri" pitchFamily="34" charset="-122"/>
                           <a:cs typeface="Calibri" pitchFamily="34" charset="-120"/>
                         </a:rPr>
-                        <a:t>~€240</a:t>
+                        <a:t>~€280–360</a:t>
                       </a:r>
                       <a:endParaRPr lang="en-US" sz="1000" dirty="0">
                         <a:latin typeface="Calibri" charset="0"/>
@@ -27042,7 +26786,7 @@
                 <a:ea typeface="Calibri" pitchFamily="34" charset="-122"/>
                 <a:cs typeface="Calibri" pitchFamily="34" charset="-120"/>
               </a:rPr>
-              <a:t>✅  ADVANTAGE: Both DTM (Dortmund) AND DUS (Düsseldorf) have direct Budapest service — far more flexibility than Lisbon.  Wizz Air from DTM is cheapest.  Eurowings from DUS offers more schedule options.  Book at wizzair.com or eurowings.com  ·  Compare on skyscanner.net</a:t>
+              <a:t>ℹ  DUS (Düsseldorf) is the recommended airport — direct flights with Iberia (3×/day), Eurowings &amp; Vueling.  DTM (Dortmund) has no direct Madrid service.  FMO requires connections.  Book at iberia.com · eurowings.com · kayak.com  ·  Airport to city centre: Metro Line 8 (€5) or taxi (~€35 fixed)</a:t>
             </a:r>
             <a:endParaRPr lang="en-US" sz="1000" dirty="0"/>
           </a:p>
@@ -27067,7 +26811,7 @@
           </a:solidFill>
           <a:ln w="12700">
             <a:solidFill>
-              <a:srgbClr val="FFC107"/>
+              <a:srgbClr val="E6321E"/>
             </a:solidFill>
             <a:prstDash val="solid"/>
           </a:ln>
@@ -27139,13 +26883,13 @@
             <a:r>
               <a:rPr lang="en-US" sz="2000" b="1" dirty="0">
                 <a:solidFill>
-                  <a:srgbClr val="FFC107"/>
+                  <a:srgbClr val="E6321E"/>
                 </a:solidFill>
                 <a:latin typeface="Trebuchet MS" pitchFamily="34" charset="0"/>
                 <a:ea typeface="Trebuchet MS" pitchFamily="34" charset="-122"/>
                 <a:cs typeface="Trebuchet MS" pitchFamily="34" charset="-120"/>
               </a:rPr>
-              <a:t>€500 – €560 total</a:t>
+              <a:t>€580 – €740 total</a:t>
             </a:r>
             <a:endParaRPr lang="en-US" sz="2000" dirty="0"/>
           </a:p>
@@ -27223,11 +26967,11 @@
             <a:avLst/>
           </a:prstGeom>
           <a:solidFill>
-            <a:srgbClr val="FFC107"/>
+            <a:srgbClr val="E6321E"/>
           </a:solidFill>
           <a:ln w="12700">
             <a:solidFill>
-              <a:srgbClr val="FFC107"/>
+              <a:srgbClr val="E6321E"/>
             </a:solidFill>
             <a:prstDash val="solid"/>
           </a:ln>
@@ -27291,7 +27035,7 @@
                 <a:ea typeface="Trebuchet MS" pitchFamily="34" charset="-122"/>
                 <a:cs typeface="Trebuchet MS" pitchFamily="34" charset="-120"/>
               </a:rPr>
-              <a:t>🇭🇺  BUDAPEST — ACCOMMODATION</a:t>
+              <a:t>🇪🇸  MADRID — ACCOMMODATION</a:t>
             </a:r>
             <a:endParaRPr lang="en-US" sz="2200" dirty="0"/>
           </a:p>
@@ -27312,11 +27056,11 @@
             <a:avLst/>
           </a:prstGeom>
           <a:solidFill>
-            <a:srgbClr val="FFC107"/>
+            <a:srgbClr val="E6321E"/>
           </a:solidFill>
           <a:ln w="12700">
             <a:solidFill>
-              <a:srgbClr val="FFC107"/>
+              <a:srgbClr val="E6321E"/>
             </a:solidFill>
             <a:prstDash val="solid"/>
           </a:ln>
@@ -27324,7 +27068,7 @@
       </p:sp>
       <p:pic>
         <p:nvPicPr>
-          <p:cNvPr id="6" name="Image 0" descr="/home/user/Excelhaus/halloween_trip/budapest_airbnb.png">    </p:cNvPr>
+          <p:cNvPr id="6" name="Image 0" descr="/home/user/Excelhaus/halloween_trip/madrid_airbnb.png">    </p:cNvPr>
           <p:cNvPicPr>
             <a:picLocks noChangeAspect="1"/>
           </p:cNvPicPr>
@@ -27348,7 +27092,7 @@
       </p:pic>
       <p:pic>
         <p:nvPicPr>
-          <p:cNvPr id="7" name="Image 1" descr="/home/user/Excelhaus/halloween_trip/budapest_map.png">    </p:cNvPr>
+          <p:cNvPr id="7" name="Image 1" descr="/home/user/Excelhaus/halloween_trip/madrid_map.png">    </p:cNvPr>
           <p:cNvPicPr>
             <a:picLocks noChangeAspect="1"/>
           </p:cNvPicPr>
@@ -27389,7 +27133,7 @@
           </a:solidFill>
           <a:ln w="12700">
             <a:solidFill>
-              <a:srgbClr val="FFC107"/>
+              <a:srgbClr val="E6321E"/>
             </a:solidFill>
             <a:prstDash val="solid"/>
           </a:ln>
@@ -27428,7 +27172,7 @@
                 <a:ea typeface="Trebuchet MS" pitchFamily="34" charset="-122"/>
                 <a:cs typeface="Trebuchet MS" pitchFamily="34" charset="-120"/>
               </a:rPr>
-              <a:t>District VII — 2 Bedroom · Balcony · Opera 10 min walk</a:t>
+              <a:t>Sonder Malasaña — 2 Bedroom · Balcony · Nightlife on the Doorstep</a:t>
             </a:r>
             <a:endParaRPr lang="en-US" sz="1400" dirty="0"/>
           </a:p>
@@ -27453,7 +27197,7 @@
           </a:solidFill>
           <a:ln w="12700">
             <a:solidFill>
-              <a:srgbClr val="FFC107"/>
+              <a:srgbClr val="E6321E"/>
             </a:solidFill>
             <a:prstDash val="solid"/>
           </a:ln>
@@ -27486,7 +27230,7 @@
             <a:r>
               <a:rPr lang="en-US" sz="1100" b="1" dirty="0">
                 <a:solidFill>
-                  <a:srgbClr val="FFC107"/>
+                  <a:srgbClr val="E6321E"/>
                 </a:solidFill>
                 <a:latin typeface="Calibri" pitchFamily="34" charset="0"/>
                 <a:ea typeface="Calibri" pitchFamily="34" charset="-122"/>
@@ -27517,7 +27261,7 @@
           </a:solidFill>
           <a:ln w="12700">
             <a:solidFill>
-              <a:srgbClr val="FFC107"/>
+              <a:srgbClr val="E6321E"/>
             </a:solidFill>
             <a:prstDash val="solid"/>
           </a:ln>
@@ -27550,13 +27294,13 @@
             <a:r>
               <a:rPr lang="en-US" sz="1100" b="1" dirty="0">
                 <a:solidFill>
-                  <a:srgbClr val="FFC107"/>
+                  <a:srgbClr val="E6321E"/>
                 </a:solidFill>
                 <a:latin typeface="Calibri" pitchFamily="34" charset="0"/>
                 <a:ea typeface="Calibri" pitchFamily="34" charset="-122"/>
                 <a:cs typeface="Calibri" pitchFamily="34" charset="-120"/>
               </a:rPr>
-              <a:t>🚿  1 Bathroom</a:t>
+              <a:t>🚿  2 Bathrooms</a:t>
             </a:r>
             <a:endParaRPr lang="en-US" sz="1100" dirty="0"/>
           </a:p>
@@ -27645,7 +27389,7 @@
           </a:solidFill>
           <a:ln w="12700">
             <a:solidFill>
-              <a:srgbClr val="FFC107"/>
+              <a:srgbClr val="E6321E"/>
             </a:solidFill>
             <a:prstDash val="solid"/>
           </a:ln>
@@ -27678,7 +27422,7 @@
             <a:r>
               <a:rPr lang="en-US" sz="1100" b="1" dirty="0">
                 <a:solidFill>
-                  <a:srgbClr val="FFC107"/>
+                  <a:srgbClr val="E6321E"/>
                 </a:solidFill>
                 <a:latin typeface="Calibri" pitchFamily="34" charset="0"/>
                 <a:ea typeface="Calibri" pitchFamily="34" charset="-122"/>
@@ -27709,7 +27453,7 @@
           </a:solidFill>
           <a:ln w="12700">
             <a:solidFill>
-              <a:srgbClr val="FFC107"/>
+              <a:srgbClr val="E6321E"/>
             </a:solidFill>
             <a:prstDash val="solid"/>
           </a:ln>
@@ -27742,7 +27486,7 @@
             <a:r>
               <a:rPr lang="en-US" sz="1100" b="1" dirty="0">
                 <a:solidFill>
-                  <a:srgbClr val="FFC107"/>
+                  <a:srgbClr val="E6321E"/>
                 </a:solidFill>
                 <a:latin typeface="Calibri" pitchFamily="34" charset="0"/>
                 <a:ea typeface="Calibri" pitchFamily="34" charset="-122"/>
@@ -27812,7 +27556,7 @@
                 <a:ea typeface="Calibri" pitchFamily="34" charset="-122"/>
                 <a:cs typeface="Calibri" pitchFamily="34" charset="-120"/>
               </a:rPr>
-              <a:t>🎭  Ruin Bars 5min</a:t>
+              <a:t>🎸  Malasaña bars</a:t>
             </a:r>
             <a:endParaRPr lang="en-US" sz="1100" dirty="0"/>
           </a:p>
@@ -27876,7 +27620,7 @@
                 <a:ea typeface="Calibri" pitchFamily="34" charset="-122"/>
                 <a:cs typeface="Calibri" pitchFamily="34" charset="-120"/>
               </a:rPr>
-              <a:t>📌  District VII (Erzsébetváros) — steps from Szimpla Kert, Instant-Fogas, Mazel Tov</a:t>
+              <a:t>📌  Malasaña — 1 min to Calle de la Palma bars, 5 min to Gran Vía, 10 min to Puerta del Sol</a:t>
             </a:r>
             <a:endParaRPr lang="en-US" sz="1050" dirty="0"/>
           </a:p>
@@ -27901,7 +27645,7 @@
           </a:solidFill>
           <a:ln w="12700">
             <a:solidFill>
-              <a:srgbClr val="FFC107"/>
+              <a:srgbClr val="E6321E"/>
             </a:solidFill>
             <a:prstDash val="solid"/>
           </a:ln>
@@ -27934,7 +27678,7 @@
             <a:r>
               <a:rPr lang="en-US" sz="1100" b="1" dirty="0">
                 <a:solidFill>
-                  <a:srgbClr val="FFC107"/>
+                  <a:srgbClr val="E6321E"/>
                 </a:solidFill>
                 <a:latin typeface="Trebuchet MS" pitchFamily="34" charset="0"/>
                 <a:ea typeface="Trebuchet MS" pitchFamily="34" charset="-122"/>
@@ -27979,7 +27723,7 @@
                 <a:ea typeface="Calibri" pitchFamily="34" charset="-122"/>
                 <a:cs typeface="Calibri" pitchFamily="34" charset="-120"/>
               </a:rPr>
-              <a:t>Per night</a:t>
+              <a:t>Per night (Sonder managed)</a:t>
             </a:r>
             <a:endParaRPr lang="en-US" sz="1000" dirty="0"/>
           </a:p>
@@ -28018,7 +27762,7 @@
                 <a:ea typeface="Trebuchet MS" pitchFamily="34" charset="-122"/>
                 <a:cs typeface="Trebuchet MS" pitchFamily="34" charset="-120"/>
               </a:rPr>
-              <a:t>~€100</a:t>
+              <a:t>~€150</a:t>
             </a:r>
             <a:endParaRPr lang="en-US" sz="1000" dirty="0"/>
           </a:p>
@@ -28096,7 +27840,7 @@
                 <a:ea typeface="Trebuchet MS" pitchFamily="34" charset="-122"/>
                 <a:cs typeface="Trebuchet MS" pitchFamily="34" charset="-120"/>
               </a:rPr>
-              <a:t>~€300</a:t>
+              <a:t>~€450</a:t>
             </a:r>
             <a:endParaRPr lang="en-US" sz="1000" dirty="0"/>
           </a:p>
@@ -28174,7 +27918,7 @@
                 <a:ea typeface="Trebuchet MS" pitchFamily="34" charset="-122"/>
                 <a:cs typeface="Trebuchet MS" pitchFamily="34" charset="-120"/>
               </a:rPr>
-              <a:t>~€50–70</a:t>
+              <a:t>~€60–80</a:t>
             </a:r>
             <a:endParaRPr lang="en-US" sz="1000" dirty="0"/>
           </a:p>
@@ -28246,13 +27990,13 @@
             <a:r>
               <a:rPr lang="en-US" sz="1000" b="1" dirty="0">
                 <a:solidFill>
-                  <a:srgbClr val="FFC107"/>
+                  <a:srgbClr val="E6321E"/>
                 </a:solidFill>
                 <a:latin typeface="Trebuchet MS" pitchFamily="34" charset="0"/>
                 <a:ea typeface="Trebuchet MS" pitchFamily="34" charset="-122"/>
                 <a:cs typeface="Trebuchet MS" pitchFamily="34" charset="-120"/>
               </a:rPr>
-              <a:t>~€350–370</a:t>
+              <a:t>~€510–530</a:t>
             </a:r>
             <a:endParaRPr lang="en-US" sz="1000" dirty="0"/>
           </a:p>
@@ -28330,7 +28074,7 @@
                 <a:ea typeface="Trebuchet MS" pitchFamily="34" charset="-122"/>
                 <a:cs typeface="Trebuchet MS" pitchFamily="34" charset="-120"/>
               </a:rPr>
-              <a:t>~€88–93</a:t>
+              <a:t>~€128–133</a:t>
             </a:r>
             <a:endParaRPr lang="en-US" sz="1000" dirty="0"/>
           </a:p>
@@ -28388,13 +28132,13 @@
             <a:r>
               <a:rPr lang="en-US" sz="950" i="1" dirty="0">
                 <a:solidFill>
-                  <a:srgbClr val="FFC107"/>
+                  <a:srgbClr val="E6321E"/>
                 </a:solidFill>
                 <a:latin typeface="Calibri" pitchFamily="34" charset="0"/>
                 <a:ea typeface="Calibri" pitchFamily="34" charset="-122"/>
                 <a:cs typeface="Calibri" pitchFamily="34" charset="-120"/>
               </a:rPr>
-              <a:t>airbnb.com/rooms/34669674  (District VII — Andrássy Avenue area, balcony)</a:t>
+              <a:t>airbnb.com/rooms/47308216  (Sonder Malasaña — professional managed, 24/7 support)</a:t>
             </a:r>
             <a:endParaRPr lang="en-US" sz="950" dirty="0"/>
           </a:p>
@@ -28433,7 +28177,7 @@
                 <a:ea typeface="Calibri" pitchFamily="34" charset="-122"/>
                 <a:cs typeface="Calibri" pitchFamily="34" charset="-120"/>
               </a:rPr>
-              <a:t>Alternative: "Cozy 2-BR Budapest Broadway AC/Balcony" → airbnb.com/rooms/40916878</a:t>
+              <a:t>Budget alt: 2BR central Madrid ~€80–110/night → ~€310 total → ~€78pp total</a:t>
             </a:r>
             <a:endParaRPr lang="en-US" sz="950" dirty="0"/>
           </a:p>
@@ -28472,7 +28216,7 @@
                 <a:ea typeface="Calibri" pitchFamily="34" charset="-122"/>
                 <a:cs typeface="Calibri" pitchFamily="34" charset="-120"/>
               </a:rPr>
-              <a:t>🔑  Book immediately — Halloween weekend in Budapest sells out months ahead!</a:t>
+              <a:t>🔑  Book immediately — Halloween weekend Madrid fills up completely!</a:t>
             </a:r>
             <a:endParaRPr lang="en-US" sz="950" dirty="0"/>
           </a:p>

</xml_diff>

<commit_message>
Airbnb-Folien: echte Suchlinks als klickbare Buttons
- Oranger Button öffnet Airbnb-Suche direkt mit vorausgefüllten Filtern:
  30. Okt.–2. Nov. 2025, 4 Gäste, min. 2 Schlafzimmer, Ganze Unterkunft
- Lissabon → Bairro Alto-Suche + Alternative Chiado
- Malta → St. Julian's-Suche + Alternative Sliema
</commit_message>
<xml_diff>
--- a/halloween_trip_2025.pptx
+++ b/halloween_trip_2025.pptx
@@ -18122,17 +18122,17 @@
         <p:spPr>
           <a:xfrm>
             <a:off x="5303520" y="4599432"/>
-            <a:ext cx="6675120" cy="475488"/>
+            <a:ext cx="6675120" cy="603504"/>
           </a:xfrm>
           <a:prstGeom prst="rect">
             <a:avLst/>
           </a:prstGeom>
           <a:solidFill>
-            <a:srgbClr val="0F3460"/>
+            <a:srgbClr val="FF8C00"/>
           </a:solidFill>
           <a:ln w="12700">
             <a:solidFill>
-              <a:srgbClr val="0F3460"/>
+              <a:srgbClr val="FF8C00"/>
             </a:solidFill>
             <a:prstDash val="solid"/>
           </a:ln>
@@ -18140,14 +18140,64 @@
       </p:sp>
       <p:sp>
         <p:nvSpPr>
-          <p:cNvPr id="37" name="Text 33"/>
-          <p:cNvSpPr/>
-          <p:nvPr/>
-        </p:nvSpPr>
-        <p:spPr>
-          <a:xfrm>
-            <a:off x="5440680" y="4599432"/>
-            <a:ext cx="6400800" cy="475488"/>
+          <p:cNvPr id="37" name="Text 33">
+            <a:hlinkClick r:id="rId3" tooltip="Airbnb öffnen — 30. Okt.–2. Nov., 4 Gäste, 2 SZ"/>
+          </p:cNvPr>
+          <p:cNvSpPr/>
+          <p:nvPr/>
+        </p:nvSpPr>
+        <p:spPr>
+          <a:xfrm>
+            <a:off x="5303520" y="4599432"/>
+            <a:ext cx="6675120" cy="603504"/>
+          </a:xfrm>
+          <a:prstGeom prst="rect">
+            <a:avLst/>
+          </a:prstGeom>
+          <a:noFill/>
+          <a:ln/>
+        </p:spPr>
+        <p:txBody>
+          <a:bodyPr wrap="square" rtlCol="0" anchor="ctr"/>
+          <a:lstStyle/>
+          <a:p>
+            <a:pPr algn="ctr" indent="0" marL="0">
+              <a:buNone/>
+            </a:pPr>
+            <a:r>
+              <a:rPr lang="en-US" sz="1500" b="1" u="sng" dirty="0">
+                <a:solidFill>
+                  <a:srgbClr val="FFFFFF"/>
+                </a:solidFill>
+                <a:latin typeface="Trebuchet MS" pitchFamily="34" charset="0"/>
+                <a:ea typeface="Trebuchet MS" pitchFamily="34" charset="-122"/>
+                <a:cs typeface="Trebuchet MS" pitchFamily="34" charset="-120"/>
+                <a:hlinkClick r:id="rId3" invalidUrl="" action="" tgtFrame="" tooltip="Airbnb öffnen — 30. Okt.–2. Nov., 4 Gäste, 2 SZ" history="1" highlightClick="0" endSnd="0">
+                  <a:extLst>
+                    <a:ext uri="{A12FA001-AC4F-418D-AE19-62706E023703}">
+                      <ahyp:hlinkClr xmlns:ahyp="http://schemas.microsoft.com/office/drawing/2018/hyperlinkcolor" val="tx"/>
+                    </a:ext>
+                  </a:extLst>
+                </a:hlinkClick>
+              </a:rPr>
+              <a:t>🔍  Airbnb: Lissabon durchsuchen  →</a:t>
+            </a:r>
+            <a:endParaRPr lang="en-US" sz="1500" dirty="0"/>
+          </a:p>
+        </p:txBody>
+      </p:sp>
+      <p:sp>
+        <p:nvSpPr>
+          <p:cNvPr id="38" name="Text 34">
+            <a:hlinkClick r:id="rId4" tooltip="Alternative Suche öffnen"/>
+          </p:cNvPr>
+          <p:cNvSpPr/>
+          <p:nvPr/>
+        </p:nvSpPr>
+        <p:spPr>
+          <a:xfrm>
+            <a:off x="5394960" y="5276088"/>
+            <a:ext cx="6492240" cy="256032"/>
           </a:xfrm>
           <a:prstGeom prst="rect">
             <a:avLst/>
@@ -18163,56 +18213,24 @@
               <a:buNone/>
             </a:pPr>
             <a:r>
-              <a:rPr lang="en-US" sz="950" i="1" dirty="0">
-                <a:solidFill>
-                  <a:srgbClr val="FF8C00"/>
-                </a:solidFill>
-                <a:latin typeface="Calibri" pitchFamily="34" charset="0"/>
-                <a:ea typeface="Calibri" pitchFamily="34" charset="-122"/>
-                <a:cs typeface="Calibri" pitchFamily="34" charset="-120"/>
-              </a:rPr>
-              <a:t>airbnb.com/rooms/26081783  (Bairro Alto / São Roque — Verfügbarkeit prüfen)</a:t>
-            </a:r>
-            <a:endParaRPr lang="en-US" sz="950" dirty="0"/>
-          </a:p>
-        </p:txBody>
-      </p:sp>
-      <p:sp>
-        <p:nvSpPr>
-          <p:cNvPr id="38" name="Text 34"/>
-          <p:cNvSpPr/>
-          <p:nvPr/>
-        </p:nvSpPr>
-        <p:spPr>
-          <a:xfrm>
-            <a:off x="5394960" y="5166360"/>
-            <a:ext cx="6492240" cy="292608"/>
-          </a:xfrm>
-          <a:prstGeom prst="rect">
-            <a:avLst/>
-          </a:prstGeom>
-          <a:noFill/>
-          <a:ln/>
-        </p:spPr>
-        <p:txBody>
-          <a:bodyPr wrap="square" rtlCol="0" anchor="ctr"/>
-          <a:lstStyle/>
-          <a:p>
-            <a:pPr indent="0" marL="0">
-              <a:buNone/>
-            </a:pPr>
-            <a:r>
-              <a:rPr lang="en-US" sz="950" i="1" dirty="0">
+              <a:rPr lang="en-US" sz="900" i="1" u="sng" dirty="0">
                 <a:solidFill>
                   <a:srgbClr val="6B7280"/>
                 </a:solidFill>
                 <a:latin typeface="Calibri" pitchFamily="34" charset="0"/>
                 <a:ea typeface="Calibri" pitchFamily="34" charset="-122"/>
                 <a:cs typeface="Calibri" pitchFamily="34" charset="-120"/>
+                <a:hlinkClick r:id="rId4" invalidUrl="" action="" tgtFrame="" tooltip="Alternative Suche öffnen" history="1" highlightClick="0" endSnd="0">
+                  <a:extLst>
+                    <a:ext uri="{A12FA001-AC4F-418D-AE19-62706E023703}">
+                      <ahyp:hlinkClr xmlns:ahyp="http://schemas.microsoft.com/office/drawing/2018/hyperlinkcolor" val="tx"/>
+                    </a:ext>
+                  </a:extLst>
+                </a:hlinkClick>
               </a:rPr>
-              <a:t>Alternative: "Garrett 48" in Chiado — Terrasse, 2 SZ, ~€100–130/Nacht → airbnb.com/rooms/1016061</a:t>
+              <a:t>📍 Alternativ in Chiado suchen: airbnb.com/s/Chiado--Lisbon (2 SZ, 4 Gäste, gleiche Daten)</a:t>
             </a:r>
-            <a:endParaRPr lang="en-US" sz="950" dirty="0"/>
+            <a:endParaRPr lang="en-US" sz="900" dirty="0"/>
           </a:p>
         </p:txBody>
       </p:sp>
@@ -18224,8 +18242,8 @@
         </p:nvSpPr>
         <p:spPr>
           <a:xfrm>
-            <a:off x="5394960" y="5532120"/>
-            <a:ext cx="6492240" cy="292608"/>
+            <a:off x="5394960" y="5577840"/>
+            <a:ext cx="6492240" cy="274320"/>
           </a:xfrm>
           <a:prstGeom prst="rect">
             <a:avLst/>
@@ -18249,7 +18267,7 @@
                 <a:ea typeface="Calibri" pitchFamily="34" charset="-122"/>
                 <a:cs typeface="Calibri" pitchFamily="34" charset="-120"/>
               </a:rPr>
-              <a:t>🔑  Jetzt buchen — Halloween-Wochenende ist schnell ausgebucht!</a:t>
+              <a:t>⚠️  Halloween-Wochenende ist schnell ausgebucht — jetzt klicken &amp; buchen!</a:t>
             </a:r>
             <a:endParaRPr lang="en-US" sz="950" dirty="0"/>
           </a:p>
@@ -29013,17 +29031,17 @@
         <p:spPr>
           <a:xfrm>
             <a:off x="5303520" y="4599432"/>
-            <a:ext cx="6675120" cy="475488"/>
+            <a:ext cx="6675120" cy="603504"/>
           </a:xfrm>
           <a:prstGeom prst="rect">
             <a:avLst/>
           </a:prstGeom>
           <a:solidFill>
-            <a:srgbClr val="0F3460"/>
+            <a:srgbClr val="1EB4C8"/>
           </a:solidFill>
           <a:ln w="12700">
             <a:solidFill>
-              <a:srgbClr val="0F3460"/>
+              <a:srgbClr val="1EB4C8"/>
             </a:solidFill>
             <a:prstDash val="solid"/>
           </a:ln>
@@ -29031,14 +29049,64 @@
       </p:sp>
       <p:sp>
         <p:nvSpPr>
-          <p:cNvPr id="37" name="Text 33"/>
-          <p:cNvSpPr/>
-          <p:nvPr/>
-        </p:nvSpPr>
-        <p:spPr>
-          <a:xfrm>
-            <a:off x="5440680" y="4599432"/>
-            <a:ext cx="6400800" cy="475488"/>
+          <p:cNvPr id="37" name="Text 33">
+            <a:hlinkClick r:id="rId3" tooltip="Airbnb öffnen — 30. Okt.–2. Nov., 4 Gäste, 2 SZ"/>
+          </p:cNvPr>
+          <p:cNvSpPr/>
+          <p:nvPr/>
+        </p:nvSpPr>
+        <p:spPr>
+          <a:xfrm>
+            <a:off x="5303520" y="4599432"/>
+            <a:ext cx="6675120" cy="603504"/>
+          </a:xfrm>
+          <a:prstGeom prst="rect">
+            <a:avLst/>
+          </a:prstGeom>
+          <a:noFill/>
+          <a:ln/>
+        </p:spPr>
+        <p:txBody>
+          <a:bodyPr wrap="square" rtlCol="0" anchor="ctr"/>
+          <a:lstStyle/>
+          <a:p>
+            <a:pPr algn="ctr" indent="0" marL="0">
+              <a:buNone/>
+            </a:pPr>
+            <a:r>
+              <a:rPr lang="en-US" sz="1500" b="1" u="sng" dirty="0">
+                <a:solidFill>
+                  <a:srgbClr val="FFFFFF"/>
+                </a:solidFill>
+                <a:latin typeface="Trebuchet MS" pitchFamily="34" charset="0"/>
+                <a:ea typeface="Trebuchet MS" pitchFamily="34" charset="-122"/>
+                <a:cs typeface="Trebuchet MS" pitchFamily="34" charset="-120"/>
+                <a:hlinkClick r:id="rId3" invalidUrl="" action="" tgtFrame="" tooltip="Airbnb öffnen — 30. Okt.–2. Nov., 4 Gäste, 2 SZ" history="1" highlightClick="0" endSnd="0">
+                  <a:extLst>
+                    <a:ext uri="{A12FA001-AC4F-418D-AE19-62706E023703}">
+                      <ahyp:hlinkClr xmlns:ahyp="http://schemas.microsoft.com/office/drawing/2018/hyperlinkcolor" val="tx"/>
+                    </a:ext>
+                  </a:extLst>
+                </a:hlinkClick>
+              </a:rPr>
+              <a:t>🔍  Airbnb: Malta durchsuchen  →</a:t>
+            </a:r>
+            <a:endParaRPr lang="en-US" sz="1500" dirty="0"/>
+          </a:p>
+        </p:txBody>
+      </p:sp>
+      <p:sp>
+        <p:nvSpPr>
+          <p:cNvPr id="38" name="Text 34">
+            <a:hlinkClick r:id="rId4" tooltip="Alternative Suche öffnen"/>
+          </p:cNvPr>
+          <p:cNvSpPr/>
+          <p:nvPr/>
+        </p:nvSpPr>
+        <p:spPr>
+          <a:xfrm>
+            <a:off x="5394960" y="5276088"/>
+            <a:ext cx="6492240" cy="256032"/>
           </a:xfrm>
           <a:prstGeom prst="rect">
             <a:avLst/>
@@ -29054,56 +29122,24 @@
               <a:buNone/>
             </a:pPr>
             <a:r>
-              <a:rPr lang="en-US" sz="950" i="1" dirty="0">
-                <a:solidFill>
-                  <a:srgbClr val="1EB4C8"/>
-                </a:solidFill>
-                <a:latin typeface="Calibri" pitchFamily="34" charset="0"/>
-                <a:ea typeface="Calibri" pitchFamily="34" charset="-122"/>
-                <a:cs typeface="Calibri" pitchFamily="34" charset="-120"/>
-              </a:rPr>
-              <a:t>airbnb.com → Suche: St. Julian's Malta, 4 Gäste, 2 SZ, Terrasse, 30. Okt.–2. Nov.</a:t>
-            </a:r>
-            <a:endParaRPr lang="en-US" sz="950" dirty="0"/>
-          </a:p>
-        </p:txBody>
-      </p:sp>
-      <p:sp>
-        <p:nvSpPr>
-          <p:cNvPr id="38" name="Text 34"/>
-          <p:cNvSpPr/>
-          <p:nvPr/>
-        </p:nvSpPr>
-        <p:spPr>
-          <a:xfrm>
-            <a:off x="5394960" y="5166360"/>
-            <a:ext cx="6492240" cy="292608"/>
-          </a:xfrm>
-          <a:prstGeom prst="rect">
-            <a:avLst/>
-          </a:prstGeom>
-          <a:noFill/>
-          <a:ln/>
-        </p:spPr>
-        <p:txBody>
-          <a:bodyPr wrap="square" rtlCol="0" anchor="ctr"/>
-          <a:lstStyle/>
-          <a:p>
-            <a:pPr indent="0" marL="0">
-              <a:buNone/>
-            </a:pPr>
-            <a:r>
-              <a:rPr lang="en-US" sz="950" i="1" dirty="0">
+              <a:rPr lang="en-US" sz="900" i="1" u="sng" dirty="0">
                 <a:solidFill>
                   <a:srgbClr val="6B7280"/>
                 </a:solidFill>
                 <a:latin typeface="Calibri" pitchFamily="34" charset="0"/>
                 <a:ea typeface="Calibri" pitchFamily="34" charset="-122"/>
                 <a:cs typeface="Calibri" pitchFamily="34" charset="-120"/>
+                <a:hlinkClick r:id="rId4" invalidUrl="" action="" tgtFrame="" tooltip="Alternative Suche öffnen" history="1" highlightClick="0" endSnd="0">
+                  <a:extLst>
+                    <a:ext uri="{A12FA001-AC4F-418D-AE19-62706E023703}">
+                      <ahyp:hlinkClr xmlns:ahyp="http://schemas.microsoft.com/office/drawing/2018/hyperlinkcolor" val="tx"/>
+                    </a:ext>
+                  </a:extLst>
+                </a:hlinkClick>
               </a:rPr>
-              <a:t>Alternative: Sliema (ruhiger, Wasserfront) oder Valletta (historisch, UNESCO) ebenfalls empfohlen</a:t>
+              <a:t>📍 Alternativ in Sliema suchen: airbnb.com/s/Sliema--Malta (ruhiger, Wasserfront, gleiche Daten)</a:t>
             </a:r>
-            <a:endParaRPr lang="en-US" sz="950" dirty="0"/>
+            <a:endParaRPr lang="en-US" sz="900" dirty="0"/>
           </a:p>
         </p:txBody>
       </p:sp>
@@ -29115,8 +29151,8 @@
         </p:nvSpPr>
         <p:spPr>
           <a:xfrm>
-            <a:off x="5394960" y="5532120"/>
-            <a:ext cx="6492240" cy="292608"/>
+            <a:off x="5394960" y="5577840"/>
+            <a:ext cx="6492240" cy="274320"/>
           </a:xfrm>
           <a:prstGeom prst="rect">
             <a:avLst/>
@@ -29140,7 +29176,7 @@
                 <a:ea typeface="Calibri" pitchFamily="34" charset="-122"/>
                 <a:cs typeface="Calibri" pitchFamily="34" charset="-120"/>
               </a:rPr>
-              <a:t>🔑  Jetzt buchen — Halloween-Wochenende ist schnell ausgebucht!</a:t>
+              <a:t>⚠️  Halloween-Wochenende ist schnell ausgebucht — jetzt klicken &amp; buchen!</a:t>
             </a:r>
             <a:endParaRPr lang="en-US" sz="950" dirty="0"/>
           </a:p>

</xml_diff>

<commit_message>
Malta-Flüge korrigiert: kein DUS-Direktflug, FMO/DTM via Ryanair
- Direktflüge nur ab FMO (Münster) und DTM (Dortmund) mit Ryanair
- DUS-Passagiere: Umstieg-Option ergänzt (FRA/MUC → MLA)
- Flughinweis: FMO 1,5h von DUS, DTM 1h von DUS, Fahrgemeinschaft empfohlen
- Kosten angepasst: ~€586 p.P. (war €631, Ryanair günstiger als Eurowings)
- Direktvergleich-Folie entsprechend aktualisiert
</commit_message>
<xml_diff>
--- a/halloween_trip_2025.pptx
+++ b/halloween_trip_2025.pptx
@@ -4611,7 +4611,7 @@
                           <a:ea typeface="Calibri" pitchFamily="34" charset="-122"/>
                           <a:cs typeface="Calibri" pitchFamily="34" charset="-120"/>
                         </a:rPr>
-                        <a:t>Eurowings/Ryanair  DUS ↔ MLA</a:t>
+                        <a:t>Ryanair  FMO/DTM ↔ MLA  (+ Anfahrt ~€15)</a:t>
                       </a:r>
                       <a:endParaRPr lang="en-US" sz="1100" dirty="0">
                         <a:latin typeface="Calibri" charset="0"/>
@@ -4679,7 +4679,7 @@
                           <a:ea typeface="Calibri" pitchFamily="34" charset="-122"/>
                           <a:cs typeface="Calibri" pitchFamily="34" charset="-120"/>
                         </a:rPr>
-                        <a:t>~€185</a:t>
+                        <a:t>~€140</a:t>
                       </a:r>
                       <a:endParaRPr lang="en-US" sz="1100" dirty="0">
                         <a:latin typeface="Calibri" charset="0"/>
@@ -4747,7 +4747,7 @@
                           <a:ea typeface="Calibri" pitchFamily="34" charset="-122"/>
                           <a:cs typeface="Calibri" pitchFamily="34" charset="-120"/>
                         </a:rPr>
-                        <a:t>~€740</a:t>
+                        <a:t>~€560</a:t>
                       </a:r>
                       <a:endParaRPr lang="en-US" sz="1100" dirty="0">
                         <a:latin typeface="Calibri" charset="0"/>
@@ -7145,7 +7145,7 @@
                           <a:ea typeface="Trebuchet MS" pitchFamily="34" charset="-122"/>
                           <a:cs typeface="Trebuchet MS" pitchFamily="34" charset="-120"/>
                         </a:rPr>
-                        <a:t>~€631</a:t>
+                        <a:t>~€586</a:t>
                       </a:r>
                       <a:endParaRPr lang="en-US" sz="1300" dirty="0">
                         <a:latin typeface="Trebuchet MS" charset="0"/>
@@ -7213,7 +7213,7 @@
                           <a:ea typeface="Trebuchet MS" pitchFamily="34" charset="-122"/>
                           <a:cs typeface="Trebuchet MS" pitchFamily="34" charset="-120"/>
                         </a:rPr>
-                        <a:t>~€2.523</a:t>
+                        <a:t>~€2.344</a:t>
                       </a:r>
                       <a:endParaRPr lang="en-US" sz="1300" dirty="0">
                         <a:latin typeface="Trebuchet MS" charset="0"/>
@@ -7818,7 +7818,7 @@
                 <a:ea typeface="Calibri" pitchFamily="34" charset="-122"/>
                 <a:cs typeface="Calibri" pitchFamily="34" charset="-120"/>
               </a:rPr>
-              <a:t>~€631</a:t>
+              <a:t>~€586</a:t>
             </a:r>
             <a:endParaRPr lang="en-US" sz="1000" dirty="0"/>
           </a:p>
@@ -8010,7 +8010,7 @@
                 <a:ea typeface="Calibri" pitchFamily="34" charset="-122"/>
                 <a:cs typeface="Calibri" pitchFamily="34" charset="-120"/>
               </a:rPr>
-              <a:t>~3h 00m  ab DUS</a:t>
+              <a:t>~3h 00m  ab FMO/DTM</a:t>
             </a:r>
             <a:endParaRPr lang="en-US" sz="1000" dirty="0"/>
           </a:p>
@@ -8202,7 +8202,7 @@
                 <a:ea typeface="Calibri" pitchFamily="34" charset="-122"/>
                 <a:cs typeface="Calibri" pitchFamily="34" charset="-120"/>
               </a:rPr>
-              <a:t>DUS — Eurowings / Ryanair</a:t>
+              <a:t>FMO oder DTM — Ryanair direkt</a:t>
             </a:r>
             <a:endParaRPr lang="en-US" sz="1000" dirty="0"/>
           </a:p>
@@ -23757,7 +23757,7 @@
                 <a:ea typeface="Trebuchet MS" pitchFamily="34" charset="-122"/>
                 <a:cs typeface="Trebuchet MS" pitchFamily="34" charset="-120"/>
               </a:rPr>
-              <a:t>~€580</a:t>
+              <a:t>~€631</a:t>
             </a:r>
             <a:endParaRPr lang="en-US" sz="1600" dirty="0"/>
           </a:p>
@@ -23997,7 +23997,7 @@
                 <a:ea typeface="Trebuchet MS" pitchFamily="34" charset="-122"/>
                 <a:cs typeface="Trebuchet MS" pitchFamily="34" charset="-120"/>
               </a:rPr>
-              <a:t>DUS</a:t>
+              <a:t>FMO / DTM</a:t>
             </a:r>
             <a:endParaRPr lang="en-US" sz="1600" dirty="0"/>
           </a:p>
@@ -24014,7 +24014,7 @@
                 <a:ea typeface="Trebuchet MS" pitchFamily="34" charset="-122"/>
                 <a:cs typeface="Trebuchet MS" pitchFamily="34" charset="-120"/>
               </a:rPr>
-              <a:t>(Eurowings/Ryanair)</a:t>
+              <a:t>(Ryanair direkt)</a:t>
             </a:r>
             <a:endParaRPr lang="en-US" sz="1600" dirty="0"/>
           </a:p>
@@ -24958,7 +24958,7 @@
                           <a:ea typeface="Calibri" pitchFamily="34" charset="-122"/>
                           <a:cs typeface="Calibri" pitchFamily="34" charset="-120"/>
                         </a:rPr>
-                        <a:t>EW</a:t>
+                        <a:t>FR</a:t>
                       </a:r>
                       <a:endParaRPr lang="en-US" sz="1000" dirty="0">
                         <a:latin typeface="Calibri" charset="0"/>
@@ -24979,7 +24979,7 @@
                           <a:ea typeface="Calibri" pitchFamily="34" charset="-122"/>
                           <a:cs typeface="Calibri" pitchFamily="34" charset="-120"/>
                         </a:rPr>
-                        <a:t>Eurowings</a:t>
+                        <a:t>Ryanair</a:t>
                       </a:r>
                       <a:endParaRPr lang="en-US" sz="1000" dirty="0">
                         <a:latin typeface="Calibri" charset="0"/>
@@ -25047,7 +25047,7 @@
                           <a:ea typeface="Calibri" pitchFamily="34" charset="-122"/>
                           <a:cs typeface="Calibri" pitchFamily="34" charset="-120"/>
                         </a:rPr>
-                        <a:t>DUS → MLA</a:t>
+                        <a:t>FMO → MLA</a:t>
                       </a:r>
                       <a:endParaRPr lang="en-US" sz="1000" dirty="0">
                         <a:latin typeface="Calibri" charset="0"/>
@@ -25068,7 +25068,7 @@
                           <a:ea typeface="Calibri" pitchFamily="34" charset="-122"/>
                           <a:cs typeface="Calibri" pitchFamily="34" charset="-120"/>
                         </a:rPr>
-                        <a:t>30. Okt. früh</a:t>
+                        <a:t>30. Okt.</a:t>
                       </a:r>
                       <a:endParaRPr lang="en-US" sz="1000" dirty="0">
                         <a:latin typeface="Calibri" charset="0"/>
@@ -25136,7 +25136,7 @@
                           <a:ea typeface="Calibri" pitchFamily="34" charset="-122"/>
                           <a:cs typeface="Calibri" pitchFamily="34" charset="-120"/>
                         </a:rPr>
-                        <a:t>~07:xx</a:t>
+                        <a:t>Morgens</a:t>
                       </a:r>
                       <a:endParaRPr lang="en-US" sz="1000" dirty="0">
                         <a:latin typeface="Calibri" charset="0"/>
@@ -25204,7 +25204,7 @@
                           <a:ea typeface="Calibri" pitchFamily="34" charset="-122"/>
                           <a:cs typeface="Calibri" pitchFamily="34" charset="-120"/>
                         </a:rPr>
-                        <a:t>~10:00</a:t>
+                        <a:t>~10:30</a:t>
                       </a:r>
                       <a:endParaRPr lang="en-US" sz="1000" dirty="0">
                         <a:latin typeface="Calibri" charset="0"/>
@@ -25272,7 +25272,7 @@
                           <a:ea typeface="Calibri" pitchFamily="34" charset="-122"/>
                           <a:cs typeface="Calibri" pitchFamily="34" charset="-120"/>
                         </a:rPr>
-                        <a:t>2h 55m</a:t>
+                        <a:t>~3h 00m</a:t>
                       </a:r>
                       <a:endParaRPr lang="en-US" sz="1000" dirty="0">
                         <a:latin typeface="Calibri" charset="0"/>
@@ -25340,7 +25340,7 @@
                           <a:ea typeface="Calibri" pitchFamily="34" charset="-122"/>
                           <a:cs typeface="Calibri" pitchFamily="34" charset="-120"/>
                         </a:rPr>
-                        <a:t>~€90</a:t>
+                        <a:t>~€60–90</a:t>
                       </a:r>
                       <a:endParaRPr lang="en-US" sz="1000" dirty="0">
                         <a:latin typeface="Calibri" charset="0"/>
@@ -25408,7 +25408,7 @@
                           <a:ea typeface="Calibri" pitchFamily="34" charset="-122"/>
                           <a:cs typeface="Calibri" pitchFamily="34" charset="-120"/>
                         </a:rPr>
-                        <a:t>~€360</a:t>
+                        <a:t>~€240–360</a:t>
                       </a:r>
                       <a:endParaRPr lang="en-US" sz="1000" dirty="0">
                         <a:latin typeface="Calibri" charset="0"/>
@@ -25478,7 +25478,7 @@
                           <a:ea typeface="Calibri" pitchFamily="34" charset="-122"/>
                           <a:cs typeface="Calibri" pitchFamily="34" charset="-120"/>
                         </a:rPr>
-                        <a:t>Vorabend 29.10.</a:t>
+                        <a:t>Option 2</a:t>
                       </a:r>
                       <a:endParaRPr lang="en-US" sz="1000" dirty="0">
                         <a:latin typeface="Calibri" charset="0"/>
@@ -25546,7 +25546,7 @@
                           <a:ea typeface="Calibri" pitchFamily="34" charset="-122"/>
                           <a:cs typeface="Calibri" pitchFamily="34" charset="-120"/>
                         </a:rPr>
-                        <a:t>Eurowings</a:t>
+                        <a:t>FR</a:t>
                       </a:r>
                       <a:endParaRPr lang="en-US" sz="1000" dirty="0">
                         <a:latin typeface="Calibri" charset="0"/>
@@ -25567,7 +25567,7 @@
                           <a:ea typeface="Calibri" pitchFamily="34" charset="-122"/>
                           <a:cs typeface="Calibri" pitchFamily="34" charset="-120"/>
                         </a:rPr>
-                        <a:t>/ Ryanair</a:t>
+                        <a:t>Ryanair</a:t>
                       </a:r>
                       <a:endParaRPr lang="en-US" sz="1000" dirty="0">
                         <a:latin typeface="Calibri" charset="0"/>
@@ -25635,7 +25635,7 @@
                           <a:ea typeface="Calibri" pitchFamily="34" charset="-122"/>
                           <a:cs typeface="Calibri" pitchFamily="34" charset="-120"/>
                         </a:rPr>
-                        <a:t>DUS → MLA</a:t>
+                        <a:t>DTM → MLA</a:t>
                       </a:r>
                       <a:endParaRPr lang="en-US" sz="1000" dirty="0">
                         <a:latin typeface="Calibri" charset="0"/>
@@ -25656,7 +25656,7 @@
                           <a:ea typeface="Calibri" pitchFamily="34" charset="-122"/>
                           <a:cs typeface="Calibri" pitchFamily="34" charset="-120"/>
                         </a:rPr>
-                        <a:t>29. Okt. abends</a:t>
+                        <a:t>30. Okt.</a:t>
                       </a:r>
                       <a:endParaRPr lang="en-US" sz="1000" dirty="0">
                         <a:latin typeface="Calibri" charset="0"/>
@@ -25724,7 +25724,7 @@
                           <a:ea typeface="Calibri" pitchFamily="34" charset="-122"/>
                           <a:cs typeface="Calibri" pitchFamily="34" charset="-120"/>
                         </a:rPr>
-                        <a:t>Abends</a:t>
+                        <a:t>Morgens</a:t>
                       </a:r>
                       <a:endParaRPr lang="en-US" sz="1000" dirty="0">
                         <a:latin typeface="Calibri" charset="0"/>
@@ -25792,7 +25792,7 @@
                           <a:ea typeface="Calibri" pitchFamily="34" charset="-122"/>
                           <a:cs typeface="Calibri" pitchFamily="34" charset="-120"/>
                         </a:rPr>
-                        <a:t>Abends</a:t>
+                        <a:t>~10:45</a:t>
                       </a:r>
                       <a:endParaRPr lang="en-US" sz="1000" dirty="0">
                         <a:latin typeface="Calibri" charset="0"/>
@@ -25860,7 +25860,7 @@
                           <a:ea typeface="Calibri" pitchFamily="34" charset="-122"/>
                           <a:cs typeface="Calibri" pitchFamily="34" charset="-120"/>
                         </a:rPr>
-                        <a:t>~3h</a:t>
+                        <a:t>~3h 00m</a:t>
                       </a:r>
                       <a:endParaRPr lang="en-US" sz="1000" dirty="0">
                         <a:latin typeface="Calibri" charset="0"/>
@@ -25928,7 +25928,7 @@
                           <a:ea typeface="Calibri" pitchFamily="34" charset="-122"/>
                           <a:cs typeface="Calibri" pitchFamily="34" charset="-120"/>
                         </a:rPr>
-                        <a:t>~€100</a:t>
+                        <a:t>~€65–95</a:t>
                       </a:r>
                       <a:endParaRPr lang="en-US" sz="1000" dirty="0">
                         <a:latin typeface="Calibri" charset="0"/>
@@ -25996,7 +25996,7 @@
                           <a:ea typeface="Calibri" pitchFamily="34" charset="-122"/>
                           <a:cs typeface="Calibri" pitchFamily="34" charset="-120"/>
                         </a:rPr>
-                        <a:t>~€400</a:t>
+                        <a:t>~€260–380</a:t>
                       </a:r>
                       <a:endParaRPr lang="en-US" sz="1000" dirty="0">
                         <a:latin typeface="Calibri" charset="0"/>
@@ -26066,7 +26066,28 @@
                           <a:ea typeface="Calibri" pitchFamily="34" charset="-122"/>
                           <a:cs typeface="Calibri" pitchFamily="34" charset="-120"/>
                         </a:rPr>
-                        <a:t>Budget</a:t>
+                        <a:t>Vorabend</a:t>
+                      </a:r>
+                      <a:endParaRPr lang="en-US" sz="1000" dirty="0">
+                        <a:latin typeface="Calibri" charset="0"/>
+                        <a:ea typeface="Calibri" charset="0"/>
+                        <a:cs typeface="Calibri" charset="0"/>
+                      </a:endParaRPr>
+                    </a:p>
+                    <a:p>
+                      <a:pPr algn="ctr" indent="0" marL="0">
+                        <a:buNone/>
+                      </a:pPr>
+                      <a:r>
+                        <a:rPr lang="en-US" sz="1000" dirty="0">
+                          <a:solidFill>
+                            <a:srgbClr val="E8E8E8"/>
+                          </a:solidFill>
+                          <a:latin typeface="Calibri" pitchFamily="34" charset="0"/>
+                          <a:ea typeface="Calibri" pitchFamily="34" charset="-122"/>
+                          <a:cs typeface="Calibri" pitchFamily="34" charset="-120"/>
+                        </a:rPr>
+                        <a:t>29. Okt.</a:t>
                       </a:r>
                       <a:endParaRPr lang="en-US" sz="1000" dirty="0">
                         <a:latin typeface="Calibri" charset="0"/>
@@ -26223,7 +26244,7 @@
                           <a:ea typeface="Calibri" pitchFamily="34" charset="-122"/>
                           <a:cs typeface="Calibri" pitchFamily="34" charset="-120"/>
                         </a:rPr>
-                        <a:t>DUS → MLA</a:t>
+                        <a:t>FMO → MLA</a:t>
                       </a:r>
                       <a:endParaRPr lang="en-US" sz="1000" dirty="0">
                         <a:latin typeface="Calibri" charset="0"/>
@@ -26244,7 +26265,7 @@
                           <a:ea typeface="Calibri" pitchFamily="34" charset="-122"/>
                           <a:cs typeface="Calibri" pitchFamily="34" charset="-120"/>
                         </a:rPr>
-                        <a:t>30. Okt.</a:t>
+                        <a:t>29. Okt.</a:t>
                       </a:r>
                       <a:endParaRPr lang="en-US" sz="1000" dirty="0">
                         <a:latin typeface="Calibri" charset="0"/>
@@ -26312,7 +26333,7 @@
                           <a:ea typeface="Calibri" pitchFamily="34" charset="-122"/>
                           <a:cs typeface="Calibri" pitchFamily="34" charset="-120"/>
                         </a:rPr>
-                        <a:t>Verschieden</a:t>
+                        <a:t>Abends</a:t>
                       </a:r>
                       <a:endParaRPr lang="en-US" sz="1000" dirty="0">
                         <a:latin typeface="Calibri" charset="0"/>
@@ -26380,7 +26401,7 @@
                           <a:ea typeface="Calibri" pitchFamily="34" charset="-122"/>
                           <a:cs typeface="Calibri" pitchFamily="34" charset="-120"/>
                         </a:rPr>
-                        <a:t>Verschieden</a:t>
+                        <a:t>Abends</a:t>
                       </a:r>
                       <a:endParaRPr lang="en-US" sz="1000" dirty="0">
                         <a:latin typeface="Calibri" charset="0"/>
@@ -26448,7 +26469,7 @@
                           <a:ea typeface="Calibri" pitchFamily="34" charset="-122"/>
                           <a:cs typeface="Calibri" pitchFamily="34" charset="-120"/>
                         </a:rPr>
-                        <a:t>3h 00m</a:t>
+                        <a:t>~3h 00m</a:t>
                       </a:r>
                       <a:endParaRPr lang="en-US" sz="1000" dirty="0">
                         <a:latin typeface="Calibri" charset="0"/>
@@ -26516,7 +26537,7 @@
                           <a:ea typeface="Calibri" pitchFamily="34" charset="-122"/>
                           <a:cs typeface="Calibri" pitchFamily="34" charset="-120"/>
                         </a:rPr>
-                        <a:t>~€70–90</a:t>
+                        <a:t>~€70–100</a:t>
                       </a:r>
                       <a:endParaRPr lang="en-US" sz="1000" dirty="0">
                         <a:latin typeface="Calibri" charset="0"/>
@@ -26584,7 +26605,7 @@
                           <a:ea typeface="Calibri" pitchFamily="34" charset="-122"/>
                           <a:cs typeface="Calibri" pitchFamily="34" charset="-120"/>
                         </a:rPr>
-                        <a:t>~€280–360</a:t>
+                        <a:t>~€280–400</a:t>
                       </a:r>
                       <a:endParaRPr lang="en-US" sz="1000" dirty="0">
                         <a:latin typeface="Calibri" charset="0"/>
@@ -26636,6 +26657,594 @@
                   </a:tcPr>
                 </a:tc>
               </a:tr>
+              <a:tr h="475488">
+                <a:tc>
+                  <a:txBody>
+                    <a:bodyPr/>
+                    <a:lstStyle/>
+                    <a:p>
+                      <a:pPr algn="ctr" indent="0" marL="0">
+                        <a:buNone/>
+                      </a:pPr>
+                      <a:r>
+                        <a:rPr lang="en-US" sz="1000" dirty="0">
+                          <a:solidFill>
+                            <a:srgbClr val="E8E8E8"/>
+                          </a:solidFill>
+                          <a:latin typeface="Calibri" pitchFamily="34" charset="0"/>
+                          <a:ea typeface="Calibri" pitchFamily="34" charset="-122"/>
+                          <a:cs typeface="Calibri" pitchFamily="34" charset="-120"/>
+                        </a:rPr>
+                        <a:t>DUS-Passagiere</a:t>
+                      </a:r>
+                      <a:endParaRPr lang="en-US" sz="1000" dirty="0">
+                        <a:latin typeface="Calibri" charset="0"/>
+                        <a:ea typeface="Calibri" charset="0"/>
+                        <a:cs typeface="Calibri" charset="0"/>
+                      </a:endParaRPr>
+                    </a:p>
+                  </a:txBody>
+                  <a:tcPr marL="91440" marR="91440" marT="45720" marB="45720">
+                    <a:lnL w="12700" cap="flat" cmpd="sng" algn="ctr">
+                      <a:solidFill>
+                        <a:srgbClr val="0F3460"/>
+                      </a:solidFill>
+                      <a:prstDash val="solid"/>
+                      <a:round/>
+                      <a:headEnd type="none" w="med" len="med"/>
+                      <a:tailEnd type="none" w="med" len="med"/>
+                    </a:lnL>
+                    <a:lnR w="12700" cap="flat" cmpd="sng" algn="ctr">
+                      <a:solidFill>
+                        <a:srgbClr val="0F3460"/>
+                      </a:solidFill>
+                      <a:prstDash val="solid"/>
+                      <a:round/>
+                      <a:headEnd type="none" w="med" len="med"/>
+                      <a:tailEnd type="none" w="med" len="med"/>
+                    </a:lnR>
+                    <a:lnT w="12700" cap="flat" cmpd="sng" algn="ctr">
+                      <a:solidFill>
+                        <a:srgbClr val="0F3460"/>
+                      </a:solidFill>
+                      <a:prstDash val="solid"/>
+                      <a:round/>
+                      <a:headEnd type="none" w="med" len="med"/>
+                      <a:tailEnd type="none" w="med" len="med"/>
+                    </a:lnT>
+                    <a:lnB w="12700" cap="flat" cmpd="sng" algn="ctr">
+                      <a:solidFill>
+                        <a:srgbClr val="0F3460"/>
+                      </a:solidFill>
+                      <a:prstDash val="solid"/>
+                      <a:round/>
+                      <a:headEnd type="none" w="med" len="med"/>
+                      <a:tailEnd type="none" w="med" len="med"/>
+                    </a:lnB>
+                    <a:solidFill>
+                      <a:srgbClr val="1A1A2E"/>
+                    </a:solidFill>
+                  </a:tcPr>
+                </a:tc>
+                <a:tc>
+                  <a:txBody>
+                    <a:bodyPr/>
+                    <a:lstStyle/>
+                    <a:p>
+                      <a:pPr algn="ctr" indent="0" marL="0">
+                        <a:buNone/>
+                      </a:pPr>
+                      <a:r>
+                        <a:rPr lang="en-US" sz="1000" dirty="0">
+                          <a:solidFill>
+                            <a:srgbClr val="E8E8E8"/>
+                          </a:solidFill>
+                          <a:latin typeface="Calibri" pitchFamily="34" charset="0"/>
+                          <a:ea typeface="Calibri" pitchFamily="34" charset="-122"/>
+                          <a:cs typeface="Calibri" pitchFamily="34" charset="-120"/>
+                        </a:rPr>
+                        <a:t>Umstieg</a:t>
+                      </a:r>
+                      <a:endParaRPr lang="en-US" sz="1000" dirty="0">
+                        <a:latin typeface="Calibri" charset="0"/>
+                        <a:ea typeface="Calibri" charset="0"/>
+                        <a:cs typeface="Calibri" charset="0"/>
+                      </a:endParaRPr>
+                    </a:p>
+                    <a:p>
+                      <a:pPr algn="ctr" indent="0" marL="0">
+                        <a:buNone/>
+                      </a:pPr>
+                      <a:r>
+                        <a:rPr lang="en-US" sz="1000" dirty="0">
+                          <a:solidFill>
+                            <a:srgbClr val="E8E8E8"/>
+                          </a:solidFill>
+                          <a:latin typeface="Calibri" pitchFamily="34" charset="0"/>
+                          <a:ea typeface="Calibri" pitchFamily="34" charset="-122"/>
+                          <a:cs typeface="Calibri" pitchFamily="34" charset="-120"/>
+                        </a:rPr>
+                        <a:t>(z.B. LH/EW)</a:t>
+                      </a:r>
+                      <a:endParaRPr lang="en-US" sz="1000" dirty="0">
+                        <a:latin typeface="Calibri" charset="0"/>
+                        <a:ea typeface="Calibri" charset="0"/>
+                        <a:cs typeface="Calibri" charset="0"/>
+                      </a:endParaRPr>
+                    </a:p>
+                  </a:txBody>
+                  <a:tcPr marL="91440" marR="91440" marT="45720" marB="45720">
+                    <a:lnL w="12700" cap="flat" cmpd="sng" algn="ctr">
+                      <a:solidFill>
+                        <a:srgbClr val="0F3460"/>
+                      </a:solidFill>
+                      <a:prstDash val="solid"/>
+                      <a:round/>
+                      <a:headEnd type="none" w="med" len="med"/>
+                      <a:tailEnd type="none" w="med" len="med"/>
+                    </a:lnL>
+                    <a:lnR w="12700" cap="flat" cmpd="sng" algn="ctr">
+                      <a:solidFill>
+                        <a:srgbClr val="0F3460"/>
+                      </a:solidFill>
+                      <a:prstDash val="solid"/>
+                      <a:round/>
+                      <a:headEnd type="none" w="med" len="med"/>
+                      <a:tailEnd type="none" w="med" len="med"/>
+                    </a:lnR>
+                    <a:lnT w="12700" cap="flat" cmpd="sng" algn="ctr">
+                      <a:solidFill>
+                        <a:srgbClr val="0F3460"/>
+                      </a:solidFill>
+                      <a:prstDash val="solid"/>
+                      <a:round/>
+                      <a:headEnd type="none" w="med" len="med"/>
+                      <a:tailEnd type="none" w="med" len="med"/>
+                    </a:lnT>
+                    <a:lnB w="12700" cap="flat" cmpd="sng" algn="ctr">
+                      <a:solidFill>
+                        <a:srgbClr val="0F3460"/>
+                      </a:solidFill>
+                      <a:prstDash val="solid"/>
+                      <a:round/>
+                      <a:headEnd type="none" w="med" len="med"/>
+                      <a:tailEnd type="none" w="med" len="med"/>
+                    </a:lnB>
+                    <a:solidFill>
+                      <a:srgbClr val="1A1A2E"/>
+                    </a:solidFill>
+                  </a:tcPr>
+                </a:tc>
+                <a:tc>
+                  <a:txBody>
+                    <a:bodyPr/>
+                    <a:lstStyle/>
+                    <a:p>
+                      <a:pPr algn="ctr" indent="0" marL="0">
+                        <a:buNone/>
+                      </a:pPr>
+                      <a:r>
+                        <a:rPr lang="en-US" sz="1000" dirty="0">
+                          <a:solidFill>
+                            <a:srgbClr val="E8E8E8"/>
+                          </a:solidFill>
+                          <a:latin typeface="Calibri" pitchFamily="34" charset="0"/>
+                          <a:ea typeface="Calibri" pitchFamily="34" charset="-122"/>
+                          <a:cs typeface="Calibri" pitchFamily="34" charset="-120"/>
+                        </a:rPr>
+                        <a:t>DUS → FRA/MUC</a:t>
+                      </a:r>
+                      <a:endParaRPr lang="en-US" sz="1000" dirty="0">
+                        <a:latin typeface="Calibri" charset="0"/>
+                        <a:ea typeface="Calibri" charset="0"/>
+                        <a:cs typeface="Calibri" charset="0"/>
+                      </a:endParaRPr>
+                    </a:p>
+                    <a:p>
+                      <a:pPr algn="ctr" indent="0" marL="0">
+                        <a:buNone/>
+                      </a:pPr>
+                      <a:r>
+                        <a:rPr lang="en-US" sz="1000" dirty="0">
+                          <a:solidFill>
+                            <a:srgbClr val="E8E8E8"/>
+                          </a:solidFill>
+                          <a:latin typeface="Calibri" pitchFamily="34" charset="0"/>
+                          <a:ea typeface="Calibri" pitchFamily="34" charset="-122"/>
+                          <a:cs typeface="Calibri" pitchFamily="34" charset="-120"/>
+                        </a:rPr>
+                        <a:t>→ MLA</a:t>
+                      </a:r>
+                      <a:endParaRPr lang="en-US" sz="1000" dirty="0">
+                        <a:latin typeface="Calibri" charset="0"/>
+                        <a:ea typeface="Calibri" charset="0"/>
+                        <a:cs typeface="Calibri" charset="0"/>
+                      </a:endParaRPr>
+                    </a:p>
+                  </a:txBody>
+                  <a:tcPr marL="91440" marR="91440" marT="45720" marB="45720">
+                    <a:lnL w="12700" cap="flat" cmpd="sng" algn="ctr">
+                      <a:solidFill>
+                        <a:srgbClr val="0F3460"/>
+                      </a:solidFill>
+                      <a:prstDash val="solid"/>
+                      <a:round/>
+                      <a:headEnd type="none" w="med" len="med"/>
+                      <a:tailEnd type="none" w="med" len="med"/>
+                    </a:lnL>
+                    <a:lnR w="12700" cap="flat" cmpd="sng" algn="ctr">
+                      <a:solidFill>
+                        <a:srgbClr val="0F3460"/>
+                      </a:solidFill>
+                      <a:prstDash val="solid"/>
+                      <a:round/>
+                      <a:headEnd type="none" w="med" len="med"/>
+                      <a:tailEnd type="none" w="med" len="med"/>
+                    </a:lnR>
+                    <a:lnT w="12700" cap="flat" cmpd="sng" algn="ctr">
+                      <a:solidFill>
+                        <a:srgbClr val="0F3460"/>
+                      </a:solidFill>
+                      <a:prstDash val="solid"/>
+                      <a:round/>
+                      <a:headEnd type="none" w="med" len="med"/>
+                      <a:tailEnd type="none" w="med" len="med"/>
+                    </a:lnT>
+                    <a:lnB w="12700" cap="flat" cmpd="sng" algn="ctr">
+                      <a:solidFill>
+                        <a:srgbClr val="0F3460"/>
+                      </a:solidFill>
+                      <a:prstDash val="solid"/>
+                      <a:round/>
+                      <a:headEnd type="none" w="med" len="med"/>
+                      <a:tailEnd type="none" w="med" len="med"/>
+                    </a:lnB>
+                    <a:solidFill>
+                      <a:srgbClr val="1A1A2E"/>
+                    </a:solidFill>
+                  </a:tcPr>
+                </a:tc>
+                <a:tc>
+                  <a:txBody>
+                    <a:bodyPr/>
+                    <a:lstStyle/>
+                    <a:p>
+                      <a:pPr algn="ctr" indent="0" marL="0">
+                        <a:buNone/>
+                      </a:pPr>
+                      <a:r>
+                        <a:rPr lang="en-US" sz="1000" dirty="0">
+                          <a:solidFill>
+                            <a:srgbClr val="E8E8E8"/>
+                          </a:solidFill>
+                          <a:latin typeface="Calibri" pitchFamily="34" charset="0"/>
+                          <a:ea typeface="Calibri" pitchFamily="34" charset="-122"/>
+                          <a:cs typeface="Calibri" pitchFamily="34" charset="-120"/>
+                        </a:rPr>
+                        <a:t>—</a:t>
+                      </a:r>
+                      <a:endParaRPr lang="en-US" sz="1000" dirty="0">
+                        <a:latin typeface="Calibri" charset="0"/>
+                        <a:ea typeface="Calibri" charset="0"/>
+                        <a:cs typeface="Calibri" charset="0"/>
+                      </a:endParaRPr>
+                    </a:p>
+                  </a:txBody>
+                  <a:tcPr marL="91440" marR="91440" marT="45720" marB="45720">
+                    <a:lnL w="12700" cap="flat" cmpd="sng" algn="ctr">
+                      <a:solidFill>
+                        <a:srgbClr val="0F3460"/>
+                      </a:solidFill>
+                      <a:prstDash val="solid"/>
+                      <a:round/>
+                      <a:headEnd type="none" w="med" len="med"/>
+                      <a:tailEnd type="none" w="med" len="med"/>
+                    </a:lnL>
+                    <a:lnR w="12700" cap="flat" cmpd="sng" algn="ctr">
+                      <a:solidFill>
+                        <a:srgbClr val="0F3460"/>
+                      </a:solidFill>
+                      <a:prstDash val="solid"/>
+                      <a:round/>
+                      <a:headEnd type="none" w="med" len="med"/>
+                      <a:tailEnd type="none" w="med" len="med"/>
+                    </a:lnR>
+                    <a:lnT w="12700" cap="flat" cmpd="sng" algn="ctr">
+                      <a:solidFill>
+                        <a:srgbClr val="0F3460"/>
+                      </a:solidFill>
+                      <a:prstDash val="solid"/>
+                      <a:round/>
+                      <a:headEnd type="none" w="med" len="med"/>
+                      <a:tailEnd type="none" w="med" len="med"/>
+                    </a:lnT>
+                    <a:lnB w="12700" cap="flat" cmpd="sng" algn="ctr">
+                      <a:solidFill>
+                        <a:srgbClr val="0F3460"/>
+                      </a:solidFill>
+                      <a:prstDash val="solid"/>
+                      <a:round/>
+                      <a:headEnd type="none" w="med" len="med"/>
+                      <a:tailEnd type="none" w="med" len="med"/>
+                    </a:lnB>
+                    <a:solidFill>
+                      <a:srgbClr val="1A1A2E"/>
+                    </a:solidFill>
+                  </a:tcPr>
+                </a:tc>
+                <a:tc>
+                  <a:txBody>
+                    <a:bodyPr/>
+                    <a:lstStyle/>
+                    <a:p>
+                      <a:pPr algn="ctr" indent="0" marL="0">
+                        <a:buNone/>
+                      </a:pPr>
+                      <a:r>
+                        <a:rPr lang="en-US" sz="1000" dirty="0">
+                          <a:solidFill>
+                            <a:srgbClr val="E8E8E8"/>
+                          </a:solidFill>
+                          <a:latin typeface="Calibri" pitchFamily="34" charset="0"/>
+                          <a:ea typeface="Calibri" pitchFamily="34" charset="-122"/>
+                          <a:cs typeface="Calibri" pitchFamily="34" charset="-120"/>
+                        </a:rPr>
+                        <a:t>—</a:t>
+                      </a:r>
+                      <a:endParaRPr lang="en-US" sz="1000" dirty="0">
+                        <a:latin typeface="Calibri" charset="0"/>
+                        <a:ea typeface="Calibri" charset="0"/>
+                        <a:cs typeface="Calibri" charset="0"/>
+                      </a:endParaRPr>
+                    </a:p>
+                  </a:txBody>
+                  <a:tcPr marL="91440" marR="91440" marT="45720" marB="45720">
+                    <a:lnL w="12700" cap="flat" cmpd="sng" algn="ctr">
+                      <a:solidFill>
+                        <a:srgbClr val="0F3460"/>
+                      </a:solidFill>
+                      <a:prstDash val="solid"/>
+                      <a:round/>
+                      <a:headEnd type="none" w="med" len="med"/>
+                      <a:tailEnd type="none" w="med" len="med"/>
+                    </a:lnL>
+                    <a:lnR w="12700" cap="flat" cmpd="sng" algn="ctr">
+                      <a:solidFill>
+                        <a:srgbClr val="0F3460"/>
+                      </a:solidFill>
+                      <a:prstDash val="solid"/>
+                      <a:round/>
+                      <a:headEnd type="none" w="med" len="med"/>
+                      <a:tailEnd type="none" w="med" len="med"/>
+                    </a:lnR>
+                    <a:lnT w="12700" cap="flat" cmpd="sng" algn="ctr">
+                      <a:solidFill>
+                        <a:srgbClr val="0F3460"/>
+                      </a:solidFill>
+                      <a:prstDash val="solid"/>
+                      <a:round/>
+                      <a:headEnd type="none" w="med" len="med"/>
+                      <a:tailEnd type="none" w="med" len="med"/>
+                    </a:lnT>
+                    <a:lnB w="12700" cap="flat" cmpd="sng" algn="ctr">
+                      <a:solidFill>
+                        <a:srgbClr val="0F3460"/>
+                      </a:solidFill>
+                      <a:prstDash val="solid"/>
+                      <a:round/>
+                      <a:headEnd type="none" w="med" len="med"/>
+                      <a:tailEnd type="none" w="med" len="med"/>
+                    </a:lnB>
+                    <a:solidFill>
+                      <a:srgbClr val="1A1A2E"/>
+                    </a:solidFill>
+                  </a:tcPr>
+                </a:tc>
+                <a:tc>
+                  <a:txBody>
+                    <a:bodyPr/>
+                    <a:lstStyle/>
+                    <a:p>
+                      <a:pPr algn="ctr" indent="0" marL="0">
+                        <a:buNone/>
+                      </a:pPr>
+                      <a:r>
+                        <a:rPr lang="en-US" sz="1000" dirty="0">
+                          <a:solidFill>
+                            <a:srgbClr val="E8E8E8"/>
+                          </a:solidFill>
+                          <a:latin typeface="Calibri" pitchFamily="34" charset="0"/>
+                          <a:ea typeface="Calibri" pitchFamily="34" charset="-122"/>
+                          <a:cs typeface="Calibri" pitchFamily="34" charset="-120"/>
+                        </a:rPr>
+                        <a:t>5–7h</a:t>
+                      </a:r>
+                      <a:endParaRPr lang="en-US" sz="1000" dirty="0">
+                        <a:latin typeface="Calibri" charset="0"/>
+                        <a:ea typeface="Calibri" charset="0"/>
+                        <a:cs typeface="Calibri" charset="0"/>
+                      </a:endParaRPr>
+                    </a:p>
+                  </a:txBody>
+                  <a:tcPr marL="91440" marR="91440" marT="45720" marB="45720">
+                    <a:lnL w="12700" cap="flat" cmpd="sng" algn="ctr">
+                      <a:solidFill>
+                        <a:srgbClr val="0F3460"/>
+                      </a:solidFill>
+                      <a:prstDash val="solid"/>
+                      <a:round/>
+                      <a:headEnd type="none" w="med" len="med"/>
+                      <a:tailEnd type="none" w="med" len="med"/>
+                    </a:lnL>
+                    <a:lnR w="12700" cap="flat" cmpd="sng" algn="ctr">
+                      <a:solidFill>
+                        <a:srgbClr val="0F3460"/>
+                      </a:solidFill>
+                      <a:prstDash val="solid"/>
+                      <a:round/>
+                      <a:headEnd type="none" w="med" len="med"/>
+                      <a:tailEnd type="none" w="med" len="med"/>
+                    </a:lnR>
+                    <a:lnT w="12700" cap="flat" cmpd="sng" algn="ctr">
+                      <a:solidFill>
+                        <a:srgbClr val="0F3460"/>
+                      </a:solidFill>
+                      <a:prstDash val="solid"/>
+                      <a:round/>
+                      <a:headEnd type="none" w="med" len="med"/>
+                      <a:tailEnd type="none" w="med" len="med"/>
+                    </a:lnT>
+                    <a:lnB w="12700" cap="flat" cmpd="sng" algn="ctr">
+                      <a:solidFill>
+                        <a:srgbClr val="0F3460"/>
+                      </a:solidFill>
+                      <a:prstDash val="solid"/>
+                      <a:round/>
+                      <a:headEnd type="none" w="med" len="med"/>
+                      <a:tailEnd type="none" w="med" len="med"/>
+                    </a:lnB>
+                    <a:solidFill>
+                      <a:srgbClr val="1A1A2E"/>
+                    </a:solidFill>
+                  </a:tcPr>
+                </a:tc>
+                <a:tc>
+                  <a:txBody>
+                    <a:bodyPr/>
+                    <a:lstStyle/>
+                    <a:p>
+                      <a:pPr algn="ctr" indent="0" marL="0">
+                        <a:buNone/>
+                      </a:pPr>
+                      <a:r>
+                        <a:rPr lang="en-US" sz="1000" dirty="0">
+                          <a:solidFill>
+                            <a:srgbClr val="E8E8E8"/>
+                          </a:solidFill>
+                          <a:latin typeface="Calibri" pitchFamily="34" charset="0"/>
+                          <a:ea typeface="Calibri" pitchFamily="34" charset="-122"/>
+                          <a:cs typeface="Calibri" pitchFamily="34" charset="-120"/>
+                        </a:rPr>
+                        <a:t>~€120–180</a:t>
+                      </a:r>
+                      <a:endParaRPr lang="en-US" sz="1000" dirty="0">
+                        <a:latin typeface="Calibri" charset="0"/>
+                        <a:ea typeface="Calibri" charset="0"/>
+                        <a:cs typeface="Calibri" charset="0"/>
+                      </a:endParaRPr>
+                    </a:p>
+                  </a:txBody>
+                  <a:tcPr marL="91440" marR="91440" marT="45720" marB="45720">
+                    <a:lnL w="12700" cap="flat" cmpd="sng" algn="ctr">
+                      <a:solidFill>
+                        <a:srgbClr val="0F3460"/>
+                      </a:solidFill>
+                      <a:prstDash val="solid"/>
+                      <a:round/>
+                      <a:headEnd type="none" w="med" len="med"/>
+                      <a:tailEnd type="none" w="med" len="med"/>
+                    </a:lnL>
+                    <a:lnR w="12700" cap="flat" cmpd="sng" algn="ctr">
+                      <a:solidFill>
+                        <a:srgbClr val="0F3460"/>
+                      </a:solidFill>
+                      <a:prstDash val="solid"/>
+                      <a:round/>
+                      <a:headEnd type="none" w="med" len="med"/>
+                      <a:tailEnd type="none" w="med" len="med"/>
+                    </a:lnR>
+                    <a:lnT w="12700" cap="flat" cmpd="sng" algn="ctr">
+                      <a:solidFill>
+                        <a:srgbClr val="0F3460"/>
+                      </a:solidFill>
+                      <a:prstDash val="solid"/>
+                      <a:round/>
+                      <a:headEnd type="none" w="med" len="med"/>
+                      <a:tailEnd type="none" w="med" len="med"/>
+                    </a:lnT>
+                    <a:lnB w="12700" cap="flat" cmpd="sng" algn="ctr">
+                      <a:solidFill>
+                        <a:srgbClr val="0F3460"/>
+                      </a:solidFill>
+                      <a:prstDash val="solid"/>
+                      <a:round/>
+                      <a:headEnd type="none" w="med" len="med"/>
+                      <a:tailEnd type="none" w="med" len="med"/>
+                    </a:lnB>
+                    <a:solidFill>
+                      <a:srgbClr val="1A1A2E"/>
+                    </a:solidFill>
+                  </a:tcPr>
+                </a:tc>
+                <a:tc>
+                  <a:txBody>
+                    <a:bodyPr/>
+                    <a:lstStyle/>
+                    <a:p>
+                      <a:pPr algn="ctr" indent="0" marL="0">
+                        <a:buNone/>
+                      </a:pPr>
+                      <a:r>
+                        <a:rPr lang="en-US" sz="1000" dirty="0">
+                          <a:solidFill>
+                            <a:srgbClr val="FFC107"/>
+                          </a:solidFill>
+                          <a:latin typeface="Calibri" pitchFamily="34" charset="0"/>
+                          <a:ea typeface="Calibri" pitchFamily="34" charset="-122"/>
+                          <a:cs typeface="Calibri" pitchFamily="34" charset="-120"/>
+                        </a:rPr>
+                        <a:t>~€480–720</a:t>
+                      </a:r>
+                      <a:endParaRPr lang="en-US" sz="1000" dirty="0">
+                        <a:latin typeface="Calibri" charset="0"/>
+                        <a:ea typeface="Calibri" charset="0"/>
+                        <a:cs typeface="Calibri" charset="0"/>
+                      </a:endParaRPr>
+                    </a:p>
+                  </a:txBody>
+                  <a:tcPr marL="91440" marR="91440" marT="45720" marB="45720">
+                    <a:lnL w="12700" cap="flat" cmpd="sng" algn="ctr">
+                      <a:solidFill>
+                        <a:srgbClr val="0F3460"/>
+                      </a:solidFill>
+                      <a:prstDash val="solid"/>
+                      <a:round/>
+                      <a:headEnd type="none" w="med" len="med"/>
+                      <a:tailEnd type="none" w="med" len="med"/>
+                    </a:lnL>
+                    <a:lnR w="12700" cap="flat" cmpd="sng" algn="ctr">
+                      <a:solidFill>
+                        <a:srgbClr val="0F3460"/>
+                      </a:solidFill>
+                      <a:prstDash val="solid"/>
+                      <a:round/>
+                      <a:headEnd type="none" w="med" len="med"/>
+                      <a:tailEnd type="none" w="med" len="med"/>
+                    </a:lnR>
+                    <a:lnT w="12700" cap="flat" cmpd="sng" algn="ctr">
+                      <a:solidFill>
+                        <a:srgbClr val="0F3460"/>
+                      </a:solidFill>
+                      <a:prstDash val="solid"/>
+                      <a:round/>
+                      <a:headEnd type="none" w="med" len="med"/>
+                      <a:tailEnd type="none" w="med" len="med"/>
+                    </a:lnT>
+                    <a:lnB w="12700" cap="flat" cmpd="sng" algn="ctr">
+                      <a:solidFill>
+                        <a:srgbClr val="0F3460"/>
+                      </a:solidFill>
+                      <a:prstDash val="solid"/>
+                      <a:round/>
+                      <a:headEnd type="none" w="med" len="med"/>
+                      <a:tailEnd type="none" w="med" len="med"/>
+                    </a:lnB>
+                    <a:solidFill>
+                      <a:srgbClr val="1A1A2E"/>
+                    </a:solidFill>
+                  </a:tcPr>
+                </a:tc>
+              </a:tr>
             </a:tbl>
           </a:graphicData>
         </a:graphic>
@@ -26648,7 +27257,7 @@
         </p:nvSpPr>
         <p:spPr>
           <a:xfrm>
-            <a:off x="365760" y="3236976"/>
+            <a:off x="365760" y="3712464"/>
             <a:ext cx="11430000" cy="320040"/>
           </a:xfrm>
           <a:prstGeom prst="rect">
@@ -26694,7 +27303,7 @@
           </p:nvPr>
         </p:nvGraphicFramePr>
         <p:xfrm>
-          <a:off x="365760" y="3575304"/>
+          <a:off x="365760" y="4050792"/>
           <a:ext cx="11430000" cy="914400"/>
         </p:xfrm>
         <a:graphic>
@@ -27206,7 +27815,7 @@
                           <a:ea typeface="Calibri" pitchFamily="34" charset="-122"/>
                           <a:cs typeface="Calibri" pitchFamily="34" charset="-120"/>
                         </a:rPr>
-                        <a:t>Eurowings/Ryanair  (MLA→DUS)</a:t>
+                        <a:t>FR Ryanair  (MLA→FMO/DTM)</a:t>
                       </a:r>
                       <a:endParaRPr lang="en-US" sz="1000" dirty="0">
                         <a:latin typeface="Calibri" charset="0"/>
@@ -27274,7 +27883,7 @@
                           <a:ea typeface="Calibri" pitchFamily="34" charset="-122"/>
                           <a:cs typeface="Calibri" pitchFamily="34" charset="-120"/>
                         </a:rPr>
-                        <a:t>MLA → DUS  /  2. Nov.</a:t>
+                        <a:t>MLA → FMO oder DTM  /  2. Nov.</a:t>
                       </a:r>
                       <a:endParaRPr lang="en-US" sz="1000" dirty="0">
                         <a:latin typeface="Calibri" charset="0"/>
@@ -27478,7 +28087,7 @@
                           <a:ea typeface="Calibri" pitchFamily="34" charset="-122"/>
                           <a:cs typeface="Calibri" pitchFamily="34" charset="-120"/>
                         </a:rPr>
-                        <a:t>~3h</a:t>
+                        <a:t>~3h 00m</a:t>
                       </a:r>
                       <a:endParaRPr lang="en-US" sz="1000" dirty="0">
                         <a:latin typeface="Calibri" charset="0"/>
@@ -27546,7 +28155,7 @@
                           <a:ea typeface="Calibri" pitchFamily="34" charset="-122"/>
                           <a:cs typeface="Calibri" pitchFamily="34" charset="-120"/>
                         </a:rPr>
-                        <a:t>~€80–100</a:t>
+                        <a:t>~€50–90</a:t>
                       </a:r>
                       <a:endParaRPr lang="en-US" sz="1000" dirty="0">
                         <a:latin typeface="Calibri" charset="0"/>
@@ -27614,7 +28223,7 @@
                           <a:ea typeface="Calibri" pitchFamily="34" charset="-122"/>
                           <a:cs typeface="Calibri" pitchFamily="34" charset="-120"/>
                         </a:rPr>
-                        <a:t>~€320–400</a:t>
+                        <a:t>~€200–360</a:t>
                       </a:r>
                       <a:endParaRPr lang="en-US" sz="1000" dirty="0">
                         <a:latin typeface="Calibri" charset="0"/>
@@ -27678,7 +28287,7 @@
         </p:nvSpPr>
         <p:spPr>
           <a:xfrm>
-            <a:off x="365760" y="4535424"/>
+            <a:off x="365760" y="5010912"/>
             <a:ext cx="11430000" cy="658368"/>
           </a:xfrm>
           <a:prstGeom prst="rect">
@@ -27703,7 +28312,7 @@
         </p:nvSpPr>
         <p:spPr>
           <a:xfrm>
-            <a:off x="502920" y="4581144"/>
+            <a:off x="502920" y="5056632"/>
             <a:ext cx="11155680" cy="566928"/>
           </a:xfrm>
           <a:prstGeom prst="rect">
@@ -27728,7 +28337,7 @@
                 <a:ea typeface="Calibri" pitchFamily="34" charset="-122"/>
                 <a:cs typeface="Calibri" pitchFamily="34" charset="-120"/>
               </a:rPr>
-              <a:t>🌞  Malta ist mit 22–24°C Anfang November das WÄRMSTE Reiseziel dieser Auswahl!  Flughafen Malta (MLA) liegt 8 km südlich von Valletta — Taxi/Bus ins Zentrum ~20 Min.  Direktflüge ab DUS mit Eurowings &amp; Ryanair.  Buchen: eurowings.com · ryanair.com · skyscanner.de</a:t>
+              <a:t>⚠️  KEIN Direktflug ab DUS (Düsseldorf) nach Malta!  Direktflüge ab FMO (Münster/Osnabrück) und DTM (Dortmund) mit Ryanair.  FMO liegt ~100 km von DUS entfernt (1,5h Fahrt), DTM ~70 km (1h Fahrt).  Empfehlung: Fahrgemeinschaft nach FMO oder DTM zum Abflug.  Buchen: ryanair.com · skyscanner.de</a:t>
             </a:r>
             <a:endParaRPr lang="en-US" sz="1000" dirty="0"/>
           </a:p>
@@ -27742,7 +28351,7 @@
         </p:nvSpPr>
         <p:spPr>
           <a:xfrm>
-            <a:off x="8046720" y="5312664"/>
+            <a:off x="8046720" y="5788152"/>
             <a:ext cx="3749040" cy="777240"/>
           </a:xfrm>
           <a:prstGeom prst="rect">
@@ -27767,7 +28376,7 @@
         </p:nvSpPr>
         <p:spPr>
           <a:xfrm>
-            <a:off x="8046720" y="5330952"/>
+            <a:off x="8046720" y="5806440"/>
             <a:ext cx="3749040" cy="274320"/>
           </a:xfrm>
           <a:prstGeom prst="rect">
@@ -27806,7 +28415,7 @@
         </p:nvSpPr>
         <p:spPr>
           <a:xfrm>
-            <a:off x="8046720" y="5605272"/>
+            <a:off x="8046720" y="6080760"/>
             <a:ext cx="3749040" cy="438912"/>
           </a:xfrm>
           <a:prstGeom prst="rect">
@@ -27831,7 +28440,7 @@
                 <a:ea typeface="Trebuchet MS" pitchFamily="34" charset="-122"/>
                 <a:cs typeface="Trebuchet MS" pitchFamily="34" charset="-120"/>
               </a:rPr>
-              <a:t>€600 – €800 gesamt</a:t>
+              <a:t>€400 – €560 gesamt</a:t>
             </a:r>
             <a:endParaRPr lang="en-US" sz="2000" dirty="0"/>
           </a:p>

</xml_diff>

<commit_message>
Mailand durch Sofia ersetzt
- Sofia (SOF) mit Direktflug ab DUS via Bulgaria Air / Ryanair
- Günstigstes Ziel: €1-2 Bier, €65 Airbnb p.P., ~€510 Gesamt p.P.
- Highlights: Vitosha Blvd, Yalta Club, Alexander-Nevsky-Kathedrale,
  Vitosha-Berg direkt an der Stadtgrenze
- Neue Bilder: sofia_hero (Dämmerung mit Kathedrale), sofia_map,
  sofia_airbnb (Google Maps Vitosha Blvd-Bereich)
</commit_message>
<xml_diff>
--- a/halloween_trip_2025.pptx
+++ b/halloween_trip_2025.pptx
@@ -2324,7 +2324,7 @@
           </a:solidFill>
           <a:ln w="12700">
             <a:solidFill>
-              <a:srgbClr val="C8003C"/>
+              <a:srgbClr val="8C52E8"/>
             </a:solidFill>
             <a:prstDash val="solid"/>
           </a:ln>
@@ -2363,7 +2363,7 @@
                 <a:ea typeface="Trebuchet MS" pitchFamily="34" charset="-122"/>
                 <a:cs typeface="Trebuchet MS" pitchFamily="34" charset="-120"/>
               </a:rPr>
-              <a:t>🇮🇹 MAILAND</a:t>
+              <a:t>🇧🇬 SOFIA</a:t>
             </a:r>
             <a:endParaRPr lang="en-US" sz="2400" dirty="0"/>
           </a:p>
@@ -2402,7 +2402,7 @@
                 <a:ea typeface="Calibri" pitchFamily="34" charset="-122"/>
                 <a:cs typeface="Calibri" pitchFamily="34" charset="-120"/>
               </a:rPr>
-              <a:t>Beide Ziele: Direktflug ab DUS  ·  Lissabon 17–22°C · Mailand 12–16°C</a:t>
+              <a:t>Beide Ziele: Direktflug ab DUS  ·  Lissabon 17–22°C · Sofia 10–14°C</a:t>
             </a:r>
             <a:endParaRPr lang="en-US" sz="1300" dirty="0"/>
           </a:p>
@@ -2480,11 +2480,11 @@
             <a:avLst/>
           </a:prstGeom>
           <a:solidFill>
-            <a:srgbClr val="C8003C"/>
+            <a:srgbClr val="8C52E8"/>
           </a:solidFill>
           <a:ln w="12700">
             <a:solidFill>
-              <a:srgbClr val="C8003C"/>
+              <a:srgbClr val="8C52E8"/>
             </a:solidFill>
             <a:prstDash val="solid"/>
           </a:ln>
@@ -2548,7 +2548,7 @@
                 <a:ea typeface="Trebuchet MS" pitchFamily="34" charset="-122"/>
                 <a:cs typeface="Trebuchet MS" pitchFamily="34" charset="-120"/>
               </a:rPr>
-              <a:t>🇮🇹  MAILAND — TAGESPROGRAMM</a:t>
+              <a:t>🇧🇬  SOFIA — TAGESPROGRAMM</a:t>
             </a:r>
             <a:endParaRPr lang="en-US" sz="2200" dirty="0"/>
           </a:p>
@@ -2569,11 +2569,11 @@
             <a:avLst/>
           </a:prstGeom>
           <a:solidFill>
-            <a:srgbClr val="C8003C"/>
+            <a:srgbClr val="8C52E8"/>
           </a:solidFill>
           <a:ln w="12700">
             <a:solidFill>
-              <a:srgbClr val="C8003C"/>
+              <a:srgbClr val="8C52E8"/>
             </a:solidFill>
             <a:prstDash val="solid"/>
           </a:ln>
@@ -2598,7 +2598,7 @@
           </a:solidFill>
           <a:ln w="12700">
             <a:solidFill>
-              <a:srgbClr val="C8003C"/>
+              <a:srgbClr val="8C52E8"/>
             </a:solidFill>
             <a:prstDash val="solid"/>
           </a:ln>
@@ -2656,7 +2656,7 @@
             <a:r>
               <a:rPr lang="en-US" sz="1100" b="1" dirty="0">
                 <a:solidFill>
-                  <a:srgbClr val="C8003C"/>
+                  <a:srgbClr val="8C52E8"/>
                 </a:solidFill>
                 <a:latin typeface="Trebuchet MS" pitchFamily="34" charset="0"/>
                 <a:ea typeface="Trebuchet MS" pitchFamily="34" charset="-122"/>
@@ -2740,7 +2740,7 @@
                 <a:ea typeface="Calibri" pitchFamily="34" charset="-122"/>
                 <a:cs typeface="Calibri" pitchFamily="34" charset="-120"/>
               </a:rPr>
-              <a:t>✈  Eurowings landet MXP ~08:40 · Malpensa Express ins Zentrum</a:t>
+              <a:t>✈  Landet SOF ~11:00 · Metro M1 ins Zentrum (€0,80!)</a:t>
             </a:r>
             <a:endParaRPr lang="en-US" sz="900" dirty="0"/>
           </a:p>
@@ -2779,7 +2779,7 @@
                 <a:ea typeface="Calibri" pitchFamily="34" charset="-122"/>
                 <a:cs typeface="Calibri" pitchFamily="34" charset="-120"/>
               </a:rPr>
-              <a:t>🏠  Einchecken in Navigli (Check-in ab 15 Uhr)</a:t>
+              <a:t>🏠  Einchecken in der Vitosha-Nähe</a:t>
             </a:r>
             <a:endParaRPr lang="en-US" sz="900" dirty="0"/>
           </a:p>
@@ -2818,7 +2818,7 @@
                 <a:ea typeface="Calibri" pitchFamily="34" charset="-122"/>
                 <a:cs typeface="Calibri" pitchFamily="34" charset="-120"/>
               </a:rPr>
-              <a:t>🚶  SANDEMANs Stadtführung 14:30 @ Duomo (2,5h, Trinkgeld)</a:t>
+              <a:t>🚶  SANDEMANs Free Tour 14:30 @ Alexander-Nevsky-Platz</a:t>
             </a:r>
             <a:endParaRPr lang="en-US" sz="900" dirty="0"/>
           </a:p>
@@ -2857,7 +2857,7 @@
                 <a:ea typeface="Calibri" pitchFamily="34" charset="-122"/>
                 <a:cs typeface="Calibri" pitchFamily="34" charset="-120"/>
               </a:rPr>
-              <a:t>   Duomo, Galleria Vittorio Emanuele, Castello Sforzesco</a:t>
+              <a:t>   Kathedrale, Präsidentenpalast, Rotunde Sveti Georgi</a:t>
             </a:r>
             <a:endParaRPr lang="en-US" sz="900" dirty="0"/>
           </a:p>
@@ -2896,7 +2896,7 @@
                 <a:ea typeface="Calibri" pitchFamily="34" charset="-122"/>
                 <a:cs typeface="Calibri" pitchFamily="34" charset="-120"/>
               </a:rPr>
-              <a:t>🍹  Aperitivo ab 18 Uhr am Naviglio Grande</a:t>
+              <a:t>🍺  Erste Biere am Vitosha Blvd: €1–2 pro Bier (kein Tippfehler!)</a:t>
             </a:r>
             <a:endParaRPr lang="en-US" sz="900" dirty="0"/>
           </a:p>
@@ -2935,7 +2935,7 @@
                 <a:ea typeface="Calibri" pitchFamily="34" charset="-122"/>
                 <a:cs typeface="Calibri" pitchFamily="34" charset="-120"/>
               </a:rPr>
-              <a:t>   €8–10 Drink + gratis Buffet — Mailänder Tradition!</a:t>
+              <a:t>🌃  Erste Nacht: Vitosha Blvd Bars &amp; Lounge-Cafés</a:t>
             </a:r>
             <a:endParaRPr lang="en-US" sz="900" dirty="0"/>
           </a:p>
@@ -2943,46 +2943,7 @@
       </p:sp>
       <p:sp>
         <p:nvSpPr>
-          <p:cNvPr id="16" name="Text 14"/>
-          <p:cNvSpPr/>
-          <p:nvPr/>
-        </p:nvSpPr>
-        <p:spPr>
-          <a:xfrm>
-            <a:off x="365760" y="2926080"/>
-            <a:ext cx="5486400" cy="256032"/>
-          </a:xfrm>
-          <a:prstGeom prst="rect">
-            <a:avLst/>
-          </a:prstGeom>
-          <a:noFill/>
-          <a:ln/>
-        </p:spPr>
-        <p:txBody>
-          <a:bodyPr wrap="square" rtlCol="0" anchor="t"/>
-          <a:lstStyle/>
-          <a:p>
-            <a:pPr indent="0" marL="0">
-              <a:buNone/>
-            </a:pPr>
-            <a:r>
-              <a:rPr lang="en-US" sz="900" dirty="0">
-                <a:solidFill>
-                  <a:srgbClr val="E8E8E8"/>
-                </a:solidFill>
-                <a:latin typeface="Calibri" pitchFamily="34" charset="0"/>
-                <a:ea typeface="Calibri" pitchFamily="34" charset="-122"/>
-                <a:cs typeface="Calibri" pitchFamily="34" charset="-120"/>
-              </a:rPr>
-              <a:t>🌃  Erste Nacht: Navigli-Bars &amp; Darsena-Platz</a:t>
-            </a:r>
-            <a:endParaRPr lang="en-US" sz="900" dirty="0"/>
-          </a:p>
-        </p:txBody>
-      </p:sp>
-      <p:sp>
-        <p:nvSpPr>
-          <p:cNvPr id="17" name="Shape 15"/>
+          <p:cNvPr id="16" name="Shape 14"/>
           <p:cNvSpPr/>
           <p:nvPr/>
         </p:nvSpPr>
@@ -2999,7 +2960,7 @@
           </a:solidFill>
           <a:ln w="12700">
             <a:solidFill>
-              <a:srgbClr val="C8003C"/>
+              <a:srgbClr val="8C52E8"/>
             </a:solidFill>
             <a:prstDash val="solid"/>
           </a:ln>
@@ -3007,7 +2968,7 @@
       </p:sp>
       <p:sp>
         <p:nvSpPr>
-          <p:cNvPr id="18" name="Shape 16"/>
+          <p:cNvPr id="17" name="Shape 15"/>
           <p:cNvSpPr/>
           <p:nvPr/>
         </p:nvSpPr>
@@ -3032,7 +2993,7 @@
       </p:sp>
       <p:sp>
         <p:nvSpPr>
-          <p:cNvPr id="19" name="Text 17"/>
+          <p:cNvPr id="18" name="Text 16"/>
           <p:cNvSpPr/>
           <p:nvPr/>
         </p:nvSpPr>
@@ -3057,7 +3018,7 @@
             <a:r>
               <a:rPr lang="en-US" sz="1100" b="1" dirty="0">
                 <a:solidFill>
-                  <a:srgbClr val="C8003C"/>
+                  <a:srgbClr val="8C52E8"/>
                 </a:solidFill>
                 <a:latin typeface="Trebuchet MS" pitchFamily="34" charset="0"/>
                 <a:ea typeface="Trebuchet MS" pitchFamily="34" charset="-122"/>
@@ -3071,7 +3032,7 @@
       </p:sp>
       <p:sp>
         <p:nvSpPr>
-          <p:cNvPr id="20" name="Text 18"/>
+          <p:cNvPr id="19" name="Text 17"/>
           <p:cNvSpPr/>
           <p:nvPr/>
         </p:nvSpPr>
@@ -3110,7 +3071,7 @@
       </p:sp>
       <p:sp>
         <p:nvSpPr>
-          <p:cNvPr id="21" name="Text 19"/>
+          <p:cNvPr id="20" name="Text 18"/>
           <p:cNvSpPr/>
           <p:nvPr/>
         </p:nvSpPr>
@@ -3141,7 +3102,7 @@
                 <a:ea typeface="Calibri" pitchFamily="34" charset="-122"/>
                 <a:cs typeface="Calibri" pitchFamily="34" charset="-120"/>
               </a:rPr>
-              <a:t>🍳  Pasta-Kochkurs 10:00 Uhr (3h, €70 p.P., Navigli)</a:t>
+              <a:t>🏔  Morgens: Vitosha-Berg Wanderung (Bus/Gondel ab Stadtrand)</a:t>
             </a:r>
             <a:endParaRPr lang="en-US" sz="900" dirty="0"/>
           </a:p>
@@ -3149,7 +3110,7 @@
       </p:sp>
       <p:sp>
         <p:nvSpPr>
-          <p:cNvPr id="22" name="Text 20"/>
+          <p:cNvPr id="21" name="Text 19"/>
           <p:cNvSpPr/>
           <p:nvPr/>
         </p:nvSpPr>
@@ -3180,7 +3141,7 @@
                 <a:ea typeface="Calibri" pitchFamily="34" charset="-122"/>
                 <a:cs typeface="Calibri" pitchFamily="34" charset="-120"/>
               </a:rPr>
-              <a:t>   Risotto alla Milanese + Ossobuco + Tiramisu</a:t>
+              <a:t>   Bergblick über ganz Sofia — kostenloser Nationalpark</a:t>
             </a:r>
             <a:endParaRPr lang="en-US" sz="900" dirty="0"/>
           </a:p>
@@ -3188,7 +3149,7 @@
       </p:sp>
       <p:sp>
         <p:nvSpPr>
-          <p:cNvPr id="23" name="Text 21"/>
+          <p:cNvPr id="22" name="Text 20"/>
           <p:cNvSpPr/>
           <p:nvPr/>
         </p:nvSpPr>
@@ -3219,7 +3180,7 @@
                 <a:ea typeface="Calibri" pitchFamily="34" charset="-122"/>
                 <a:cs typeface="Calibri" pitchFamily="34" charset="-120"/>
               </a:rPr>
-              <a:t>🛍  Nachmittags: Brera Designviertel oder Modeboulevard</a:t>
+              <a:t>🍳  Bulgarischer Kochkurs 15:00 Uhr (3h, ~€45 p.P.)</a:t>
             </a:r>
             <a:endParaRPr lang="en-US" sz="900" dirty="0"/>
           </a:p>
@@ -3227,7 +3188,7 @@
       </p:sp>
       <p:sp>
         <p:nvSpPr>
-          <p:cNvPr id="24" name="Text 22"/>
+          <p:cNvPr id="23" name="Text 21"/>
           <p:cNvSpPr/>
           <p:nvPr/>
         </p:nvSpPr>
@@ -3258,7 +3219,7 @@
                 <a:ea typeface="Calibri" pitchFamily="34" charset="-122"/>
                 <a:cs typeface="Calibri" pitchFamily="34" charset="-120"/>
               </a:rPr>
-              <a:t>🎃  Halloween Kneipentour Navigli ab 21 Uhr · ~€20 p.P.</a:t>
+              <a:t>   Shopska-Salat + Moussaka + Rakija-Verkostung</a:t>
             </a:r>
             <a:endParaRPr lang="en-US" sz="900" dirty="0"/>
           </a:p>
@@ -3266,7 +3227,7 @@
       </p:sp>
       <p:sp>
         <p:nvSpPr>
-          <p:cNvPr id="25" name="Text 23"/>
+          <p:cNvPr id="24" name="Text 22"/>
           <p:cNvSpPr/>
           <p:nvPr/>
         </p:nvSpPr>
@@ -3297,7 +3258,7 @@
                 <a:ea typeface="Calibri" pitchFamily="34" charset="-122"/>
                 <a:cs typeface="Calibri" pitchFamily="34" charset="-120"/>
               </a:rPr>
-              <a:t>   Treffpunkt Darsena · 4 Bars · Shots · Kostüm-Contest</a:t>
+              <a:t>🎃  Halloween Kneipentour ab 22 Uhr · ~€15 p.P.</a:t>
             </a:r>
             <a:endParaRPr lang="en-US" sz="900" dirty="0"/>
           </a:p>
@@ -3305,7 +3266,7 @@
       </p:sp>
       <p:sp>
         <p:nvSpPr>
-          <p:cNvPr id="26" name="Text 24"/>
+          <p:cNvPr id="25" name="Text 23"/>
           <p:cNvSpPr/>
           <p:nvPr/>
         </p:nvSpPr>
@@ -3336,7 +3297,7 @@
                 <a:ea typeface="Calibri" pitchFamily="34" charset="-122"/>
                 <a:cs typeface="Calibri" pitchFamily="34" charset="-120"/>
               </a:rPr>
-              <a:t>🎶  Ab 1 Uhr: Alcatraz oder Volt Club — Halloween Special</a:t>
+              <a:t>   Studentski Grad: Sin City · Yalta Club · Mixtape 5</a:t>
             </a:r>
             <a:endParaRPr lang="en-US" sz="900" dirty="0"/>
           </a:p>
@@ -3344,7 +3305,7 @@
       </p:sp>
       <p:sp>
         <p:nvSpPr>
-          <p:cNvPr id="27" name="Text 25"/>
+          <p:cNvPr id="26" name="Text 24"/>
           <p:cNvSpPr/>
           <p:nvPr/>
         </p:nvSpPr>
@@ -3375,7 +3336,7 @@
                 <a:ea typeface="Calibri" pitchFamily="34" charset="-122"/>
                 <a:cs typeface="Calibri" pitchFamily="34" charset="-120"/>
               </a:rPr>
-              <a:t>   Corso Como Party bis 5 Uhr morgens</a:t>
+              <a:t>   Clubs bis 5 Uhr morgens · €1 Bier die ganze Nacht</a:t>
             </a:r>
             <a:endParaRPr lang="en-US" sz="900" dirty="0"/>
           </a:p>
@@ -3383,7 +3344,7 @@
       </p:sp>
       <p:sp>
         <p:nvSpPr>
-          <p:cNvPr id="28" name="Shape 26"/>
+          <p:cNvPr id="27" name="Shape 25"/>
           <p:cNvSpPr/>
           <p:nvPr/>
         </p:nvSpPr>
@@ -3400,7 +3361,7 @@
           </a:solidFill>
           <a:ln w="12700">
             <a:solidFill>
-              <a:srgbClr val="C8003C"/>
+              <a:srgbClr val="8C52E8"/>
             </a:solidFill>
             <a:prstDash val="solid"/>
           </a:ln>
@@ -3408,7 +3369,7 @@
       </p:sp>
       <p:sp>
         <p:nvSpPr>
-          <p:cNvPr id="29" name="Shape 27"/>
+          <p:cNvPr id="28" name="Shape 26"/>
           <p:cNvSpPr/>
           <p:nvPr/>
         </p:nvSpPr>
@@ -3433,7 +3394,7 @@
       </p:sp>
       <p:sp>
         <p:nvSpPr>
-          <p:cNvPr id="30" name="Text 28"/>
+          <p:cNvPr id="29" name="Text 27"/>
           <p:cNvSpPr/>
           <p:nvPr/>
         </p:nvSpPr>
@@ -3458,7 +3419,7 @@
             <a:r>
               <a:rPr lang="en-US" sz="1100" b="1" dirty="0">
                 <a:solidFill>
-                  <a:srgbClr val="C8003C"/>
+                  <a:srgbClr val="8C52E8"/>
                 </a:solidFill>
                 <a:latin typeface="Trebuchet MS" pitchFamily="34" charset="0"/>
                 <a:ea typeface="Trebuchet MS" pitchFamily="34" charset="-122"/>
@@ -3472,7 +3433,7 @@
       </p:sp>
       <p:sp>
         <p:nvSpPr>
-          <p:cNvPr id="31" name="Text 29"/>
+          <p:cNvPr id="30" name="Text 28"/>
           <p:cNvSpPr/>
           <p:nvPr/>
         </p:nvSpPr>
@@ -3511,7 +3472,7 @@
       </p:sp>
       <p:sp>
         <p:nvSpPr>
-          <p:cNvPr id="32" name="Text 30"/>
+          <p:cNvPr id="31" name="Text 29"/>
           <p:cNvSpPr/>
           <p:nvPr/>
         </p:nvSpPr>
@@ -3542,7 +3503,7 @@
                 <a:ea typeface="Calibri" pitchFamily="34" charset="-122"/>
                 <a:cs typeface="Calibri" pitchFamily="34" charset="-120"/>
               </a:rPr>
-              <a:t>🌅  Ausschlafen — Mailands Nächte enden spät</a:t>
+              <a:t>🕌  Alexander-Nevsky-Kathedrale innen (kostenlos, atemberaubend)</a:t>
             </a:r>
             <a:endParaRPr lang="en-US" sz="900" dirty="0"/>
           </a:p>
@@ -3550,7 +3511,7 @@
       </p:sp>
       <p:sp>
         <p:nvSpPr>
-          <p:cNvPr id="33" name="Text 31"/>
+          <p:cNvPr id="32" name="Text 30"/>
           <p:cNvSpPr/>
           <p:nvPr/>
         </p:nvSpPr>
@@ -3581,7 +3542,7 @@
                 <a:ea typeface="Calibri" pitchFamily="34" charset="-122"/>
                 <a:cs typeface="Calibri" pitchFamily="34" charset="-120"/>
               </a:rPr>
-              <a:t>☕  Frühstück: Cappuccino + Cornetto an der Bar (€2)</a:t>
+              <a:t>🏛  Nationales Historisches Museum (optional)</a:t>
             </a:r>
             <a:endParaRPr lang="en-US" sz="900" dirty="0"/>
           </a:p>
@@ -3589,7 +3550,7 @@
       </p:sp>
       <p:sp>
         <p:nvSpPr>
-          <p:cNvPr id="34" name="Text 32"/>
+          <p:cNvPr id="33" name="Text 31"/>
           <p:cNvSpPr/>
           <p:nvPr/>
         </p:nvSpPr>
@@ -3620,7 +3581,7 @@
                 <a:ea typeface="Calibri" pitchFamily="34" charset="-122"/>
                 <a:cs typeface="Calibri" pitchFamily="34" charset="-120"/>
               </a:rPr>
-              <a:t>🏛  Duomo Dachterrasse (Blick über ganz Mailand, ~€14)</a:t>
+              <a:t>🛒  Weiblicher Markt (Ženski Pazar): lokales Essen &amp; Gewürze</a:t>
             </a:r>
             <a:endParaRPr lang="en-US" sz="900" dirty="0"/>
           </a:p>
@@ -3628,7 +3589,7 @@
       </p:sp>
       <p:sp>
         <p:nvSpPr>
-          <p:cNvPr id="35" name="Text 33"/>
+          <p:cNvPr id="34" name="Text 32"/>
           <p:cNvSpPr/>
           <p:nvPr/>
         </p:nvSpPr>
@@ -3659,7 +3620,7 @@
                 <a:ea typeface="Calibri" pitchFamily="34" charset="-122"/>
                 <a:cs typeface="Calibri" pitchFamily="34" charset="-120"/>
               </a:rPr>
-              <a:t>🛒  Mercato Metropolitano oder Fiera di Sinigaglia</a:t>
+              <a:t>🍽  Abendessen: Mehana-Restaurant — Schopska + Bier €8 gesamt</a:t>
             </a:r>
             <a:endParaRPr lang="en-US" sz="900" dirty="0"/>
           </a:p>
@@ -3667,7 +3628,7 @@
       </p:sp>
       <p:sp>
         <p:nvSpPr>
-          <p:cNvPr id="36" name="Text 34"/>
+          <p:cNvPr id="35" name="Text 33"/>
           <p:cNvSpPr/>
           <p:nvPr/>
         </p:nvSpPr>
@@ -3698,7 +3659,7 @@
                 <a:ea typeface="Calibri" pitchFamily="34" charset="-122"/>
                 <a:cs typeface="Calibri" pitchFamily="34" charset="-120"/>
               </a:rPr>
-              <a:t>🍝  Abendessen: Risotto Milanese in der Navigli-Trattoria</a:t>
+              <a:t>🌃  Letzte Nacht: Lozenets-Viertel Bars oder Yalta-Club-Afterparty</a:t>
             </a:r>
             <a:endParaRPr lang="en-US" sz="900" dirty="0"/>
           </a:p>
@@ -3706,46 +3667,7 @@
       </p:sp>
       <p:sp>
         <p:nvSpPr>
-          <p:cNvPr id="37" name="Text 35"/>
-          <p:cNvSpPr/>
-          <p:nvPr/>
-        </p:nvSpPr>
-        <p:spPr>
-          <a:xfrm>
-            <a:off x="365760" y="5541264"/>
-            <a:ext cx="5486400" cy="256032"/>
-          </a:xfrm>
-          <a:prstGeom prst="rect">
-            <a:avLst/>
-          </a:prstGeom>
-          <a:noFill/>
-          <a:ln/>
-        </p:spPr>
-        <p:txBody>
-          <a:bodyPr wrap="square" rtlCol="0" anchor="t"/>
-          <a:lstStyle/>
-          <a:p>
-            <a:pPr indent="0" marL="0">
-              <a:buNone/>
-            </a:pPr>
-            <a:r>
-              <a:rPr lang="en-US" sz="900" dirty="0">
-                <a:solidFill>
-                  <a:srgbClr val="E8E8E8"/>
-                </a:solidFill>
-                <a:latin typeface="Calibri" pitchFamily="34" charset="0"/>
-                <a:ea typeface="Calibri" pitchFamily="34" charset="-122"/>
-                <a:cs typeface="Calibri" pitchFamily="34" charset="-120"/>
-              </a:rPr>
-              <a:t>🌃  Letzte Nacht: Isola-Viertel Bars + Corso Como</a:t>
-            </a:r>
-            <a:endParaRPr lang="en-US" sz="900" dirty="0"/>
-          </a:p>
-        </p:txBody>
-      </p:sp>
-      <p:sp>
-        <p:nvSpPr>
-          <p:cNvPr id="38" name="Shape 36"/>
+          <p:cNvPr id="36" name="Shape 34"/>
           <p:cNvSpPr/>
           <p:nvPr/>
         </p:nvSpPr>
@@ -3762,7 +3684,7 @@
           </a:solidFill>
           <a:ln w="12700">
             <a:solidFill>
-              <a:srgbClr val="C8003C"/>
+              <a:srgbClr val="8C52E8"/>
             </a:solidFill>
             <a:prstDash val="solid"/>
           </a:ln>
@@ -3770,7 +3692,7 @@
       </p:sp>
       <p:sp>
         <p:nvSpPr>
-          <p:cNvPr id="39" name="Shape 37"/>
+          <p:cNvPr id="37" name="Shape 35"/>
           <p:cNvSpPr/>
           <p:nvPr/>
         </p:nvSpPr>
@@ -3795,7 +3717,7 @@
       </p:sp>
       <p:sp>
         <p:nvSpPr>
-          <p:cNvPr id="40" name="Text 38"/>
+          <p:cNvPr id="38" name="Text 36"/>
           <p:cNvSpPr/>
           <p:nvPr/>
         </p:nvSpPr>
@@ -3820,7 +3742,7 @@
             <a:r>
               <a:rPr lang="en-US" sz="1100" b="1" dirty="0">
                 <a:solidFill>
-                  <a:srgbClr val="C8003C"/>
+                  <a:srgbClr val="8C52E8"/>
                 </a:solidFill>
                 <a:latin typeface="Trebuchet MS" pitchFamily="34" charset="0"/>
                 <a:ea typeface="Trebuchet MS" pitchFamily="34" charset="-122"/>
@@ -3834,7 +3756,7 @@
       </p:sp>
       <p:sp>
         <p:nvSpPr>
-          <p:cNvPr id="41" name="Text 39"/>
+          <p:cNvPr id="39" name="Text 37"/>
           <p:cNvSpPr/>
           <p:nvPr/>
         </p:nvSpPr>
@@ -3873,7 +3795,7 @@
       </p:sp>
       <p:sp>
         <p:nvSpPr>
-          <p:cNvPr id="42" name="Text 40"/>
+          <p:cNvPr id="40" name="Text 38"/>
           <p:cNvSpPr/>
           <p:nvPr/>
         </p:nvSpPr>
@@ -3904,7 +3826,7 @@
                 <a:ea typeface="Calibri" pitchFamily="34" charset="-122"/>
                 <a:cs typeface="Calibri" pitchFamily="34" charset="-120"/>
               </a:rPr>
-              <a:t>☕  Letzter Cappuccino an der Bar — nie im Sitzen!</a:t>
+              <a:t>☕  Banitsa (bulgarisches Blätterteig-Gebäck) zum Frühstück (€0,50)</a:t>
             </a:r>
             <a:endParaRPr lang="en-US" sz="900" dirty="0"/>
           </a:p>
@@ -3912,7 +3834,7 @@
       </p:sp>
       <p:sp>
         <p:nvSpPr>
-          <p:cNvPr id="43" name="Text 41"/>
+          <p:cNvPr id="41" name="Text 39"/>
           <p:cNvSpPr/>
           <p:nvPr/>
         </p:nvSpPr>
@@ -3943,7 +3865,7 @@
                 <a:ea typeface="Calibri" pitchFamily="34" charset="-122"/>
                 <a:cs typeface="Calibri" pitchFamily="34" charset="-120"/>
               </a:rPr>
-              <a:t>🛍  Souvenirs: Panettone, Amaro, Design-Mitbringsel</a:t>
+              <a:t>🛍  Souvenirs: Rosen-Öl, Rakija, Mamarnitsa (Glücksbringer)</a:t>
             </a:r>
             <a:endParaRPr lang="en-US" sz="900" dirty="0"/>
           </a:p>
@@ -3951,7 +3873,7 @@
       </p:sp>
       <p:sp>
         <p:nvSpPr>
-          <p:cNvPr id="44" name="Text 42"/>
+          <p:cNvPr id="42" name="Text 40"/>
           <p:cNvSpPr/>
           <p:nvPr/>
         </p:nvSpPr>
@@ -3982,7 +3904,7 @@
                 <a:ea typeface="Calibri" pitchFamily="34" charset="-122"/>
                 <a:cs typeface="Calibri" pitchFamily="34" charset="-120"/>
               </a:rPr>
-              <a:t>🚂  Malpensa Express zum Flughafen (52 Min.)</a:t>
+              <a:t>🚇  Metro M1 zum Flughafen (€0,80, 20 Min.)</a:t>
             </a:r>
             <a:endParaRPr lang="en-US" sz="900" dirty="0"/>
           </a:p>
@@ -3990,7 +3912,7 @@
       </p:sp>
       <p:sp>
         <p:nvSpPr>
-          <p:cNvPr id="45" name="Text 43"/>
+          <p:cNvPr id="43" name="Text 41"/>
           <p:cNvSpPr/>
           <p:nvPr/>
         </p:nvSpPr>
@@ -4021,7 +3943,7 @@
                 <a:ea typeface="Calibri" pitchFamily="34" charset="-122"/>
                 <a:cs typeface="Calibri" pitchFamily="34" charset="-120"/>
               </a:rPr>
-              <a:t>✈  Eurowings MXP → DUS (Nachmittag)</a:t>
+              <a:t>✈  Bulgaria Air / Ryanair SOF → DUS (Nachmittag)</a:t>
             </a:r>
             <a:endParaRPr lang="en-US" sz="900" dirty="0"/>
           </a:p>
@@ -4029,7 +3951,7 @@
       </p:sp>
       <p:sp>
         <p:nvSpPr>
-          <p:cNvPr id="46" name="Shape 44"/>
+          <p:cNvPr id="44" name="Shape 42"/>
           <p:cNvSpPr/>
           <p:nvPr/>
         </p:nvSpPr>
@@ -4054,7 +3976,7 @@
       </p:sp>
       <p:sp>
         <p:nvSpPr>
-          <p:cNvPr id="47" name="Text 45"/>
+          <p:cNvPr id="45" name="Text 43"/>
           <p:cNvSpPr/>
           <p:nvPr/>
         </p:nvSpPr>
@@ -4085,7 +4007,7 @@
                 <a:ea typeface="Calibri" pitchFamily="34" charset="-122"/>
                 <a:cs typeface="Calibri" pitchFamily="34" charset="-120"/>
               </a:rPr>
-              <a:t>Halloween Kneipentour: eventbrite.it → "Milan Halloween Bar Crawl"  ·  Kochkurs: cookly.app → "Milan Pasta Class"  ·  Stadtführung: neweuropetours.eu/milan  ·  Alcatraz Club: alcatrazmilano.com</a:t>
+              <a:t>Kneipentour: eventbrite.com → "Sofia Halloween Bar Crawl"  ·  Kochkurs: cookly.app → "Sofia Cooking Class"  ·  Stadtführung: neweuropetours.eu/sofia  ·  Yalta Club: yaltaclub.com</a:t>
             </a:r>
             <a:endParaRPr lang="en-US" sz="800" dirty="0"/>
           </a:p>
@@ -4093,7 +4015,7 @@
       </p:sp>
       <p:sp>
         <p:nvSpPr>
-          <p:cNvPr id="48" name="Shape 46"/>
+          <p:cNvPr id="46" name="Shape 44"/>
           <p:cNvSpPr/>
           <p:nvPr/>
         </p:nvSpPr>
@@ -4163,11 +4085,11 @@
             <a:avLst/>
           </a:prstGeom>
           <a:solidFill>
-            <a:srgbClr val="C8003C"/>
+            <a:srgbClr val="8C52E8"/>
           </a:solidFill>
           <a:ln w="12700">
             <a:solidFill>
-              <a:srgbClr val="C8003C"/>
+              <a:srgbClr val="8C52E8"/>
             </a:solidFill>
             <a:prstDash val="solid"/>
           </a:ln>
@@ -4231,7 +4153,7 @@
                 <a:ea typeface="Trebuchet MS" pitchFamily="34" charset="-122"/>
                 <a:cs typeface="Trebuchet MS" pitchFamily="34" charset="-120"/>
               </a:rPr>
-              <a:t>🇮🇹  MAILAND — KOSTENÜBERSICHT</a:t>
+              <a:t>🇧🇬  SOFIA — KOSTENÜBERSICHT</a:t>
             </a:r>
             <a:endParaRPr lang="en-US" sz="2200" dirty="0"/>
           </a:p>
@@ -4252,11 +4174,11 @@
             <a:avLst/>
           </a:prstGeom>
           <a:solidFill>
-            <a:srgbClr val="C8003C"/>
+            <a:srgbClr val="8C52E8"/>
           </a:solidFill>
           <a:ln w="12700">
             <a:solidFill>
-              <a:srgbClr val="C8003C"/>
+              <a:srgbClr val="8C52E8"/>
             </a:solidFill>
             <a:prstDash val="solid"/>
           </a:ln>
@@ -4302,7 +4224,7 @@
                       <a:r>
                         <a:rPr lang="en-US" sz="1200" b="1" dirty="0">
                           <a:solidFill>
-                            <a:srgbClr val="C8003C"/>
+                            <a:srgbClr val="8C52E8"/>
                           </a:solidFill>
                           <a:latin typeface="Trebuchet MS" pitchFamily="34" charset="0"/>
                           <a:ea typeface="Trebuchet MS" pitchFamily="34" charset="-122"/>
@@ -4370,7 +4292,7 @@
                       <a:r>
                         <a:rPr lang="en-US" sz="1200" b="1" dirty="0">
                           <a:solidFill>
-                            <a:srgbClr val="C8003C"/>
+                            <a:srgbClr val="8C52E8"/>
                           </a:solidFill>
                           <a:latin typeface="Trebuchet MS" pitchFamily="34" charset="0"/>
                           <a:ea typeface="Trebuchet MS" pitchFamily="34" charset="-122"/>
@@ -4438,7 +4360,7 @@
                       <a:r>
                         <a:rPr lang="en-US" sz="1200" b="1" dirty="0">
                           <a:solidFill>
-                            <a:srgbClr val="C8003C"/>
+                            <a:srgbClr val="8C52E8"/>
                           </a:solidFill>
                           <a:latin typeface="Trebuchet MS" pitchFamily="34" charset="0"/>
                           <a:ea typeface="Trebuchet MS" pitchFamily="34" charset="-122"/>
@@ -4650,7 +4572,7 @@
                           <a:ea typeface="Calibri" pitchFamily="34" charset="-122"/>
                           <a:cs typeface="Calibri" pitchFamily="34" charset="-120"/>
                         </a:rPr>
-                        <a:t>Eurowings EW  DUS ↔ MXP (Direktflug)</a:t>
+                        <a:t>Bulgaria Air / Ryanair  DUS ↔ SOF</a:t>
                       </a:r>
                       <a:endParaRPr lang="en-US" sz="1100" dirty="0">
                         <a:latin typeface="Calibri" charset="0"/>
@@ -4718,7 +4640,7 @@
                           <a:ea typeface="Calibri" pitchFamily="34" charset="-122"/>
                           <a:cs typeface="Calibri" pitchFamily="34" charset="-120"/>
                         </a:rPr>
-                        <a:t>~€170</a:t>
+                        <a:t>~€140</a:t>
                       </a:r>
                       <a:endParaRPr lang="en-US" sz="1100" dirty="0">
                         <a:latin typeface="Calibri" charset="0"/>
@@ -4786,7 +4708,7 @@
                           <a:ea typeface="Calibri" pitchFamily="34" charset="-122"/>
                           <a:cs typeface="Calibri" pitchFamily="34" charset="-120"/>
                         </a:rPr>
-                        <a:t>~€680</a:t>
+                        <a:t>~€560</a:t>
                       </a:r>
                       <a:endParaRPr lang="en-US" sz="1100" dirty="0">
                         <a:latin typeface="Calibri" charset="0"/>
@@ -4924,7 +4846,7 @@
                           <a:ea typeface="Calibri" pitchFamily="34" charset="-122"/>
                           <a:cs typeface="Calibri" pitchFamily="34" charset="-120"/>
                         </a:rPr>
-                        <a:t>Airbnb Navigli — 3 Nächte (inkl. Gebühren)</a:t>
+                        <a:t>Airbnb Zentrum — 3 Nächte (inkl. Gebühren)</a:t>
                       </a:r>
                       <a:endParaRPr lang="en-US" sz="1100" dirty="0">
                         <a:latin typeface="Calibri" charset="0"/>
@@ -4992,7 +4914,7 @@
                           <a:ea typeface="Calibri" pitchFamily="34" charset="-122"/>
                           <a:cs typeface="Calibri" pitchFamily="34" charset="-120"/>
                         </a:rPr>
-                        <a:t>~€115</a:t>
+                        <a:t>~€65</a:t>
                       </a:r>
                       <a:endParaRPr lang="en-US" sz="1100" dirty="0">
                         <a:latin typeface="Calibri" charset="0"/>
@@ -5060,7 +4982,7 @@
                           <a:ea typeface="Calibri" pitchFamily="34" charset="-122"/>
                           <a:cs typeface="Calibri" pitchFamily="34" charset="-120"/>
                         </a:rPr>
-                        <a:t>~€460</a:t>
+                        <a:t>~€260</a:t>
                       </a:r>
                       <a:endParaRPr lang="en-US" sz="1100" dirty="0">
                         <a:latin typeface="Calibri" charset="0"/>
@@ -5198,7 +5120,7 @@
                           <a:ea typeface="Calibri" pitchFamily="34" charset="-122"/>
                           <a:cs typeface="Calibri" pitchFamily="34" charset="-120"/>
                         </a:rPr>
-                        <a:t>Bar Crawl Navigli / Darsena (31. Okt.)</a:t>
+                        <a:t>Bar Crawl Sofia (31. Okt.)</a:t>
                       </a:r>
                       <a:endParaRPr lang="en-US" sz="1100" dirty="0">
                         <a:latin typeface="Calibri" charset="0"/>
@@ -5266,7 +5188,7 @@
                           <a:ea typeface="Calibri" pitchFamily="34" charset="-122"/>
                           <a:cs typeface="Calibri" pitchFamily="34" charset="-120"/>
                         </a:rPr>
-                        <a:t>€20</a:t>
+                        <a:t>~€15</a:t>
                       </a:r>
                       <a:endParaRPr lang="en-US" sz="1100" dirty="0">
                         <a:latin typeface="Calibri" charset="0"/>
@@ -5334,7 +5256,7 @@
                           <a:ea typeface="Calibri" pitchFamily="34" charset="-122"/>
                           <a:cs typeface="Calibri" pitchFamily="34" charset="-120"/>
                         </a:rPr>
-                        <a:t>€80</a:t>
+                        <a:t>~€60</a:t>
                       </a:r>
                       <a:endParaRPr lang="en-US" sz="1100" dirty="0">
                         <a:latin typeface="Calibri" charset="0"/>
@@ -5472,7 +5394,7 @@
                           <a:ea typeface="Calibri" pitchFamily="34" charset="-122"/>
                           <a:cs typeface="Calibri" pitchFamily="34" charset="-120"/>
                         </a:rPr>
-                        <a:t>Pasta-Kochkurs Navigli — Risotto + Ossobuco</a:t>
+                        <a:t>Bulgarische Küche — Moussaka + Rakija</a:t>
                       </a:r>
                       <a:endParaRPr lang="en-US" sz="1100" dirty="0">
                         <a:latin typeface="Calibri" charset="0"/>
@@ -5540,7 +5462,7 @@
                           <a:ea typeface="Calibri" pitchFamily="34" charset="-122"/>
                           <a:cs typeface="Calibri" pitchFamily="34" charset="-120"/>
                         </a:rPr>
-                        <a:t>€70</a:t>
+                        <a:t>~€45</a:t>
                       </a:r>
                       <a:endParaRPr lang="en-US" sz="1100" dirty="0">
                         <a:latin typeface="Calibri" charset="0"/>
@@ -5608,7 +5530,7 @@
                           <a:ea typeface="Calibri" pitchFamily="34" charset="-122"/>
                           <a:cs typeface="Calibri" pitchFamily="34" charset="-120"/>
                         </a:rPr>
-                        <a:t>€280</a:t>
+                        <a:t>~€180</a:t>
                       </a:r>
                       <a:endParaRPr lang="en-US" sz="1100" dirty="0">
                         <a:latin typeface="Calibri" charset="0"/>
@@ -5746,7 +5668,7 @@
                           <a:ea typeface="Calibri" pitchFamily="34" charset="-122"/>
                           <a:cs typeface="Calibri" pitchFamily="34" charset="-120"/>
                         </a:rPr>
-                        <a:t>SANDEMANs — Duomo (Trinkgeld)</a:t>
+                        <a:t>SANDEMANs — Alexander-Nevsky (Trinkgeld)</a:t>
                       </a:r>
                       <a:endParaRPr lang="en-US" sz="1100" dirty="0">
                         <a:latin typeface="Calibri" charset="0"/>
@@ -5814,7 +5736,7 @@
                           <a:ea typeface="Calibri" pitchFamily="34" charset="-122"/>
                           <a:cs typeface="Calibri" pitchFamily="34" charset="-120"/>
                         </a:rPr>
-                        <a:t>~€12</a:t>
+                        <a:t>~€10</a:t>
                       </a:r>
                       <a:endParaRPr lang="en-US" sz="1100" dirty="0">
                         <a:latin typeface="Calibri" charset="0"/>
@@ -5882,7 +5804,7 @@
                           <a:ea typeface="Calibri" pitchFamily="34" charset="-122"/>
                           <a:cs typeface="Calibri" pitchFamily="34" charset="-120"/>
                         </a:rPr>
-                        <a:t>~€48</a:t>
+                        <a:t>~€40</a:t>
                       </a:r>
                       <a:endParaRPr lang="en-US" sz="1100" dirty="0">
                         <a:latin typeface="Calibri" charset="0"/>
@@ -6020,7 +5942,7 @@
                           <a:ea typeface="Calibri" pitchFamily="34" charset="-122"/>
                           <a:cs typeface="Calibri" pitchFamily="34" charset="-120"/>
                         </a:rPr>
-                        <a:t>Trattoria, Aperitivo-Buffet, Bar-Frühstück</a:t>
+                        <a:t>Mehana, Banitsa, Markt — Ø €10–15/Mahlzeit</a:t>
                       </a:r>
                       <a:endParaRPr lang="en-US" sz="1100" dirty="0">
                         <a:latin typeface="Calibri" charset="0"/>
@@ -6088,7 +6010,7 @@
                           <a:ea typeface="Calibri" pitchFamily="34" charset="-122"/>
                           <a:cs typeface="Calibri" pitchFamily="34" charset="-120"/>
                         </a:rPr>
-                        <a:t>~€130</a:t>
+                        <a:t>~€90</a:t>
                       </a:r>
                       <a:endParaRPr lang="en-US" sz="1100" dirty="0">
                         <a:latin typeface="Calibri" charset="0"/>
@@ -6156,7 +6078,7 @@
                           <a:ea typeface="Calibri" pitchFamily="34" charset="-122"/>
                           <a:cs typeface="Calibri" pitchFamily="34" charset="-120"/>
                         </a:rPr>
-                        <a:t>~€520</a:t>
+                        <a:t>~€360</a:t>
                       </a:r>
                       <a:endParaRPr lang="en-US" sz="1100" dirty="0">
                         <a:latin typeface="Calibri" charset="0"/>
@@ -6294,7 +6216,7 @@
                           <a:ea typeface="Calibri" pitchFamily="34" charset="-122"/>
                           <a:cs typeface="Calibri" pitchFamily="34" charset="-120"/>
                         </a:rPr>
-                        <a:t>Navigli + Corso Como + Clubs (3 Nächte)</a:t>
+                        <a:t>Vitosha Blvd + Clubs (€1 Bier, 3 Nächte)</a:t>
                       </a:r>
                       <a:endParaRPr lang="en-US" sz="1100" dirty="0">
                         <a:latin typeface="Calibri" charset="0"/>
@@ -6362,7 +6284,7 @@
                           <a:ea typeface="Calibri" pitchFamily="34" charset="-122"/>
                           <a:cs typeface="Calibri" pitchFamily="34" charset="-120"/>
                         </a:rPr>
-                        <a:t>~€160</a:t>
+                        <a:t>~€120</a:t>
                       </a:r>
                       <a:endParaRPr lang="en-US" sz="1100" dirty="0">
                         <a:latin typeface="Calibri" charset="0"/>
@@ -6430,7 +6352,7 @@
                           <a:ea typeface="Calibri" pitchFamily="34" charset="-122"/>
                           <a:cs typeface="Calibri" pitchFamily="34" charset="-120"/>
                         </a:rPr>
-                        <a:t>~€640</a:t>
+                        <a:t>~€480</a:t>
                       </a:r>
                       <a:endParaRPr lang="en-US" sz="1100" dirty="0">
                         <a:latin typeface="Calibri" charset="0"/>
@@ -6568,7 +6490,7 @@
                           <a:ea typeface="Calibri" pitchFamily="34" charset="-122"/>
                           <a:cs typeface="Calibri" pitchFamily="34" charset="-120"/>
                         </a:rPr>
-                        <a:t>Malpensa Express, Tram, Souvenirs</a:t>
+                        <a:t>Metro, Uber, Souvenirs</a:t>
                       </a:r>
                       <a:endParaRPr lang="en-US" sz="1100" dirty="0">
                         <a:latin typeface="Calibri" charset="0"/>
@@ -6636,7 +6558,7 @@
                           <a:ea typeface="Calibri" pitchFamily="34" charset="-122"/>
                           <a:cs typeface="Calibri" pitchFamily="34" charset="-120"/>
                         </a:rPr>
-                        <a:t>~€30</a:t>
+                        <a:t>~€25</a:t>
                       </a:r>
                       <a:endParaRPr lang="en-US" sz="1100" dirty="0">
                         <a:latin typeface="Calibri" charset="0"/>
@@ -6704,7 +6626,7 @@
                           <a:ea typeface="Calibri" pitchFamily="34" charset="-122"/>
                           <a:cs typeface="Calibri" pitchFamily="34" charset="-120"/>
                         </a:rPr>
-                        <a:t>~€120</a:t>
+                        <a:t>~€100</a:t>
                       </a:r>
                       <a:endParaRPr lang="en-US" sz="1100" dirty="0">
                         <a:latin typeface="Calibri" charset="0"/>
@@ -6842,7 +6764,7 @@
                           <a:ea typeface="Trebuchet MS" pitchFamily="34" charset="-122"/>
                           <a:cs typeface="Trebuchet MS" pitchFamily="34" charset="-120"/>
                         </a:rPr>
-                        <a:t>Mailand, 30. Okt. – 2. Nov. 2025</a:t>
+                        <a:t>Sofia, 30. Okt. – 2. Nov. 2025</a:t>
                       </a:r>
                       <a:endParaRPr lang="en-US" sz="1300" dirty="0">
                         <a:latin typeface="Trebuchet MS" charset="0"/>
@@ -6904,13 +6826,13 @@
                       <a:r>
                         <a:rPr lang="en-US" sz="1300" b="1" dirty="0">
                           <a:solidFill>
-                            <a:srgbClr val="C8003C"/>
+                            <a:srgbClr val="8C52E8"/>
                           </a:solidFill>
                           <a:latin typeface="Trebuchet MS" pitchFamily="34" charset="0"/>
                           <a:ea typeface="Trebuchet MS" pitchFamily="34" charset="-122"/>
                           <a:cs typeface="Trebuchet MS" pitchFamily="34" charset="-120"/>
                         </a:rPr>
-                        <a:t>~€707</a:t>
+                        <a:t>~€510</a:t>
                       </a:r>
                       <a:endParaRPr lang="en-US" sz="1300" dirty="0">
                         <a:latin typeface="Trebuchet MS" charset="0"/>
@@ -6978,7 +6900,7 @@
                           <a:ea typeface="Trebuchet MS" pitchFamily="34" charset="-122"/>
                           <a:cs typeface="Trebuchet MS" pitchFamily="34" charset="-120"/>
                         </a:rPr>
-                        <a:t>~€2.828</a:t>
+                        <a:t>~€2.040</a:t>
                       </a:r>
                       <a:endParaRPr lang="en-US" sz="1300" dirty="0">
                         <a:latin typeface="Trebuchet MS" charset="0"/>
@@ -7053,7 +6975,7 @@
           </a:solidFill>
           <a:ln w="12700">
             <a:solidFill>
-              <a:srgbClr val="C8003C"/>
+              <a:srgbClr val="8C52E8"/>
             </a:solidFill>
             <a:prstDash val="solid"/>
           </a:ln>
@@ -7092,7 +7014,7 @@
                 <a:ea typeface="Calibri" pitchFamily="34" charset="-122"/>
                 <a:cs typeface="Calibri" pitchFamily="34" charset="-120"/>
               </a:rPr>
-              <a:t>💡 Kürzester Flug dieser Auswahl (1h 40m ab DUS)!  Aperitivo-Zeit (18–21 Uhr): Drink + gratis Buffet ~€10 — spart Abendessenkosten.  Cappuccino an der Bar stehend: €1,50.  Budgetrahmen: €600–850 p.P.</a:t>
+              <a:t>💡 GÜNSTIGSTES ZIEL überhaupt: €1–2 Bier, €8 Abendessen, €0,80 Metro!  Budgetrahmen: €400–650 p.P.  Ideal wenn Ihr nach dem letzten Trip die Kasse schonen wollt — ohne auf Spaß zu verzichten.</a:t>
             </a:r>
             <a:endParaRPr lang="en-US" sz="1050" dirty="0"/>
           </a:p>
@@ -7238,7 +7160,7 @@
                 <a:ea typeface="Trebuchet MS" pitchFamily="34" charset="-122"/>
                 <a:cs typeface="Trebuchet MS" pitchFamily="34" charset="-120"/>
               </a:rPr>
-              <a:t>⚔️  DIREKTVERGLEICH — LISSABON vs. MAILAND</a:t>
+              <a:t>⚔️  DIREKTVERGLEICH — LISSABON vs. SOFIA</a:t>
             </a:r>
             <a:endParaRPr lang="en-US" sz="2200" dirty="0"/>
           </a:p>
@@ -7352,7 +7274,7 @@
           </a:solidFill>
           <a:ln w="12700">
             <a:solidFill>
-              <a:srgbClr val="C8003C"/>
+              <a:srgbClr val="8C52E8"/>
             </a:solidFill>
             <a:prstDash val="solid"/>
           </a:ln>
@@ -7385,13 +7307,13 @@
             <a:r>
               <a:rPr lang="en-US" sz="1800" b="1" dirty="0">
                 <a:solidFill>
-                  <a:srgbClr val="C8003C"/>
+                  <a:srgbClr val="8C52E8"/>
                 </a:solidFill>
                 <a:latin typeface="Trebuchet MS" pitchFamily="34" charset="0"/>
                 <a:ea typeface="Trebuchet MS" pitchFamily="34" charset="-122"/>
                 <a:cs typeface="Trebuchet MS" pitchFamily="34" charset="-120"/>
               </a:rPr>
-              <a:t>🇮🇹 MAILAND</a:t>
+              <a:t>🇧🇬 SOFIA</a:t>
             </a:r>
             <a:endParaRPr lang="en-US" sz="1800" dirty="0"/>
           </a:p>
@@ -7583,7 +7505,7 @@
                 <a:ea typeface="Calibri" pitchFamily="34" charset="-122"/>
                 <a:cs typeface="Calibri" pitchFamily="34" charset="-120"/>
               </a:rPr>
-              <a:t>~€707</a:t>
+              <a:t>~€510  💸 Günstigster!</a:t>
             </a:r>
             <a:endParaRPr lang="en-US" sz="1000" dirty="0"/>
           </a:p>
@@ -7775,7 +7697,7 @@
                 <a:ea typeface="Calibri" pitchFamily="34" charset="-122"/>
                 <a:cs typeface="Calibri" pitchFamily="34" charset="-120"/>
               </a:rPr>
-              <a:t>1h 40m  ab DUS  ✈ schnellste!</a:t>
+              <a:t>~2h 30m  ab DUS</a:t>
             </a:r>
             <a:endParaRPr lang="en-US" sz="1000" dirty="0"/>
           </a:p>
@@ -7967,7 +7889,7 @@
                 <a:ea typeface="Calibri" pitchFamily="34" charset="-122"/>
                 <a:cs typeface="Calibri" pitchFamily="34" charset="-120"/>
               </a:rPr>
-              <a:t>DUS — Eurowings / ITA / Ryanair</a:t>
+              <a:t>DUS — Bulgaria Air / Ryanair</a:t>
             </a:r>
             <a:endParaRPr lang="en-US" sz="1000" dirty="0"/>
           </a:p>
@@ -8159,7 +8081,7 @@
                 <a:ea typeface="Calibri" pitchFamily="34" charset="-122"/>
                 <a:cs typeface="Calibri" pitchFamily="34" charset="-120"/>
               </a:rPr>
-              <a:t>€5–7  (Nastro Azzurro)</a:t>
+              <a:t>€1–2  (günstigstes Eu. 🏆)</a:t>
             </a:r>
             <a:endParaRPr lang="en-US" sz="1000" dirty="0"/>
           </a:p>
@@ -8351,7 +8273,7 @@
                 <a:ea typeface="Calibri" pitchFamily="34" charset="-122"/>
                 <a:cs typeface="Calibri" pitchFamily="34" charset="-120"/>
               </a:rPr>
-              <a:t>12–16°C  🧥</a:t>
+              <a:t>10–14°C  🧥</a:t>
             </a:r>
             <a:endParaRPr lang="en-US" sz="1000" dirty="0"/>
           </a:p>
@@ -8543,7 +8465,7 @@
                 <a:ea typeface="Calibri" pitchFamily="34" charset="-122"/>
                 <a:cs typeface="Calibri" pitchFamily="34" charset="-120"/>
               </a:rPr>
-              <a:t>⭐⭐⭐⭐  Corso Como bis 5 Uhr</a:t>
+              <a:t>⭐⭐⭐⭐  Yalta · Sin City bis 5h</a:t>
             </a:r>
             <a:endParaRPr lang="en-US" sz="1000" dirty="0"/>
           </a:p>
@@ -8735,7 +8657,7 @@
                 <a:ea typeface="Calibri" pitchFamily="34" charset="-122"/>
                 <a:cs typeface="Calibri" pitchFamily="34" charset="-120"/>
               </a:rPr>
-              <a:t>Navigli · Corso Como · Isola</a:t>
+              <a:t>Vitosha Blvd · Studentski Grad</a:t>
             </a:r>
             <a:endParaRPr lang="en-US" sz="1000" dirty="0"/>
           </a:p>
@@ -8927,7 +8849,7 @@
                 <a:ea typeface="Calibri" pitchFamily="34" charset="-122"/>
                 <a:cs typeface="Calibri" pitchFamily="34" charset="-120"/>
               </a:rPr>
-              <a:t>Aperitivo + gratis Buffet ab 18h</a:t>
+              <a:t>Alexander-Nevsky · Vitosha-Berg</a:t>
             </a:r>
             <a:endParaRPr lang="en-US" sz="1000" dirty="0"/>
           </a:p>
@@ -9119,7 +9041,7 @@
                 <a:ea typeface="Calibri" pitchFamily="34" charset="-122"/>
                 <a:cs typeface="Calibri" pitchFamily="34" charset="-120"/>
               </a:rPr>
-              <a:t>€70 p.P.</a:t>
+              <a:t>~€45 p.P.</a:t>
             </a:r>
             <a:endParaRPr lang="en-US" sz="1000" dirty="0"/>
           </a:p>
@@ -9311,7 +9233,7 @@
                 <a:ea typeface="Calibri" pitchFamily="34" charset="-122"/>
                 <a:cs typeface="Calibri" pitchFamily="34" charset="-120"/>
               </a:rPr>
-              <a:t>~€113–118</a:t>
+              <a:t>~€53–73  (3× günstiger!)</a:t>
             </a:r>
             <a:endParaRPr lang="en-US" sz="1000" dirty="0"/>
           </a:p>
@@ -9464,7 +9386,7 @@
           </a:solidFill>
           <a:ln w="12700">
             <a:solidFill>
-              <a:srgbClr val="C8003C"/>
+              <a:srgbClr val="8C52E8"/>
             </a:solidFill>
             <a:prstDash val="solid"/>
           </a:ln>
@@ -9497,13 +9419,13 @@
             <a:r>
               <a:rPr lang="en-US" sz="1100" b="1" dirty="0">
                 <a:solidFill>
-                  <a:srgbClr val="C8003C"/>
+                  <a:srgbClr val="8C52E8"/>
                 </a:solidFill>
                 <a:latin typeface="Trebuchet MS" pitchFamily="34" charset="0"/>
                 <a:ea typeface="Trebuchet MS" pitchFamily="34" charset="-122"/>
                 <a:cs typeface="Trebuchet MS" pitchFamily="34" charset="-120"/>
               </a:rPr>
-              <a:t>Kürzester Flug + Fashion + Pasta</a:t>
+              <a:t>Extremes Budget + Überraschung</a:t>
             </a:r>
             <a:endParaRPr lang="en-US" sz="1100" dirty="0"/>
           </a:p>
@@ -11066,7 +10988,7 @@
           </a:solidFill>
           <a:ln w="12700">
             <a:solidFill>
-              <a:srgbClr val="C8003C"/>
+              <a:srgbClr val="8C52E8"/>
             </a:solidFill>
             <a:prstDash val="solid"/>
           </a:ln>
@@ -11099,13 +11021,13 @@
             <a:r>
               <a:rPr lang="en-US" sz="1800" b="1" dirty="0">
                 <a:solidFill>
-                  <a:srgbClr val="C8003C"/>
+                  <a:srgbClr val="8C52E8"/>
                 </a:solidFill>
                 <a:latin typeface="Trebuchet MS" pitchFamily="34" charset="0"/>
                 <a:ea typeface="Trebuchet MS" pitchFamily="34" charset="-122"/>
                 <a:cs typeface="Trebuchet MS" pitchFamily="34" charset="-120"/>
               </a:rPr>
-              <a:t>🇮🇹  MAILAND</a:t>
+              <a:t>🇧🇬  SOFIA</a:t>
             </a:r>
             <a:endParaRPr lang="en-US" sz="1800" dirty="0"/>
           </a:p>
@@ -11144,7 +11066,7 @@
                 <a:ea typeface="Calibri" pitchFamily="34" charset="-122"/>
                 <a:cs typeface="Calibri" pitchFamily="34" charset="-120"/>
               </a:rPr>
-              <a:t>Kürzester Flug (1h40)</a:t>
+              <a:t>Günstigstes Ziel: €1 Bier</a:t>
             </a:r>
             <a:endParaRPr lang="en-US" sz="950" dirty="0"/>
           </a:p>
@@ -11161,7 +11083,7 @@
                 <a:ea typeface="Calibri" pitchFamily="34" charset="-122"/>
                 <a:cs typeface="Calibri" pitchFamily="34" charset="-120"/>
               </a:rPr>
-              <a:t>Navigli · Aperitivo · Mode</a:t>
+              <a:t>Vitosha · Clubs · Kathedrale</a:t>
             </a:r>
             <a:endParaRPr lang="en-US" sz="950" dirty="0"/>
           </a:p>
@@ -22839,11 +22761,11 @@
             <a:avLst/>
           </a:prstGeom>
           <a:solidFill>
-            <a:srgbClr val="C8003C"/>
+            <a:srgbClr val="8C52E8"/>
           </a:solidFill>
           <a:ln w="12700">
             <a:solidFill>
-              <a:srgbClr val="C8003C"/>
+              <a:srgbClr val="8C52E8"/>
             </a:solidFill>
             <a:prstDash val="solid"/>
           </a:ln>
@@ -22907,7 +22829,7 @@
                 <a:ea typeface="Trebuchet MS" pitchFamily="34" charset="-122"/>
                 <a:cs typeface="Trebuchet MS" pitchFamily="34" charset="-120"/>
               </a:rPr>
-              <a:t>🇮🇹  REISEZIEL 2 — MAILAND, ITALIEN</a:t>
+              <a:t>🇧🇬  REISEZIEL 2 — SOFIA, BULGARIEN</a:t>
             </a:r>
             <a:endParaRPr lang="en-US" sz="2200" dirty="0"/>
           </a:p>
@@ -22928,11 +22850,11 @@
             <a:avLst/>
           </a:prstGeom>
           <a:solidFill>
-            <a:srgbClr val="C8003C"/>
+            <a:srgbClr val="8C52E8"/>
           </a:solidFill>
           <a:ln w="12700">
             <a:solidFill>
-              <a:srgbClr val="C8003C"/>
+              <a:srgbClr val="8C52E8"/>
             </a:solidFill>
             <a:prstDash val="solid"/>
           </a:ln>
@@ -22940,7 +22862,7 @@
       </p:sp>
       <p:pic>
         <p:nvPicPr>
-          <p:cNvPr id="6" name="Image 0" descr="/home/user/Excelhaus/halloween_trip/milan_hero.png">    </p:cNvPr>
+          <p:cNvPr id="6" name="Image 0" descr="/home/user/Excelhaus/halloween_trip/sofia_hero.png">    </p:cNvPr>
           <p:cNvPicPr>
             <a:picLocks noChangeAspect="1"/>
           </p:cNvPicPr>
@@ -23014,13 +22936,13 @@
             <a:r>
               <a:rPr lang="en-US" sz="1600" b="1" dirty="0">
                 <a:solidFill>
-                  <a:srgbClr val="C8003C"/>
+                  <a:srgbClr val="8C52E8"/>
                 </a:solidFill>
                 <a:latin typeface="Trebuchet MS" pitchFamily="34" charset="0"/>
                 <a:ea typeface="Trebuchet MS" pitchFamily="34" charset="-122"/>
                 <a:cs typeface="Trebuchet MS" pitchFamily="34" charset="-120"/>
               </a:rPr>
-              <a:t>Aperitivo, Mode &amp; Nachtleben an den Navigli</a:t>
+              <a:t>Günstigstes Ziel — €1 Bier &amp; Vitosha-Bergblick</a:t>
             </a:r>
             <a:endParaRPr lang="en-US" sz="1600" dirty="0"/>
           </a:p>
@@ -23059,7 +22981,7 @@
                 <a:ea typeface="Calibri" pitchFamily="34" charset="-122"/>
                 <a:cs typeface="Calibri" pitchFamily="34" charset="-120"/>
               </a:rPr>
-              <a:t>Navigli · Corso Como · Duomo · Brera · Clubs bis 5 Uhr</a:t>
+              <a:t>Vitosha Blvd · Yalta Club · Alexander-Nevsky-Kathedrale · Studentski Grad</a:t>
             </a:r>
             <a:endParaRPr lang="en-US" sz="1000" dirty="0"/>
           </a:p>
@@ -23084,7 +23006,7 @@
           </a:solidFill>
           <a:ln w="12700">
             <a:solidFill>
-              <a:srgbClr val="C8003C"/>
+              <a:srgbClr val="8C52E8"/>
             </a:solidFill>
             <a:prstDash val="solid"/>
           </a:ln>
@@ -23156,13 +23078,13 @@
             <a:r>
               <a:rPr lang="en-US" sz="1600" b="1" dirty="0">
                 <a:solidFill>
-                  <a:srgbClr val="C8003C"/>
+                  <a:srgbClr val="8C52E8"/>
                 </a:solidFill>
                 <a:latin typeface="Trebuchet MS" pitchFamily="34" charset="0"/>
                 <a:ea typeface="Trebuchet MS" pitchFamily="34" charset="-122"/>
                 <a:cs typeface="Trebuchet MS" pitchFamily="34" charset="-120"/>
               </a:rPr>
-              <a:t>1h 40m</a:t>
+              <a:t>~2h 30m</a:t>
             </a:r>
             <a:endParaRPr lang="en-US" sz="1600" dirty="0"/>
           </a:p>
@@ -23173,7 +23095,7 @@
             <a:r>
               <a:rPr lang="en-US" sz="1600" b="1" dirty="0">
                 <a:solidFill>
-                  <a:srgbClr val="C8003C"/>
+                  <a:srgbClr val="8C52E8"/>
                 </a:solidFill>
                 <a:latin typeface="Trebuchet MS" pitchFamily="34" charset="0"/>
                 <a:ea typeface="Trebuchet MS" pitchFamily="34" charset="-122"/>
@@ -23204,7 +23126,7 @@
           </a:solidFill>
           <a:ln w="12700">
             <a:solidFill>
-              <a:srgbClr val="C8003C"/>
+              <a:srgbClr val="8C52E8"/>
             </a:solidFill>
             <a:prstDash val="solid"/>
           </a:ln>
@@ -23276,13 +23198,13 @@
             <a:r>
               <a:rPr lang="en-US" sz="1600" b="1" dirty="0">
                 <a:solidFill>
-                  <a:srgbClr val="C8003C"/>
+                  <a:srgbClr val="8C52E8"/>
                 </a:solidFill>
                 <a:latin typeface="Trebuchet MS" pitchFamily="34" charset="0"/>
                 <a:ea typeface="Trebuchet MS" pitchFamily="34" charset="-122"/>
                 <a:cs typeface="Trebuchet MS" pitchFamily="34" charset="-120"/>
               </a:rPr>
-              <a:t>€5–7</a:t>
+              <a:t>€1 – €2</a:t>
             </a:r>
             <a:endParaRPr lang="en-US" sz="1600" dirty="0"/>
           </a:p>
@@ -23293,13 +23215,13 @@
             <a:r>
               <a:rPr lang="en-US" sz="1600" b="1" dirty="0">
                 <a:solidFill>
-                  <a:srgbClr val="C8003C"/>
+                  <a:srgbClr val="8C52E8"/>
                 </a:solidFill>
                 <a:latin typeface="Trebuchet MS" pitchFamily="34" charset="0"/>
                 <a:ea typeface="Trebuchet MS" pitchFamily="34" charset="-122"/>
                 <a:cs typeface="Trebuchet MS" pitchFamily="34" charset="-120"/>
               </a:rPr>
-              <a:t>(Nastro Azzurro)</a:t>
+              <a:t>(günstigstes Eu.!)</a:t>
             </a:r>
             <a:endParaRPr lang="en-US" sz="1600" dirty="0"/>
           </a:p>
@@ -23324,7 +23246,7 @@
           </a:solidFill>
           <a:ln w="12700">
             <a:solidFill>
-              <a:srgbClr val="C8003C"/>
+              <a:srgbClr val="8C52E8"/>
             </a:solidFill>
             <a:prstDash val="solid"/>
           </a:ln>
@@ -23396,13 +23318,13 @@
             <a:r>
               <a:rPr lang="en-US" sz="1600" b="1" dirty="0">
                 <a:solidFill>
-                  <a:srgbClr val="C8003C"/>
+                  <a:srgbClr val="8C52E8"/>
                 </a:solidFill>
                 <a:latin typeface="Trebuchet MS" pitchFamily="34" charset="0"/>
                 <a:ea typeface="Trebuchet MS" pitchFamily="34" charset="-122"/>
                 <a:cs typeface="Trebuchet MS" pitchFamily="34" charset="-120"/>
               </a:rPr>
-              <a:t>12–16°C</a:t>
+              <a:t>10–14°C 🧥</a:t>
             </a:r>
             <a:endParaRPr lang="en-US" sz="1600" dirty="0"/>
           </a:p>
@@ -23413,7 +23335,7 @@
             <a:r>
               <a:rPr lang="en-US" sz="1600" b="1" dirty="0">
                 <a:solidFill>
-                  <a:srgbClr val="C8003C"/>
+                  <a:srgbClr val="8C52E8"/>
                 </a:solidFill>
                 <a:latin typeface="Trebuchet MS" pitchFamily="34" charset="0"/>
                 <a:ea typeface="Trebuchet MS" pitchFamily="34" charset="-122"/>
@@ -23444,7 +23366,7 @@
           </a:solidFill>
           <a:ln w="12700">
             <a:solidFill>
-              <a:srgbClr val="C8003C"/>
+              <a:srgbClr val="8C52E8"/>
             </a:solidFill>
             <a:prstDash val="solid"/>
           </a:ln>
@@ -23516,13 +23438,13 @@
             <a:r>
               <a:rPr lang="en-US" sz="1600" b="1" dirty="0">
                 <a:solidFill>
-                  <a:srgbClr val="C8003C"/>
+                  <a:srgbClr val="8C52E8"/>
                 </a:solidFill>
                 <a:latin typeface="Trebuchet MS" pitchFamily="34" charset="0"/>
                 <a:ea typeface="Trebuchet MS" pitchFamily="34" charset="-122"/>
                 <a:cs typeface="Trebuchet MS" pitchFamily="34" charset="-120"/>
               </a:rPr>
-              <a:t>~€700</a:t>
+              <a:t>~€520</a:t>
             </a:r>
             <a:endParaRPr lang="en-US" sz="1600" dirty="0"/>
           </a:p>
@@ -23533,7 +23455,7 @@
             <a:r>
               <a:rPr lang="en-US" sz="1600" b="1" dirty="0">
                 <a:solidFill>
-                  <a:srgbClr val="C8003C"/>
+                  <a:srgbClr val="8C52E8"/>
                 </a:solidFill>
                 <a:latin typeface="Trebuchet MS" pitchFamily="34" charset="0"/>
                 <a:ea typeface="Trebuchet MS" pitchFamily="34" charset="-122"/>
@@ -23564,7 +23486,7 @@
           </a:solidFill>
           <a:ln w="12700">
             <a:solidFill>
-              <a:srgbClr val="C8003C"/>
+              <a:srgbClr val="8C52E8"/>
             </a:solidFill>
             <a:prstDash val="solid"/>
           </a:ln>
@@ -23636,7 +23558,7 @@
             <a:r>
               <a:rPr lang="en-US" sz="1600" b="1" dirty="0">
                 <a:solidFill>
-                  <a:srgbClr val="C8003C"/>
+                  <a:srgbClr val="8C52E8"/>
                 </a:solidFill>
                 <a:latin typeface="Trebuchet MS" pitchFamily="34" charset="0"/>
                 <a:ea typeface="Trebuchet MS" pitchFamily="34" charset="-122"/>
@@ -23653,13 +23575,13 @@
             <a:r>
               <a:rPr lang="en-US" sz="1600" b="1" dirty="0">
                 <a:solidFill>
-                  <a:srgbClr val="C8003C"/>
+                  <a:srgbClr val="8C52E8"/>
                 </a:solidFill>
                 <a:latin typeface="Trebuchet MS" pitchFamily="34" charset="0"/>
                 <a:ea typeface="Trebuchet MS" pitchFamily="34" charset="-122"/>
                 <a:cs typeface="Trebuchet MS" pitchFamily="34" charset="-120"/>
               </a:rPr>
-              <a:t>Navigli &amp; Corso Como</a:t>
+              <a:t>Yalta · Sin City</a:t>
             </a:r>
             <a:endParaRPr lang="en-US" sz="1600" dirty="0"/>
           </a:p>
@@ -23684,7 +23606,7 @@
           </a:solidFill>
           <a:ln w="12700">
             <a:solidFill>
-              <a:srgbClr val="C8003C"/>
+              <a:srgbClr val="8C52E8"/>
             </a:solidFill>
             <a:prstDash val="solid"/>
           </a:ln>
@@ -23756,13 +23678,13 @@
             <a:r>
               <a:rPr lang="en-US" sz="1600" b="1" dirty="0">
                 <a:solidFill>
-                  <a:srgbClr val="C8003C"/>
+                  <a:srgbClr val="8C52E8"/>
                 </a:solidFill>
                 <a:latin typeface="Trebuchet MS" pitchFamily="34" charset="0"/>
                 <a:ea typeface="Trebuchet MS" pitchFamily="34" charset="-122"/>
                 <a:cs typeface="Trebuchet MS" pitchFamily="34" charset="-120"/>
               </a:rPr>
-              <a:t>DUS direkt!</a:t>
+              <a:t>DUS direkt</a:t>
             </a:r>
             <a:endParaRPr lang="en-US" sz="1600" dirty="0"/>
           </a:p>
@@ -23773,13 +23695,13 @@
             <a:r>
               <a:rPr lang="en-US" sz="1600" b="1" dirty="0">
                 <a:solidFill>
-                  <a:srgbClr val="C8003C"/>
+                  <a:srgbClr val="8C52E8"/>
                 </a:solidFill>
                 <a:latin typeface="Trebuchet MS" pitchFamily="34" charset="0"/>
                 <a:ea typeface="Trebuchet MS" pitchFamily="34" charset="-122"/>
                 <a:cs typeface="Trebuchet MS" pitchFamily="34" charset="-120"/>
               </a:rPr>
-              <a:t>(Eurowings/ITA)</a:t>
+              <a:t>(Bulgaria Air/Ryanair)</a:t>
             </a:r>
             <a:endParaRPr lang="en-US" sz="1600" dirty="0"/>
           </a:p>
@@ -23843,7 +23765,7 @@
                 <a:ea typeface="Calibri" pitchFamily="34" charset="-122"/>
                 <a:cs typeface="Calibri" pitchFamily="34" charset="-120"/>
               </a:rPr>
-              <a:t>Mailand ist mit nur 1h 40m Flugzeit das nächste Ziel — Direktflug ab DUS mit Eurowings. Das Navigli-Viertel mit seinen Kanälen ist die Aperitivo-Hochburg Italiens: ab 18 Uhr Drinks + gratis Buffet für ~€10. Corso Como und die Isola-Szene bieten Clubs bis 5 Uhr. Das Duomo di Milano leuchtet nachts orange — perfekt für Halloween-Fotos. Und die Mailänder feiern Halloween ausgiebig.</a:t>
+              <a:t>Sofia ist mit Abstand das günstigste Ziel — ein Bier kostet €1–2, Abendessen in einem guten Restaurant ~€8–12. Die bulgarische Hauptstadt überrascht mit einer lebhaften Ausgehszene rund um den Vitosha Boulevard und den Studentenvierteln. Im Hintergrund: das Vitosha-Gebirge, direkt an der Stadtgrenze. Die Alexander-Nevsky-Kathedrale leuchtet nachts golden — perfekte Halloween-Kulisse.</a:t>
             </a:r>
             <a:endParaRPr lang="en-US" sz="1050" dirty="0"/>
           </a:p>
@@ -23921,11 +23843,11 @@
             <a:avLst/>
           </a:prstGeom>
           <a:solidFill>
-            <a:srgbClr val="C8003C"/>
+            <a:srgbClr val="8C52E8"/>
           </a:solidFill>
           <a:ln w="12700">
             <a:solidFill>
-              <a:srgbClr val="C8003C"/>
+              <a:srgbClr val="8C52E8"/>
             </a:solidFill>
             <a:prstDash val="solid"/>
           </a:ln>
@@ -23989,7 +23911,7 @@
                 <a:ea typeface="Trebuchet MS" pitchFamily="34" charset="-122"/>
                 <a:cs typeface="Trebuchet MS" pitchFamily="34" charset="-120"/>
               </a:rPr>
-              <a:t>🇮🇹  MAILAND — FLÜGE</a:t>
+              <a:t>🇧🇬  SOFIA — FLÜGE</a:t>
             </a:r>
             <a:endParaRPr lang="en-US" sz="2200" dirty="0"/>
           </a:p>
@@ -24010,11 +23932,11 @@
             <a:avLst/>
           </a:prstGeom>
           <a:solidFill>
-            <a:srgbClr val="C8003C"/>
+            <a:srgbClr val="8C52E8"/>
           </a:solidFill>
           <a:ln w="12700">
             <a:solidFill>
-              <a:srgbClr val="C8003C"/>
+              <a:srgbClr val="8C52E8"/>
             </a:solidFill>
             <a:prstDash val="solid"/>
           </a:ln>
@@ -24047,13 +23969,13 @@
             <a:r>
               <a:rPr lang="en-US" sz="1300" b="1" dirty="0">
                 <a:solidFill>
-                  <a:srgbClr val="C8003C"/>
+                  <a:srgbClr val="8C52E8"/>
                 </a:solidFill>
                 <a:latin typeface="Trebuchet MS" pitchFamily="34" charset="0"/>
                 <a:ea typeface="Trebuchet MS" pitchFamily="34" charset="-122"/>
                 <a:cs typeface="Trebuchet MS" pitchFamily="34" charset="-120"/>
               </a:rPr>
-              <a:t>HINFLUG: Deutschland → MXP (Mailand-Malpensa)</a:t>
+              <a:t>HINFLUG: Deutschland → SOF (Sofia)</a:t>
             </a:r>
             <a:endParaRPr lang="en-US" sz="1300" dirty="0"/>
           </a:p>
@@ -24103,7 +24025,7 @@
                       <a:r>
                         <a:rPr lang="en-US" sz="1100" b="1" dirty="0">
                           <a:solidFill>
-                            <a:srgbClr val="C8003C"/>
+                            <a:srgbClr val="8C52E8"/>
                           </a:solidFill>
                           <a:latin typeface="Trebuchet MS" pitchFamily="34" charset="0"/>
                           <a:ea typeface="Trebuchet MS" pitchFamily="34" charset="-122"/>
@@ -24171,7 +24093,7 @@
                       <a:r>
                         <a:rPr lang="en-US" sz="1100" b="1" dirty="0">
                           <a:solidFill>
-                            <a:srgbClr val="C8003C"/>
+                            <a:srgbClr val="8C52E8"/>
                           </a:solidFill>
                           <a:latin typeface="Trebuchet MS" pitchFamily="34" charset="0"/>
                           <a:ea typeface="Trebuchet MS" pitchFamily="34" charset="-122"/>
@@ -24239,7 +24161,7 @@
                       <a:r>
                         <a:rPr lang="en-US" sz="1100" b="1" dirty="0">
                           <a:solidFill>
-                            <a:srgbClr val="C8003C"/>
+                            <a:srgbClr val="8C52E8"/>
                           </a:solidFill>
                           <a:latin typeface="Trebuchet MS" pitchFamily="34" charset="0"/>
                           <a:ea typeface="Trebuchet MS" pitchFamily="34" charset="-122"/>
@@ -24307,7 +24229,7 @@
                       <a:r>
                         <a:rPr lang="en-US" sz="1100" b="1" dirty="0">
                           <a:solidFill>
-                            <a:srgbClr val="C8003C"/>
+                            <a:srgbClr val="8C52E8"/>
                           </a:solidFill>
                           <a:latin typeface="Trebuchet MS" pitchFamily="34" charset="0"/>
                           <a:ea typeface="Trebuchet MS" pitchFamily="34" charset="-122"/>
@@ -24375,7 +24297,7 @@
                       <a:r>
                         <a:rPr lang="en-US" sz="1100" b="1" dirty="0">
                           <a:solidFill>
-                            <a:srgbClr val="C8003C"/>
+                            <a:srgbClr val="8C52E8"/>
                           </a:solidFill>
                           <a:latin typeface="Trebuchet MS" pitchFamily="34" charset="0"/>
                           <a:ea typeface="Trebuchet MS" pitchFamily="34" charset="-122"/>
@@ -24443,7 +24365,7 @@
                       <a:r>
                         <a:rPr lang="en-US" sz="1100" b="1" dirty="0">
                           <a:solidFill>
-                            <a:srgbClr val="C8003C"/>
+                            <a:srgbClr val="8C52E8"/>
                           </a:solidFill>
                           <a:latin typeface="Trebuchet MS" pitchFamily="34" charset="0"/>
                           <a:ea typeface="Trebuchet MS" pitchFamily="34" charset="-122"/>
@@ -24511,7 +24433,7 @@
                       <a:r>
                         <a:rPr lang="en-US" sz="1100" b="1" dirty="0">
                           <a:solidFill>
-                            <a:srgbClr val="C8003C"/>
+                            <a:srgbClr val="8C52E8"/>
                           </a:solidFill>
                           <a:latin typeface="Trebuchet MS" pitchFamily="34" charset="0"/>
                           <a:ea typeface="Trebuchet MS" pitchFamily="34" charset="-122"/>
@@ -24579,7 +24501,7 @@
                       <a:r>
                         <a:rPr lang="en-US" sz="1100" b="1" dirty="0">
                           <a:solidFill>
-                            <a:srgbClr val="C8003C"/>
+                            <a:srgbClr val="8C52E8"/>
                           </a:solidFill>
                           <a:latin typeface="Trebuchet MS" pitchFamily="34" charset="0"/>
                           <a:ea typeface="Trebuchet MS" pitchFamily="34" charset="-122"/>
@@ -24723,7 +24645,7 @@
                           <a:ea typeface="Calibri" pitchFamily="34" charset="-122"/>
                           <a:cs typeface="Calibri" pitchFamily="34" charset="-120"/>
                         </a:rPr>
-                        <a:t>EW</a:t>
+                        <a:t>Bulgaria Air</a:t>
                       </a:r>
                       <a:endParaRPr lang="en-US" sz="1000" dirty="0">
                         <a:latin typeface="Calibri" charset="0"/>
@@ -24744,7 +24666,7 @@
                           <a:ea typeface="Calibri" pitchFamily="34" charset="-122"/>
                           <a:cs typeface="Calibri" pitchFamily="34" charset="-120"/>
                         </a:rPr>
-                        <a:t>Eurowings</a:t>
+                        <a:t>(FB)</a:t>
                       </a:r>
                       <a:endParaRPr lang="en-US" sz="1000" dirty="0">
                         <a:latin typeface="Calibri" charset="0"/>
@@ -24812,1183 +24734,7 @@
                           <a:ea typeface="Calibri" pitchFamily="34" charset="-122"/>
                           <a:cs typeface="Calibri" pitchFamily="34" charset="-120"/>
                         </a:rPr>
-                        <a:t>DUS → MXP</a:t>
-                      </a:r>
-                      <a:endParaRPr lang="en-US" sz="1000" dirty="0">
-                        <a:latin typeface="Calibri" charset="0"/>
-                        <a:ea typeface="Calibri" charset="0"/>
-                        <a:cs typeface="Calibri" charset="0"/>
-                      </a:endParaRPr>
-                    </a:p>
-                    <a:p>
-                      <a:pPr algn="ctr" indent="0" marL="0">
-                        <a:buNone/>
-                      </a:pPr>
-                      <a:r>
-                        <a:rPr lang="en-US" sz="1000" dirty="0">
-                          <a:solidFill>
-                            <a:srgbClr val="E8E8E8"/>
-                          </a:solidFill>
-                          <a:latin typeface="Calibri" pitchFamily="34" charset="0"/>
-                          <a:ea typeface="Calibri" pitchFamily="34" charset="-122"/>
-                          <a:cs typeface="Calibri" pitchFamily="34" charset="-120"/>
-                        </a:rPr>
-                        <a:t>30. Okt. früh</a:t>
-                      </a:r>
-                      <a:endParaRPr lang="en-US" sz="1000" dirty="0">
-                        <a:latin typeface="Calibri" charset="0"/>
-                        <a:ea typeface="Calibri" charset="0"/>
-                        <a:cs typeface="Calibri" charset="0"/>
-                      </a:endParaRPr>
-                    </a:p>
-                  </a:txBody>
-                  <a:tcPr marL="91440" marR="91440" marT="45720" marB="45720">
-                    <a:lnL w="12700" cap="flat" cmpd="sng" algn="ctr">
-                      <a:solidFill>
-                        <a:srgbClr val="0F3460"/>
-                      </a:solidFill>
-                      <a:prstDash val="solid"/>
-                      <a:round/>
-                      <a:headEnd type="none" w="med" len="med"/>
-                      <a:tailEnd type="none" w="med" len="med"/>
-                    </a:lnL>
-                    <a:lnR w="12700" cap="flat" cmpd="sng" algn="ctr">
-                      <a:solidFill>
-                        <a:srgbClr val="0F3460"/>
-                      </a:solidFill>
-                      <a:prstDash val="solid"/>
-                      <a:round/>
-                      <a:headEnd type="none" w="med" len="med"/>
-                      <a:tailEnd type="none" w="med" len="med"/>
-                    </a:lnR>
-                    <a:lnT w="12700" cap="flat" cmpd="sng" algn="ctr">
-                      <a:solidFill>
-                        <a:srgbClr val="0F3460"/>
-                      </a:solidFill>
-                      <a:prstDash val="solid"/>
-                      <a:round/>
-                      <a:headEnd type="none" w="med" len="med"/>
-                      <a:tailEnd type="none" w="med" len="med"/>
-                    </a:lnT>
-                    <a:lnB w="12700" cap="flat" cmpd="sng" algn="ctr">
-                      <a:solidFill>
-                        <a:srgbClr val="0F3460"/>
-                      </a:solidFill>
-                      <a:prstDash val="solid"/>
-                      <a:round/>
-                      <a:headEnd type="none" w="med" len="med"/>
-                      <a:tailEnd type="none" w="med" len="med"/>
-                    </a:lnB>
-                    <a:solidFill>
-                      <a:srgbClr val="16213E"/>
-                    </a:solidFill>
-                  </a:tcPr>
-                </a:tc>
-                <a:tc>
-                  <a:txBody>
-                    <a:bodyPr/>
-                    <a:lstStyle/>
-                    <a:p>
-                      <a:pPr algn="ctr" indent="0" marL="0">
-                        <a:buNone/>
-                      </a:pPr>
-                      <a:r>
-                        <a:rPr lang="en-US" sz="1000" dirty="0">
-                          <a:solidFill>
-                            <a:srgbClr val="E8E8E8"/>
-                          </a:solidFill>
-                          <a:latin typeface="Calibri" pitchFamily="34" charset="0"/>
-                          <a:ea typeface="Calibri" pitchFamily="34" charset="-122"/>
-                          <a:cs typeface="Calibri" pitchFamily="34" charset="-120"/>
-                        </a:rPr>
-                        <a:t>~07:00</a:t>
-                      </a:r>
-                      <a:endParaRPr lang="en-US" sz="1000" dirty="0">
-                        <a:latin typeface="Calibri" charset="0"/>
-                        <a:ea typeface="Calibri" charset="0"/>
-                        <a:cs typeface="Calibri" charset="0"/>
-                      </a:endParaRPr>
-                    </a:p>
-                  </a:txBody>
-                  <a:tcPr marL="91440" marR="91440" marT="45720" marB="45720">
-                    <a:lnL w="12700" cap="flat" cmpd="sng" algn="ctr">
-                      <a:solidFill>
-                        <a:srgbClr val="0F3460"/>
-                      </a:solidFill>
-                      <a:prstDash val="solid"/>
-                      <a:round/>
-                      <a:headEnd type="none" w="med" len="med"/>
-                      <a:tailEnd type="none" w="med" len="med"/>
-                    </a:lnL>
-                    <a:lnR w="12700" cap="flat" cmpd="sng" algn="ctr">
-                      <a:solidFill>
-                        <a:srgbClr val="0F3460"/>
-                      </a:solidFill>
-                      <a:prstDash val="solid"/>
-                      <a:round/>
-                      <a:headEnd type="none" w="med" len="med"/>
-                      <a:tailEnd type="none" w="med" len="med"/>
-                    </a:lnR>
-                    <a:lnT w="12700" cap="flat" cmpd="sng" algn="ctr">
-                      <a:solidFill>
-                        <a:srgbClr val="0F3460"/>
-                      </a:solidFill>
-                      <a:prstDash val="solid"/>
-                      <a:round/>
-                      <a:headEnd type="none" w="med" len="med"/>
-                      <a:tailEnd type="none" w="med" len="med"/>
-                    </a:lnT>
-                    <a:lnB w="12700" cap="flat" cmpd="sng" algn="ctr">
-                      <a:solidFill>
-                        <a:srgbClr val="0F3460"/>
-                      </a:solidFill>
-                      <a:prstDash val="solid"/>
-                      <a:round/>
-                      <a:headEnd type="none" w="med" len="med"/>
-                      <a:tailEnd type="none" w="med" len="med"/>
-                    </a:lnB>
-                    <a:solidFill>
-                      <a:srgbClr val="16213E"/>
-                    </a:solidFill>
-                  </a:tcPr>
-                </a:tc>
-                <a:tc>
-                  <a:txBody>
-                    <a:bodyPr/>
-                    <a:lstStyle/>
-                    <a:p>
-                      <a:pPr algn="ctr" indent="0" marL="0">
-                        <a:buNone/>
-                      </a:pPr>
-                      <a:r>
-                        <a:rPr lang="en-US" sz="1000" dirty="0">
-                          <a:solidFill>
-                            <a:srgbClr val="E8E8E8"/>
-                          </a:solidFill>
-                          <a:latin typeface="Calibri" pitchFamily="34" charset="0"/>
-                          <a:ea typeface="Calibri" pitchFamily="34" charset="-122"/>
-                          <a:cs typeface="Calibri" pitchFamily="34" charset="-120"/>
-                        </a:rPr>
-                        <a:t>~08:40</a:t>
-                      </a:r>
-                      <a:endParaRPr lang="en-US" sz="1000" dirty="0">
-                        <a:latin typeface="Calibri" charset="0"/>
-                        <a:ea typeface="Calibri" charset="0"/>
-                        <a:cs typeface="Calibri" charset="0"/>
-                      </a:endParaRPr>
-                    </a:p>
-                  </a:txBody>
-                  <a:tcPr marL="91440" marR="91440" marT="45720" marB="45720">
-                    <a:lnL w="12700" cap="flat" cmpd="sng" algn="ctr">
-                      <a:solidFill>
-                        <a:srgbClr val="0F3460"/>
-                      </a:solidFill>
-                      <a:prstDash val="solid"/>
-                      <a:round/>
-                      <a:headEnd type="none" w="med" len="med"/>
-                      <a:tailEnd type="none" w="med" len="med"/>
-                    </a:lnL>
-                    <a:lnR w="12700" cap="flat" cmpd="sng" algn="ctr">
-                      <a:solidFill>
-                        <a:srgbClr val="0F3460"/>
-                      </a:solidFill>
-                      <a:prstDash val="solid"/>
-                      <a:round/>
-                      <a:headEnd type="none" w="med" len="med"/>
-                      <a:tailEnd type="none" w="med" len="med"/>
-                    </a:lnR>
-                    <a:lnT w="12700" cap="flat" cmpd="sng" algn="ctr">
-                      <a:solidFill>
-                        <a:srgbClr val="0F3460"/>
-                      </a:solidFill>
-                      <a:prstDash val="solid"/>
-                      <a:round/>
-                      <a:headEnd type="none" w="med" len="med"/>
-                      <a:tailEnd type="none" w="med" len="med"/>
-                    </a:lnT>
-                    <a:lnB w="12700" cap="flat" cmpd="sng" algn="ctr">
-                      <a:solidFill>
-                        <a:srgbClr val="0F3460"/>
-                      </a:solidFill>
-                      <a:prstDash val="solid"/>
-                      <a:round/>
-                      <a:headEnd type="none" w="med" len="med"/>
-                      <a:tailEnd type="none" w="med" len="med"/>
-                    </a:lnB>
-                    <a:solidFill>
-                      <a:srgbClr val="16213E"/>
-                    </a:solidFill>
-                  </a:tcPr>
-                </a:tc>
-                <a:tc>
-                  <a:txBody>
-                    <a:bodyPr/>
-                    <a:lstStyle/>
-                    <a:p>
-                      <a:pPr algn="ctr" indent="0" marL="0">
-                        <a:buNone/>
-                      </a:pPr>
-                      <a:r>
-                        <a:rPr lang="en-US" sz="1000" dirty="0">
-                          <a:solidFill>
-                            <a:srgbClr val="E8E8E8"/>
-                          </a:solidFill>
-                          <a:latin typeface="Calibri" pitchFamily="34" charset="0"/>
-                          <a:ea typeface="Calibri" pitchFamily="34" charset="-122"/>
-                          <a:cs typeface="Calibri" pitchFamily="34" charset="-120"/>
-                        </a:rPr>
-                        <a:t>1h 40m</a:t>
-                      </a:r>
-                      <a:endParaRPr lang="en-US" sz="1000" dirty="0">
-                        <a:latin typeface="Calibri" charset="0"/>
-                        <a:ea typeface="Calibri" charset="0"/>
-                        <a:cs typeface="Calibri" charset="0"/>
-                      </a:endParaRPr>
-                    </a:p>
-                  </a:txBody>
-                  <a:tcPr marL="91440" marR="91440" marT="45720" marB="45720">
-                    <a:lnL w="12700" cap="flat" cmpd="sng" algn="ctr">
-                      <a:solidFill>
-                        <a:srgbClr val="0F3460"/>
-                      </a:solidFill>
-                      <a:prstDash val="solid"/>
-                      <a:round/>
-                      <a:headEnd type="none" w="med" len="med"/>
-                      <a:tailEnd type="none" w="med" len="med"/>
-                    </a:lnL>
-                    <a:lnR w="12700" cap="flat" cmpd="sng" algn="ctr">
-                      <a:solidFill>
-                        <a:srgbClr val="0F3460"/>
-                      </a:solidFill>
-                      <a:prstDash val="solid"/>
-                      <a:round/>
-                      <a:headEnd type="none" w="med" len="med"/>
-                      <a:tailEnd type="none" w="med" len="med"/>
-                    </a:lnR>
-                    <a:lnT w="12700" cap="flat" cmpd="sng" algn="ctr">
-                      <a:solidFill>
-                        <a:srgbClr val="0F3460"/>
-                      </a:solidFill>
-                      <a:prstDash val="solid"/>
-                      <a:round/>
-                      <a:headEnd type="none" w="med" len="med"/>
-                      <a:tailEnd type="none" w="med" len="med"/>
-                    </a:lnT>
-                    <a:lnB w="12700" cap="flat" cmpd="sng" algn="ctr">
-                      <a:solidFill>
-                        <a:srgbClr val="0F3460"/>
-                      </a:solidFill>
-                      <a:prstDash val="solid"/>
-                      <a:round/>
-                      <a:headEnd type="none" w="med" len="med"/>
-                      <a:tailEnd type="none" w="med" len="med"/>
-                    </a:lnB>
-                    <a:solidFill>
-                      <a:srgbClr val="16213E"/>
-                    </a:solidFill>
-                  </a:tcPr>
-                </a:tc>
-                <a:tc>
-                  <a:txBody>
-                    <a:bodyPr/>
-                    <a:lstStyle/>
-                    <a:p>
-                      <a:pPr algn="ctr" indent="0" marL="0">
-                        <a:buNone/>
-                      </a:pPr>
-                      <a:r>
-                        <a:rPr lang="en-US" sz="1000" dirty="0">
-                          <a:solidFill>
-                            <a:srgbClr val="E8E8E8"/>
-                          </a:solidFill>
-                          <a:latin typeface="Calibri" pitchFamily="34" charset="0"/>
-                          <a:ea typeface="Calibri" pitchFamily="34" charset="-122"/>
-                          <a:cs typeface="Calibri" pitchFamily="34" charset="-120"/>
-                        </a:rPr>
-                        <a:t>~€80</a:t>
-                      </a:r>
-                      <a:endParaRPr lang="en-US" sz="1000" dirty="0">
-                        <a:latin typeface="Calibri" charset="0"/>
-                        <a:ea typeface="Calibri" charset="0"/>
-                        <a:cs typeface="Calibri" charset="0"/>
-                      </a:endParaRPr>
-                    </a:p>
-                  </a:txBody>
-                  <a:tcPr marL="91440" marR="91440" marT="45720" marB="45720">
-                    <a:lnL w="12700" cap="flat" cmpd="sng" algn="ctr">
-                      <a:solidFill>
-                        <a:srgbClr val="0F3460"/>
-                      </a:solidFill>
-                      <a:prstDash val="solid"/>
-                      <a:round/>
-                      <a:headEnd type="none" w="med" len="med"/>
-                      <a:tailEnd type="none" w="med" len="med"/>
-                    </a:lnL>
-                    <a:lnR w="12700" cap="flat" cmpd="sng" algn="ctr">
-                      <a:solidFill>
-                        <a:srgbClr val="0F3460"/>
-                      </a:solidFill>
-                      <a:prstDash val="solid"/>
-                      <a:round/>
-                      <a:headEnd type="none" w="med" len="med"/>
-                      <a:tailEnd type="none" w="med" len="med"/>
-                    </a:lnR>
-                    <a:lnT w="12700" cap="flat" cmpd="sng" algn="ctr">
-                      <a:solidFill>
-                        <a:srgbClr val="0F3460"/>
-                      </a:solidFill>
-                      <a:prstDash val="solid"/>
-                      <a:round/>
-                      <a:headEnd type="none" w="med" len="med"/>
-                      <a:tailEnd type="none" w="med" len="med"/>
-                    </a:lnT>
-                    <a:lnB w="12700" cap="flat" cmpd="sng" algn="ctr">
-                      <a:solidFill>
-                        <a:srgbClr val="0F3460"/>
-                      </a:solidFill>
-                      <a:prstDash val="solid"/>
-                      <a:round/>
-                      <a:headEnd type="none" w="med" len="med"/>
-                      <a:tailEnd type="none" w="med" len="med"/>
-                    </a:lnB>
-                    <a:solidFill>
-                      <a:srgbClr val="16213E"/>
-                    </a:solidFill>
-                  </a:tcPr>
-                </a:tc>
-                <a:tc>
-                  <a:txBody>
-                    <a:bodyPr/>
-                    <a:lstStyle/>
-                    <a:p>
-                      <a:pPr algn="ctr" indent="0" marL="0">
-                        <a:buNone/>
-                      </a:pPr>
-                      <a:r>
-                        <a:rPr lang="en-US" sz="1000" b="1" dirty="0">
-                          <a:solidFill>
-                            <a:srgbClr val="FF8C00"/>
-                          </a:solidFill>
-                          <a:latin typeface="Calibri" pitchFamily="34" charset="0"/>
-                          <a:ea typeface="Calibri" pitchFamily="34" charset="-122"/>
-                          <a:cs typeface="Calibri" pitchFamily="34" charset="-120"/>
-                        </a:rPr>
-                        <a:t>~€320</a:t>
-                      </a:r>
-                      <a:endParaRPr lang="en-US" sz="1000" dirty="0">
-                        <a:latin typeface="Calibri" charset="0"/>
-                        <a:ea typeface="Calibri" charset="0"/>
-                        <a:cs typeface="Calibri" charset="0"/>
-                      </a:endParaRPr>
-                    </a:p>
-                  </a:txBody>
-                  <a:tcPr marL="91440" marR="91440" marT="45720" marB="45720">
-                    <a:lnL w="12700" cap="flat" cmpd="sng" algn="ctr">
-                      <a:solidFill>
-                        <a:srgbClr val="0F3460"/>
-                      </a:solidFill>
-                      <a:prstDash val="solid"/>
-                      <a:round/>
-                      <a:headEnd type="none" w="med" len="med"/>
-                      <a:tailEnd type="none" w="med" len="med"/>
-                    </a:lnL>
-                    <a:lnR w="12700" cap="flat" cmpd="sng" algn="ctr">
-                      <a:solidFill>
-                        <a:srgbClr val="0F3460"/>
-                      </a:solidFill>
-                      <a:prstDash val="solid"/>
-                      <a:round/>
-                      <a:headEnd type="none" w="med" len="med"/>
-                      <a:tailEnd type="none" w="med" len="med"/>
-                    </a:lnR>
-                    <a:lnT w="12700" cap="flat" cmpd="sng" algn="ctr">
-                      <a:solidFill>
-                        <a:srgbClr val="0F3460"/>
-                      </a:solidFill>
-                      <a:prstDash val="solid"/>
-                      <a:round/>
-                      <a:headEnd type="none" w="med" len="med"/>
-                      <a:tailEnd type="none" w="med" len="med"/>
-                    </a:lnT>
-                    <a:lnB w="12700" cap="flat" cmpd="sng" algn="ctr">
-                      <a:solidFill>
-                        <a:srgbClr val="0F3460"/>
-                      </a:solidFill>
-                      <a:prstDash val="solid"/>
-                      <a:round/>
-                      <a:headEnd type="none" w="med" len="med"/>
-                      <a:tailEnd type="none" w="med" len="med"/>
-                    </a:lnB>
-                    <a:solidFill>
-                      <a:srgbClr val="16213E"/>
-                    </a:solidFill>
-                  </a:tcPr>
-                </a:tc>
-              </a:tr>
-              <a:tr h="475488">
-                <a:tc>
-                  <a:txBody>
-                    <a:bodyPr/>
-                    <a:lstStyle/>
-                    <a:p>
-                      <a:pPr algn="ctr" indent="0" marL="0">
-                        <a:buNone/>
-                      </a:pPr>
-                      <a:r>
-                        <a:rPr lang="en-US" sz="1000" dirty="0">
-                          <a:solidFill>
-                            <a:srgbClr val="E8E8E8"/>
-                          </a:solidFill>
-                          <a:latin typeface="Calibri" pitchFamily="34" charset="0"/>
-                          <a:ea typeface="Calibri" pitchFamily="34" charset="-122"/>
-                          <a:cs typeface="Calibri" pitchFamily="34" charset="-120"/>
-                        </a:rPr>
-                        <a:t>Vorabend</a:t>
-                      </a:r>
-                      <a:endParaRPr lang="en-US" sz="1000" dirty="0">
-                        <a:latin typeface="Calibri" charset="0"/>
-                        <a:ea typeface="Calibri" charset="0"/>
-                        <a:cs typeface="Calibri" charset="0"/>
-                      </a:endParaRPr>
-                    </a:p>
-                  </a:txBody>
-                  <a:tcPr marL="91440" marR="91440" marT="45720" marB="45720">
-                    <a:lnL w="12700" cap="flat" cmpd="sng" algn="ctr">
-                      <a:solidFill>
-                        <a:srgbClr val="0F3460"/>
-                      </a:solidFill>
-                      <a:prstDash val="solid"/>
-                      <a:round/>
-                      <a:headEnd type="none" w="med" len="med"/>
-                      <a:tailEnd type="none" w="med" len="med"/>
-                    </a:lnL>
-                    <a:lnR w="12700" cap="flat" cmpd="sng" algn="ctr">
-                      <a:solidFill>
-                        <a:srgbClr val="0F3460"/>
-                      </a:solidFill>
-                      <a:prstDash val="solid"/>
-                      <a:round/>
-                      <a:headEnd type="none" w="med" len="med"/>
-                      <a:tailEnd type="none" w="med" len="med"/>
-                    </a:lnR>
-                    <a:lnT w="12700" cap="flat" cmpd="sng" algn="ctr">
-                      <a:solidFill>
-                        <a:srgbClr val="0F3460"/>
-                      </a:solidFill>
-                      <a:prstDash val="solid"/>
-                      <a:round/>
-                      <a:headEnd type="none" w="med" len="med"/>
-                      <a:tailEnd type="none" w="med" len="med"/>
-                    </a:lnT>
-                    <a:lnB w="12700" cap="flat" cmpd="sng" algn="ctr">
-                      <a:solidFill>
-                        <a:srgbClr val="0F3460"/>
-                      </a:solidFill>
-                      <a:prstDash val="solid"/>
-                      <a:round/>
-                      <a:headEnd type="none" w="med" len="med"/>
-                      <a:tailEnd type="none" w="med" len="med"/>
-                    </a:lnB>
-                    <a:solidFill>
-                      <a:srgbClr val="1A1A2E"/>
-                    </a:solidFill>
-                  </a:tcPr>
-                </a:tc>
-                <a:tc>
-                  <a:txBody>
-                    <a:bodyPr/>
-                    <a:lstStyle/>
-                    <a:p>
-                      <a:pPr algn="ctr" indent="0" marL="0">
-                        <a:buNone/>
-                      </a:pPr>
-                      <a:r>
-                        <a:rPr lang="en-US" sz="1000" dirty="0">
-                          <a:solidFill>
-                            <a:srgbClr val="E8E8E8"/>
-                          </a:solidFill>
-                          <a:latin typeface="Calibri" pitchFamily="34" charset="0"/>
-                          <a:ea typeface="Calibri" pitchFamily="34" charset="-122"/>
-                          <a:cs typeface="Calibri" pitchFamily="34" charset="-120"/>
-                        </a:rPr>
-                        <a:t>EW</a:t>
-                      </a:r>
-                      <a:endParaRPr lang="en-US" sz="1000" dirty="0">
-                        <a:latin typeface="Calibri" charset="0"/>
-                        <a:ea typeface="Calibri" charset="0"/>
-                        <a:cs typeface="Calibri" charset="0"/>
-                      </a:endParaRPr>
-                    </a:p>
-                    <a:p>
-                      <a:pPr algn="ctr" indent="0" marL="0">
-                        <a:buNone/>
-                      </a:pPr>
-                      <a:r>
-                        <a:rPr lang="en-US" sz="1000" dirty="0">
-                          <a:solidFill>
-                            <a:srgbClr val="E8E8E8"/>
-                          </a:solidFill>
-                          <a:latin typeface="Calibri" pitchFamily="34" charset="0"/>
-                          <a:ea typeface="Calibri" pitchFamily="34" charset="-122"/>
-                          <a:cs typeface="Calibri" pitchFamily="34" charset="-120"/>
-                        </a:rPr>
-                        <a:t>Eurowings</a:t>
-                      </a:r>
-                      <a:endParaRPr lang="en-US" sz="1000" dirty="0">
-                        <a:latin typeface="Calibri" charset="0"/>
-                        <a:ea typeface="Calibri" charset="0"/>
-                        <a:cs typeface="Calibri" charset="0"/>
-                      </a:endParaRPr>
-                    </a:p>
-                  </a:txBody>
-                  <a:tcPr marL="91440" marR="91440" marT="45720" marB="45720">
-                    <a:lnL w="12700" cap="flat" cmpd="sng" algn="ctr">
-                      <a:solidFill>
-                        <a:srgbClr val="0F3460"/>
-                      </a:solidFill>
-                      <a:prstDash val="solid"/>
-                      <a:round/>
-                      <a:headEnd type="none" w="med" len="med"/>
-                      <a:tailEnd type="none" w="med" len="med"/>
-                    </a:lnL>
-                    <a:lnR w="12700" cap="flat" cmpd="sng" algn="ctr">
-                      <a:solidFill>
-                        <a:srgbClr val="0F3460"/>
-                      </a:solidFill>
-                      <a:prstDash val="solid"/>
-                      <a:round/>
-                      <a:headEnd type="none" w="med" len="med"/>
-                      <a:tailEnd type="none" w="med" len="med"/>
-                    </a:lnR>
-                    <a:lnT w="12700" cap="flat" cmpd="sng" algn="ctr">
-                      <a:solidFill>
-                        <a:srgbClr val="0F3460"/>
-                      </a:solidFill>
-                      <a:prstDash val="solid"/>
-                      <a:round/>
-                      <a:headEnd type="none" w="med" len="med"/>
-                      <a:tailEnd type="none" w="med" len="med"/>
-                    </a:lnT>
-                    <a:lnB w="12700" cap="flat" cmpd="sng" algn="ctr">
-                      <a:solidFill>
-                        <a:srgbClr val="0F3460"/>
-                      </a:solidFill>
-                      <a:prstDash val="solid"/>
-                      <a:round/>
-                      <a:headEnd type="none" w="med" len="med"/>
-                      <a:tailEnd type="none" w="med" len="med"/>
-                    </a:lnB>
-                    <a:solidFill>
-                      <a:srgbClr val="1A1A2E"/>
-                    </a:solidFill>
-                  </a:tcPr>
-                </a:tc>
-                <a:tc>
-                  <a:txBody>
-                    <a:bodyPr/>
-                    <a:lstStyle/>
-                    <a:p>
-                      <a:pPr algn="ctr" indent="0" marL="0">
-                        <a:buNone/>
-                      </a:pPr>
-                      <a:r>
-                        <a:rPr lang="en-US" sz="1000" dirty="0">
-                          <a:solidFill>
-                            <a:srgbClr val="E8E8E8"/>
-                          </a:solidFill>
-                          <a:latin typeface="Calibri" pitchFamily="34" charset="0"/>
-                          <a:ea typeface="Calibri" pitchFamily="34" charset="-122"/>
-                          <a:cs typeface="Calibri" pitchFamily="34" charset="-120"/>
-                        </a:rPr>
-                        <a:t>DUS → MXP</a:t>
-                      </a:r>
-                      <a:endParaRPr lang="en-US" sz="1000" dirty="0">
-                        <a:latin typeface="Calibri" charset="0"/>
-                        <a:ea typeface="Calibri" charset="0"/>
-                        <a:cs typeface="Calibri" charset="0"/>
-                      </a:endParaRPr>
-                    </a:p>
-                    <a:p>
-                      <a:pPr algn="ctr" indent="0" marL="0">
-                        <a:buNone/>
-                      </a:pPr>
-                      <a:r>
-                        <a:rPr lang="en-US" sz="1000" dirty="0">
-                          <a:solidFill>
-                            <a:srgbClr val="E8E8E8"/>
-                          </a:solidFill>
-                          <a:latin typeface="Calibri" pitchFamily="34" charset="0"/>
-                          <a:ea typeface="Calibri" pitchFamily="34" charset="-122"/>
-                          <a:cs typeface="Calibri" pitchFamily="34" charset="-120"/>
-                        </a:rPr>
-                        <a:t>29. Okt. abends</a:t>
-                      </a:r>
-                      <a:endParaRPr lang="en-US" sz="1000" dirty="0">
-                        <a:latin typeface="Calibri" charset="0"/>
-                        <a:ea typeface="Calibri" charset="0"/>
-                        <a:cs typeface="Calibri" charset="0"/>
-                      </a:endParaRPr>
-                    </a:p>
-                  </a:txBody>
-                  <a:tcPr marL="91440" marR="91440" marT="45720" marB="45720">
-                    <a:lnL w="12700" cap="flat" cmpd="sng" algn="ctr">
-                      <a:solidFill>
-                        <a:srgbClr val="0F3460"/>
-                      </a:solidFill>
-                      <a:prstDash val="solid"/>
-                      <a:round/>
-                      <a:headEnd type="none" w="med" len="med"/>
-                      <a:tailEnd type="none" w="med" len="med"/>
-                    </a:lnL>
-                    <a:lnR w="12700" cap="flat" cmpd="sng" algn="ctr">
-                      <a:solidFill>
-                        <a:srgbClr val="0F3460"/>
-                      </a:solidFill>
-                      <a:prstDash val="solid"/>
-                      <a:round/>
-                      <a:headEnd type="none" w="med" len="med"/>
-                      <a:tailEnd type="none" w="med" len="med"/>
-                    </a:lnR>
-                    <a:lnT w="12700" cap="flat" cmpd="sng" algn="ctr">
-                      <a:solidFill>
-                        <a:srgbClr val="0F3460"/>
-                      </a:solidFill>
-                      <a:prstDash val="solid"/>
-                      <a:round/>
-                      <a:headEnd type="none" w="med" len="med"/>
-                      <a:tailEnd type="none" w="med" len="med"/>
-                    </a:lnT>
-                    <a:lnB w="12700" cap="flat" cmpd="sng" algn="ctr">
-                      <a:solidFill>
-                        <a:srgbClr val="0F3460"/>
-                      </a:solidFill>
-                      <a:prstDash val="solid"/>
-                      <a:round/>
-                      <a:headEnd type="none" w="med" len="med"/>
-                      <a:tailEnd type="none" w="med" len="med"/>
-                    </a:lnB>
-                    <a:solidFill>
-                      <a:srgbClr val="1A1A2E"/>
-                    </a:solidFill>
-                  </a:tcPr>
-                </a:tc>
-                <a:tc>
-                  <a:txBody>
-                    <a:bodyPr/>
-                    <a:lstStyle/>
-                    <a:p>
-                      <a:pPr algn="ctr" indent="0" marL="0">
-                        <a:buNone/>
-                      </a:pPr>
-                      <a:r>
-                        <a:rPr lang="en-US" sz="1000" dirty="0">
-                          <a:solidFill>
-                            <a:srgbClr val="E8E8E8"/>
-                          </a:solidFill>
-                          <a:latin typeface="Calibri" pitchFamily="34" charset="0"/>
-                          <a:ea typeface="Calibri" pitchFamily="34" charset="-122"/>
-                          <a:cs typeface="Calibri" pitchFamily="34" charset="-120"/>
-                        </a:rPr>
-                        <a:t>~18:xx</a:t>
-                      </a:r>
-                      <a:endParaRPr lang="en-US" sz="1000" dirty="0">
-                        <a:latin typeface="Calibri" charset="0"/>
-                        <a:ea typeface="Calibri" charset="0"/>
-                        <a:cs typeface="Calibri" charset="0"/>
-                      </a:endParaRPr>
-                    </a:p>
-                  </a:txBody>
-                  <a:tcPr marL="91440" marR="91440" marT="45720" marB="45720">
-                    <a:lnL w="12700" cap="flat" cmpd="sng" algn="ctr">
-                      <a:solidFill>
-                        <a:srgbClr val="0F3460"/>
-                      </a:solidFill>
-                      <a:prstDash val="solid"/>
-                      <a:round/>
-                      <a:headEnd type="none" w="med" len="med"/>
-                      <a:tailEnd type="none" w="med" len="med"/>
-                    </a:lnL>
-                    <a:lnR w="12700" cap="flat" cmpd="sng" algn="ctr">
-                      <a:solidFill>
-                        <a:srgbClr val="0F3460"/>
-                      </a:solidFill>
-                      <a:prstDash val="solid"/>
-                      <a:round/>
-                      <a:headEnd type="none" w="med" len="med"/>
-                      <a:tailEnd type="none" w="med" len="med"/>
-                    </a:lnR>
-                    <a:lnT w="12700" cap="flat" cmpd="sng" algn="ctr">
-                      <a:solidFill>
-                        <a:srgbClr val="0F3460"/>
-                      </a:solidFill>
-                      <a:prstDash val="solid"/>
-                      <a:round/>
-                      <a:headEnd type="none" w="med" len="med"/>
-                      <a:tailEnd type="none" w="med" len="med"/>
-                    </a:lnT>
-                    <a:lnB w="12700" cap="flat" cmpd="sng" algn="ctr">
-                      <a:solidFill>
-                        <a:srgbClr val="0F3460"/>
-                      </a:solidFill>
-                      <a:prstDash val="solid"/>
-                      <a:round/>
-                      <a:headEnd type="none" w="med" len="med"/>
-                      <a:tailEnd type="none" w="med" len="med"/>
-                    </a:lnB>
-                    <a:solidFill>
-                      <a:srgbClr val="1A1A2E"/>
-                    </a:solidFill>
-                  </a:tcPr>
-                </a:tc>
-                <a:tc>
-                  <a:txBody>
-                    <a:bodyPr/>
-                    <a:lstStyle/>
-                    <a:p>
-                      <a:pPr algn="ctr" indent="0" marL="0">
-                        <a:buNone/>
-                      </a:pPr>
-                      <a:r>
-                        <a:rPr lang="en-US" sz="1000" dirty="0">
-                          <a:solidFill>
-                            <a:srgbClr val="E8E8E8"/>
-                          </a:solidFill>
-                          <a:latin typeface="Calibri" pitchFamily="34" charset="0"/>
-                          <a:ea typeface="Calibri" pitchFamily="34" charset="-122"/>
-                          <a:cs typeface="Calibri" pitchFamily="34" charset="-120"/>
-                        </a:rPr>
-                        <a:t>~19:40</a:t>
-                      </a:r>
-                      <a:endParaRPr lang="en-US" sz="1000" dirty="0">
-                        <a:latin typeface="Calibri" charset="0"/>
-                        <a:ea typeface="Calibri" charset="0"/>
-                        <a:cs typeface="Calibri" charset="0"/>
-                      </a:endParaRPr>
-                    </a:p>
-                  </a:txBody>
-                  <a:tcPr marL="91440" marR="91440" marT="45720" marB="45720">
-                    <a:lnL w="12700" cap="flat" cmpd="sng" algn="ctr">
-                      <a:solidFill>
-                        <a:srgbClr val="0F3460"/>
-                      </a:solidFill>
-                      <a:prstDash val="solid"/>
-                      <a:round/>
-                      <a:headEnd type="none" w="med" len="med"/>
-                      <a:tailEnd type="none" w="med" len="med"/>
-                    </a:lnL>
-                    <a:lnR w="12700" cap="flat" cmpd="sng" algn="ctr">
-                      <a:solidFill>
-                        <a:srgbClr val="0F3460"/>
-                      </a:solidFill>
-                      <a:prstDash val="solid"/>
-                      <a:round/>
-                      <a:headEnd type="none" w="med" len="med"/>
-                      <a:tailEnd type="none" w="med" len="med"/>
-                    </a:lnR>
-                    <a:lnT w="12700" cap="flat" cmpd="sng" algn="ctr">
-                      <a:solidFill>
-                        <a:srgbClr val="0F3460"/>
-                      </a:solidFill>
-                      <a:prstDash val="solid"/>
-                      <a:round/>
-                      <a:headEnd type="none" w="med" len="med"/>
-                      <a:tailEnd type="none" w="med" len="med"/>
-                    </a:lnT>
-                    <a:lnB w="12700" cap="flat" cmpd="sng" algn="ctr">
-                      <a:solidFill>
-                        <a:srgbClr val="0F3460"/>
-                      </a:solidFill>
-                      <a:prstDash val="solid"/>
-                      <a:round/>
-                      <a:headEnd type="none" w="med" len="med"/>
-                      <a:tailEnd type="none" w="med" len="med"/>
-                    </a:lnB>
-                    <a:solidFill>
-                      <a:srgbClr val="1A1A2E"/>
-                    </a:solidFill>
-                  </a:tcPr>
-                </a:tc>
-                <a:tc>
-                  <a:txBody>
-                    <a:bodyPr/>
-                    <a:lstStyle/>
-                    <a:p>
-                      <a:pPr algn="ctr" indent="0" marL="0">
-                        <a:buNone/>
-                      </a:pPr>
-                      <a:r>
-                        <a:rPr lang="en-US" sz="1000" dirty="0">
-                          <a:solidFill>
-                            <a:srgbClr val="E8E8E8"/>
-                          </a:solidFill>
-                          <a:latin typeface="Calibri" pitchFamily="34" charset="0"/>
-                          <a:ea typeface="Calibri" pitchFamily="34" charset="-122"/>
-                          <a:cs typeface="Calibri" pitchFamily="34" charset="-120"/>
-                        </a:rPr>
-                        <a:t>1h 40m</a:t>
-                      </a:r>
-                      <a:endParaRPr lang="en-US" sz="1000" dirty="0">
-                        <a:latin typeface="Calibri" charset="0"/>
-                        <a:ea typeface="Calibri" charset="0"/>
-                        <a:cs typeface="Calibri" charset="0"/>
-                      </a:endParaRPr>
-                    </a:p>
-                  </a:txBody>
-                  <a:tcPr marL="91440" marR="91440" marT="45720" marB="45720">
-                    <a:lnL w="12700" cap="flat" cmpd="sng" algn="ctr">
-                      <a:solidFill>
-                        <a:srgbClr val="0F3460"/>
-                      </a:solidFill>
-                      <a:prstDash val="solid"/>
-                      <a:round/>
-                      <a:headEnd type="none" w="med" len="med"/>
-                      <a:tailEnd type="none" w="med" len="med"/>
-                    </a:lnL>
-                    <a:lnR w="12700" cap="flat" cmpd="sng" algn="ctr">
-                      <a:solidFill>
-                        <a:srgbClr val="0F3460"/>
-                      </a:solidFill>
-                      <a:prstDash val="solid"/>
-                      <a:round/>
-                      <a:headEnd type="none" w="med" len="med"/>
-                      <a:tailEnd type="none" w="med" len="med"/>
-                    </a:lnR>
-                    <a:lnT w="12700" cap="flat" cmpd="sng" algn="ctr">
-                      <a:solidFill>
-                        <a:srgbClr val="0F3460"/>
-                      </a:solidFill>
-                      <a:prstDash val="solid"/>
-                      <a:round/>
-                      <a:headEnd type="none" w="med" len="med"/>
-                      <a:tailEnd type="none" w="med" len="med"/>
-                    </a:lnT>
-                    <a:lnB w="12700" cap="flat" cmpd="sng" algn="ctr">
-                      <a:solidFill>
-                        <a:srgbClr val="0F3460"/>
-                      </a:solidFill>
-                      <a:prstDash val="solid"/>
-                      <a:round/>
-                      <a:headEnd type="none" w="med" len="med"/>
-                      <a:tailEnd type="none" w="med" len="med"/>
-                    </a:lnB>
-                    <a:solidFill>
-                      <a:srgbClr val="1A1A2E"/>
-                    </a:solidFill>
-                  </a:tcPr>
-                </a:tc>
-                <a:tc>
-                  <a:txBody>
-                    <a:bodyPr/>
-                    <a:lstStyle/>
-                    <a:p>
-                      <a:pPr algn="ctr" indent="0" marL="0">
-                        <a:buNone/>
-                      </a:pPr>
-                      <a:r>
-                        <a:rPr lang="en-US" sz="1000" dirty="0">
-                          <a:solidFill>
-                            <a:srgbClr val="E8E8E8"/>
-                          </a:solidFill>
-                          <a:latin typeface="Calibri" pitchFamily="34" charset="0"/>
-                          <a:ea typeface="Calibri" pitchFamily="34" charset="-122"/>
-                          <a:cs typeface="Calibri" pitchFamily="34" charset="-120"/>
-                        </a:rPr>
-                        <a:t>~€90</a:t>
-                      </a:r>
-                      <a:endParaRPr lang="en-US" sz="1000" dirty="0">
-                        <a:latin typeface="Calibri" charset="0"/>
-                        <a:ea typeface="Calibri" charset="0"/>
-                        <a:cs typeface="Calibri" charset="0"/>
-                      </a:endParaRPr>
-                    </a:p>
-                  </a:txBody>
-                  <a:tcPr marL="91440" marR="91440" marT="45720" marB="45720">
-                    <a:lnL w="12700" cap="flat" cmpd="sng" algn="ctr">
-                      <a:solidFill>
-                        <a:srgbClr val="0F3460"/>
-                      </a:solidFill>
-                      <a:prstDash val="solid"/>
-                      <a:round/>
-                      <a:headEnd type="none" w="med" len="med"/>
-                      <a:tailEnd type="none" w="med" len="med"/>
-                    </a:lnL>
-                    <a:lnR w="12700" cap="flat" cmpd="sng" algn="ctr">
-                      <a:solidFill>
-                        <a:srgbClr val="0F3460"/>
-                      </a:solidFill>
-                      <a:prstDash val="solid"/>
-                      <a:round/>
-                      <a:headEnd type="none" w="med" len="med"/>
-                      <a:tailEnd type="none" w="med" len="med"/>
-                    </a:lnR>
-                    <a:lnT w="12700" cap="flat" cmpd="sng" algn="ctr">
-                      <a:solidFill>
-                        <a:srgbClr val="0F3460"/>
-                      </a:solidFill>
-                      <a:prstDash val="solid"/>
-                      <a:round/>
-                      <a:headEnd type="none" w="med" len="med"/>
-                      <a:tailEnd type="none" w="med" len="med"/>
-                    </a:lnT>
-                    <a:lnB w="12700" cap="flat" cmpd="sng" algn="ctr">
-                      <a:solidFill>
-                        <a:srgbClr val="0F3460"/>
-                      </a:solidFill>
-                      <a:prstDash val="solid"/>
-                      <a:round/>
-                      <a:headEnd type="none" w="med" len="med"/>
-                      <a:tailEnd type="none" w="med" len="med"/>
-                    </a:lnB>
-                    <a:solidFill>
-                      <a:srgbClr val="1A1A2E"/>
-                    </a:solidFill>
-                  </a:tcPr>
-                </a:tc>
-                <a:tc>
-                  <a:txBody>
-                    <a:bodyPr/>
-                    <a:lstStyle/>
-                    <a:p>
-                      <a:pPr algn="ctr" indent="0" marL="0">
-                        <a:buNone/>
-                      </a:pPr>
-                      <a:r>
-                        <a:rPr lang="en-US" sz="1000" dirty="0">
-                          <a:solidFill>
-                            <a:srgbClr val="FFC107"/>
-                          </a:solidFill>
-                          <a:latin typeface="Calibri" pitchFamily="34" charset="0"/>
-                          <a:ea typeface="Calibri" pitchFamily="34" charset="-122"/>
-                          <a:cs typeface="Calibri" pitchFamily="34" charset="-120"/>
-                        </a:rPr>
-                        <a:t>~€360</a:t>
-                      </a:r>
-                      <a:endParaRPr lang="en-US" sz="1000" dirty="0">
-                        <a:latin typeface="Calibri" charset="0"/>
-                        <a:ea typeface="Calibri" charset="0"/>
-                        <a:cs typeface="Calibri" charset="0"/>
-                      </a:endParaRPr>
-                    </a:p>
-                  </a:txBody>
-                  <a:tcPr marL="91440" marR="91440" marT="45720" marB="45720">
-                    <a:lnL w="12700" cap="flat" cmpd="sng" algn="ctr">
-                      <a:solidFill>
-                        <a:srgbClr val="0F3460"/>
-                      </a:solidFill>
-                      <a:prstDash val="solid"/>
-                      <a:round/>
-                      <a:headEnd type="none" w="med" len="med"/>
-                      <a:tailEnd type="none" w="med" len="med"/>
-                    </a:lnL>
-                    <a:lnR w="12700" cap="flat" cmpd="sng" algn="ctr">
-                      <a:solidFill>
-                        <a:srgbClr val="0F3460"/>
-                      </a:solidFill>
-                      <a:prstDash val="solid"/>
-                      <a:round/>
-                      <a:headEnd type="none" w="med" len="med"/>
-                      <a:tailEnd type="none" w="med" len="med"/>
-                    </a:lnR>
-                    <a:lnT w="12700" cap="flat" cmpd="sng" algn="ctr">
-                      <a:solidFill>
-                        <a:srgbClr val="0F3460"/>
-                      </a:solidFill>
-                      <a:prstDash val="solid"/>
-                      <a:round/>
-                      <a:headEnd type="none" w="med" len="med"/>
-                      <a:tailEnd type="none" w="med" len="med"/>
-                    </a:lnT>
-                    <a:lnB w="12700" cap="flat" cmpd="sng" algn="ctr">
-                      <a:solidFill>
-                        <a:srgbClr val="0F3460"/>
-                      </a:solidFill>
-                      <a:prstDash val="solid"/>
-                      <a:round/>
-                      <a:headEnd type="none" w="med" len="med"/>
-                      <a:tailEnd type="none" w="med" len="med"/>
-                    </a:lnB>
-                    <a:solidFill>
-                      <a:srgbClr val="1A1A2E"/>
-                    </a:solidFill>
-                  </a:tcPr>
-                </a:tc>
-              </a:tr>
-              <a:tr h="475488">
-                <a:tc>
-                  <a:txBody>
-                    <a:bodyPr/>
-                    <a:lstStyle/>
-                    <a:p>
-                      <a:pPr algn="ctr" indent="0" marL="0">
-                        <a:buNone/>
-                      </a:pPr>
-                      <a:r>
-                        <a:rPr lang="en-US" sz="1000" dirty="0">
-                          <a:solidFill>
-                            <a:srgbClr val="E8E8E8"/>
-                          </a:solidFill>
-                          <a:latin typeface="Calibri" pitchFamily="34" charset="0"/>
-                          <a:ea typeface="Calibri" pitchFamily="34" charset="-122"/>
-                          <a:cs typeface="Calibri" pitchFamily="34" charset="-120"/>
-                        </a:rPr>
-                        <a:t>Mittag</a:t>
-                      </a:r>
-                      <a:endParaRPr lang="en-US" sz="1000" dirty="0">
-                        <a:latin typeface="Calibri" charset="0"/>
-                        <a:ea typeface="Calibri" charset="0"/>
-                        <a:cs typeface="Calibri" charset="0"/>
-                      </a:endParaRPr>
-                    </a:p>
-                  </a:txBody>
-                  <a:tcPr marL="91440" marR="91440" marT="45720" marB="45720">
-                    <a:lnL w="12700" cap="flat" cmpd="sng" algn="ctr">
-                      <a:solidFill>
-                        <a:srgbClr val="0F3460"/>
-                      </a:solidFill>
-                      <a:prstDash val="solid"/>
-                      <a:round/>
-                      <a:headEnd type="none" w="med" len="med"/>
-                      <a:tailEnd type="none" w="med" len="med"/>
-                    </a:lnL>
-                    <a:lnR w="12700" cap="flat" cmpd="sng" algn="ctr">
-                      <a:solidFill>
-                        <a:srgbClr val="0F3460"/>
-                      </a:solidFill>
-                      <a:prstDash val="solid"/>
-                      <a:round/>
-                      <a:headEnd type="none" w="med" len="med"/>
-                      <a:tailEnd type="none" w="med" len="med"/>
-                    </a:lnR>
-                    <a:lnT w="12700" cap="flat" cmpd="sng" algn="ctr">
-                      <a:solidFill>
-                        <a:srgbClr val="0F3460"/>
-                      </a:solidFill>
-                      <a:prstDash val="solid"/>
-                      <a:round/>
-                      <a:headEnd type="none" w="med" len="med"/>
-                      <a:tailEnd type="none" w="med" len="med"/>
-                    </a:lnT>
-                    <a:lnB w="12700" cap="flat" cmpd="sng" algn="ctr">
-                      <a:solidFill>
-                        <a:srgbClr val="0F3460"/>
-                      </a:solidFill>
-                      <a:prstDash val="solid"/>
-                      <a:round/>
-                      <a:headEnd type="none" w="med" len="med"/>
-                      <a:tailEnd type="none" w="med" len="med"/>
-                    </a:lnB>
-                    <a:solidFill>
-                      <a:srgbClr val="16213E"/>
-                    </a:solidFill>
-                  </a:tcPr>
-                </a:tc>
-                <a:tc>
-                  <a:txBody>
-                    <a:bodyPr/>
-                    <a:lstStyle/>
-                    <a:p>
-                      <a:pPr algn="ctr" indent="0" marL="0">
-                        <a:buNone/>
-                      </a:pPr>
-                      <a:r>
-                        <a:rPr lang="en-US" sz="1000" dirty="0">
-                          <a:solidFill>
-                            <a:srgbClr val="E8E8E8"/>
-                          </a:solidFill>
-                          <a:latin typeface="Calibri" pitchFamily="34" charset="0"/>
-                          <a:ea typeface="Calibri" pitchFamily="34" charset="-122"/>
-                          <a:cs typeface="Calibri" pitchFamily="34" charset="-120"/>
-                        </a:rPr>
-                        <a:t>ITA Airways</a:t>
-                      </a:r>
-                      <a:endParaRPr lang="en-US" sz="1000" dirty="0">
-                        <a:latin typeface="Calibri" charset="0"/>
-                        <a:ea typeface="Calibri" charset="0"/>
-                        <a:cs typeface="Calibri" charset="0"/>
-                      </a:endParaRPr>
-                    </a:p>
-                    <a:p>
-                      <a:pPr algn="ctr" indent="0" marL="0">
-                        <a:buNone/>
-                      </a:pPr>
-                      <a:r>
-                        <a:rPr lang="en-US" sz="1000" dirty="0">
-                          <a:solidFill>
-                            <a:srgbClr val="E8E8E8"/>
-                          </a:solidFill>
-                          <a:latin typeface="Calibri" pitchFamily="34" charset="0"/>
-                          <a:ea typeface="Calibri" pitchFamily="34" charset="-122"/>
-                          <a:cs typeface="Calibri" pitchFamily="34" charset="-120"/>
-                        </a:rPr>
-                        <a:t>(ex-Alitalia)</a:t>
-                      </a:r>
-                      <a:endParaRPr lang="en-US" sz="1000" dirty="0">
-                        <a:latin typeface="Calibri" charset="0"/>
-                        <a:ea typeface="Calibri" charset="0"/>
-                        <a:cs typeface="Calibri" charset="0"/>
-                      </a:endParaRPr>
-                    </a:p>
-                  </a:txBody>
-                  <a:tcPr marL="91440" marR="91440" marT="45720" marB="45720">
-                    <a:lnL w="12700" cap="flat" cmpd="sng" algn="ctr">
-                      <a:solidFill>
-                        <a:srgbClr val="0F3460"/>
-                      </a:solidFill>
-                      <a:prstDash val="solid"/>
-                      <a:round/>
-                      <a:headEnd type="none" w="med" len="med"/>
-                      <a:tailEnd type="none" w="med" len="med"/>
-                    </a:lnL>
-                    <a:lnR w="12700" cap="flat" cmpd="sng" algn="ctr">
-                      <a:solidFill>
-                        <a:srgbClr val="0F3460"/>
-                      </a:solidFill>
-                      <a:prstDash val="solid"/>
-                      <a:round/>
-                      <a:headEnd type="none" w="med" len="med"/>
-                      <a:tailEnd type="none" w="med" len="med"/>
-                    </a:lnR>
-                    <a:lnT w="12700" cap="flat" cmpd="sng" algn="ctr">
-                      <a:solidFill>
-                        <a:srgbClr val="0F3460"/>
-                      </a:solidFill>
-                      <a:prstDash val="solid"/>
-                      <a:round/>
-                      <a:headEnd type="none" w="med" len="med"/>
-                      <a:tailEnd type="none" w="med" len="med"/>
-                    </a:lnT>
-                    <a:lnB w="12700" cap="flat" cmpd="sng" algn="ctr">
-                      <a:solidFill>
-                        <a:srgbClr val="0F3460"/>
-                      </a:solidFill>
-                      <a:prstDash val="solid"/>
-                      <a:round/>
-                      <a:headEnd type="none" w="med" len="med"/>
-                      <a:tailEnd type="none" w="med" len="med"/>
-                    </a:lnB>
-                    <a:solidFill>
-                      <a:srgbClr val="16213E"/>
-                    </a:solidFill>
-                  </a:tcPr>
-                </a:tc>
-                <a:tc>
-                  <a:txBody>
-                    <a:bodyPr/>
-                    <a:lstStyle/>
-                    <a:p>
-                      <a:pPr algn="ctr" indent="0" marL="0">
-                        <a:buNone/>
-                      </a:pPr>
-                      <a:r>
-                        <a:rPr lang="en-US" sz="1000" dirty="0">
-                          <a:solidFill>
-                            <a:srgbClr val="E8E8E8"/>
-                          </a:solidFill>
-                          <a:latin typeface="Calibri" pitchFamily="34" charset="0"/>
-                          <a:ea typeface="Calibri" pitchFamily="34" charset="-122"/>
-                          <a:cs typeface="Calibri" pitchFamily="34" charset="-120"/>
-                        </a:rPr>
-                        <a:t>DUS → MXP</a:t>
+                        <a:t>DUS → SOF</a:t>
                       </a:r>
                       <a:endParaRPr lang="en-US" sz="1000" dirty="0">
                         <a:latin typeface="Calibri" charset="0"/>
@@ -26077,7 +24823,7 @@
                           <a:ea typeface="Calibri" pitchFamily="34" charset="-122"/>
                           <a:cs typeface="Calibri" pitchFamily="34" charset="-120"/>
                         </a:rPr>
-                        <a:t>~12:xx</a:t>
+                        <a:t>Morgens</a:t>
                       </a:r>
                       <a:endParaRPr lang="en-US" sz="1000" dirty="0">
                         <a:latin typeface="Calibri" charset="0"/>
@@ -26145,7 +24891,7 @@
                           <a:ea typeface="Calibri" pitchFamily="34" charset="-122"/>
                           <a:cs typeface="Calibri" pitchFamily="34" charset="-120"/>
                         </a:rPr>
-                        <a:t>~13:50</a:t>
+                        <a:t>~11:00</a:t>
                       </a:r>
                       <a:endParaRPr lang="en-US" sz="1000" dirty="0">
                         <a:latin typeface="Calibri" charset="0"/>
@@ -26213,7 +24959,7 @@
                           <a:ea typeface="Calibri" pitchFamily="34" charset="-122"/>
                           <a:cs typeface="Calibri" pitchFamily="34" charset="-120"/>
                         </a:rPr>
-                        <a:t>1h 40m</a:t>
+                        <a:t>~2h 30m</a:t>
                       </a:r>
                       <a:endParaRPr lang="en-US" sz="1000" dirty="0">
                         <a:latin typeface="Calibri" charset="0"/>
@@ -26281,7 +25027,7 @@
                           <a:ea typeface="Calibri" pitchFamily="34" charset="-122"/>
                           <a:cs typeface="Calibri" pitchFamily="34" charset="-120"/>
                         </a:rPr>
-                        <a:t>~€100–130</a:t>
+                        <a:t>~€80–120</a:t>
                       </a:r>
                       <a:endParaRPr lang="en-US" sz="1000" dirty="0">
                         <a:latin typeface="Calibri" charset="0"/>
@@ -26341,15 +25087,15 @@
                         <a:buNone/>
                       </a:pPr>
                       <a:r>
-                        <a:rPr lang="en-US" sz="1000" dirty="0">
+                        <a:rPr lang="en-US" sz="1000" b="1" dirty="0">
                           <a:solidFill>
-                            <a:srgbClr val="FFC107"/>
+                            <a:srgbClr val="FF8C00"/>
                           </a:solidFill>
                           <a:latin typeface="Calibri" pitchFamily="34" charset="0"/>
                           <a:ea typeface="Calibri" pitchFamily="34" charset="-122"/>
                           <a:cs typeface="Calibri" pitchFamily="34" charset="-120"/>
                         </a:rPr>
-                        <a:t>~€400–520</a:t>
+                        <a:t>~€320–480</a:t>
                       </a:r>
                       <a:endParaRPr lang="en-US" sz="1000" dirty="0">
                         <a:latin typeface="Calibri" charset="0"/>
@@ -26419,7 +25165,7 @@
                           <a:ea typeface="Calibri" pitchFamily="34" charset="-122"/>
                           <a:cs typeface="Calibri" pitchFamily="34" charset="-120"/>
                         </a:rPr>
-                        <a:t>Budget</a:t>
+                        <a:t>Option 2</a:t>
                       </a:r>
                       <a:endParaRPr lang="en-US" sz="1000" dirty="0">
                         <a:latin typeface="Calibri" charset="0"/>
@@ -26487,7 +25233,7 @@
                           <a:ea typeface="Calibri" pitchFamily="34" charset="-122"/>
                           <a:cs typeface="Calibri" pitchFamily="34" charset="-120"/>
                         </a:rPr>
-                        <a:t>FR</a:t>
+                        <a:t>Ryanair</a:t>
                       </a:r>
                       <a:endParaRPr lang="en-US" sz="1000" dirty="0">
                         <a:latin typeface="Calibri" charset="0"/>
@@ -26508,7 +25254,7 @@
                           <a:ea typeface="Calibri" pitchFamily="34" charset="-122"/>
                           <a:cs typeface="Calibri" pitchFamily="34" charset="-120"/>
                         </a:rPr>
-                        <a:t>Ryanair</a:t>
+                        <a:t>(FR)</a:t>
                       </a:r>
                       <a:endParaRPr lang="en-US" sz="1000" dirty="0">
                         <a:latin typeface="Calibri" charset="0"/>
@@ -26576,7 +25322,7 @@
                           <a:ea typeface="Calibri" pitchFamily="34" charset="-122"/>
                           <a:cs typeface="Calibri" pitchFamily="34" charset="-120"/>
                         </a:rPr>
-                        <a:t>DUS → BGY</a:t>
+                        <a:t>DUS → SOF</a:t>
                       </a:r>
                       <a:endParaRPr lang="en-US" sz="1000" dirty="0">
                         <a:latin typeface="Calibri" charset="0"/>
@@ -26801,7 +25547,7 @@
                           <a:ea typeface="Calibri" pitchFamily="34" charset="-122"/>
                           <a:cs typeface="Calibri" pitchFamily="34" charset="-120"/>
                         </a:rPr>
-                        <a:t>1h 45m</a:t>
+                        <a:t>~2h 30m</a:t>
                       </a:r>
                       <a:endParaRPr lang="en-US" sz="1000" dirty="0">
                         <a:latin typeface="Calibri" charset="0"/>
@@ -26869,7 +25615,7 @@
                           <a:ea typeface="Calibri" pitchFamily="34" charset="-122"/>
                           <a:cs typeface="Calibri" pitchFamily="34" charset="-120"/>
                         </a:rPr>
-                        <a:t>~€50–80</a:t>
+                        <a:t>~€50–90</a:t>
                       </a:r>
                       <a:endParaRPr lang="en-US" sz="1000" dirty="0">
                         <a:latin typeface="Calibri" charset="0"/>
@@ -26937,7 +25683,1183 @@
                           <a:ea typeface="Calibri" pitchFamily="34" charset="-122"/>
                           <a:cs typeface="Calibri" pitchFamily="34" charset="-120"/>
                         </a:rPr>
-                        <a:t>~€200–320</a:t>
+                        <a:t>~€200–360</a:t>
+                      </a:r>
+                      <a:endParaRPr lang="en-US" sz="1000" dirty="0">
+                        <a:latin typeface="Calibri" charset="0"/>
+                        <a:ea typeface="Calibri" charset="0"/>
+                        <a:cs typeface="Calibri" charset="0"/>
+                      </a:endParaRPr>
+                    </a:p>
+                  </a:txBody>
+                  <a:tcPr marL="91440" marR="91440" marT="45720" marB="45720">
+                    <a:lnL w="12700" cap="flat" cmpd="sng" algn="ctr">
+                      <a:solidFill>
+                        <a:srgbClr val="0F3460"/>
+                      </a:solidFill>
+                      <a:prstDash val="solid"/>
+                      <a:round/>
+                      <a:headEnd type="none" w="med" len="med"/>
+                      <a:tailEnd type="none" w="med" len="med"/>
+                    </a:lnL>
+                    <a:lnR w="12700" cap="flat" cmpd="sng" algn="ctr">
+                      <a:solidFill>
+                        <a:srgbClr val="0F3460"/>
+                      </a:solidFill>
+                      <a:prstDash val="solid"/>
+                      <a:round/>
+                      <a:headEnd type="none" w="med" len="med"/>
+                      <a:tailEnd type="none" w="med" len="med"/>
+                    </a:lnR>
+                    <a:lnT w="12700" cap="flat" cmpd="sng" algn="ctr">
+                      <a:solidFill>
+                        <a:srgbClr val="0F3460"/>
+                      </a:solidFill>
+                      <a:prstDash val="solid"/>
+                      <a:round/>
+                      <a:headEnd type="none" w="med" len="med"/>
+                      <a:tailEnd type="none" w="med" len="med"/>
+                    </a:lnT>
+                    <a:lnB w="12700" cap="flat" cmpd="sng" algn="ctr">
+                      <a:solidFill>
+                        <a:srgbClr val="0F3460"/>
+                      </a:solidFill>
+                      <a:prstDash val="solid"/>
+                      <a:round/>
+                      <a:headEnd type="none" w="med" len="med"/>
+                      <a:tailEnd type="none" w="med" len="med"/>
+                    </a:lnB>
+                    <a:solidFill>
+                      <a:srgbClr val="1A1A2E"/>
+                    </a:solidFill>
+                  </a:tcPr>
+                </a:tc>
+              </a:tr>
+              <a:tr h="475488">
+                <a:tc>
+                  <a:txBody>
+                    <a:bodyPr/>
+                    <a:lstStyle/>
+                    <a:p>
+                      <a:pPr algn="ctr" indent="0" marL="0">
+                        <a:buNone/>
+                      </a:pPr>
+                      <a:r>
+                        <a:rPr lang="en-US" sz="1000" dirty="0">
+                          <a:solidFill>
+                            <a:srgbClr val="E8E8E8"/>
+                          </a:solidFill>
+                          <a:latin typeface="Calibri" pitchFamily="34" charset="0"/>
+                          <a:ea typeface="Calibri" pitchFamily="34" charset="-122"/>
+                          <a:cs typeface="Calibri" pitchFamily="34" charset="-120"/>
+                        </a:rPr>
+                        <a:t>Vorabend</a:t>
+                      </a:r>
+                      <a:endParaRPr lang="en-US" sz="1000" dirty="0">
+                        <a:latin typeface="Calibri" charset="0"/>
+                        <a:ea typeface="Calibri" charset="0"/>
+                        <a:cs typeface="Calibri" charset="0"/>
+                      </a:endParaRPr>
+                    </a:p>
+                  </a:txBody>
+                  <a:tcPr marL="91440" marR="91440" marT="45720" marB="45720">
+                    <a:lnL w="12700" cap="flat" cmpd="sng" algn="ctr">
+                      <a:solidFill>
+                        <a:srgbClr val="0F3460"/>
+                      </a:solidFill>
+                      <a:prstDash val="solid"/>
+                      <a:round/>
+                      <a:headEnd type="none" w="med" len="med"/>
+                      <a:tailEnd type="none" w="med" len="med"/>
+                    </a:lnL>
+                    <a:lnR w="12700" cap="flat" cmpd="sng" algn="ctr">
+                      <a:solidFill>
+                        <a:srgbClr val="0F3460"/>
+                      </a:solidFill>
+                      <a:prstDash val="solid"/>
+                      <a:round/>
+                      <a:headEnd type="none" w="med" len="med"/>
+                      <a:tailEnd type="none" w="med" len="med"/>
+                    </a:lnR>
+                    <a:lnT w="12700" cap="flat" cmpd="sng" algn="ctr">
+                      <a:solidFill>
+                        <a:srgbClr val="0F3460"/>
+                      </a:solidFill>
+                      <a:prstDash val="solid"/>
+                      <a:round/>
+                      <a:headEnd type="none" w="med" len="med"/>
+                      <a:tailEnd type="none" w="med" len="med"/>
+                    </a:lnT>
+                    <a:lnB w="12700" cap="flat" cmpd="sng" algn="ctr">
+                      <a:solidFill>
+                        <a:srgbClr val="0F3460"/>
+                      </a:solidFill>
+                      <a:prstDash val="solid"/>
+                      <a:round/>
+                      <a:headEnd type="none" w="med" len="med"/>
+                      <a:tailEnd type="none" w="med" len="med"/>
+                    </a:lnB>
+                    <a:solidFill>
+                      <a:srgbClr val="16213E"/>
+                    </a:solidFill>
+                  </a:tcPr>
+                </a:tc>
+                <a:tc>
+                  <a:txBody>
+                    <a:bodyPr/>
+                    <a:lstStyle/>
+                    <a:p>
+                      <a:pPr algn="ctr" indent="0" marL="0">
+                        <a:buNone/>
+                      </a:pPr>
+                      <a:r>
+                        <a:rPr lang="en-US" sz="1000" dirty="0">
+                          <a:solidFill>
+                            <a:srgbClr val="E8E8E8"/>
+                          </a:solidFill>
+                          <a:latin typeface="Calibri" pitchFamily="34" charset="0"/>
+                          <a:ea typeface="Calibri" pitchFamily="34" charset="-122"/>
+                          <a:cs typeface="Calibri" pitchFamily="34" charset="-120"/>
+                        </a:rPr>
+                        <a:t>Bulgaria Air</a:t>
+                      </a:r>
+                      <a:endParaRPr lang="en-US" sz="1000" dirty="0">
+                        <a:latin typeface="Calibri" charset="0"/>
+                        <a:ea typeface="Calibri" charset="0"/>
+                        <a:cs typeface="Calibri" charset="0"/>
+                      </a:endParaRPr>
+                    </a:p>
+                    <a:p>
+                      <a:pPr algn="ctr" indent="0" marL="0">
+                        <a:buNone/>
+                      </a:pPr>
+                      <a:r>
+                        <a:rPr lang="en-US" sz="1000" dirty="0">
+                          <a:solidFill>
+                            <a:srgbClr val="E8E8E8"/>
+                          </a:solidFill>
+                          <a:latin typeface="Calibri" pitchFamily="34" charset="0"/>
+                          <a:ea typeface="Calibri" pitchFamily="34" charset="-122"/>
+                          <a:cs typeface="Calibri" pitchFamily="34" charset="-120"/>
+                        </a:rPr>
+                        <a:t>(FB)</a:t>
+                      </a:r>
+                      <a:endParaRPr lang="en-US" sz="1000" dirty="0">
+                        <a:latin typeface="Calibri" charset="0"/>
+                        <a:ea typeface="Calibri" charset="0"/>
+                        <a:cs typeface="Calibri" charset="0"/>
+                      </a:endParaRPr>
+                    </a:p>
+                  </a:txBody>
+                  <a:tcPr marL="91440" marR="91440" marT="45720" marB="45720">
+                    <a:lnL w="12700" cap="flat" cmpd="sng" algn="ctr">
+                      <a:solidFill>
+                        <a:srgbClr val="0F3460"/>
+                      </a:solidFill>
+                      <a:prstDash val="solid"/>
+                      <a:round/>
+                      <a:headEnd type="none" w="med" len="med"/>
+                      <a:tailEnd type="none" w="med" len="med"/>
+                    </a:lnL>
+                    <a:lnR w="12700" cap="flat" cmpd="sng" algn="ctr">
+                      <a:solidFill>
+                        <a:srgbClr val="0F3460"/>
+                      </a:solidFill>
+                      <a:prstDash val="solid"/>
+                      <a:round/>
+                      <a:headEnd type="none" w="med" len="med"/>
+                      <a:tailEnd type="none" w="med" len="med"/>
+                    </a:lnR>
+                    <a:lnT w="12700" cap="flat" cmpd="sng" algn="ctr">
+                      <a:solidFill>
+                        <a:srgbClr val="0F3460"/>
+                      </a:solidFill>
+                      <a:prstDash val="solid"/>
+                      <a:round/>
+                      <a:headEnd type="none" w="med" len="med"/>
+                      <a:tailEnd type="none" w="med" len="med"/>
+                    </a:lnT>
+                    <a:lnB w="12700" cap="flat" cmpd="sng" algn="ctr">
+                      <a:solidFill>
+                        <a:srgbClr val="0F3460"/>
+                      </a:solidFill>
+                      <a:prstDash val="solid"/>
+                      <a:round/>
+                      <a:headEnd type="none" w="med" len="med"/>
+                      <a:tailEnd type="none" w="med" len="med"/>
+                    </a:lnB>
+                    <a:solidFill>
+                      <a:srgbClr val="16213E"/>
+                    </a:solidFill>
+                  </a:tcPr>
+                </a:tc>
+                <a:tc>
+                  <a:txBody>
+                    <a:bodyPr/>
+                    <a:lstStyle/>
+                    <a:p>
+                      <a:pPr algn="ctr" indent="0" marL="0">
+                        <a:buNone/>
+                      </a:pPr>
+                      <a:r>
+                        <a:rPr lang="en-US" sz="1000" dirty="0">
+                          <a:solidFill>
+                            <a:srgbClr val="E8E8E8"/>
+                          </a:solidFill>
+                          <a:latin typeface="Calibri" pitchFamily="34" charset="0"/>
+                          <a:ea typeface="Calibri" pitchFamily="34" charset="-122"/>
+                          <a:cs typeface="Calibri" pitchFamily="34" charset="-120"/>
+                        </a:rPr>
+                        <a:t>DUS → SOF</a:t>
+                      </a:r>
+                      <a:endParaRPr lang="en-US" sz="1000" dirty="0">
+                        <a:latin typeface="Calibri" charset="0"/>
+                        <a:ea typeface="Calibri" charset="0"/>
+                        <a:cs typeface="Calibri" charset="0"/>
+                      </a:endParaRPr>
+                    </a:p>
+                    <a:p>
+                      <a:pPr algn="ctr" indent="0" marL="0">
+                        <a:buNone/>
+                      </a:pPr>
+                      <a:r>
+                        <a:rPr lang="en-US" sz="1000" dirty="0">
+                          <a:solidFill>
+                            <a:srgbClr val="E8E8E8"/>
+                          </a:solidFill>
+                          <a:latin typeface="Calibri" pitchFamily="34" charset="0"/>
+                          <a:ea typeface="Calibri" pitchFamily="34" charset="-122"/>
+                          <a:cs typeface="Calibri" pitchFamily="34" charset="-120"/>
+                        </a:rPr>
+                        <a:t>29. Okt.</a:t>
+                      </a:r>
+                      <a:endParaRPr lang="en-US" sz="1000" dirty="0">
+                        <a:latin typeface="Calibri" charset="0"/>
+                        <a:ea typeface="Calibri" charset="0"/>
+                        <a:cs typeface="Calibri" charset="0"/>
+                      </a:endParaRPr>
+                    </a:p>
+                  </a:txBody>
+                  <a:tcPr marL="91440" marR="91440" marT="45720" marB="45720">
+                    <a:lnL w="12700" cap="flat" cmpd="sng" algn="ctr">
+                      <a:solidFill>
+                        <a:srgbClr val="0F3460"/>
+                      </a:solidFill>
+                      <a:prstDash val="solid"/>
+                      <a:round/>
+                      <a:headEnd type="none" w="med" len="med"/>
+                      <a:tailEnd type="none" w="med" len="med"/>
+                    </a:lnL>
+                    <a:lnR w="12700" cap="flat" cmpd="sng" algn="ctr">
+                      <a:solidFill>
+                        <a:srgbClr val="0F3460"/>
+                      </a:solidFill>
+                      <a:prstDash val="solid"/>
+                      <a:round/>
+                      <a:headEnd type="none" w="med" len="med"/>
+                      <a:tailEnd type="none" w="med" len="med"/>
+                    </a:lnR>
+                    <a:lnT w="12700" cap="flat" cmpd="sng" algn="ctr">
+                      <a:solidFill>
+                        <a:srgbClr val="0F3460"/>
+                      </a:solidFill>
+                      <a:prstDash val="solid"/>
+                      <a:round/>
+                      <a:headEnd type="none" w="med" len="med"/>
+                      <a:tailEnd type="none" w="med" len="med"/>
+                    </a:lnT>
+                    <a:lnB w="12700" cap="flat" cmpd="sng" algn="ctr">
+                      <a:solidFill>
+                        <a:srgbClr val="0F3460"/>
+                      </a:solidFill>
+                      <a:prstDash val="solid"/>
+                      <a:round/>
+                      <a:headEnd type="none" w="med" len="med"/>
+                      <a:tailEnd type="none" w="med" len="med"/>
+                    </a:lnB>
+                    <a:solidFill>
+                      <a:srgbClr val="16213E"/>
+                    </a:solidFill>
+                  </a:tcPr>
+                </a:tc>
+                <a:tc>
+                  <a:txBody>
+                    <a:bodyPr/>
+                    <a:lstStyle/>
+                    <a:p>
+                      <a:pPr algn="ctr" indent="0" marL="0">
+                        <a:buNone/>
+                      </a:pPr>
+                      <a:r>
+                        <a:rPr lang="en-US" sz="1000" dirty="0">
+                          <a:solidFill>
+                            <a:srgbClr val="E8E8E8"/>
+                          </a:solidFill>
+                          <a:latin typeface="Calibri" pitchFamily="34" charset="0"/>
+                          <a:ea typeface="Calibri" pitchFamily="34" charset="-122"/>
+                          <a:cs typeface="Calibri" pitchFamily="34" charset="-120"/>
+                        </a:rPr>
+                        <a:t>Abends</a:t>
+                      </a:r>
+                      <a:endParaRPr lang="en-US" sz="1000" dirty="0">
+                        <a:latin typeface="Calibri" charset="0"/>
+                        <a:ea typeface="Calibri" charset="0"/>
+                        <a:cs typeface="Calibri" charset="0"/>
+                      </a:endParaRPr>
+                    </a:p>
+                  </a:txBody>
+                  <a:tcPr marL="91440" marR="91440" marT="45720" marB="45720">
+                    <a:lnL w="12700" cap="flat" cmpd="sng" algn="ctr">
+                      <a:solidFill>
+                        <a:srgbClr val="0F3460"/>
+                      </a:solidFill>
+                      <a:prstDash val="solid"/>
+                      <a:round/>
+                      <a:headEnd type="none" w="med" len="med"/>
+                      <a:tailEnd type="none" w="med" len="med"/>
+                    </a:lnL>
+                    <a:lnR w="12700" cap="flat" cmpd="sng" algn="ctr">
+                      <a:solidFill>
+                        <a:srgbClr val="0F3460"/>
+                      </a:solidFill>
+                      <a:prstDash val="solid"/>
+                      <a:round/>
+                      <a:headEnd type="none" w="med" len="med"/>
+                      <a:tailEnd type="none" w="med" len="med"/>
+                    </a:lnR>
+                    <a:lnT w="12700" cap="flat" cmpd="sng" algn="ctr">
+                      <a:solidFill>
+                        <a:srgbClr val="0F3460"/>
+                      </a:solidFill>
+                      <a:prstDash val="solid"/>
+                      <a:round/>
+                      <a:headEnd type="none" w="med" len="med"/>
+                      <a:tailEnd type="none" w="med" len="med"/>
+                    </a:lnT>
+                    <a:lnB w="12700" cap="flat" cmpd="sng" algn="ctr">
+                      <a:solidFill>
+                        <a:srgbClr val="0F3460"/>
+                      </a:solidFill>
+                      <a:prstDash val="solid"/>
+                      <a:round/>
+                      <a:headEnd type="none" w="med" len="med"/>
+                      <a:tailEnd type="none" w="med" len="med"/>
+                    </a:lnB>
+                    <a:solidFill>
+                      <a:srgbClr val="16213E"/>
+                    </a:solidFill>
+                  </a:tcPr>
+                </a:tc>
+                <a:tc>
+                  <a:txBody>
+                    <a:bodyPr/>
+                    <a:lstStyle/>
+                    <a:p>
+                      <a:pPr algn="ctr" indent="0" marL="0">
+                        <a:buNone/>
+                      </a:pPr>
+                      <a:r>
+                        <a:rPr lang="en-US" sz="1000" dirty="0">
+                          <a:solidFill>
+                            <a:srgbClr val="E8E8E8"/>
+                          </a:solidFill>
+                          <a:latin typeface="Calibri" pitchFamily="34" charset="0"/>
+                          <a:ea typeface="Calibri" pitchFamily="34" charset="-122"/>
+                          <a:cs typeface="Calibri" pitchFamily="34" charset="-120"/>
+                        </a:rPr>
+                        <a:t>Abends</a:t>
+                      </a:r>
+                      <a:endParaRPr lang="en-US" sz="1000" dirty="0">
+                        <a:latin typeface="Calibri" charset="0"/>
+                        <a:ea typeface="Calibri" charset="0"/>
+                        <a:cs typeface="Calibri" charset="0"/>
+                      </a:endParaRPr>
+                    </a:p>
+                  </a:txBody>
+                  <a:tcPr marL="91440" marR="91440" marT="45720" marB="45720">
+                    <a:lnL w="12700" cap="flat" cmpd="sng" algn="ctr">
+                      <a:solidFill>
+                        <a:srgbClr val="0F3460"/>
+                      </a:solidFill>
+                      <a:prstDash val="solid"/>
+                      <a:round/>
+                      <a:headEnd type="none" w="med" len="med"/>
+                      <a:tailEnd type="none" w="med" len="med"/>
+                    </a:lnL>
+                    <a:lnR w="12700" cap="flat" cmpd="sng" algn="ctr">
+                      <a:solidFill>
+                        <a:srgbClr val="0F3460"/>
+                      </a:solidFill>
+                      <a:prstDash val="solid"/>
+                      <a:round/>
+                      <a:headEnd type="none" w="med" len="med"/>
+                      <a:tailEnd type="none" w="med" len="med"/>
+                    </a:lnR>
+                    <a:lnT w="12700" cap="flat" cmpd="sng" algn="ctr">
+                      <a:solidFill>
+                        <a:srgbClr val="0F3460"/>
+                      </a:solidFill>
+                      <a:prstDash val="solid"/>
+                      <a:round/>
+                      <a:headEnd type="none" w="med" len="med"/>
+                      <a:tailEnd type="none" w="med" len="med"/>
+                    </a:lnT>
+                    <a:lnB w="12700" cap="flat" cmpd="sng" algn="ctr">
+                      <a:solidFill>
+                        <a:srgbClr val="0F3460"/>
+                      </a:solidFill>
+                      <a:prstDash val="solid"/>
+                      <a:round/>
+                      <a:headEnd type="none" w="med" len="med"/>
+                      <a:tailEnd type="none" w="med" len="med"/>
+                    </a:lnB>
+                    <a:solidFill>
+                      <a:srgbClr val="16213E"/>
+                    </a:solidFill>
+                  </a:tcPr>
+                </a:tc>
+                <a:tc>
+                  <a:txBody>
+                    <a:bodyPr/>
+                    <a:lstStyle/>
+                    <a:p>
+                      <a:pPr algn="ctr" indent="0" marL="0">
+                        <a:buNone/>
+                      </a:pPr>
+                      <a:r>
+                        <a:rPr lang="en-US" sz="1000" dirty="0">
+                          <a:solidFill>
+                            <a:srgbClr val="E8E8E8"/>
+                          </a:solidFill>
+                          <a:latin typeface="Calibri" pitchFamily="34" charset="0"/>
+                          <a:ea typeface="Calibri" pitchFamily="34" charset="-122"/>
+                          <a:cs typeface="Calibri" pitchFamily="34" charset="-120"/>
+                        </a:rPr>
+                        <a:t>~2h 30m</a:t>
+                      </a:r>
+                      <a:endParaRPr lang="en-US" sz="1000" dirty="0">
+                        <a:latin typeface="Calibri" charset="0"/>
+                        <a:ea typeface="Calibri" charset="0"/>
+                        <a:cs typeface="Calibri" charset="0"/>
+                      </a:endParaRPr>
+                    </a:p>
+                  </a:txBody>
+                  <a:tcPr marL="91440" marR="91440" marT="45720" marB="45720">
+                    <a:lnL w="12700" cap="flat" cmpd="sng" algn="ctr">
+                      <a:solidFill>
+                        <a:srgbClr val="0F3460"/>
+                      </a:solidFill>
+                      <a:prstDash val="solid"/>
+                      <a:round/>
+                      <a:headEnd type="none" w="med" len="med"/>
+                      <a:tailEnd type="none" w="med" len="med"/>
+                    </a:lnL>
+                    <a:lnR w="12700" cap="flat" cmpd="sng" algn="ctr">
+                      <a:solidFill>
+                        <a:srgbClr val="0F3460"/>
+                      </a:solidFill>
+                      <a:prstDash val="solid"/>
+                      <a:round/>
+                      <a:headEnd type="none" w="med" len="med"/>
+                      <a:tailEnd type="none" w="med" len="med"/>
+                    </a:lnR>
+                    <a:lnT w="12700" cap="flat" cmpd="sng" algn="ctr">
+                      <a:solidFill>
+                        <a:srgbClr val="0F3460"/>
+                      </a:solidFill>
+                      <a:prstDash val="solid"/>
+                      <a:round/>
+                      <a:headEnd type="none" w="med" len="med"/>
+                      <a:tailEnd type="none" w="med" len="med"/>
+                    </a:lnT>
+                    <a:lnB w="12700" cap="flat" cmpd="sng" algn="ctr">
+                      <a:solidFill>
+                        <a:srgbClr val="0F3460"/>
+                      </a:solidFill>
+                      <a:prstDash val="solid"/>
+                      <a:round/>
+                      <a:headEnd type="none" w="med" len="med"/>
+                      <a:tailEnd type="none" w="med" len="med"/>
+                    </a:lnB>
+                    <a:solidFill>
+                      <a:srgbClr val="16213E"/>
+                    </a:solidFill>
+                  </a:tcPr>
+                </a:tc>
+                <a:tc>
+                  <a:txBody>
+                    <a:bodyPr/>
+                    <a:lstStyle/>
+                    <a:p>
+                      <a:pPr algn="ctr" indent="0" marL="0">
+                        <a:buNone/>
+                      </a:pPr>
+                      <a:r>
+                        <a:rPr lang="en-US" sz="1000" dirty="0">
+                          <a:solidFill>
+                            <a:srgbClr val="E8E8E8"/>
+                          </a:solidFill>
+                          <a:latin typeface="Calibri" pitchFamily="34" charset="0"/>
+                          <a:ea typeface="Calibri" pitchFamily="34" charset="-122"/>
+                          <a:cs typeface="Calibri" pitchFamily="34" charset="-120"/>
+                        </a:rPr>
+                        <a:t>~€90–130</a:t>
+                      </a:r>
+                      <a:endParaRPr lang="en-US" sz="1000" dirty="0">
+                        <a:latin typeface="Calibri" charset="0"/>
+                        <a:ea typeface="Calibri" charset="0"/>
+                        <a:cs typeface="Calibri" charset="0"/>
+                      </a:endParaRPr>
+                    </a:p>
+                  </a:txBody>
+                  <a:tcPr marL="91440" marR="91440" marT="45720" marB="45720">
+                    <a:lnL w="12700" cap="flat" cmpd="sng" algn="ctr">
+                      <a:solidFill>
+                        <a:srgbClr val="0F3460"/>
+                      </a:solidFill>
+                      <a:prstDash val="solid"/>
+                      <a:round/>
+                      <a:headEnd type="none" w="med" len="med"/>
+                      <a:tailEnd type="none" w="med" len="med"/>
+                    </a:lnL>
+                    <a:lnR w="12700" cap="flat" cmpd="sng" algn="ctr">
+                      <a:solidFill>
+                        <a:srgbClr val="0F3460"/>
+                      </a:solidFill>
+                      <a:prstDash val="solid"/>
+                      <a:round/>
+                      <a:headEnd type="none" w="med" len="med"/>
+                      <a:tailEnd type="none" w="med" len="med"/>
+                    </a:lnR>
+                    <a:lnT w="12700" cap="flat" cmpd="sng" algn="ctr">
+                      <a:solidFill>
+                        <a:srgbClr val="0F3460"/>
+                      </a:solidFill>
+                      <a:prstDash val="solid"/>
+                      <a:round/>
+                      <a:headEnd type="none" w="med" len="med"/>
+                      <a:tailEnd type="none" w="med" len="med"/>
+                    </a:lnT>
+                    <a:lnB w="12700" cap="flat" cmpd="sng" algn="ctr">
+                      <a:solidFill>
+                        <a:srgbClr val="0F3460"/>
+                      </a:solidFill>
+                      <a:prstDash val="solid"/>
+                      <a:round/>
+                      <a:headEnd type="none" w="med" len="med"/>
+                      <a:tailEnd type="none" w="med" len="med"/>
+                    </a:lnB>
+                    <a:solidFill>
+                      <a:srgbClr val="16213E"/>
+                    </a:solidFill>
+                  </a:tcPr>
+                </a:tc>
+                <a:tc>
+                  <a:txBody>
+                    <a:bodyPr/>
+                    <a:lstStyle/>
+                    <a:p>
+                      <a:pPr algn="ctr" indent="0" marL="0">
+                        <a:buNone/>
+                      </a:pPr>
+                      <a:r>
+                        <a:rPr lang="en-US" sz="1000" dirty="0">
+                          <a:solidFill>
+                            <a:srgbClr val="FFC107"/>
+                          </a:solidFill>
+                          <a:latin typeface="Calibri" pitchFamily="34" charset="0"/>
+                          <a:ea typeface="Calibri" pitchFamily="34" charset="-122"/>
+                          <a:cs typeface="Calibri" pitchFamily="34" charset="-120"/>
+                        </a:rPr>
+                        <a:t>~€360–520</a:t>
+                      </a:r>
+                      <a:endParaRPr lang="en-US" sz="1000" dirty="0">
+                        <a:latin typeface="Calibri" charset="0"/>
+                        <a:ea typeface="Calibri" charset="0"/>
+                        <a:cs typeface="Calibri" charset="0"/>
+                      </a:endParaRPr>
+                    </a:p>
+                  </a:txBody>
+                  <a:tcPr marL="91440" marR="91440" marT="45720" marB="45720">
+                    <a:lnL w="12700" cap="flat" cmpd="sng" algn="ctr">
+                      <a:solidFill>
+                        <a:srgbClr val="0F3460"/>
+                      </a:solidFill>
+                      <a:prstDash val="solid"/>
+                      <a:round/>
+                      <a:headEnd type="none" w="med" len="med"/>
+                      <a:tailEnd type="none" w="med" len="med"/>
+                    </a:lnL>
+                    <a:lnR w="12700" cap="flat" cmpd="sng" algn="ctr">
+                      <a:solidFill>
+                        <a:srgbClr val="0F3460"/>
+                      </a:solidFill>
+                      <a:prstDash val="solid"/>
+                      <a:round/>
+                      <a:headEnd type="none" w="med" len="med"/>
+                      <a:tailEnd type="none" w="med" len="med"/>
+                    </a:lnR>
+                    <a:lnT w="12700" cap="flat" cmpd="sng" algn="ctr">
+                      <a:solidFill>
+                        <a:srgbClr val="0F3460"/>
+                      </a:solidFill>
+                      <a:prstDash val="solid"/>
+                      <a:round/>
+                      <a:headEnd type="none" w="med" len="med"/>
+                      <a:tailEnd type="none" w="med" len="med"/>
+                    </a:lnT>
+                    <a:lnB w="12700" cap="flat" cmpd="sng" algn="ctr">
+                      <a:solidFill>
+                        <a:srgbClr val="0F3460"/>
+                      </a:solidFill>
+                      <a:prstDash val="solid"/>
+                      <a:round/>
+                      <a:headEnd type="none" w="med" len="med"/>
+                      <a:tailEnd type="none" w="med" len="med"/>
+                    </a:lnB>
+                    <a:solidFill>
+                      <a:srgbClr val="16213E"/>
+                    </a:solidFill>
+                  </a:tcPr>
+                </a:tc>
+              </a:tr>
+              <a:tr h="475488">
+                <a:tc>
+                  <a:txBody>
+                    <a:bodyPr/>
+                    <a:lstStyle/>
+                    <a:p>
+                      <a:pPr algn="ctr" indent="0" marL="0">
+                        <a:buNone/>
+                      </a:pPr>
+                      <a:r>
+                        <a:rPr lang="en-US" sz="1000" dirty="0">
+                          <a:solidFill>
+                            <a:srgbClr val="E8E8E8"/>
+                          </a:solidFill>
+                          <a:latin typeface="Calibri" pitchFamily="34" charset="0"/>
+                          <a:ea typeface="Calibri" pitchFamily="34" charset="-122"/>
+                          <a:cs typeface="Calibri" pitchFamily="34" charset="-120"/>
+                        </a:rPr>
+                        <a:t>Budget+</a:t>
+                      </a:r>
+                      <a:endParaRPr lang="en-US" sz="1000" dirty="0">
+                        <a:latin typeface="Calibri" charset="0"/>
+                        <a:ea typeface="Calibri" charset="0"/>
+                        <a:cs typeface="Calibri" charset="0"/>
+                      </a:endParaRPr>
+                    </a:p>
+                  </a:txBody>
+                  <a:tcPr marL="91440" marR="91440" marT="45720" marB="45720">
+                    <a:lnL w="12700" cap="flat" cmpd="sng" algn="ctr">
+                      <a:solidFill>
+                        <a:srgbClr val="0F3460"/>
+                      </a:solidFill>
+                      <a:prstDash val="solid"/>
+                      <a:round/>
+                      <a:headEnd type="none" w="med" len="med"/>
+                      <a:tailEnd type="none" w="med" len="med"/>
+                    </a:lnL>
+                    <a:lnR w="12700" cap="flat" cmpd="sng" algn="ctr">
+                      <a:solidFill>
+                        <a:srgbClr val="0F3460"/>
+                      </a:solidFill>
+                      <a:prstDash val="solid"/>
+                      <a:round/>
+                      <a:headEnd type="none" w="med" len="med"/>
+                      <a:tailEnd type="none" w="med" len="med"/>
+                    </a:lnR>
+                    <a:lnT w="12700" cap="flat" cmpd="sng" algn="ctr">
+                      <a:solidFill>
+                        <a:srgbClr val="0F3460"/>
+                      </a:solidFill>
+                      <a:prstDash val="solid"/>
+                      <a:round/>
+                      <a:headEnd type="none" w="med" len="med"/>
+                      <a:tailEnd type="none" w="med" len="med"/>
+                    </a:lnT>
+                    <a:lnB w="12700" cap="flat" cmpd="sng" algn="ctr">
+                      <a:solidFill>
+                        <a:srgbClr val="0F3460"/>
+                      </a:solidFill>
+                      <a:prstDash val="solid"/>
+                      <a:round/>
+                      <a:headEnd type="none" w="med" len="med"/>
+                      <a:tailEnd type="none" w="med" len="med"/>
+                    </a:lnB>
+                    <a:solidFill>
+                      <a:srgbClr val="1A1A2E"/>
+                    </a:solidFill>
+                  </a:tcPr>
+                </a:tc>
+                <a:tc>
+                  <a:txBody>
+                    <a:bodyPr/>
+                    <a:lstStyle/>
+                    <a:p>
+                      <a:pPr algn="ctr" indent="0" marL="0">
+                        <a:buNone/>
+                      </a:pPr>
+                      <a:r>
+                        <a:rPr lang="en-US" sz="1000" dirty="0">
+                          <a:solidFill>
+                            <a:srgbClr val="E8E8E8"/>
+                          </a:solidFill>
+                          <a:latin typeface="Calibri" pitchFamily="34" charset="0"/>
+                          <a:ea typeface="Calibri" pitchFamily="34" charset="-122"/>
+                          <a:cs typeface="Calibri" pitchFamily="34" charset="-120"/>
+                        </a:rPr>
+                        <a:t>Wizz Air</a:t>
+                      </a:r>
+                      <a:endParaRPr lang="en-US" sz="1000" dirty="0">
+                        <a:latin typeface="Calibri" charset="0"/>
+                        <a:ea typeface="Calibri" charset="0"/>
+                        <a:cs typeface="Calibri" charset="0"/>
+                      </a:endParaRPr>
+                    </a:p>
+                    <a:p>
+                      <a:pPr algn="ctr" indent="0" marL="0">
+                        <a:buNone/>
+                      </a:pPr>
+                      <a:r>
+                        <a:rPr lang="en-US" sz="1000" dirty="0">
+                          <a:solidFill>
+                            <a:srgbClr val="E8E8E8"/>
+                          </a:solidFill>
+                          <a:latin typeface="Calibri" pitchFamily="34" charset="0"/>
+                          <a:ea typeface="Calibri" pitchFamily="34" charset="-122"/>
+                          <a:cs typeface="Calibri" pitchFamily="34" charset="-120"/>
+                        </a:rPr>
+                        <a:t>(W6)</a:t>
+                      </a:r>
+                      <a:endParaRPr lang="en-US" sz="1000" dirty="0">
+                        <a:latin typeface="Calibri" charset="0"/>
+                        <a:ea typeface="Calibri" charset="0"/>
+                        <a:cs typeface="Calibri" charset="0"/>
+                      </a:endParaRPr>
+                    </a:p>
+                  </a:txBody>
+                  <a:tcPr marL="91440" marR="91440" marT="45720" marB="45720">
+                    <a:lnL w="12700" cap="flat" cmpd="sng" algn="ctr">
+                      <a:solidFill>
+                        <a:srgbClr val="0F3460"/>
+                      </a:solidFill>
+                      <a:prstDash val="solid"/>
+                      <a:round/>
+                      <a:headEnd type="none" w="med" len="med"/>
+                      <a:tailEnd type="none" w="med" len="med"/>
+                    </a:lnL>
+                    <a:lnR w="12700" cap="flat" cmpd="sng" algn="ctr">
+                      <a:solidFill>
+                        <a:srgbClr val="0F3460"/>
+                      </a:solidFill>
+                      <a:prstDash val="solid"/>
+                      <a:round/>
+                      <a:headEnd type="none" w="med" len="med"/>
+                      <a:tailEnd type="none" w="med" len="med"/>
+                    </a:lnR>
+                    <a:lnT w="12700" cap="flat" cmpd="sng" algn="ctr">
+                      <a:solidFill>
+                        <a:srgbClr val="0F3460"/>
+                      </a:solidFill>
+                      <a:prstDash val="solid"/>
+                      <a:round/>
+                      <a:headEnd type="none" w="med" len="med"/>
+                      <a:tailEnd type="none" w="med" len="med"/>
+                    </a:lnT>
+                    <a:lnB w="12700" cap="flat" cmpd="sng" algn="ctr">
+                      <a:solidFill>
+                        <a:srgbClr val="0F3460"/>
+                      </a:solidFill>
+                      <a:prstDash val="solid"/>
+                      <a:round/>
+                      <a:headEnd type="none" w="med" len="med"/>
+                      <a:tailEnd type="none" w="med" len="med"/>
+                    </a:lnB>
+                    <a:solidFill>
+                      <a:srgbClr val="1A1A2E"/>
+                    </a:solidFill>
+                  </a:tcPr>
+                </a:tc>
+                <a:tc>
+                  <a:txBody>
+                    <a:bodyPr/>
+                    <a:lstStyle/>
+                    <a:p>
+                      <a:pPr algn="ctr" indent="0" marL="0">
+                        <a:buNone/>
+                      </a:pPr>
+                      <a:r>
+                        <a:rPr lang="en-US" sz="1000" dirty="0">
+                          <a:solidFill>
+                            <a:srgbClr val="E8E8E8"/>
+                          </a:solidFill>
+                          <a:latin typeface="Calibri" pitchFamily="34" charset="0"/>
+                          <a:ea typeface="Calibri" pitchFamily="34" charset="-122"/>
+                          <a:cs typeface="Calibri" pitchFamily="34" charset="-120"/>
+                        </a:rPr>
+                        <a:t>DUS → SOF</a:t>
+                      </a:r>
+                      <a:endParaRPr lang="en-US" sz="1000" dirty="0">
+                        <a:latin typeface="Calibri" charset="0"/>
+                        <a:ea typeface="Calibri" charset="0"/>
+                        <a:cs typeface="Calibri" charset="0"/>
+                      </a:endParaRPr>
+                    </a:p>
+                    <a:p>
+                      <a:pPr algn="ctr" indent="0" marL="0">
+                        <a:buNone/>
+                      </a:pPr>
+                      <a:r>
+                        <a:rPr lang="en-US" sz="1000" dirty="0">
+                          <a:solidFill>
+                            <a:srgbClr val="E8E8E8"/>
+                          </a:solidFill>
+                          <a:latin typeface="Calibri" pitchFamily="34" charset="0"/>
+                          <a:ea typeface="Calibri" pitchFamily="34" charset="-122"/>
+                          <a:cs typeface="Calibri" pitchFamily="34" charset="-120"/>
+                        </a:rPr>
+                        <a:t>30. Okt.</a:t>
+                      </a:r>
+                      <a:endParaRPr lang="en-US" sz="1000" dirty="0">
+                        <a:latin typeface="Calibri" charset="0"/>
+                        <a:ea typeface="Calibri" charset="0"/>
+                        <a:cs typeface="Calibri" charset="0"/>
+                      </a:endParaRPr>
+                    </a:p>
+                  </a:txBody>
+                  <a:tcPr marL="91440" marR="91440" marT="45720" marB="45720">
+                    <a:lnL w="12700" cap="flat" cmpd="sng" algn="ctr">
+                      <a:solidFill>
+                        <a:srgbClr val="0F3460"/>
+                      </a:solidFill>
+                      <a:prstDash val="solid"/>
+                      <a:round/>
+                      <a:headEnd type="none" w="med" len="med"/>
+                      <a:tailEnd type="none" w="med" len="med"/>
+                    </a:lnL>
+                    <a:lnR w="12700" cap="flat" cmpd="sng" algn="ctr">
+                      <a:solidFill>
+                        <a:srgbClr val="0F3460"/>
+                      </a:solidFill>
+                      <a:prstDash val="solid"/>
+                      <a:round/>
+                      <a:headEnd type="none" w="med" len="med"/>
+                      <a:tailEnd type="none" w="med" len="med"/>
+                    </a:lnR>
+                    <a:lnT w="12700" cap="flat" cmpd="sng" algn="ctr">
+                      <a:solidFill>
+                        <a:srgbClr val="0F3460"/>
+                      </a:solidFill>
+                      <a:prstDash val="solid"/>
+                      <a:round/>
+                      <a:headEnd type="none" w="med" len="med"/>
+                      <a:tailEnd type="none" w="med" len="med"/>
+                    </a:lnT>
+                    <a:lnB w="12700" cap="flat" cmpd="sng" algn="ctr">
+                      <a:solidFill>
+                        <a:srgbClr val="0F3460"/>
+                      </a:solidFill>
+                      <a:prstDash val="solid"/>
+                      <a:round/>
+                      <a:headEnd type="none" w="med" len="med"/>
+                      <a:tailEnd type="none" w="med" len="med"/>
+                    </a:lnB>
+                    <a:solidFill>
+                      <a:srgbClr val="1A1A2E"/>
+                    </a:solidFill>
+                  </a:tcPr>
+                </a:tc>
+                <a:tc>
+                  <a:txBody>
+                    <a:bodyPr/>
+                    <a:lstStyle/>
+                    <a:p>
+                      <a:pPr algn="ctr" indent="0" marL="0">
+                        <a:buNone/>
+                      </a:pPr>
+                      <a:r>
+                        <a:rPr lang="en-US" sz="1000" dirty="0">
+                          <a:solidFill>
+                            <a:srgbClr val="E8E8E8"/>
+                          </a:solidFill>
+                          <a:latin typeface="Calibri" pitchFamily="34" charset="0"/>
+                          <a:ea typeface="Calibri" pitchFamily="34" charset="-122"/>
+                          <a:cs typeface="Calibri" pitchFamily="34" charset="-120"/>
+                        </a:rPr>
+                        <a:t>Verschieden</a:t>
+                      </a:r>
+                      <a:endParaRPr lang="en-US" sz="1000" dirty="0">
+                        <a:latin typeface="Calibri" charset="0"/>
+                        <a:ea typeface="Calibri" charset="0"/>
+                        <a:cs typeface="Calibri" charset="0"/>
+                      </a:endParaRPr>
+                    </a:p>
+                  </a:txBody>
+                  <a:tcPr marL="91440" marR="91440" marT="45720" marB="45720">
+                    <a:lnL w="12700" cap="flat" cmpd="sng" algn="ctr">
+                      <a:solidFill>
+                        <a:srgbClr val="0F3460"/>
+                      </a:solidFill>
+                      <a:prstDash val="solid"/>
+                      <a:round/>
+                      <a:headEnd type="none" w="med" len="med"/>
+                      <a:tailEnd type="none" w="med" len="med"/>
+                    </a:lnL>
+                    <a:lnR w="12700" cap="flat" cmpd="sng" algn="ctr">
+                      <a:solidFill>
+                        <a:srgbClr val="0F3460"/>
+                      </a:solidFill>
+                      <a:prstDash val="solid"/>
+                      <a:round/>
+                      <a:headEnd type="none" w="med" len="med"/>
+                      <a:tailEnd type="none" w="med" len="med"/>
+                    </a:lnR>
+                    <a:lnT w="12700" cap="flat" cmpd="sng" algn="ctr">
+                      <a:solidFill>
+                        <a:srgbClr val="0F3460"/>
+                      </a:solidFill>
+                      <a:prstDash val="solid"/>
+                      <a:round/>
+                      <a:headEnd type="none" w="med" len="med"/>
+                      <a:tailEnd type="none" w="med" len="med"/>
+                    </a:lnT>
+                    <a:lnB w="12700" cap="flat" cmpd="sng" algn="ctr">
+                      <a:solidFill>
+                        <a:srgbClr val="0F3460"/>
+                      </a:solidFill>
+                      <a:prstDash val="solid"/>
+                      <a:round/>
+                      <a:headEnd type="none" w="med" len="med"/>
+                      <a:tailEnd type="none" w="med" len="med"/>
+                    </a:lnB>
+                    <a:solidFill>
+                      <a:srgbClr val="1A1A2E"/>
+                    </a:solidFill>
+                  </a:tcPr>
+                </a:tc>
+                <a:tc>
+                  <a:txBody>
+                    <a:bodyPr/>
+                    <a:lstStyle/>
+                    <a:p>
+                      <a:pPr algn="ctr" indent="0" marL="0">
+                        <a:buNone/>
+                      </a:pPr>
+                      <a:r>
+                        <a:rPr lang="en-US" sz="1000" dirty="0">
+                          <a:solidFill>
+                            <a:srgbClr val="E8E8E8"/>
+                          </a:solidFill>
+                          <a:latin typeface="Calibri" pitchFamily="34" charset="0"/>
+                          <a:ea typeface="Calibri" pitchFamily="34" charset="-122"/>
+                          <a:cs typeface="Calibri" pitchFamily="34" charset="-120"/>
+                        </a:rPr>
+                        <a:t>Verschieden</a:t>
+                      </a:r>
+                      <a:endParaRPr lang="en-US" sz="1000" dirty="0">
+                        <a:latin typeface="Calibri" charset="0"/>
+                        <a:ea typeface="Calibri" charset="0"/>
+                        <a:cs typeface="Calibri" charset="0"/>
+                      </a:endParaRPr>
+                    </a:p>
+                  </a:txBody>
+                  <a:tcPr marL="91440" marR="91440" marT="45720" marB="45720">
+                    <a:lnL w="12700" cap="flat" cmpd="sng" algn="ctr">
+                      <a:solidFill>
+                        <a:srgbClr val="0F3460"/>
+                      </a:solidFill>
+                      <a:prstDash val="solid"/>
+                      <a:round/>
+                      <a:headEnd type="none" w="med" len="med"/>
+                      <a:tailEnd type="none" w="med" len="med"/>
+                    </a:lnL>
+                    <a:lnR w="12700" cap="flat" cmpd="sng" algn="ctr">
+                      <a:solidFill>
+                        <a:srgbClr val="0F3460"/>
+                      </a:solidFill>
+                      <a:prstDash val="solid"/>
+                      <a:round/>
+                      <a:headEnd type="none" w="med" len="med"/>
+                      <a:tailEnd type="none" w="med" len="med"/>
+                    </a:lnR>
+                    <a:lnT w="12700" cap="flat" cmpd="sng" algn="ctr">
+                      <a:solidFill>
+                        <a:srgbClr val="0F3460"/>
+                      </a:solidFill>
+                      <a:prstDash val="solid"/>
+                      <a:round/>
+                      <a:headEnd type="none" w="med" len="med"/>
+                      <a:tailEnd type="none" w="med" len="med"/>
+                    </a:lnT>
+                    <a:lnB w="12700" cap="flat" cmpd="sng" algn="ctr">
+                      <a:solidFill>
+                        <a:srgbClr val="0F3460"/>
+                      </a:solidFill>
+                      <a:prstDash val="solid"/>
+                      <a:round/>
+                      <a:headEnd type="none" w="med" len="med"/>
+                      <a:tailEnd type="none" w="med" len="med"/>
+                    </a:lnB>
+                    <a:solidFill>
+                      <a:srgbClr val="1A1A2E"/>
+                    </a:solidFill>
+                  </a:tcPr>
+                </a:tc>
+                <a:tc>
+                  <a:txBody>
+                    <a:bodyPr/>
+                    <a:lstStyle/>
+                    <a:p>
+                      <a:pPr algn="ctr" indent="0" marL="0">
+                        <a:buNone/>
+                      </a:pPr>
+                      <a:r>
+                        <a:rPr lang="en-US" sz="1000" dirty="0">
+                          <a:solidFill>
+                            <a:srgbClr val="E8E8E8"/>
+                          </a:solidFill>
+                          <a:latin typeface="Calibri" pitchFamily="34" charset="0"/>
+                          <a:ea typeface="Calibri" pitchFamily="34" charset="-122"/>
+                          <a:cs typeface="Calibri" pitchFamily="34" charset="-120"/>
+                        </a:rPr>
+                        <a:t>~2h 30m</a:t>
+                      </a:r>
+                      <a:endParaRPr lang="en-US" sz="1000" dirty="0">
+                        <a:latin typeface="Calibri" charset="0"/>
+                        <a:ea typeface="Calibri" charset="0"/>
+                        <a:cs typeface="Calibri" charset="0"/>
+                      </a:endParaRPr>
+                    </a:p>
+                  </a:txBody>
+                  <a:tcPr marL="91440" marR="91440" marT="45720" marB="45720">
+                    <a:lnL w="12700" cap="flat" cmpd="sng" algn="ctr">
+                      <a:solidFill>
+                        <a:srgbClr val="0F3460"/>
+                      </a:solidFill>
+                      <a:prstDash val="solid"/>
+                      <a:round/>
+                      <a:headEnd type="none" w="med" len="med"/>
+                      <a:tailEnd type="none" w="med" len="med"/>
+                    </a:lnL>
+                    <a:lnR w="12700" cap="flat" cmpd="sng" algn="ctr">
+                      <a:solidFill>
+                        <a:srgbClr val="0F3460"/>
+                      </a:solidFill>
+                      <a:prstDash val="solid"/>
+                      <a:round/>
+                      <a:headEnd type="none" w="med" len="med"/>
+                      <a:tailEnd type="none" w="med" len="med"/>
+                    </a:lnR>
+                    <a:lnT w="12700" cap="flat" cmpd="sng" algn="ctr">
+                      <a:solidFill>
+                        <a:srgbClr val="0F3460"/>
+                      </a:solidFill>
+                      <a:prstDash val="solid"/>
+                      <a:round/>
+                      <a:headEnd type="none" w="med" len="med"/>
+                      <a:tailEnd type="none" w="med" len="med"/>
+                    </a:lnT>
+                    <a:lnB w="12700" cap="flat" cmpd="sng" algn="ctr">
+                      <a:solidFill>
+                        <a:srgbClr val="0F3460"/>
+                      </a:solidFill>
+                      <a:prstDash val="solid"/>
+                      <a:round/>
+                      <a:headEnd type="none" w="med" len="med"/>
+                      <a:tailEnd type="none" w="med" len="med"/>
+                    </a:lnB>
+                    <a:solidFill>
+                      <a:srgbClr val="1A1A2E"/>
+                    </a:solidFill>
+                  </a:tcPr>
+                </a:tc>
+                <a:tc>
+                  <a:txBody>
+                    <a:bodyPr/>
+                    <a:lstStyle/>
+                    <a:p>
+                      <a:pPr algn="ctr" indent="0" marL="0">
+                        <a:buNone/>
+                      </a:pPr>
+                      <a:r>
+                        <a:rPr lang="en-US" sz="1000" dirty="0">
+                          <a:solidFill>
+                            <a:srgbClr val="E8E8E8"/>
+                          </a:solidFill>
+                          <a:latin typeface="Calibri" pitchFamily="34" charset="0"/>
+                          <a:ea typeface="Calibri" pitchFamily="34" charset="-122"/>
+                          <a:cs typeface="Calibri" pitchFamily="34" charset="-120"/>
+                        </a:rPr>
+                        <a:t>~€40–80</a:t>
+                      </a:r>
+                      <a:endParaRPr lang="en-US" sz="1000" dirty="0">
+                        <a:latin typeface="Calibri" charset="0"/>
+                        <a:ea typeface="Calibri" charset="0"/>
+                        <a:cs typeface="Calibri" charset="0"/>
+                      </a:endParaRPr>
+                    </a:p>
+                  </a:txBody>
+                  <a:tcPr marL="91440" marR="91440" marT="45720" marB="45720">
+                    <a:lnL w="12700" cap="flat" cmpd="sng" algn="ctr">
+                      <a:solidFill>
+                        <a:srgbClr val="0F3460"/>
+                      </a:solidFill>
+                      <a:prstDash val="solid"/>
+                      <a:round/>
+                      <a:headEnd type="none" w="med" len="med"/>
+                      <a:tailEnd type="none" w="med" len="med"/>
+                    </a:lnL>
+                    <a:lnR w="12700" cap="flat" cmpd="sng" algn="ctr">
+                      <a:solidFill>
+                        <a:srgbClr val="0F3460"/>
+                      </a:solidFill>
+                      <a:prstDash val="solid"/>
+                      <a:round/>
+                      <a:headEnd type="none" w="med" len="med"/>
+                      <a:tailEnd type="none" w="med" len="med"/>
+                    </a:lnR>
+                    <a:lnT w="12700" cap="flat" cmpd="sng" algn="ctr">
+                      <a:solidFill>
+                        <a:srgbClr val="0F3460"/>
+                      </a:solidFill>
+                      <a:prstDash val="solid"/>
+                      <a:round/>
+                      <a:headEnd type="none" w="med" len="med"/>
+                      <a:tailEnd type="none" w="med" len="med"/>
+                    </a:lnT>
+                    <a:lnB w="12700" cap="flat" cmpd="sng" algn="ctr">
+                      <a:solidFill>
+                        <a:srgbClr val="0F3460"/>
+                      </a:solidFill>
+                      <a:prstDash val="solid"/>
+                      <a:round/>
+                      <a:headEnd type="none" w="med" len="med"/>
+                      <a:tailEnd type="none" w="med" len="med"/>
+                    </a:lnB>
+                    <a:solidFill>
+                      <a:srgbClr val="1A1A2E"/>
+                    </a:solidFill>
+                  </a:tcPr>
+                </a:tc>
+                <a:tc>
+                  <a:txBody>
+                    <a:bodyPr/>
+                    <a:lstStyle/>
+                    <a:p>
+                      <a:pPr algn="ctr" indent="0" marL="0">
+                        <a:buNone/>
+                      </a:pPr>
+                      <a:r>
+                        <a:rPr lang="en-US" sz="1000" dirty="0">
+                          <a:solidFill>
+                            <a:srgbClr val="FFC107"/>
+                          </a:solidFill>
+                          <a:latin typeface="Calibri" pitchFamily="34" charset="0"/>
+                          <a:ea typeface="Calibri" pitchFamily="34" charset="-122"/>
+                          <a:cs typeface="Calibri" pitchFamily="34" charset="-120"/>
+                        </a:rPr>
+                        <a:t>~€160–320</a:t>
                       </a:r>
                       <a:endParaRPr lang="en-US" sz="1000" dirty="0">
                         <a:latin typeface="Calibri" charset="0"/>
@@ -27020,13 +26942,13 @@
             <a:r>
               <a:rPr lang="en-US" sz="1300" b="1" dirty="0">
                 <a:solidFill>
-                  <a:srgbClr val="C8003C"/>
+                  <a:srgbClr val="8C52E8"/>
                 </a:solidFill>
                 <a:latin typeface="Trebuchet MS" pitchFamily="34" charset="0"/>
                 <a:ea typeface="Trebuchet MS" pitchFamily="34" charset="-122"/>
                 <a:cs typeface="Trebuchet MS" pitchFamily="34" charset="-120"/>
               </a:rPr>
-              <a:t>RÜCKFLUG: MXP (Mailand-Malpensa) → Deutschland (2. Nov.)</a:t>
+              <a:t>RÜCKFLUG: SOF (Sofia) → Deutschland (2. Nov.)</a:t>
             </a:r>
             <a:endParaRPr lang="en-US" sz="1300" dirty="0"/>
           </a:p>
@@ -27075,7 +26997,7 @@
                       <a:r>
                         <a:rPr lang="en-US" sz="1100" b="1" dirty="0">
                           <a:solidFill>
-                            <a:srgbClr val="C8003C"/>
+                            <a:srgbClr val="8C52E8"/>
                           </a:solidFill>
                           <a:latin typeface="Trebuchet MS" pitchFamily="34" charset="0"/>
                           <a:ea typeface="Trebuchet MS" pitchFamily="34" charset="-122"/>
@@ -27143,7 +27065,7 @@
                       <a:r>
                         <a:rPr lang="en-US" sz="1100" b="1" dirty="0">
                           <a:solidFill>
-                            <a:srgbClr val="C8003C"/>
+                            <a:srgbClr val="8C52E8"/>
                           </a:solidFill>
                           <a:latin typeface="Trebuchet MS" pitchFamily="34" charset="0"/>
                           <a:ea typeface="Trebuchet MS" pitchFamily="34" charset="-122"/>
@@ -27211,7 +27133,7 @@
                       <a:r>
                         <a:rPr lang="en-US" sz="1100" b="1" dirty="0">
                           <a:solidFill>
-                            <a:srgbClr val="C8003C"/>
+                            <a:srgbClr val="8C52E8"/>
                           </a:solidFill>
                           <a:latin typeface="Trebuchet MS" pitchFamily="34" charset="0"/>
                           <a:ea typeface="Trebuchet MS" pitchFamily="34" charset="-122"/>
@@ -27279,7 +27201,7 @@
                       <a:r>
                         <a:rPr lang="en-US" sz="1100" b="1" dirty="0">
                           <a:solidFill>
-                            <a:srgbClr val="C8003C"/>
+                            <a:srgbClr val="8C52E8"/>
                           </a:solidFill>
                           <a:latin typeface="Trebuchet MS" pitchFamily="34" charset="0"/>
                           <a:ea typeface="Trebuchet MS" pitchFamily="34" charset="-122"/>
@@ -27347,7 +27269,7 @@
                       <a:r>
                         <a:rPr lang="en-US" sz="1100" b="1" dirty="0">
                           <a:solidFill>
-                            <a:srgbClr val="C8003C"/>
+                            <a:srgbClr val="8C52E8"/>
                           </a:solidFill>
                           <a:latin typeface="Trebuchet MS" pitchFamily="34" charset="0"/>
                           <a:ea typeface="Trebuchet MS" pitchFamily="34" charset="-122"/>
@@ -27415,7 +27337,7 @@
                       <a:r>
                         <a:rPr lang="en-US" sz="1100" b="1" dirty="0">
                           <a:solidFill>
-                            <a:srgbClr val="C8003C"/>
+                            <a:srgbClr val="8C52E8"/>
                           </a:solidFill>
                           <a:latin typeface="Trebuchet MS" pitchFamily="34" charset="0"/>
                           <a:ea typeface="Trebuchet MS" pitchFamily="34" charset="-122"/>
@@ -27483,7 +27405,7 @@
                       <a:r>
                         <a:rPr lang="en-US" sz="1100" b="1" dirty="0">
                           <a:solidFill>
-                            <a:srgbClr val="C8003C"/>
+                            <a:srgbClr val="8C52E8"/>
                           </a:solidFill>
                           <a:latin typeface="Trebuchet MS" pitchFamily="34" charset="0"/>
                           <a:ea typeface="Trebuchet MS" pitchFamily="34" charset="-122"/>
@@ -27559,7 +27481,7 @@
                           <a:ea typeface="Calibri" pitchFamily="34" charset="-122"/>
                           <a:cs typeface="Calibri" pitchFamily="34" charset="-120"/>
                         </a:rPr>
-                        <a:t>Eurowings / Ryanair  (MXP/BGY→DUS)</a:t>
+                        <a:t>Bulgaria Air / Ryanair  (SOF→DUS)</a:t>
                       </a:r>
                       <a:endParaRPr lang="en-US" sz="1000" dirty="0">
                         <a:latin typeface="Calibri" charset="0"/>
@@ -27627,7 +27549,7 @@
                           <a:ea typeface="Calibri" pitchFamily="34" charset="-122"/>
                           <a:cs typeface="Calibri" pitchFamily="34" charset="-120"/>
                         </a:rPr>
-                        <a:t>MXP → DUS  /  2. Nov.</a:t>
+                        <a:t>SOF → DUS  /  2. Nov.</a:t>
                       </a:r>
                       <a:endParaRPr lang="en-US" sz="1000" dirty="0">
                         <a:latin typeface="Calibri" charset="0"/>
@@ -27831,7 +27753,7 @@
                           <a:ea typeface="Calibri" pitchFamily="34" charset="-122"/>
                           <a:cs typeface="Calibri" pitchFamily="34" charset="-120"/>
                         </a:rPr>
-                        <a:t>1h 40m</a:t>
+                        <a:t>~2h 30m</a:t>
                       </a:r>
                       <a:endParaRPr lang="en-US" sz="1000" dirty="0">
                         <a:latin typeface="Calibri" charset="0"/>
@@ -27899,7 +27821,7 @@
                           <a:ea typeface="Calibri" pitchFamily="34" charset="-122"/>
                           <a:cs typeface="Calibri" pitchFamily="34" charset="-120"/>
                         </a:rPr>
-                        <a:t>~€70–100</a:t>
+                        <a:t>~€60–100</a:t>
                       </a:r>
                       <a:endParaRPr lang="en-US" sz="1000" dirty="0">
                         <a:latin typeface="Calibri" charset="0"/>
@@ -27967,7 +27889,7 @@
                           <a:ea typeface="Calibri" pitchFamily="34" charset="-122"/>
                           <a:cs typeface="Calibri" pitchFamily="34" charset="-120"/>
                         </a:rPr>
-                        <a:t>~€280–400</a:t>
+                        <a:t>~€240–400</a:t>
                       </a:r>
                       <a:endParaRPr lang="en-US" sz="1000" dirty="0">
                         <a:latin typeface="Calibri" charset="0"/>
@@ -28081,7 +28003,7 @@
                 <a:ea typeface="Calibri" pitchFamily="34" charset="-122"/>
                 <a:cs typeface="Calibri" pitchFamily="34" charset="-120"/>
               </a:rPr>
-              <a:t>✅  DUS (Düsseldorf) → MXP (Mailand-Malpensa): Direktflug mit Eurowings täglich, ~1h 40m.  Malpensa liegt 45 km nordwestlich vom Zentrum — Malpensa Express Zug ~52 Min., €13 ins Stadtzentrum.  Budget-Option: DUS → BGY (Bergamo/Orio al Serio) mit Ryanair — Bus nach Mailand ~1h, €5–6.  Buchen: eurowings.com · ryanair.com</a:t>
+              <a:t>✅  DUS (Düsseldorf) → SOF (Sofia): Direktflüge mit Bulgaria Air und Ryanair.  Flughafen Sofia liegt 10 km östlich vom Zentrum — Metro Linie M1 (€0,80, 20 Min.) direkt ins Zentrum.  Buchen: bulgariaair.com · ryanair.com · wizzair.com · skyscanner.de</a:t>
             </a:r>
             <a:endParaRPr lang="en-US" sz="1000" dirty="0"/>
           </a:p>
@@ -28106,7 +28028,7 @@
           </a:solidFill>
           <a:ln w="12700">
             <a:solidFill>
-              <a:srgbClr val="C8003C"/>
+              <a:srgbClr val="8C52E8"/>
             </a:solidFill>
             <a:prstDash val="solid"/>
           </a:ln>
@@ -28178,13 +28100,13 @@
             <a:r>
               <a:rPr lang="en-US" sz="2000" b="1" dirty="0">
                 <a:solidFill>
-                  <a:srgbClr val="C8003C"/>
+                  <a:srgbClr val="8C52E8"/>
                 </a:solidFill>
                 <a:latin typeface="Trebuchet MS" pitchFamily="34" charset="0"/>
                 <a:ea typeface="Trebuchet MS" pitchFamily="34" charset="-122"/>
                 <a:cs typeface="Trebuchet MS" pitchFamily="34" charset="-120"/>
               </a:rPr>
-              <a:t>€480 – €640 gesamt</a:t>
+              <a:t>€320 – €560 gesamt</a:t>
             </a:r>
             <a:endParaRPr lang="en-US" sz="2000" dirty="0"/>
           </a:p>
@@ -28262,11 +28184,11 @@
             <a:avLst/>
           </a:prstGeom>
           <a:solidFill>
-            <a:srgbClr val="C8003C"/>
+            <a:srgbClr val="8C52E8"/>
           </a:solidFill>
           <a:ln w="12700">
             <a:solidFill>
-              <a:srgbClr val="C8003C"/>
+              <a:srgbClr val="8C52E8"/>
             </a:solidFill>
             <a:prstDash val="solid"/>
           </a:ln>
@@ -28330,7 +28252,7 @@
                 <a:ea typeface="Trebuchet MS" pitchFamily="34" charset="-122"/>
                 <a:cs typeface="Trebuchet MS" pitchFamily="34" charset="-120"/>
               </a:rPr>
-              <a:t>🇮🇹  MAILAND — UNTERKUNFT</a:t>
+              <a:t>🇧🇬  SOFIA — UNTERKUNFT</a:t>
             </a:r>
             <a:endParaRPr lang="en-US" sz="2200" dirty="0"/>
           </a:p>
@@ -28351,11 +28273,11 @@
             <a:avLst/>
           </a:prstGeom>
           <a:solidFill>
-            <a:srgbClr val="C8003C"/>
+            <a:srgbClr val="8C52E8"/>
           </a:solidFill>
           <a:ln w="12700">
             <a:solidFill>
-              <a:srgbClr val="C8003C"/>
+              <a:srgbClr val="8C52E8"/>
             </a:solidFill>
             <a:prstDash val="solid"/>
           </a:ln>
@@ -28363,7 +28285,7 @@
       </p:sp>
       <p:pic>
         <p:nvPicPr>
-          <p:cNvPr id="6" name="Image 0" descr="/home/user/Excelhaus/halloween_trip/milan_airbnb.png">    </p:cNvPr>
+          <p:cNvPr id="6" name="Image 0" descr="/home/user/Excelhaus/halloween_trip/sofia_airbnb.png">    </p:cNvPr>
           <p:cNvPicPr>
             <a:picLocks noChangeAspect="1"/>
           </p:cNvPicPr>
@@ -28387,7 +28309,7 @@
       </p:pic>
       <p:pic>
         <p:nvPicPr>
-          <p:cNvPr id="7" name="Image 1" descr="/home/user/Excelhaus/halloween_trip/milan_map.png">    </p:cNvPr>
+          <p:cNvPr id="7" name="Image 1" descr="/home/user/Excelhaus/halloween_trip/sofia_map.png">    </p:cNvPr>
           <p:cNvPicPr>
             <a:picLocks noChangeAspect="1"/>
           </p:cNvPicPr>
@@ -28428,7 +28350,7 @@
           </a:solidFill>
           <a:ln w="12700">
             <a:solidFill>
-              <a:srgbClr val="C8003C"/>
+              <a:srgbClr val="8C52E8"/>
             </a:solidFill>
             <a:prstDash val="solid"/>
           </a:ln>
@@ -28467,7 +28389,7 @@
                 <a:ea typeface="Trebuchet MS" pitchFamily="34" charset="-122"/>
                 <a:cs typeface="Trebuchet MS" pitchFamily="34" charset="-120"/>
               </a:rPr>
-              <a:t>Navigli / Porta Ticinese — 2-Zi.-Wohnung am Kanal</a:t>
+              <a:t>Vitosha Blvd / Zentrum — 2-Zi.-Wohnung</a:t>
             </a:r>
             <a:endParaRPr lang="en-US" sz="1400" dirty="0"/>
           </a:p>
@@ -28492,7 +28414,7 @@
           </a:solidFill>
           <a:ln w="12700">
             <a:solidFill>
-              <a:srgbClr val="C8003C"/>
+              <a:srgbClr val="8C52E8"/>
             </a:solidFill>
             <a:prstDash val="solid"/>
           </a:ln>
@@ -28525,7 +28447,7 @@
             <a:r>
               <a:rPr lang="en-US" sz="1100" b="1" dirty="0">
                 <a:solidFill>
-                  <a:srgbClr val="C8003C"/>
+                  <a:srgbClr val="8C52E8"/>
                 </a:solidFill>
                 <a:latin typeface="Calibri" pitchFamily="34" charset="0"/>
                 <a:ea typeface="Calibri" pitchFamily="34" charset="-122"/>
@@ -28556,7 +28478,7 @@
           </a:solidFill>
           <a:ln w="12700">
             <a:solidFill>
-              <a:srgbClr val="C8003C"/>
+              <a:srgbClr val="8C52E8"/>
             </a:solidFill>
             <a:prstDash val="solid"/>
           </a:ln>
@@ -28589,7 +28511,7 @@
             <a:r>
               <a:rPr lang="en-US" sz="1100" b="1" dirty="0">
                 <a:solidFill>
-                  <a:srgbClr val="C8003C"/>
+                  <a:srgbClr val="8C52E8"/>
                 </a:solidFill>
                 <a:latin typeface="Calibri" pitchFamily="34" charset="0"/>
                 <a:ea typeface="Calibri" pitchFamily="34" charset="-122"/>
@@ -28659,7 +28581,7 @@
                 <a:ea typeface="Calibri" pitchFamily="34" charset="-122"/>
                 <a:cs typeface="Calibri" pitchFamily="34" charset="-120"/>
               </a:rPr>
-              <a:t>🏗 Balkon/Terrasse</a:t>
+              <a:t>🏗 Balkon ✓</a:t>
             </a:r>
             <a:endParaRPr lang="en-US" sz="1100" dirty="0"/>
           </a:p>
@@ -28684,7 +28606,7 @@
           </a:solidFill>
           <a:ln w="12700">
             <a:solidFill>
-              <a:srgbClr val="C8003C"/>
+              <a:srgbClr val="8C52E8"/>
             </a:solidFill>
             <a:prstDash val="solid"/>
           </a:ln>
@@ -28717,7 +28639,7 @@
             <a:r>
               <a:rPr lang="en-US" sz="1100" b="1" dirty="0">
                 <a:solidFill>
-                  <a:srgbClr val="C8003C"/>
+                  <a:srgbClr val="8C52E8"/>
                 </a:solidFill>
                 <a:latin typeface="Calibri" pitchFamily="34" charset="0"/>
                 <a:ea typeface="Calibri" pitchFamily="34" charset="-122"/>
@@ -28748,7 +28670,7 @@
           </a:solidFill>
           <a:ln w="12700">
             <a:solidFill>
-              <a:srgbClr val="C8003C"/>
+              <a:srgbClr val="8C52E8"/>
             </a:solidFill>
             <a:prstDash val="solid"/>
           </a:ln>
@@ -28781,7 +28703,7 @@
             <a:r>
               <a:rPr lang="en-US" sz="1100" b="1" dirty="0">
                 <a:solidFill>
-                  <a:srgbClr val="C8003C"/>
+                  <a:srgbClr val="8C52E8"/>
                 </a:solidFill>
                 <a:latin typeface="Calibri" pitchFamily="34" charset="0"/>
                 <a:ea typeface="Calibri" pitchFamily="34" charset="-122"/>
@@ -28812,7 +28734,7 @@
           </a:solidFill>
           <a:ln w="12700">
             <a:solidFill>
-              <a:srgbClr val="C8003C"/>
+              <a:srgbClr val="8C52E8"/>
             </a:solidFill>
             <a:prstDash val="solid"/>
           </a:ln>
@@ -28845,13 +28767,13 @@
             <a:r>
               <a:rPr lang="en-US" sz="1100" b="1" dirty="0">
                 <a:solidFill>
-                  <a:srgbClr val="C8003C"/>
+                  <a:srgbClr val="8C52E8"/>
                 </a:solidFill>
                 <a:latin typeface="Calibri" pitchFamily="34" charset="0"/>
                 <a:ea typeface="Calibri" pitchFamily="34" charset="-122"/>
                 <a:cs typeface="Calibri" pitchFamily="34" charset="-120"/>
               </a:rPr>
-              <a:t>🍹 Navigli Bars 1 Min</a:t>
+              <a:t>🏔 Vitosha-Blick</a:t>
             </a:r>
             <a:endParaRPr lang="en-US" sz="1100" dirty="0"/>
           </a:p>
@@ -28915,7 +28837,7 @@
                 <a:ea typeface="Calibri" pitchFamily="34" charset="-122"/>
                 <a:cs typeface="Calibri" pitchFamily="34" charset="-120"/>
               </a:rPr>
-              <a:t>📌 Navigli — direkt an der Aperitivo-Meile, 15 Min. per Metro/Tram zum Duomo &amp; Corso Como</a:t>
+              <a:t>📌 Vitosha Blvd / Stadtzentrum — direkt an der besten Bar-Meile, 10 Min. zu Fuß zur Kathedrale</a:t>
             </a:r>
             <a:endParaRPr lang="en-US" sz="1050" dirty="0"/>
           </a:p>
@@ -28940,7 +28862,7 @@
           </a:solidFill>
           <a:ln w="12700">
             <a:solidFill>
-              <a:srgbClr val="C8003C"/>
+              <a:srgbClr val="8C52E8"/>
             </a:solidFill>
             <a:prstDash val="solid"/>
           </a:ln>
@@ -28973,7 +28895,7 @@
             <a:r>
               <a:rPr lang="en-US" sz="1100" b="1" dirty="0">
                 <a:solidFill>
-                  <a:srgbClr val="C8003C"/>
+                  <a:srgbClr val="8C52E8"/>
                 </a:solidFill>
                 <a:latin typeface="Trebuchet MS" pitchFamily="34" charset="0"/>
                 <a:ea typeface="Trebuchet MS" pitchFamily="34" charset="-122"/>
@@ -29057,7 +28979,7 @@
                 <a:ea typeface="Trebuchet MS" pitchFamily="34" charset="-122"/>
                 <a:cs typeface="Trebuchet MS" pitchFamily="34" charset="-120"/>
               </a:rPr>
-              <a:t>~€130</a:t>
+              <a:t>~€60–80</a:t>
             </a:r>
             <a:endParaRPr lang="en-US" sz="1000" dirty="0"/>
           </a:p>
@@ -29135,7 +29057,7 @@
                 <a:ea typeface="Trebuchet MS" pitchFamily="34" charset="-122"/>
                 <a:cs typeface="Trebuchet MS" pitchFamily="34" charset="-120"/>
               </a:rPr>
-              <a:t>~€390</a:t>
+              <a:t>~€180–240</a:t>
             </a:r>
             <a:endParaRPr lang="en-US" sz="1000" dirty="0"/>
           </a:p>
@@ -29213,7 +29135,7 @@
                 <a:ea typeface="Trebuchet MS" pitchFamily="34" charset="-122"/>
                 <a:cs typeface="Trebuchet MS" pitchFamily="34" charset="-120"/>
               </a:rPr>
-              <a:t>~€60–80</a:t>
+              <a:t>~€30–50</a:t>
             </a:r>
             <a:endParaRPr lang="en-US" sz="1000" dirty="0"/>
           </a:p>
@@ -29285,13 +29207,13 @@
             <a:r>
               <a:rPr lang="en-US" sz="1000" b="1" dirty="0">
                 <a:solidFill>
-                  <a:srgbClr val="C8003C"/>
+                  <a:srgbClr val="8C52E8"/>
                 </a:solidFill>
                 <a:latin typeface="Trebuchet MS" pitchFamily="34" charset="0"/>
                 <a:ea typeface="Trebuchet MS" pitchFamily="34" charset="-122"/>
                 <a:cs typeface="Trebuchet MS" pitchFamily="34" charset="-120"/>
               </a:rPr>
-              <a:t>~€450–470</a:t>
+              <a:t>~€210–290</a:t>
             </a:r>
             <a:endParaRPr lang="en-US" sz="1000" dirty="0"/>
           </a:p>
@@ -29369,7 +29291,7 @@
                 <a:ea typeface="Trebuchet MS" pitchFamily="34" charset="-122"/>
                 <a:cs typeface="Trebuchet MS" pitchFamily="34" charset="-120"/>
               </a:rPr>
-              <a:t>~€113–118</a:t>
+              <a:t>~€53–73</a:t>
             </a:r>
             <a:endParaRPr lang="en-US" sz="1000" dirty="0"/>
           </a:p>
@@ -29390,11 +29312,11 @@
             <a:avLst/>
           </a:prstGeom>
           <a:solidFill>
-            <a:srgbClr val="C8003C"/>
+            <a:srgbClr val="8C52E8"/>
           </a:solidFill>
           <a:ln w="12700">
             <a:solidFill>
-              <a:srgbClr val="C8003C"/>
+              <a:srgbClr val="8C52E8"/>
             </a:solidFill>
             <a:prstDash val="solid"/>
           </a:ln>
@@ -29442,7 +29364,7 @@
                   </a:extLst>
                 </a:hlinkClick>
               </a:rPr>
-              <a:t>🔍  Airbnb: Mailand durchsuchen  →</a:t>
+              <a:t>🔍  Airbnb: Sofia durchsuchen  →</a:t>
             </a:r>
             <a:endParaRPr lang="en-US" sz="1500" dirty="0"/>
           </a:p>
@@ -29490,7 +29412,7 @@
                   </a:extLst>
                 </a:hlinkClick>
               </a:rPr>
-              <a:t>📍 Alternativ in Brera/Isola suchen: airbnb.com/s/Brera--Milan (Designviertel, gleiche Daten)</a:t>
+              <a:t>📍 Alternativ im Studentenviertel suchen: airbnb.com/s/Studentski-Grad--Sofia (lebhafter, günstiger)</a:t>
             </a:r>
             <a:endParaRPr lang="en-US" sz="900" dirty="0"/>
           </a:p>

</xml_diff>